<commit_message>
Playwright deck: rewrite How it works as a diagram with a worked login example
</commit_message>
<xml_diff>
--- a/presentations/Web_Test_Automation_Playwright.pptx
+++ b/presentations/Web_Test_Automation_Playwright.pptx
@@ -6480,7 +6480,7 @@
                 <a:ea typeface="Segoe UI" pitchFamily="34" charset="-122"/>
                 <a:cs typeface="Segoe UI" pitchFamily="34" charset="-120"/>
               </a:rPr>
-              <a:t>One process drives a real browser over a debug protocol - no Selenium grid, no browser driver binaries</a:t>
+              <a:t>Think of it as a tester who never gets tired, never gets bored, and never forgets a step</a:t>
             </a:r>
             <a:endParaRPr lang="en-US" sz="1400" dirty="0"/>
           </a:p>
@@ -6508,41 +6508,14 @@
       </p:sp>
       <p:sp>
         <p:nvSpPr>
-          <p:cNvPr id="5" name="Shape 3"/>
-          <p:cNvSpPr/>
-          <p:nvPr/>
-        </p:nvSpPr>
-        <p:spPr>
-          <a:xfrm>
-            <a:off x="566928" y="1719072"/>
-            <a:ext cx="1962851" cy="960120"/>
-          </a:xfrm>
-          <a:prstGeom prst="roundRect">
-            <a:avLst>
-              <a:gd name="adj" fmla="val 7619"/>
-            </a:avLst>
-          </a:prstGeom>
-          <a:solidFill>
-            <a:srgbClr val="E8F0F8"/>
-          </a:solidFill>
-          <a:ln w="12700">
-            <a:solidFill>
-              <a:srgbClr val="C9DAEA"/>
-            </a:solidFill>
-            <a:prstDash val="solid"/>
-          </a:ln>
-        </p:spPr>
-      </p:sp>
-      <p:sp>
-        <p:nvSpPr>
-          <p:cNvPr id="6" name="Text 4"/>
-          <p:cNvSpPr/>
-          <p:nvPr/>
-        </p:nvSpPr>
-        <p:spPr>
-          <a:xfrm>
-            <a:off x="640080" y="1773936"/>
-            <a:ext cx="1816547" cy="850392"/>
+          <p:cNvPr id="5" name="Text 3"/>
+          <p:cNvSpPr/>
+          <p:nvPr/>
+        </p:nvSpPr>
+        <p:spPr>
+          <a:xfrm>
+            <a:off x="566928" y="1627632"/>
+            <a:ext cx="4754880" cy="292608"/>
           </a:xfrm>
           <a:prstGeom prst="rect">
             <a:avLst/>
@@ -6554,11 +6527,11 @@
           <a:bodyPr wrap="square" rtlCol="0" anchor="ctr"/>
           <a:lstStyle/>
           <a:p>
-            <a:pPr algn="ctr" indent="0" marL="0">
-              <a:buNone/>
-            </a:pPr>
-            <a:r>
-              <a:rPr lang="en-US" sz="1200" b="1" dirty="0">
+            <a:pPr indent="0" marL="0">
+              <a:buNone/>
+            </a:pPr>
+            <a:r>
+              <a:rPr lang="en-US" sz="1500" b="1" dirty="0">
                 <a:solidFill>
                   <a:srgbClr val="1A1A1E"/>
                 </a:solidFill>
@@ -6566,205 +6539,25 @@
                 <a:ea typeface="Segoe UI" pitchFamily="34" charset="-122"/>
                 <a:cs typeface="Segoe UI" pitchFamily="34" charset="-120"/>
               </a:rPr>
-              <a:t>Test file</a:t>
-            </a:r>
-            <a:endParaRPr lang="en-US" sz="1200" dirty="0"/>
-          </a:p>
-          <a:p>
-            <a:pPr algn="ctr" indent="0" marL="0">
-              <a:buNone/>
-            </a:pPr>
-            <a:r>
-              <a:rPr lang="en-US" sz="1200" b="1" dirty="0">
-                <a:solidFill>
-                  <a:srgbClr val="1A1A1E"/>
-                </a:solidFill>
-                <a:latin typeface="Segoe UI" pitchFamily="34" charset="0"/>
-                <a:ea typeface="Segoe UI" pitchFamily="34" charset="-122"/>
-                <a:cs typeface="Segoe UI" pitchFamily="34" charset="-120"/>
-              </a:rPr>
-              <a:t>(TypeScript)</a:t>
-            </a:r>
-            <a:endParaRPr lang="en-US" sz="1200" dirty="0"/>
-          </a:p>
-        </p:txBody>
-      </p:sp>
-      <p:sp>
-        <p:nvSpPr>
-          <p:cNvPr id="7" name="Text 5"/>
-          <p:cNvSpPr/>
-          <p:nvPr/>
-        </p:nvSpPr>
-        <p:spPr>
-          <a:xfrm>
-            <a:off x="2529779" y="1719072"/>
-            <a:ext cx="310896" cy="960120"/>
-          </a:xfrm>
-          <a:prstGeom prst="rect">
-            <a:avLst/>
-          </a:prstGeom>
-          <a:noFill/>
-          <a:ln/>
-        </p:spPr>
-        <p:txBody>
-          <a:bodyPr wrap="square" rtlCol="0" anchor="ctr"/>
-          <a:lstStyle/>
-          <a:p>
-            <a:pPr algn="ctr" indent="0" marL="0">
-              <a:buNone/>
-            </a:pPr>
-            <a:r>
-              <a:rPr lang="en-US" sz="1700" b="1" dirty="0">
-                <a:solidFill>
-                  <a:srgbClr val="71717A"/>
-                </a:solidFill>
-                <a:latin typeface="Segoe UI" pitchFamily="34" charset="0"/>
-                <a:ea typeface="Segoe UI" pitchFamily="34" charset="-122"/>
-                <a:cs typeface="Segoe UI" pitchFamily="34" charset="-120"/>
-              </a:rPr>
-              <a:t>→</a:t>
-            </a:r>
-            <a:endParaRPr lang="en-US" sz="1700" dirty="0"/>
-          </a:p>
-        </p:txBody>
-      </p:sp>
-      <p:sp>
-        <p:nvSpPr>
-          <p:cNvPr id="8" name="Shape 6"/>
-          <p:cNvSpPr/>
-          <p:nvPr/>
-        </p:nvSpPr>
-        <p:spPr>
-          <a:xfrm>
-            <a:off x="2840675" y="1719072"/>
-            <a:ext cx="1962851" cy="960120"/>
-          </a:xfrm>
-          <a:prstGeom prst="roundRect">
-            <a:avLst>
-              <a:gd name="adj" fmla="val 7619"/>
-            </a:avLst>
-          </a:prstGeom>
-          <a:solidFill>
-            <a:srgbClr val="E8F0F8"/>
-          </a:solidFill>
-          <a:ln w="12700">
-            <a:solidFill>
-              <a:srgbClr val="C9DAEA"/>
-            </a:solidFill>
-            <a:prstDash val="solid"/>
-          </a:ln>
-        </p:spPr>
-      </p:sp>
-      <p:sp>
-        <p:nvSpPr>
-          <p:cNvPr id="9" name="Text 7"/>
-          <p:cNvSpPr/>
-          <p:nvPr/>
-        </p:nvSpPr>
-        <p:spPr>
-          <a:xfrm>
-            <a:off x="2913827" y="1773936"/>
-            <a:ext cx="1816547" cy="850392"/>
-          </a:xfrm>
-          <a:prstGeom prst="rect">
-            <a:avLst/>
-          </a:prstGeom>
-          <a:noFill/>
-          <a:ln/>
-        </p:spPr>
-        <p:txBody>
-          <a:bodyPr wrap="square" rtlCol="0" anchor="ctr"/>
-          <a:lstStyle/>
-          <a:p>
-            <a:pPr algn="ctr" indent="0" marL="0">
-              <a:buNone/>
-            </a:pPr>
-            <a:r>
-              <a:rPr lang="en-US" sz="1200" b="1" dirty="0">
-                <a:solidFill>
-                  <a:srgbClr val="1A1A1E"/>
-                </a:solidFill>
-                <a:latin typeface="Segoe UI" pitchFamily="34" charset="0"/>
-                <a:ea typeface="Segoe UI" pitchFamily="34" charset="-122"/>
-                <a:cs typeface="Segoe UI" pitchFamily="34" charset="-120"/>
-              </a:rPr>
-              <a:t>Playwright</a:t>
-            </a:r>
-            <a:endParaRPr lang="en-US" sz="1200" dirty="0"/>
-          </a:p>
-          <a:p>
-            <a:pPr algn="ctr" indent="0" marL="0">
-              <a:buNone/>
-            </a:pPr>
-            <a:r>
-              <a:rPr lang="en-US" sz="1200" b="1" dirty="0">
-                <a:solidFill>
-                  <a:srgbClr val="1A1A1E"/>
-                </a:solidFill>
-                <a:latin typeface="Segoe UI" pitchFamily="34" charset="0"/>
-                <a:ea typeface="Segoe UI" pitchFamily="34" charset="-122"/>
-                <a:cs typeface="Segoe UI" pitchFamily="34" charset="-120"/>
-              </a:rPr>
-              <a:t>test runner</a:t>
-            </a:r>
-            <a:endParaRPr lang="en-US" sz="1200" dirty="0"/>
-          </a:p>
-        </p:txBody>
-      </p:sp>
-      <p:sp>
-        <p:nvSpPr>
-          <p:cNvPr id="10" name="Text 8"/>
-          <p:cNvSpPr/>
-          <p:nvPr/>
-        </p:nvSpPr>
-        <p:spPr>
-          <a:xfrm>
-            <a:off x="4803526" y="1719072"/>
-            <a:ext cx="310896" cy="960120"/>
-          </a:xfrm>
-          <a:prstGeom prst="rect">
-            <a:avLst/>
-          </a:prstGeom>
-          <a:noFill/>
-          <a:ln/>
-        </p:spPr>
-        <p:txBody>
-          <a:bodyPr wrap="square" rtlCol="0" anchor="ctr"/>
-          <a:lstStyle/>
-          <a:p>
-            <a:pPr algn="ctr" indent="0" marL="0">
-              <a:buNone/>
-            </a:pPr>
-            <a:r>
-              <a:rPr lang="en-US" sz="1700" b="1" dirty="0">
-                <a:solidFill>
-                  <a:srgbClr val="71717A"/>
-                </a:solidFill>
-                <a:latin typeface="Segoe UI" pitchFamily="34" charset="0"/>
-                <a:ea typeface="Segoe UI" pitchFamily="34" charset="-122"/>
-                <a:cs typeface="Segoe UI" pitchFamily="34" charset="-120"/>
-              </a:rPr>
-              <a:t>→</a:t>
-            </a:r>
-            <a:endParaRPr lang="en-US" sz="1700" dirty="0"/>
-          </a:p>
-        </p:txBody>
-      </p:sp>
-      <p:sp>
-        <p:nvSpPr>
-          <p:cNvPr id="11" name="Shape 9"/>
-          <p:cNvSpPr/>
-          <p:nvPr/>
-        </p:nvSpPr>
-        <p:spPr>
-          <a:xfrm>
-            <a:off x="5114422" y="1719072"/>
-            <a:ext cx="1962851" cy="960120"/>
-          </a:xfrm>
-          <a:prstGeom prst="roundRect">
-            <a:avLst>
-              <a:gd name="adj" fmla="val 7619"/>
-            </a:avLst>
+              <a:t>What we write down</a:t>
+            </a:r>
+            <a:endParaRPr lang="en-US" sz="1500" dirty="0"/>
+          </a:p>
+        </p:txBody>
+      </p:sp>
+      <p:sp>
+        <p:nvSpPr>
+          <p:cNvPr id="6" name="Shape 4"/>
+          <p:cNvSpPr/>
+          <p:nvPr/>
+        </p:nvSpPr>
+        <p:spPr>
+          <a:xfrm>
+            <a:off x="566928" y="2103120"/>
+            <a:ext cx="292608" cy="292608"/>
+          </a:xfrm>
+          <a:prstGeom prst="ellipse">
+            <a:avLst/>
           </a:prstGeom>
           <a:solidFill>
             <a:srgbClr val="0B5FA5"/>
@@ -6779,14 +6572,14 @@
       </p:sp>
       <p:sp>
         <p:nvSpPr>
-          <p:cNvPr id="12" name="Text 10"/>
-          <p:cNvSpPr/>
-          <p:nvPr/>
-        </p:nvSpPr>
-        <p:spPr>
-          <a:xfrm>
-            <a:off x="5187574" y="1773936"/>
-            <a:ext cx="1816547" cy="850392"/>
+          <p:cNvPr id="7" name="Text 5"/>
+          <p:cNvSpPr/>
+          <p:nvPr/>
+        </p:nvSpPr>
+        <p:spPr>
+          <a:xfrm>
+            <a:off x="566928" y="2103120"/>
+            <a:ext cx="292608" cy="292608"/>
           </a:xfrm>
           <a:prstGeom prst="rect">
             <a:avLst/>
@@ -6802,7 +6595,7 @@
               <a:buNone/>
             </a:pPr>
             <a:r>
-              <a:rPr lang="en-US" sz="1200" b="1" dirty="0">
+              <a:rPr lang="en-US" sz="1250" b="1" dirty="0">
                 <a:solidFill>
                   <a:srgbClr val="FFFFFF"/>
                 </a:solidFill>
@@ -6810,39 +6603,22 @@
                 <a:ea typeface="Segoe UI" pitchFamily="34" charset="-122"/>
                 <a:cs typeface="Segoe UI" pitchFamily="34" charset="-120"/>
               </a:rPr>
-              <a:t>Browser over</a:t>
-            </a:r>
-            <a:endParaRPr lang="en-US" sz="1200" dirty="0"/>
-          </a:p>
-          <a:p>
-            <a:pPr algn="ctr" indent="0" marL="0">
-              <a:buNone/>
-            </a:pPr>
-            <a:r>
-              <a:rPr lang="en-US" sz="1200" b="1" dirty="0">
-                <a:solidFill>
-                  <a:srgbClr val="FFFFFF"/>
-                </a:solidFill>
-                <a:latin typeface="Segoe UI" pitchFamily="34" charset="0"/>
-                <a:ea typeface="Segoe UI" pitchFamily="34" charset="-122"/>
-                <a:cs typeface="Segoe UI" pitchFamily="34" charset="-120"/>
-              </a:rPr>
-              <a:t>CDP / WebSocket</a:t>
-            </a:r>
-            <a:endParaRPr lang="en-US" sz="1200" dirty="0"/>
-          </a:p>
-        </p:txBody>
-      </p:sp>
-      <p:sp>
-        <p:nvSpPr>
-          <p:cNvPr id="13" name="Text 11"/>
-          <p:cNvSpPr/>
-          <p:nvPr/>
-        </p:nvSpPr>
-        <p:spPr>
-          <a:xfrm>
-            <a:off x="7077273" y="1719072"/>
-            <a:ext cx="310896" cy="960120"/>
+              <a:t>1</a:t>
+            </a:r>
+            <a:endParaRPr lang="en-US" sz="1250" dirty="0"/>
+          </a:p>
+        </p:txBody>
+      </p:sp>
+      <p:sp>
+        <p:nvSpPr>
+          <p:cNvPr id="8" name="Text 6"/>
+          <p:cNvSpPr/>
+          <p:nvPr/>
+        </p:nvSpPr>
+        <p:spPr>
+          <a:xfrm>
+            <a:off x="969264" y="2084832"/>
+            <a:ext cx="4389120" cy="274320"/>
           </a:xfrm>
           <a:prstGeom prst="rect">
             <a:avLst/>
@@ -6854,46 +6630,46 @@
           <a:bodyPr wrap="square" rtlCol="0" anchor="ctr"/>
           <a:lstStyle/>
           <a:p>
-            <a:pPr algn="ctr" indent="0" marL="0">
-              <a:buNone/>
-            </a:pPr>
-            <a:r>
-              <a:rPr lang="en-US" sz="1700" b="1" dirty="0">
-                <a:solidFill>
-                  <a:srgbClr val="71717A"/>
-                </a:solidFill>
-                <a:latin typeface="Segoe UI" pitchFamily="34" charset="0"/>
-                <a:ea typeface="Segoe UI" pitchFamily="34" charset="-122"/>
-                <a:cs typeface="Segoe UI" pitchFamily="34" charset="-120"/>
-              </a:rPr>
-              <a:t>→</a:t>
-            </a:r>
-            <a:endParaRPr lang="en-US" sz="1700" dirty="0"/>
-          </a:p>
-        </p:txBody>
-      </p:sp>
-      <p:sp>
-        <p:nvSpPr>
-          <p:cNvPr id="14" name="Shape 12"/>
-          <p:cNvSpPr/>
-          <p:nvPr/>
-        </p:nvSpPr>
-        <p:spPr>
-          <a:xfrm>
-            <a:off x="7388169" y="1719072"/>
-            <a:ext cx="1962851" cy="960120"/>
+            <a:pPr indent="0" marL="0">
+              <a:buNone/>
+            </a:pPr>
+            <a:r>
+              <a:rPr lang="en-US" sz="1350" b="1" dirty="0">
+                <a:solidFill>
+                  <a:srgbClr val="1A1A1E"/>
+                </a:solidFill>
+                <a:latin typeface="Segoe UI" pitchFamily="34" charset="0"/>
+                <a:ea typeface="Segoe UI" pitchFamily="34" charset="-122"/>
+                <a:cs typeface="Segoe UI" pitchFamily="34" charset="-120"/>
+              </a:rPr>
+              <a:t>Type the user name into the box</a:t>
+            </a:r>
+            <a:endParaRPr lang="en-US" sz="1350" dirty="0"/>
+          </a:p>
+        </p:txBody>
+      </p:sp>
+      <p:sp>
+        <p:nvSpPr>
+          <p:cNvPr id="9" name="Shape 7"/>
+          <p:cNvSpPr/>
+          <p:nvPr/>
+        </p:nvSpPr>
+        <p:spPr>
+          <a:xfrm>
+            <a:off x="969264" y="2395728"/>
+            <a:ext cx="4526280" cy="384048"/>
           </a:xfrm>
           <a:prstGeom prst="roundRect">
             <a:avLst>
-              <a:gd name="adj" fmla="val 7619"/>
+              <a:gd name="adj" fmla="val 11905"/>
             </a:avLst>
           </a:prstGeom>
           <a:solidFill>
-            <a:srgbClr val="E8F0F8"/>
+            <a:srgbClr val="1E1E24"/>
           </a:solidFill>
           <a:ln w="12700">
             <a:solidFill>
-              <a:srgbClr val="C9DAEA"/>
+              <a:srgbClr val="1E1E24"/>
             </a:solidFill>
             <a:prstDash val="solid"/>
           </a:ln>
@@ -6901,14 +6677,14 @@
       </p:sp>
       <p:sp>
         <p:nvSpPr>
-          <p:cNvPr id="15" name="Text 13"/>
-          <p:cNvSpPr/>
-          <p:nvPr/>
-        </p:nvSpPr>
-        <p:spPr>
-          <a:xfrm>
-            <a:off x="7461321" y="1773936"/>
-            <a:ext cx="1816547" cy="850392"/>
+          <p:cNvPr id="10" name="Text 8"/>
+          <p:cNvSpPr/>
+          <p:nvPr/>
+        </p:nvSpPr>
+        <p:spPr>
+          <a:xfrm>
+            <a:off x="1078992" y="2395728"/>
+            <a:ext cx="4343400" cy="384048"/>
           </a:xfrm>
           <a:prstGeom prst="rect">
             <a:avLst/>
@@ -6920,102 +6696,44 @@
           <a:bodyPr wrap="square" rtlCol="0" anchor="ctr"/>
           <a:lstStyle/>
           <a:p>
-            <a:pPr algn="ctr" indent="0" marL="0">
-              <a:buNone/>
-            </a:pPr>
-            <a:r>
-              <a:rPr lang="en-US" sz="1200" b="1" dirty="0">
-                <a:solidFill>
-                  <a:srgbClr val="1A1A1E"/>
-                </a:solidFill>
-                <a:latin typeface="Segoe UI" pitchFamily="34" charset="0"/>
-                <a:ea typeface="Segoe UI" pitchFamily="34" charset="-122"/>
-                <a:cs typeface="Segoe UI" pitchFamily="34" charset="-120"/>
-              </a:rPr>
-              <a:t>Real page</a:t>
-            </a:r>
-            <a:endParaRPr lang="en-US" sz="1200" dirty="0"/>
-          </a:p>
-          <a:p>
-            <a:pPr algn="ctr" indent="0" marL="0">
-              <a:buNone/>
-            </a:pPr>
-            <a:r>
-              <a:rPr lang="en-US" sz="1200" b="1" dirty="0">
-                <a:solidFill>
-                  <a:srgbClr val="1A1A1E"/>
-                </a:solidFill>
-                <a:latin typeface="Segoe UI" pitchFamily="34" charset="0"/>
-                <a:ea typeface="Segoe UI" pitchFamily="34" charset="-122"/>
-                <a:cs typeface="Segoe UI" pitchFamily="34" charset="-120"/>
-              </a:rPr>
-              <a:t>on UAT</a:t>
-            </a:r>
-            <a:endParaRPr lang="en-US" sz="1200" dirty="0"/>
-          </a:p>
-        </p:txBody>
-      </p:sp>
-      <p:sp>
-        <p:nvSpPr>
-          <p:cNvPr id="16" name="Text 14"/>
-          <p:cNvSpPr/>
-          <p:nvPr/>
-        </p:nvSpPr>
-        <p:spPr>
-          <a:xfrm>
-            <a:off x="9351020" y="1719072"/>
-            <a:ext cx="310896" cy="960120"/>
-          </a:xfrm>
-          <a:prstGeom prst="rect">
-            <a:avLst/>
-          </a:prstGeom>
-          <a:noFill/>
-          <a:ln/>
-        </p:spPr>
-        <p:txBody>
-          <a:bodyPr wrap="square" rtlCol="0" anchor="ctr"/>
-          <a:lstStyle/>
-          <a:p>
-            <a:pPr algn="ctr" indent="0" marL="0">
-              <a:buNone/>
-            </a:pPr>
-            <a:r>
-              <a:rPr lang="en-US" sz="1700" b="1" dirty="0">
-                <a:solidFill>
-                  <a:srgbClr val="71717A"/>
-                </a:solidFill>
-                <a:latin typeface="Segoe UI" pitchFamily="34" charset="0"/>
-                <a:ea typeface="Segoe UI" pitchFamily="34" charset="-122"/>
-                <a:cs typeface="Segoe UI" pitchFamily="34" charset="-120"/>
-              </a:rPr>
-              <a:t>→</a:t>
-            </a:r>
-            <a:endParaRPr lang="en-US" sz="1700" dirty="0"/>
-          </a:p>
-        </p:txBody>
-      </p:sp>
-      <p:sp>
-        <p:nvSpPr>
-          <p:cNvPr id="17" name="Shape 15"/>
-          <p:cNvSpPr/>
-          <p:nvPr/>
-        </p:nvSpPr>
-        <p:spPr>
-          <a:xfrm>
-            <a:off x="9661916" y="1719072"/>
-            <a:ext cx="1962851" cy="960120"/>
-          </a:xfrm>
-          <a:prstGeom prst="roundRect">
-            <a:avLst>
-              <a:gd name="adj" fmla="val 7619"/>
-            </a:avLst>
+            <a:pPr indent="0" marL="0">
+              <a:buNone/>
+            </a:pPr>
+            <a:r>
+              <a:rPr lang="en-US" sz="1000" dirty="0">
+                <a:solidFill>
+                  <a:srgbClr val="E8E8EC"/>
+                </a:solidFill>
+                <a:latin typeface="Consolas" pitchFamily="34" charset="0"/>
+                <a:ea typeface="Consolas" pitchFamily="34" charset="-122"/>
+                <a:cs typeface="Consolas" pitchFamily="34" charset="-120"/>
+              </a:rPr>
+              <a:t>page.getByPlaceholder('User name').fill('admin.ko')</a:t>
+            </a:r>
+            <a:endParaRPr lang="en-US" sz="1000" dirty="0"/>
+          </a:p>
+        </p:txBody>
+      </p:sp>
+      <p:sp>
+        <p:nvSpPr>
+          <p:cNvPr id="11" name="Shape 9"/>
+          <p:cNvSpPr/>
+          <p:nvPr/>
+        </p:nvSpPr>
+        <p:spPr>
+          <a:xfrm>
+            <a:off x="566928" y="3035808"/>
+            <a:ext cx="292608" cy="292608"/>
+          </a:xfrm>
+          <a:prstGeom prst="ellipse">
+            <a:avLst/>
           </a:prstGeom>
           <a:solidFill>
-            <a:srgbClr val="E8F0F8"/>
+            <a:srgbClr val="0B5FA5"/>
           </a:solidFill>
           <a:ln w="12700">
             <a:solidFill>
-              <a:srgbClr val="C9DAEA"/>
+              <a:srgbClr val="0B5FA5"/>
             </a:solidFill>
             <a:prstDash val="solid"/>
           </a:ln>
@@ -7023,14 +6741,222 @@
       </p:sp>
       <p:sp>
         <p:nvSpPr>
+          <p:cNvPr id="12" name="Text 10"/>
+          <p:cNvSpPr/>
+          <p:nvPr/>
+        </p:nvSpPr>
+        <p:spPr>
+          <a:xfrm>
+            <a:off x="566928" y="3035808"/>
+            <a:ext cx="292608" cy="292608"/>
+          </a:xfrm>
+          <a:prstGeom prst="rect">
+            <a:avLst/>
+          </a:prstGeom>
+          <a:noFill/>
+          <a:ln/>
+        </p:spPr>
+        <p:txBody>
+          <a:bodyPr wrap="square" rtlCol="0" anchor="ctr"/>
+          <a:lstStyle/>
+          <a:p>
+            <a:pPr algn="ctr" indent="0" marL="0">
+              <a:buNone/>
+            </a:pPr>
+            <a:r>
+              <a:rPr lang="en-US" sz="1250" b="1" dirty="0">
+                <a:solidFill>
+                  <a:srgbClr val="FFFFFF"/>
+                </a:solidFill>
+                <a:latin typeface="Segoe UI" pitchFamily="34" charset="0"/>
+                <a:ea typeface="Segoe UI" pitchFamily="34" charset="-122"/>
+                <a:cs typeface="Segoe UI" pitchFamily="34" charset="-120"/>
+              </a:rPr>
+              <a:t>2</a:t>
+            </a:r>
+            <a:endParaRPr lang="en-US" sz="1250" dirty="0"/>
+          </a:p>
+        </p:txBody>
+      </p:sp>
+      <p:sp>
+        <p:nvSpPr>
+          <p:cNvPr id="13" name="Text 11"/>
+          <p:cNvSpPr/>
+          <p:nvPr/>
+        </p:nvSpPr>
+        <p:spPr>
+          <a:xfrm>
+            <a:off x="969264" y="3017520"/>
+            <a:ext cx="4389120" cy="274320"/>
+          </a:xfrm>
+          <a:prstGeom prst="rect">
+            <a:avLst/>
+          </a:prstGeom>
+          <a:noFill/>
+          <a:ln/>
+        </p:spPr>
+        <p:txBody>
+          <a:bodyPr wrap="square" rtlCol="0" anchor="ctr"/>
+          <a:lstStyle/>
+          <a:p>
+            <a:pPr indent="0" marL="0">
+              <a:buNone/>
+            </a:pPr>
+            <a:r>
+              <a:rPr lang="en-US" sz="1350" b="1" dirty="0">
+                <a:solidFill>
+                  <a:srgbClr val="1A1A1E"/>
+                </a:solidFill>
+                <a:latin typeface="Segoe UI" pitchFamily="34" charset="0"/>
+                <a:ea typeface="Segoe UI" pitchFamily="34" charset="-122"/>
+                <a:cs typeface="Segoe UI" pitchFamily="34" charset="-120"/>
+              </a:rPr>
+              <a:t>Type the password</a:t>
+            </a:r>
+            <a:endParaRPr lang="en-US" sz="1350" dirty="0"/>
+          </a:p>
+        </p:txBody>
+      </p:sp>
+      <p:sp>
+        <p:nvSpPr>
+          <p:cNvPr id="14" name="Shape 12"/>
+          <p:cNvSpPr/>
+          <p:nvPr/>
+        </p:nvSpPr>
+        <p:spPr>
+          <a:xfrm>
+            <a:off x="969264" y="3328416"/>
+            <a:ext cx="4526280" cy="384048"/>
+          </a:xfrm>
+          <a:prstGeom prst="roundRect">
+            <a:avLst>
+              <a:gd name="adj" fmla="val 11905"/>
+            </a:avLst>
+          </a:prstGeom>
+          <a:solidFill>
+            <a:srgbClr val="1E1E24"/>
+          </a:solidFill>
+          <a:ln w="12700">
+            <a:solidFill>
+              <a:srgbClr val="1E1E24"/>
+            </a:solidFill>
+            <a:prstDash val="solid"/>
+          </a:ln>
+        </p:spPr>
+      </p:sp>
+      <p:sp>
+        <p:nvSpPr>
+          <p:cNvPr id="15" name="Text 13"/>
+          <p:cNvSpPr/>
+          <p:nvPr/>
+        </p:nvSpPr>
+        <p:spPr>
+          <a:xfrm>
+            <a:off x="1078992" y="3328416"/>
+            <a:ext cx="4343400" cy="384048"/>
+          </a:xfrm>
+          <a:prstGeom prst="rect">
+            <a:avLst/>
+          </a:prstGeom>
+          <a:noFill/>
+          <a:ln/>
+        </p:spPr>
+        <p:txBody>
+          <a:bodyPr wrap="square" rtlCol="0" anchor="ctr"/>
+          <a:lstStyle/>
+          <a:p>
+            <a:pPr indent="0" marL="0">
+              <a:buNone/>
+            </a:pPr>
+            <a:r>
+              <a:rPr lang="en-US" sz="1000" dirty="0">
+                <a:solidFill>
+                  <a:srgbClr val="E8E8EC"/>
+                </a:solidFill>
+                <a:latin typeface="Consolas" pitchFamily="34" charset="0"/>
+                <a:ea typeface="Consolas" pitchFamily="34" charset="-122"/>
+                <a:cs typeface="Consolas" pitchFamily="34" charset="-120"/>
+              </a:rPr>
+              <a:t>page.getByPlaceholder('Password').fill('••••••')</a:t>
+            </a:r>
+            <a:endParaRPr lang="en-US" sz="1000" dirty="0"/>
+          </a:p>
+        </p:txBody>
+      </p:sp>
+      <p:sp>
+        <p:nvSpPr>
+          <p:cNvPr id="16" name="Shape 14"/>
+          <p:cNvSpPr/>
+          <p:nvPr/>
+        </p:nvSpPr>
+        <p:spPr>
+          <a:xfrm>
+            <a:off x="566928" y="3968496"/>
+            <a:ext cx="292608" cy="292608"/>
+          </a:xfrm>
+          <a:prstGeom prst="ellipse">
+            <a:avLst/>
+          </a:prstGeom>
+          <a:solidFill>
+            <a:srgbClr val="0B5FA5"/>
+          </a:solidFill>
+          <a:ln w="12700">
+            <a:solidFill>
+              <a:srgbClr val="0B5FA5"/>
+            </a:solidFill>
+            <a:prstDash val="solid"/>
+          </a:ln>
+        </p:spPr>
+      </p:sp>
+      <p:sp>
+        <p:nvSpPr>
+          <p:cNvPr id="17" name="Text 15"/>
+          <p:cNvSpPr/>
+          <p:nvPr/>
+        </p:nvSpPr>
+        <p:spPr>
+          <a:xfrm>
+            <a:off x="566928" y="3968496"/>
+            <a:ext cx="292608" cy="292608"/>
+          </a:xfrm>
+          <a:prstGeom prst="rect">
+            <a:avLst/>
+          </a:prstGeom>
+          <a:noFill/>
+          <a:ln/>
+        </p:spPr>
+        <p:txBody>
+          <a:bodyPr wrap="square" rtlCol="0" anchor="ctr"/>
+          <a:lstStyle/>
+          <a:p>
+            <a:pPr algn="ctr" indent="0" marL="0">
+              <a:buNone/>
+            </a:pPr>
+            <a:r>
+              <a:rPr lang="en-US" sz="1250" b="1" dirty="0">
+                <a:solidFill>
+                  <a:srgbClr val="FFFFFF"/>
+                </a:solidFill>
+                <a:latin typeface="Segoe UI" pitchFamily="34" charset="0"/>
+                <a:ea typeface="Segoe UI" pitchFamily="34" charset="-122"/>
+                <a:cs typeface="Segoe UI" pitchFamily="34" charset="-120"/>
+              </a:rPr>
+              <a:t>3</a:t>
+            </a:r>
+            <a:endParaRPr lang="en-US" sz="1250" dirty="0"/>
+          </a:p>
+        </p:txBody>
+      </p:sp>
+      <p:sp>
+        <p:nvSpPr>
           <p:cNvPr id="18" name="Text 16"/>
           <p:cNvSpPr/>
           <p:nvPr/>
         </p:nvSpPr>
         <p:spPr>
           <a:xfrm>
-            <a:off x="9735068" y="1773936"/>
-            <a:ext cx="1816547" cy="850392"/>
+            <a:off x="969264" y="3950208"/>
+            <a:ext cx="4389120" cy="274320"/>
           </a:xfrm>
           <a:prstGeom prst="rect">
             <a:avLst/>
@@ -7042,51 +6968,969 @@
           <a:bodyPr wrap="square" rtlCol="0" anchor="ctr"/>
           <a:lstStyle/>
           <a:p>
+            <a:pPr indent="0" marL="0">
+              <a:buNone/>
+            </a:pPr>
+            <a:r>
+              <a:rPr lang="en-US" sz="1350" b="1" dirty="0">
+                <a:solidFill>
+                  <a:srgbClr val="1A1A1E"/>
+                </a:solidFill>
+                <a:latin typeface="Segoe UI" pitchFamily="34" charset="0"/>
+                <a:ea typeface="Segoe UI" pitchFamily="34" charset="-122"/>
+                <a:cs typeface="Segoe UI" pitchFamily="34" charset="-120"/>
+              </a:rPr>
+              <a:t>Press the Sign in button</a:t>
+            </a:r>
+            <a:endParaRPr lang="en-US" sz="1350" dirty="0"/>
+          </a:p>
+        </p:txBody>
+      </p:sp>
+      <p:sp>
+        <p:nvSpPr>
+          <p:cNvPr id="19" name="Shape 17"/>
+          <p:cNvSpPr/>
+          <p:nvPr/>
+        </p:nvSpPr>
+        <p:spPr>
+          <a:xfrm>
+            <a:off x="969264" y="4261104"/>
+            <a:ext cx="4526280" cy="384048"/>
+          </a:xfrm>
+          <a:prstGeom prst="roundRect">
+            <a:avLst>
+              <a:gd name="adj" fmla="val 11905"/>
+            </a:avLst>
+          </a:prstGeom>
+          <a:solidFill>
+            <a:srgbClr val="1E1E24"/>
+          </a:solidFill>
+          <a:ln w="12700">
+            <a:solidFill>
+              <a:srgbClr val="1E1E24"/>
+            </a:solidFill>
+            <a:prstDash val="solid"/>
+          </a:ln>
+        </p:spPr>
+      </p:sp>
+      <p:sp>
+        <p:nvSpPr>
+          <p:cNvPr id="20" name="Text 18"/>
+          <p:cNvSpPr/>
+          <p:nvPr/>
+        </p:nvSpPr>
+        <p:spPr>
+          <a:xfrm>
+            <a:off x="1078992" y="4261104"/>
+            <a:ext cx="4343400" cy="384048"/>
+          </a:xfrm>
+          <a:prstGeom prst="rect">
+            <a:avLst/>
+          </a:prstGeom>
+          <a:noFill/>
+          <a:ln/>
+        </p:spPr>
+        <p:txBody>
+          <a:bodyPr wrap="square" rtlCol="0" anchor="ctr"/>
+          <a:lstStyle/>
+          <a:p>
+            <a:pPr indent="0" marL="0">
+              <a:buNone/>
+            </a:pPr>
+            <a:r>
+              <a:rPr lang="en-US" sz="1000" dirty="0">
+                <a:solidFill>
+                  <a:srgbClr val="E8E8EC"/>
+                </a:solidFill>
+                <a:latin typeface="Consolas" pitchFamily="34" charset="0"/>
+                <a:ea typeface="Consolas" pitchFamily="34" charset="-122"/>
+                <a:cs typeface="Consolas" pitchFamily="34" charset="-120"/>
+              </a:rPr>
+              <a:t>page.locator('#btnSignIn').click()</a:t>
+            </a:r>
+            <a:endParaRPr lang="en-US" sz="1000" dirty="0"/>
+          </a:p>
+        </p:txBody>
+      </p:sp>
+      <p:sp>
+        <p:nvSpPr>
+          <p:cNvPr id="21" name="Shape 19"/>
+          <p:cNvSpPr/>
+          <p:nvPr/>
+        </p:nvSpPr>
+        <p:spPr>
+          <a:xfrm>
+            <a:off x="566928" y="4901184"/>
+            <a:ext cx="292608" cy="292608"/>
+          </a:xfrm>
+          <a:prstGeom prst="ellipse">
+            <a:avLst/>
+          </a:prstGeom>
+          <a:solidFill>
+            <a:srgbClr val="0B5FA5"/>
+          </a:solidFill>
+          <a:ln w="12700">
+            <a:solidFill>
+              <a:srgbClr val="0B5FA5"/>
+            </a:solidFill>
+            <a:prstDash val="solid"/>
+          </a:ln>
+        </p:spPr>
+      </p:sp>
+      <p:sp>
+        <p:nvSpPr>
+          <p:cNvPr id="22" name="Text 20"/>
+          <p:cNvSpPr/>
+          <p:nvPr/>
+        </p:nvSpPr>
+        <p:spPr>
+          <a:xfrm>
+            <a:off x="566928" y="4901184"/>
+            <a:ext cx="292608" cy="292608"/>
+          </a:xfrm>
+          <a:prstGeom prst="rect">
+            <a:avLst/>
+          </a:prstGeom>
+          <a:noFill/>
+          <a:ln/>
+        </p:spPr>
+        <p:txBody>
+          <a:bodyPr wrap="square" rtlCol="0" anchor="ctr"/>
+          <a:lstStyle/>
+          <a:p>
             <a:pPr algn="ctr" indent="0" marL="0">
               <a:buNone/>
             </a:pPr>
             <a:r>
+              <a:rPr lang="en-US" sz="1250" b="1" dirty="0">
+                <a:solidFill>
+                  <a:srgbClr val="FFFFFF"/>
+                </a:solidFill>
+                <a:latin typeface="Segoe UI" pitchFamily="34" charset="0"/>
+                <a:ea typeface="Segoe UI" pitchFamily="34" charset="-122"/>
+                <a:cs typeface="Segoe UI" pitchFamily="34" charset="-120"/>
+              </a:rPr>
+              <a:t>4</a:t>
+            </a:r>
+            <a:endParaRPr lang="en-US" sz="1250" dirty="0"/>
+          </a:p>
+        </p:txBody>
+      </p:sp>
+      <p:sp>
+        <p:nvSpPr>
+          <p:cNvPr id="23" name="Text 21"/>
+          <p:cNvSpPr/>
+          <p:nvPr/>
+        </p:nvSpPr>
+        <p:spPr>
+          <a:xfrm>
+            <a:off x="969264" y="4882896"/>
+            <a:ext cx="4389120" cy="274320"/>
+          </a:xfrm>
+          <a:prstGeom prst="rect">
+            <a:avLst/>
+          </a:prstGeom>
+          <a:noFill/>
+          <a:ln/>
+        </p:spPr>
+        <p:txBody>
+          <a:bodyPr wrap="square" rtlCol="0" anchor="ctr"/>
+          <a:lstStyle/>
+          <a:p>
+            <a:pPr indent="0" marL="0">
+              <a:buNone/>
+            </a:pPr>
+            <a:r>
+              <a:rPr lang="en-US" sz="1350" b="1" dirty="0">
+                <a:solidFill>
+                  <a:srgbClr val="1A1A1E"/>
+                </a:solidFill>
+                <a:latin typeface="Segoe UI" pitchFamily="34" charset="0"/>
+                <a:ea typeface="Segoe UI" pitchFamily="34" charset="-122"/>
+                <a:cs typeface="Segoe UI" pitchFamily="34" charset="-120"/>
+              </a:rPr>
+              <a:t>Check we landed on the job list</a:t>
+            </a:r>
+            <a:endParaRPr lang="en-US" sz="1350" dirty="0"/>
+          </a:p>
+        </p:txBody>
+      </p:sp>
+      <p:sp>
+        <p:nvSpPr>
+          <p:cNvPr id="24" name="Shape 22"/>
+          <p:cNvSpPr/>
+          <p:nvPr/>
+        </p:nvSpPr>
+        <p:spPr>
+          <a:xfrm>
+            <a:off x="969264" y="5193792"/>
+            <a:ext cx="4526280" cy="384048"/>
+          </a:xfrm>
+          <a:prstGeom prst="roundRect">
+            <a:avLst>
+              <a:gd name="adj" fmla="val 11905"/>
+            </a:avLst>
+          </a:prstGeom>
+          <a:solidFill>
+            <a:srgbClr val="1E1E24"/>
+          </a:solidFill>
+          <a:ln w="12700">
+            <a:solidFill>
+              <a:srgbClr val="1E1E24"/>
+            </a:solidFill>
+            <a:prstDash val="solid"/>
+          </a:ln>
+        </p:spPr>
+      </p:sp>
+      <p:sp>
+        <p:nvSpPr>
+          <p:cNvPr id="25" name="Text 23"/>
+          <p:cNvSpPr/>
+          <p:nvPr/>
+        </p:nvSpPr>
+        <p:spPr>
+          <a:xfrm>
+            <a:off x="1078992" y="5193792"/>
+            <a:ext cx="4343400" cy="384048"/>
+          </a:xfrm>
+          <a:prstGeom prst="rect">
+            <a:avLst/>
+          </a:prstGeom>
+          <a:noFill/>
+          <a:ln/>
+        </p:spPr>
+        <p:txBody>
+          <a:bodyPr wrap="square" rtlCol="0" anchor="ctr"/>
+          <a:lstStyle/>
+          <a:p>
+            <a:pPr indent="0" marL="0">
+              <a:buNone/>
+            </a:pPr>
+            <a:r>
+              <a:rPr lang="en-US" sz="1000" dirty="0">
+                <a:solidFill>
+                  <a:srgbClr val="E8E8EC"/>
+                </a:solidFill>
+                <a:latin typeface="Consolas" pitchFamily="34" charset="0"/>
+                <a:ea typeface="Consolas" pitchFamily="34" charset="-122"/>
+                <a:cs typeface="Consolas" pitchFamily="34" charset="-120"/>
+              </a:rPr>
+              <a:t>expect(page).toHaveURL(/msu\/joblst/)</a:t>
+            </a:r>
+            <a:endParaRPr lang="en-US" sz="1000" dirty="0"/>
+          </a:p>
+        </p:txBody>
+      </p:sp>
+      <p:sp>
+        <p:nvSpPr>
+          <p:cNvPr id="26" name="Text 24"/>
+          <p:cNvSpPr/>
+          <p:nvPr/>
+        </p:nvSpPr>
+        <p:spPr>
+          <a:xfrm>
+            <a:off x="5623560" y="1627632"/>
+            <a:ext cx="5943600" cy="292608"/>
+          </a:xfrm>
+          <a:prstGeom prst="rect">
+            <a:avLst/>
+          </a:prstGeom>
+          <a:noFill/>
+          <a:ln/>
+        </p:spPr>
+        <p:txBody>
+          <a:bodyPr wrap="square" rtlCol="0" anchor="ctr"/>
+          <a:lstStyle/>
+          <a:p>
+            <a:pPr indent="0" marL="0">
+              <a:buNone/>
+            </a:pPr>
+            <a:r>
+              <a:rPr lang="en-US" sz="1500" b="1" dirty="0">
+                <a:solidFill>
+                  <a:srgbClr val="1A1A1E"/>
+                </a:solidFill>
+                <a:latin typeface="Segoe UI" pitchFamily="34" charset="0"/>
+                <a:ea typeface="Segoe UI" pitchFamily="34" charset="-122"/>
+                <a:cs typeface="Segoe UI" pitchFamily="34" charset="-120"/>
+              </a:rPr>
+              <a:t>What happens on the real site</a:t>
+            </a:r>
+            <a:endParaRPr lang="en-US" sz="1500" dirty="0"/>
+          </a:p>
+        </p:txBody>
+      </p:sp>
+      <p:sp>
+        <p:nvSpPr>
+          <p:cNvPr id="27" name="Shape 25"/>
+          <p:cNvSpPr/>
+          <p:nvPr/>
+        </p:nvSpPr>
+        <p:spPr>
+          <a:xfrm>
+            <a:off x="5623560" y="2011680"/>
+            <a:ext cx="5989320" cy="2487168"/>
+          </a:xfrm>
+          <a:prstGeom prst="roundRect">
+            <a:avLst>
+              <a:gd name="adj" fmla="val 2206"/>
+            </a:avLst>
+          </a:prstGeom>
+          <a:solidFill>
+            <a:srgbClr val="FFFFFF"/>
+          </a:solidFill>
+          <a:ln w="12700">
+            <a:solidFill>
+              <a:srgbClr val="C9CDD4"/>
+            </a:solidFill>
+            <a:prstDash val="solid"/>
+          </a:ln>
+        </p:spPr>
+      </p:sp>
+      <p:sp>
+        <p:nvSpPr>
+          <p:cNvPr id="28" name="Shape 26"/>
+          <p:cNvSpPr/>
+          <p:nvPr/>
+        </p:nvSpPr>
+        <p:spPr>
+          <a:xfrm>
+            <a:off x="5623560" y="2011680"/>
+            <a:ext cx="5989320" cy="329184"/>
+          </a:xfrm>
+          <a:prstGeom prst="rect">
+            <a:avLst/>
+          </a:prstGeom>
+          <a:solidFill>
+            <a:srgbClr val="EDEEF2"/>
+          </a:solidFill>
+          <a:ln w="12700">
+            <a:solidFill>
+              <a:srgbClr val="C9CDD4"/>
+            </a:solidFill>
+            <a:prstDash val="solid"/>
+          </a:ln>
+        </p:spPr>
+      </p:sp>
+      <p:sp>
+        <p:nvSpPr>
+          <p:cNvPr id="29" name="Shape 27"/>
+          <p:cNvSpPr/>
+          <p:nvPr/>
+        </p:nvSpPr>
+        <p:spPr>
+          <a:xfrm>
+            <a:off x="5769864" y="2121408"/>
+            <a:ext cx="109728" cy="109728"/>
+          </a:xfrm>
+          <a:prstGeom prst="ellipse">
+            <a:avLst/>
+          </a:prstGeom>
+          <a:solidFill>
+            <a:srgbClr val="E06C61"/>
+          </a:solidFill>
+          <a:ln w="12700">
+            <a:solidFill>
+              <a:srgbClr val="E06C61"/>
+            </a:solidFill>
+            <a:prstDash val="solid"/>
+          </a:ln>
+        </p:spPr>
+      </p:sp>
+      <p:sp>
+        <p:nvSpPr>
+          <p:cNvPr id="30" name="Shape 28"/>
+          <p:cNvSpPr/>
+          <p:nvPr/>
+        </p:nvSpPr>
+        <p:spPr>
+          <a:xfrm>
+            <a:off x="5952744" y="2121408"/>
+            <a:ext cx="109728" cy="109728"/>
+          </a:xfrm>
+          <a:prstGeom prst="ellipse">
+            <a:avLst/>
+          </a:prstGeom>
+          <a:solidFill>
+            <a:srgbClr val="E3B341"/>
+          </a:solidFill>
+          <a:ln w="12700">
+            <a:solidFill>
+              <a:srgbClr val="E3B341"/>
+            </a:solidFill>
+            <a:prstDash val="solid"/>
+          </a:ln>
+        </p:spPr>
+      </p:sp>
+      <p:sp>
+        <p:nvSpPr>
+          <p:cNvPr id="31" name="Shape 29"/>
+          <p:cNvSpPr/>
+          <p:nvPr/>
+        </p:nvSpPr>
+        <p:spPr>
+          <a:xfrm>
+            <a:off x="6135624" y="2121408"/>
+            <a:ext cx="109728" cy="109728"/>
+          </a:xfrm>
+          <a:prstGeom prst="ellipse">
+            <a:avLst/>
+          </a:prstGeom>
+          <a:solidFill>
+            <a:srgbClr val="7DC46B"/>
+          </a:solidFill>
+          <a:ln w="12700">
+            <a:solidFill>
+              <a:srgbClr val="7DC46B"/>
+            </a:solidFill>
+            <a:prstDash val="solid"/>
+          </a:ln>
+        </p:spPr>
+      </p:sp>
+      <p:sp>
+        <p:nvSpPr>
+          <p:cNvPr id="32" name="Shape 30"/>
+          <p:cNvSpPr/>
+          <p:nvPr/>
+        </p:nvSpPr>
+        <p:spPr>
+          <a:xfrm>
+            <a:off x="6409944" y="2075688"/>
+            <a:ext cx="4983480" cy="201168"/>
+          </a:xfrm>
+          <a:prstGeom prst="roundRect">
+            <a:avLst>
+              <a:gd name="adj" fmla="val 22727"/>
+            </a:avLst>
+          </a:prstGeom>
+          <a:solidFill>
+            <a:srgbClr val="FFFFFF"/>
+          </a:solidFill>
+          <a:ln w="12700">
+            <a:solidFill>
+              <a:srgbClr val="D6D9DF"/>
+            </a:solidFill>
+            <a:prstDash val="solid"/>
+          </a:ln>
+        </p:spPr>
+      </p:sp>
+      <p:sp>
+        <p:nvSpPr>
+          <p:cNvPr id="33" name="Text 31"/>
+          <p:cNvSpPr/>
+          <p:nvPr/>
+        </p:nvSpPr>
+        <p:spPr>
+          <a:xfrm>
+            <a:off x="6501384" y="2075688"/>
+            <a:ext cx="4892040" cy="201168"/>
+          </a:xfrm>
+          <a:prstGeom prst="rect">
+            <a:avLst/>
+          </a:prstGeom>
+          <a:noFill/>
+          <a:ln/>
+        </p:spPr>
+        <p:txBody>
+          <a:bodyPr wrap="square" rtlCol="0" anchor="ctr"/>
+          <a:lstStyle/>
+          <a:p>
+            <a:pPr indent="0" marL="0">
+              <a:buNone/>
+            </a:pPr>
+            <a:r>
+              <a:rPr lang="en-US" sz="900" dirty="0">
+                <a:solidFill>
+                  <a:srgbClr val="71717A"/>
+                </a:solidFill>
+                <a:latin typeface="Segoe UI" pitchFamily="34" charset="0"/>
+                <a:ea typeface="Segoe UI" pitchFamily="34" charset="-122"/>
+                <a:cs typeface="Segoe UI" pitchFamily="34" charset="-120"/>
+              </a:rPr>
+              <a:t>roadside-uat.aspireasia.net/auth/login</a:t>
+            </a:r>
+            <a:endParaRPr lang="en-US" sz="900" dirty="0"/>
+          </a:p>
+        </p:txBody>
+      </p:sp>
+      <p:sp>
+        <p:nvSpPr>
+          <p:cNvPr id="34" name="Shape 32"/>
+          <p:cNvSpPr/>
+          <p:nvPr/>
+        </p:nvSpPr>
+        <p:spPr>
+          <a:xfrm>
+            <a:off x="5879592" y="2779776"/>
+            <a:ext cx="3931920" cy="402336"/>
+          </a:xfrm>
+          <a:prstGeom prst="roundRect">
+            <a:avLst>
+              <a:gd name="adj" fmla="val 11364"/>
+            </a:avLst>
+          </a:prstGeom>
+          <a:solidFill>
+            <a:srgbClr val="FBFBFC"/>
+          </a:solidFill>
+          <a:ln w="12700">
+            <a:solidFill>
+              <a:srgbClr val="C9CDD4"/>
+            </a:solidFill>
+            <a:prstDash val="solid"/>
+          </a:ln>
+        </p:spPr>
+      </p:sp>
+      <p:sp>
+        <p:nvSpPr>
+          <p:cNvPr id="35" name="Text 33"/>
+          <p:cNvSpPr/>
+          <p:nvPr/>
+        </p:nvSpPr>
+        <p:spPr>
+          <a:xfrm>
+            <a:off x="5879592" y="2560320"/>
+            <a:ext cx="3931920" cy="201168"/>
+          </a:xfrm>
+          <a:prstGeom prst="rect">
+            <a:avLst/>
+          </a:prstGeom>
+          <a:noFill/>
+          <a:ln/>
+        </p:spPr>
+        <p:txBody>
+          <a:bodyPr wrap="square" rtlCol="0" anchor="ctr"/>
+          <a:lstStyle/>
+          <a:p>
+            <a:pPr indent="0" marL="0">
+              <a:buNone/>
+            </a:pPr>
+            <a:r>
+              <a:rPr lang="en-US" sz="950" dirty="0">
+                <a:solidFill>
+                  <a:srgbClr val="71717A"/>
+                </a:solidFill>
+                <a:latin typeface="Segoe UI" pitchFamily="34" charset="0"/>
+                <a:ea typeface="Segoe UI" pitchFamily="34" charset="-122"/>
+                <a:cs typeface="Segoe UI" pitchFamily="34" charset="-120"/>
+              </a:rPr>
+              <a:t>User name</a:t>
+            </a:r>
+            <a:endParaRPr lang="en-US" sz="950" dirty="0"/>
+          </a:p>
+        </p:txBody>
+      </p:sp>
+      <p:sp>
+        <p:nvSpPr>
+          <p:cNvPr id="36" name="Text 34"/>
+          <p:cNvSpPr/>
+          <p:nvPr/>
+        </p:nvSpPr>
+        <p:spPr>
+          <a:xfrm>
+            <a:off x="6007608" y="2779776"/>
+            <a:ext cx="3675888" cy="402336"/>
+          </a:xfrm>
+          <a:prstGeom prst="rect">
+            <a:avLst/>
+          </a:prstGeom>
+          <a:noFill/>
+          <a:ln/>
+        </p:spPr>
+        <p:txBody>
+          <a:bodyPr wrap="square" rtlCol="0" anchor="ctr"/>
+          <a:lstStyle/>
+          <a:p>
+            <a:pPr indent="0" marL="0">
+              <a:buNone/>
+            </a:pPr>
+            <a:r>
+              <a:rPr lang="en-US" sz="1200" dirty="0">
+                <a:solidFill>
+                  <a:srgbClr val="1A1A1E"/>
+                </a:solidFill>
+                <a:latin typeface="Segoe UI" pitchFamily="34" charset="0"/>
+                <a:ea typeface="Segoe UI" pitchFamily="34" charset="-122"/>
+                <a:cs typeface="Segoe UI" pitchFamily="34" charset="-120"/>
+              </a:rPr>
+              <a:t>admin.ko</a:t>
+            </a:r>
+            <a:endParaRPr lang="en-US" sz="1200" dirty="0"/>
+          </a:p>
+        </p:txBody>
+      </p:sp>
+      <p:sp>
+        <p:nvSpPr>
+          <p:cNvPr id="37" name="Shape 35"/>
+          <p:cNvSpPr/>
+          <p:nvPr/>
+        </p:nvSpPr>
+        <p:spPr>
+          <a:xfrm>
+            <a:off x="9948672" y="2834640"/>
+            <a:ext cx="274320" cy="274320"/>
+          </a:xfrm>
+          <a:prstGeom prst="ellipse">
+            <a:avLst/>
+          </a:prstGeom>
+          <a:solidFill>
+            <a:srgbClr val="0B5FA5"/>
+          </a:solidFill>
+          <a:ln w="12700">
+            <a:solidFill>
+              <a:srgbClr val="0B5FA5"/>
+            </a:solidFill>
+            <a:prstDash val="solid"/>
+          </a:ln>
+        </p:spPr>
+      </p:sp>
+      <p:sp>
+        <p:nvSpPr>
+          <p:cNvPr id="38" name="Text 36"/>
+          <p:cNvSpPr/>
+          <p:nvPr/>
+        </p:nvSpPr>
+        <p:spPr>
+          <a:xfrm>
+            <a:off x="9948672" y="2834640"/>
+            <a:ext cx="274320" cy="274320"/>
+          </a:xfrm>
+          <a:prstGeom prst="rect">
+            <a:avLst/>
+          </a:prstGeom>
+          <a:noFill/>
+          <a:ln/>
+        </p:spPr>
+        <p:txBody>
+          <a:bodyPr wrap="square" rtlCol="0" anchor="ctr"/>
+          <a:lstStyle/>
+          <a:p>
+            <a:pPr algn="ctr" indent="0" marL="0">
+              <a:buNone/>
+            </a:pPr>
+            <a:r>
+              <a:rPr lang="en-US" sz="1250" b="1" dirty="0">
+                <a:solidFill>
+                  <a:srgbClr val="FFFFFF"/>
+                </a:solidFill>
+                <a:latin typeface="Segoe UI" pitchFamily="34" charset="0"/>
+                <a:ea typeface="Segoe UI" pitchFamily="34" charset="-122"/>
+                <a:cs typeface="Segoe UI" pitchFamily="34" charset="-120"/>
+              </a:rPr>
+              <a:t>1</a:t>
+            </a:r>
+            <a:endParaRPr lang="en-US" sz="1250" dirty="0"/>
+          </a:p>
+        </p:txBody>
+      </p:sp>
+      <p:sp>
+        <p:nvSpPr>
+          <p:cNvPr id="39" name="Shape 37"/>
+          <p:cNvSpPr/>
+          <p:nvPr/>
+        </p:nvSpPr>
+        <p:spPr>
+          <a:xfrm>
+            <a:off x="5879592" y="3474720"/>
+            <a:ext cx="3931920" cy="402336"/>
+          </a:xfrm>
+          <a:prstGeom prst="roundRect">
+            <a:avLst>
+              <a:gd name="adj" fmla="val 11364"/>
+            </a:avLst>
+          </a:prstGeom>
+          <a:solidFill>
+            <a:srgbClr val="FBFBFC"/>
+          </a:solidFill>
+          <a:ln w="12700">
+            <a:solidFill>
+              <a:srgbClr val="C9CDD4"/>
+            </a:solidFill>
+            <a:prstDash val="solid"/>
+          </a:ln>
+        </p:spPr>
+      </p:sp>
+      <p:sp>
+        <p:nvSpPr>
+          <p:cNvPr id="40" name="Text 38"/>
+          <p:cNvSpPr/>
+          <p:nvPr/>
+        </p:nvSpPr>
+        <p:spPr>
+          <a:xfrm>
+            <a:off x="5879592" y="3255264"/>
+            <a:ext cx="3931920" cy="201168"/>
+          </a:xfrm>
+          <a:prstGeom prst="rect">
+            <a:avLst/>
+          </a:prstGeom>
+          <a:noFill/>
+          <a:ln/>
+        </p:spPr>
+        <p:txBody>
+          <a:bodyPr wrap="square" rtlCol="0" anchor="ctr"/>
+          <a:lstStyle/>
+          <a:p>
+            <a:pPr indent="0" marL="0">
+              <a:buNone/>
+            </a:pPr>
+            <a:r>
+              <a:rPr lang="en-US" sz="950" dirty="0">
+                <a:solidFill>
+                  <a:srgbClr val="71717A"/>
+                </a:solidFill>
+                <a:latin typeface="Segoe UI" pitchFamily="34" charset="0"/>
+                <a:ea typeface="Segoe UI" pitchFamily="34" charset="-122"/>
+                <a:cs typeface="Segoe UI" pitchFamily="34" charset="-120"/>
+              </a:rPr>
+              <a:t>Password</a:t>
+            </a:r>
+            <a:endParaRPr lang="en-US" sz="950" dirty="0"/>
+          </a:p>
+        </p:txBody>
+      </p:sp>
+      <p:sp>
+        <p:nvSpPr>
+          <p:cNvPr id="41" name="Text 39"/>
+          <p:cNvSpPr/>
+          <p:nvPr/>
+        </p:nvSpPr>
+        <p:spPr>
+          <a:xfrm>
+            <a:off x="6007608" y="3474720"/>
+            <a:ext cx="3675888" cy="402336"/>
+          </a:xfrm>
+          <a:prstGeom prst="rect">
+            <a:avLst/>
+          </a:prstGeom>
+          <a:noFill/>
+          <a:ln/>
+        </p:spPr>
+        <p:txBody>
+          <a:bodyPr wrap="square" rtlCol="0" anchor="ctr"/>
+          <a:lstStyle/>
+          <a:p>
+            <a:pPr indent="0" marL="0">
+              <a:buNone/>
+            </a:pPr>
+            <a:r>
+              <a:rPr lang="en-US" sz="1200" dirty="0">
+                <a:solidFill>
+                  <a:srgbClr val="1A1A1E"/>
+                </a:solidFill>
+                <a:latin typeface="Segoe UI" pitchFamily="34" charset="0"/>
+                <a:ea typeface="Segoe UI" pitchFamily="34" charset="-122"/>
+                <a:cs typeface="Segoe UI" pitchFamily="34" charset="-120"/>
+              </a:rPr>
+              <a:t>••••••</a:t>
+            </a:r>
+            <a:endParaRPr lang="en-US" sz="1200" dirty="0"/>
+          </a:p>
+        </p:txBody>
+      </p:sp>
+      <p:sp>
+        <p:nvSpPr>
+          <p:cNvPr id="42" name="Shape 40"/>
+          <p:cNvSpPr/>
+          <p:nvPr/>
+        </p:nvSpPr>
+        <p:spPr>
+          <a:xfrm>
+            <a:off x="9948672" y="3529584"/>
+            <a:ext cx="274320" cy="274320"/>
+          </a:xfrm>
+          <a:prstGeom prst="ellipse">
+            <a:avLst/>
+          </a:prstGeom>
+          <a:solidFill>
+            <a:srgbClr val="0B5FA5"/>
+          </a:solidFill>
+          <a:ln w="12700">
+            <a:solidFill>
+              <a:srgbClr val="0B5FA5"/>
+            </a:solidFill>
+            <a:prstDash val="solid"/>
+          </a:ln>
+        </p:spPr>
+      </p:sp>
+      <p:sp>
+        <p:nvSpPr>
+          <p:cNvPr id="43" name="Text 41"/>
+          <p:cNvSpPr/>
+          <p:nvPr/>
+        </p:nvSpPr>
+        <p:spPr>
+          <a:xfrm>
+            <a:off x="9948672" y="3529584"/>
+            <a:ext cx="274320" cy="274320"/>
+          </a:xfrm>
+          <a:prstGeom prst="rect">
+            <a:avLst/>
+          </a:prstGeom>
+          <a:noFill/>
+          <a:ln/>
+        </p:spPr>
+        <p:txBody>
+          <a:bodyPr wrap="square" rtlCol="0" anchor="ctr"/>
+          <a:lstStyle/>
+          <a:p>
+            <a:pPr algn="ctr" indent="0" marL="0">
+              <a:buNone/>
+            </a:pPr>
+            <a:r>
+              <a:rPr lang="en-US" sz="1250" b="1" dirty="0">
+                <a:solidFill>
+                  <a:srgbClr val="FFFFFF"/>
+                </a:solidFill>
+                <a:latin typeface="Segoe UI" pitchFamily="34" charset="0"/>
+                <a:ea typeface="Segoe UI" pitchFamily="34" charset="-122"/>
+                <a:cs typeface="Segoe UI" pitchFamily="34" charset="-120"/>
+              </a:rPr>
+              <a:t>2</a:t>
+            </a:r>
+            <a:endParaRPr lang="en-US" sz="1250" dirty="0"/>
+          </a:p>
+        </p:txBody>
+      </p:sp>
+      <p:sp>
+        <p:nvSpPr>
+          <p:cNvPr id="44" name="Shape 42"/>
+          <p:cNvSpPr/>
+          <p:nvPr/>
+        </p:nvSpPr>
+        <p:spPr>
+          <a:xfrm>
+            <a:off x="5879592" y="4078224"/>
+            <a:ext cx="1371600" cy="384048"/>
+          </a:xfrm>
+          <a:prstGeom prst="roundRect">
+            <a:avLst>
+              <a:gd name="adj" fmla="val 11905"/>
+            </a:avLst>
+          </a:prstGeom>
+          <a:solidFill>
+            <a:srgbClr val="0B5FA5"/>
+          </a:solidFill>
+          <a:ln w="12700">
+            <a:solidFill>
+              <a:srgbClr val="0B5FA5"/>
+            </a:solidFill>
+            <a:prstDash val="solid"/>
+          </a:ln>
+        </p:spPr>
+      </p:sp>
+      <p:sp>
+        <p:nvSpPr>
+          <p:cNvPr id="45" name="Text 43"/>
+          <p:cNvSpPr/>
+          <p:nvPr/>
+        </p:nvSpPr>
+        <p:spPr>
+          <a:xfrm>
+            <a:off x="5879592" y="4078224"/>
+            <a:ext cx="1371600" cy="384048"/>
+          </a:xfrm>
+          <a:prstGeom prst="rect">
+            <a:avLst/>
+          </a:prstGeom>
+          <a:noFill/>
+          <a:ln/>
+        </p:spPr>
+        <p:txBody>
+          <a:bodyPr wrap="square" rtlCol="0" anchor="ctr"/>
+          <a:lstStyle/>
+          <a:p>
+            <a:pPr algn="ctr" indent="0" marL="0">
+              <a:buNone/>
+            </a:pPr>
+            <a:r>
               <a:rPr lang="en-US" sz="1200" b="1" dirty="0">
                 <a:solidFill>
-                  <a:srgbClr val="1A1A1E"/>
-                </a:solidFill>
-                <a:latin typeface="Segoe UI" pitchFamily="34" charset="0"/>
-                <a:ea typeface="Segoe UI" pitchFamily="34" charset="-122"/>
-                <a:cs typeface="Segoe UI" pitchFamily="34" charset="-120"/>
-              </a:rPr>
-              <a:t>Trace, video,</a:t>
+                  <a:srgbClr val="FFFFFF"/>
+                </a:solidFill>
+                <a:latin typeface="Segoe UI" pitchFamily="34" charset="0"/>
+                <a:ea typeface="Segoe UI" pitchFamily="34" charset="-122"/>
+                <a:cs typeface="Segoe UI" pitchFamily="34" charset="-120"/>
+              </a:rPr>
+              <a:t>Sign in</a:t>
             </a:r>
             <a:endParaRPr lang="en-US" sz="1200" dirty="0"/>
           </a:p>
+        </p:txBody>
+      </p:sp>
+      <p:sp>
+        <p:nvSpPr>
+          <p:cNvPr id="46" name="Shape 44"/>
+          <p:cNvSpPr/>
+          <p:nvPr/>
+        </p:nvSpPr>
+        <p:spPr>
+          <a:xfrm>
+            <a:off x="7397496" y="4133088"/>
+            <a:ext cx="274320" cy="274320"/>
+          </a:xfrm>
+          <a:prstGeom prst="ellipse">
+            <a:avLst/>
+          </a:prstGeom>
+          <a:solidFill>
+            <a:srgbClr val="0B5FA5"/>
+          </a:solidFill>
+          <a:ln w="12700">
+            <a:solidFill>
+              <a:srgbClr val="0B5FA5"/>
+            </a:solidFill>
+            <a:prstDash val="solid"/>
+          </a:ln>
+        </p:spPr>
+      </p:sp>
+      <p:sp>
+        <p:nvSpPr>
+          <p:cNvPr id="47" name="Text 45"/>
+          <p:cNvSpPr/>
+          <p:nvPr/>
+        </p:nvSpPr>
+        <p:spPr>
+          <a:xfrm>
+            <a:off x="7397496" y="4133088"/>
+            <a:ext cx="274320" cy="274320"/>
+          </a:xfrm>
+          <a:prstGeom prst="rect">
+            <a:avLst/>
+          </a:prstGeom>
+          <a:noFill/>
+          <a:ln/>
+        </p:spPr>
+        <p:txBody>
+          <a:bodyPr wrap="square" rtlCol="0" anchor="ctr"/>
+          <a:lstStyle/>
           <a:p>
             <a:pPr algn="ctr" indent="0" marL="0">
               <a:buNone/>
             </a:pPr>
             <a:r>
-              <a:rPr lang="en-US" sz="1200" b="1" dirty="0">
-                <a:solidFill>
-                  <a:srgbClr val="1A1A1E"/>
-                </a:solidFill>
-                <a:latin typeface="Segoe UI" pitchFamily="34" charset="0"/>
-                <a:ea typeface="Segoe UI" pitchFamily="34" charset="-122"/>
-                <a:cs typeface="Segoe UI" pitchFamily="34" charset="-120"/>
-              </a:rPr>
-              <a:t>screenshots</a:t>
-            </a:r>
-            <a:endParaRPr lang="en-US" sz="1200" dirty="0"/>
-          </a:p>
-        </p:txBody>
-      </p:sp>
-      <p:sp>
-        <p:nvSpPr>
-          <p:cNvPr id="19" name="Text 17"/>
-          <p:cNvSpPr/>
-          <p:nvPr/>
-        </p:nvSpPr>
-        <p:spPr>
-          <a:xfrm>
-            <a:off x="566928" y="2999232"/>
-            <a:ext cx="11057839" cy="4023360"/>
+              <a:rPr lang="en-US" sz="1250" b="1" dirty="0">
+                <a:solidFill>
+                  <a:srgbClr val="FFFFFF"/>
+                </a:solidFill>
+                <a:latin typeface="Segoe UI" pitchFamily="34" charset="0"/>
+                <a:ea typeface="Segoe UI" pitchFamily="34" charset="-122"/>
+                <a:cs typeface="Segoe UI" pitchFamily="34" charset="-120"/>
+              </a:rPr>
+              <a:t>3</a:t>
+            </a:r>
+            <a:endParaRPr lang="en-US" sz="1250" dirty="0"/>
+          </a:p>
+        </p:txBody>
+      </p:sp>
+      <p:sp>
+        <p:nvSpPr>
+          <p:cNvPr id="48" name="Text 46"/>
+          <p:cNvSpPr/>
+          <p:nvPr/>
+        </p:nvSpPr>
+        <p:spPr>
+          <a:xfrm>
+            <a:off x="5623560" y="4553712"/>
+            <a:ext cx="5989320" cy="274320"/>
           </a:xfrm>
           <a:prstGeom prst="rect">
             <a:avLst/>
@@ -7095,103 +7939,434 @@
           <a:ln/>
         </p:spPr>
         <p:txBody>
-          <a:bodyPr wrap="square" rtlCol="0" anchor="t"/>
-          <a:lstStyle/>
-          <a:p>
-            <a:pPr marL="342900" indent="-342900">
-              <a:lnSpc>
-                <a:spcPct val="115000"/>
-              </a:lnSpc>
-              <a:spcAft>
-                <a:spcPts val="1000"/>
-              </a:spcAft>
-              <a:buSzPct val="100000"/>
-              <a:buChar char="•"/>
-            </a:pPr>
-            <a:r>
-              <a:rPr lang="en-US" sz="1450" dirty="0">
-                <a:solidFill>
-                  <a:srgbClr val="1A1A1E"/>
-                </a:solidFill>
-                <a:latin typeface="Segoe UI" pitchFamily="34" charset="0"/>
-                <a:ea typeface="Segoe UI" pitchFamily="34" charset="-122"/>
-                <a:cs typeface="Segoe UI" pitchFamily="34" charset="-120"/>
-              </a:rPr>
-              <a:t>Browser context per test = clean cookies and storage, so tests cannot leak into each other</a:t>
-            </a:r>
-            <a:endParaRPr lang="en-US" sz="1450" dirty="0"/>
-          </a:p>
-          <a:p>
-            <a:pPr marL="342900" indent="-342900">
-              <a:lnSpc>
-                <a:spcPct val="115000"/>
-              </a:lnSpc>
-              <a:spcAft>
-                <a:spcPts val="1000"/>
-              </a:spcAft>
-              <a:buSzPct val="100000"/>
-              <a:buChar char="•"/>
-            </a:pPr>
-            <a:r>
-              <a:rPr lang="en-US" sz="1450" dirty="0">
-                <a:solidFill>
-                  <a:srgbClr val="1A1A1E"/>
-                </a:solidFill>
-                <a:latin typeface="Segoe UI" pitchFamily="34" charset="0"/>
-                <a:ea typeface="Segoe UI" pitchFamily="34" charset="-122"/>
-                <a:cs typeface="Segoe UI" pitchFamily="34" charset="-120"/>
-              </a:rPr>
-              <a:t>We sign in once in a setup project and reuse the stored session, so 11 of the 13 cases skip the login screen</a:t>
-            </a:r>
-            <a:endParaRPr lang="en-US" sz="1450" dirty="0"/>
-          </a:p>
-          <a:p>
-            <a:pPr marL="342900" indent="-342900">
-              <a:lnSpc>
-                <a:spcPct val="115000"/>
-              </a:lnSpc>
-              <a:spcAft>
-                <a:spcPts val="1000"/>
-              </a:spcAft>
-              <a:buSzPct val="100000"/>
-              <a:buChar char="•"/>
-            </a:pPr>
-            <a:r>
-              <a:rPr lang="en-US" sz="1450" dirty="0">
-                <a:solidFill>
-                  <a:srgbClr val="1A1A1E"/>
-                </a:solidFill>
-                <a:latin typeface="Segoe UI" pitchFamily="34" charset="0"/>
-                <a:ea typeface="Segoe UI" pitchFamily="34" charset="-122"/>
-                <a:cs typeface="Segoe UI" pitchFamily="34" charset="-120"/>
-              </a:rPr>
-              <a:t>Locators are lazy: they resolve at the moment of the action, so a re-rendered element is not a stale reference</a:t>
-            </a:r>
-            <a:endParaRPr lang="en-US" sz="1450" dirty="0"/>
-          </a:p>
-          <a:p>
-            <a:pPr marL="342900" indent="-342900">
-              <a:lnSpc>
-                <a:spcPct val="115000"/>
-              </a:lnSpc>
-              <a:spcAft>
-                <a:spcPts val="1000"/>
-              </a:spcAft>
-              <a:buSzPct val="100000"/>
-              <a:buChar char="•"/>
-            </a:pPr>
-            <a:r>
-              <a:rPr lang="en-US" sz="1450" dirty="0">
-                <a:solidFill>
-                  <a:srgbClr val="1A1A1E"/>
-                </a:solidFill>
-                <a:latin typeface="Segoe UI" pitchFamily="34" charset="0"/>
-                <a:ea typeface="Segoe UI" pitchFamily="34" charset="-122"/>
-                <a:cs typeface="Segoe UI" pitchFamily="34" charset="-120"/>
-              </a:rPr>
-              <a:t>Everything is observable - the run can record the network, the console and the DOM without extra code</a:t>
-            </a:r>
-            <a:endParaRPr lang="en-US" sz="1450" dirty="0"/>
+          <a:bodyPr wrap="square" rtlCol="0" anchor="ctr"/>
+          <a:lstStyle/>
+          <a:p>
+            <a:pPr algn="ctr" indent="0" marL="0">
+              <a:buNone/>
+            </a:pPr>
+            <a:r>
+              <a:rPr lang="en-US" sz="1800" b="1" dirty="0">
+                <a:solidFill>
+                  <a:srgbClr val="71717A"/>
+                </a:solidFill>
+                <a:latin typeface="Segoe UI" pitchFamily="34" charset="0"/>
+                <a:ea typeface="Segoe UI" pitchFamily="34" charset="-122"/>
+                <a:cs typeface="Segoe UI" pitchFamily="34" charset="-120"/>
+              </a:rPr>
+              <a:t>↓</a:t>
+            </a:r>
+            <a:endParaRPr lang="en-US" sz="1800" dirty="0"/>
+          </a:p>
+        </p:txBody>
+      </p:sp>
+      <p:sp>
+        <p:nvSpPr>
+          <p:cNvPr id="49" name="Shape 47"/>
+          <p:cNvSpPr/>
+          <p:nvPr/>
+        </p:nvSpPr>
+        <p:spPr>
+          <a:xfrm>
+            <a:off x="5623560" y="4782312"/>
+            <a:ext cx="5989320" cy="1325880"/>
+          </a:xfrm>
+          <a:prstGeom prst="roundRect">
+            <a:avLst>
+              <a:gd name="adj" fmla="val 4138"/>
+            </a:avLst>
+          </a:prstGeom>
+          <a:solidFill>
+            <a:srgbClr val="FFFFFF"/>
+          </a:solidFill>
+          <a:ln w="12700">
+            <a:solidFill>
+              <a:srgbClr val="C9CDD4"/>
+            </a:solidFill>
+            <a:prstDash val="solid"/>
+          </a:ln>
+        </p:spPr>
+      </p:sp>
+      <p:sp>
+        <p:nvSpPr>
+          <p:cNvPr id="50" name="Shape 48"/>
+          <p:cNvSpPr/>
+          <p:nvPr/>
+        </p:nvSpPr>
+        <p:spPr>
+          <a:xfrm>
+            <a:off x="5623560" y="4782312"/>
+            <a:ext cx="5989320" cy="329184"/>
+          </a:xfrm>
+          <a:prstGeom prst="rect">
+            <a:avLst/>
+          </a:prstGeom>
+          <a:solidFill>
+            <a:srgbClr val="EDEEF2"/>
+          </a:solidFill>
+          <a:ln w="12700">
+            <a:solidFill>
+              <a:srgbClr val="C9CDD4"/>
+            </a:solidFill>
+            <a:prstDash val="solid"/>
+          </a:ln>
+        </p:spPr>
+      </p:sp>
+      <p:sp>
+        <p:nvSpPr>
+          <p:cNvPr id="51" name="Shape 49"/>
+          <p:cNvSpPr/>
+          <p:nvPr/>
+        </p:nvSpPr>
+        <p:spPr>
+          <a:xfrm>
+            <a:off x="5769864" y="4892040"/>
+            <a:ext cx="109728" cy="109728"/>
+          </a:xfrm>
+          <a:prstGeom prst="ellipse">
+            <a:avLst/>
+          </a:prstGeom>
+          <a:solidFill>
+            <a:srgbClr val="E06C61"/>
+          </a:solidFill>
+          <a:ln w="12700">
+            <a:solidFill>
+              <a:srgbClr val="E06C61"/>
+            </a:solidFill>
+            <a:prstDash val="solid"/>
+          </a:ln>
+        </p:spPr>
+      </p:sp>
+      <p:sp>
+        <p:nvSpPr>
+          <p:cNvPr id="52" name="Shape 50"/>
+          <p:cNvSpPr/>
+          <p:nvPr/>
+        </p:nvSpPr>
+        <p:spPr>
+          <a:xfrm>
+            <a:off x="5952744" y="4892040"/>
+            <a:ext cx="109728" cy="109728"/>
+          </a:xfrm>
+          <a:prstGeom prst="ellipse">
+            <a:avLst/>
+          </a:prstGeom>
+          <a:solidFill>
+            <a:srgbClr val="E3B341"/>
+          </a:solidFill>
+          <a:ln w="12700">
+            <a:solidFill>
+              <a:srgbClr val="E3B341"/>
+            </a:solidFill>
+            <a:prstDash val="solid"/>
+          </a:ln>
+        </p:spPr>
+      </p:sp>
+      <p:sp>
+        <p:nvSpPr>
+          <p:cNvPr id="53" name="Shape 51"/>
+          <p:cNvSpPr/>
+          <p:nvPr/>
+        </p:nvSpPr>
+        <p:spPr>
+          <a:xfrm>
+            <a:off x="6135624" y="4892040"/>
+            <a:ext cx="109728" cy="109728"/>
+          </a:xfrm>
+          <a:prstGeom prst="ellipse">
+            <a:avLst/>
+          </a:prstGeom>
+          <a:solidFill>
+            <a:srgbClr val="7DC46B"/>
+          </a:solidFill>
+          <a:ln w="12700">
+            <a:solidFill>
+              <a:srgbClr val="7DC46B"/>
+            </a:solidFill>
+            <a:prstDash val="solid"/>
+          </a:ln>
+        </p:spPr>
+      </p:sp>
+      <p:sp>
+        <p:nvSpPr>
+          <p:cNvPr id="54" name="Shape 52"/>
+          <p:cNvSpPr/>
+          <p:nvPr/>
+        </p:nvSpPr>
+        <p:spPr>
+          <a:xfrm>
+            <a:off x="6409944" y="4846320"/>
+            <a:ext cx="4983480" cy="201168"/>
+          </a:xfrm>
+          <a:prstGeom prst="roundRect">
+            <a:avLst>
+              <a:gd name="adj" fmla="val 22727"/>
+            </a:avLst>
+          </a:prstGeom>
+          <a:solidFill>
+            <a:srgbClr val="FFFFFF"/>
+          </a:solidFill>
+          <a:ln w="12700">
+            <a:solidFill>
+              <a:srgbClr val="D6D9DF"/>
+            </a:solidFill>
+            <a:prstDash val="solid"/>
+          </a:ln>
+        </p:spPr>
+      </p:sp>
+      <p:sp>
+        <p:nvSpPr>
+          <p:cNvPr id="55" name="Text 53"/>
+          <p:cNvSpPr/>
+          <p:nvPr/>
+        </p:nvSpPr>
+        <p:spPr>
+          <a:xfrm>
+            <a:off x="6501384" y="4846320"/>
+            <a:ext cx="4892040" cy="201168"/>
+          </a:xfrm>
+          <a:prstGeom prst="rect">
+            <a:avLst/>
+          </a:prstGeom>
+          <a:noFill/>
+          <a:ln/>
+        </p:spPr>
+        <p:txBody>
+          <a:bodyPr wrap="square" rtlCol="0" anchor="ctr"/>
+          <a:lstStyle/>
+          <a:p>
+            <a:pPr indent="0" marL="0">
+              <a:buNone/>
+            </a:pPr>
+            <a:r>
+              <a:rPr lang="en-US" sz="900" dirty="0">
+                <a:solidFill>
+                  <a:srgbClr val="71717A"/>
+                </a:solidFill>
+                <a:latin typeface="Segoe UI" pitchFamily="34" charset="0"/>
+                <a:ea typeface="Segoe UI" pitchFamily="34" charset="-122"/>
+                <a:cs typeface="Segoe UI" pitchFamily="34" charset="-120"/>
+              </a:rPr>
+              <a:t>roadside-uat.aspireasia.net/msu/joblst</a:t>
+            </a:r>
+            <a:endParaRPr lang="en-US" sz="900" dirty="0"/>
+          </a:p>
+        </p:txBody>
+      </p:sp>
+      <p:sp>
+        <p:nvSpPr>
+          <p:cNvPr id="56" name="Shape 54"/>
+          <p:cNvSpPr/>
+          <p:nvPr/>
+        </p:nvSpPr>
+        <p:spPr>
+          <a:xfrm>
+            <a:off x="5879592" y="5422392"/>
+            <a:ext cx="3017520" cy="118872"/>
+          </a:xfrm>
+          <a:prstGeom prst="rect">
+            <a:avLst/>
+          </a:prstGeom>
+          <a:solidFill>
+            <a:srgbClr val="CFD4DB"/>
+          </a:solidFill>
+          <a:ln w="12700">
+            <a:solidFill>
+              <a:srgbClr val="CFD4DB"/>
+            </a:solidFill>
+            <a:prstDash val="solid"/>
+          </a:ln>
+        </p:spPr>
+      </p:sp>
+      <p:sp>
+        <p:nvSpPr>
+          <p:cNvPr id="57" name="Shape 55"/>
+          <p:cNvSpPr/>
+          <p:nvPr/>
+        </p:nvSpPr>
+        <p:spPr>
+          <a:xfrm>
+            <a:off x="5879592" y="5641848"/>
+            <a:ext cx="3017520" cy="118872"/>
+          </a:xfrm>
+          <a:prstGeom prst="rect">
+            <a:avLst/>
+          </a:prstGeom>
+          <a:solidFill>
+            <a:srgbClr val="E7E9ED"/>
+          </a:solidFill>
+          <a:ln w="12700">
+            <a:solidFill>
+              <a:srgbClr val="E7E9ED"/>
+            </a:solidFill>
+            <a:prstDash val="solid"/>
+          </a:ln>
+        </p:spPr>
+      </p:sp>
+      <p:sp>
+        <p:nvSpPr>
+          <p:cNvPr id="58" name="Shape 56"/>
+          <p:cNvSpPr/>
+          <p:nvPr/>
+        </p:nvSpPr>
+        <p:spPr>
+          <a:xfrm>
+            <a:off x="5879592" y="5861304"/>
+            <a:ext cx="3017520" cy="118872"/>
+          </a:xfrm>
+          <a:prstGeom prst="rect">
+            <a:avLst/>
+          </a:prstGeom>
+          <a:solidFill>
+            <a:srgbClr val="E7E9ED"/>
+          </a:solidFill>
+          <a:ln w="12700">
+            <a:solidFill>
+              <a:srgbClr val="E7E9ED"/>
+            </a:solidFill>
+            <a:prstDash val="solid"/>
+          </a:ln>
+        </p:spPr>
+      </p:sp>
+      <p:sp>
+        <p:nvSpPr>
+          <p:cNvPr id="59" name="Shape 57"/>
+          <p:cNvSpPr/>
+          <p:nvPr/>
+        </p:nvSpPr>
+        <p:spPr>
+          <a:xfrm>
+            <a:off x="9171432" y="5550408"/>
+            <a:ext cx="274320" cy="274320"/>
+          </a:xfrm>
+          <a:prstGeom prst="ellipse">
+            <a:avLst/>
+          </a:prstGeom>
+          <a:solidFill>
+            <a:srgbClr val="15803D"/>
+          </a:solidFill>
+          <a:ln w="12700">
+            <a:solidFill>
+              <a:srgbClr val="15803D"/>
+            </a:solidFill>
+            <a:prstDash val="solid"/>
+          </a:ln>
+        </p:spPr>
+      </p:sp>
+      <p:sp>
+        <p:nvSpPr>
+          <p:cNvPr id="60" name="Text 58"/>
+          <p:cNvSpPr/>
+          <p:nvPr/>
+        </p:nvSpPr>
+        <p:spPr>
+          <a:xfrm>
+            <a:off x="9171432" y="5550408"/>
+            <a:ext cx="274320" cy="274320"/>
+          </a:xfrm>
+          <a:prstGeom prst="rect">
+            <a:avLst/>
+          </a:prstGeom>
+          <a:noFill/>
+          <a:ln/>
+        </p:spPr>
+        <p:txBody>
+          <a:bodyPr wrap="square" rtlCol="0" anchor="ctr"/>
+          <a:lstStyle/>
+          <a:p>
+            <a:pPr algn="ctr" indent="0" marL="0">
+              <a:buNone/>
+            </a:pPr>
+            <a:r>
+              <a:rPr lang="en-US" sz="1250" b="1" dirty="0">
+                <a:solidFill>
+                  <a:srgbClr val="FFFFFF"/>
+                </a:solidFill>
+                <a:latin typeface="Segoe UI" pitchFamily="34" charset="0"/>
+                <a:ea typeface="Segoe UI" pitchFamily="34" charset="-122"/>
+                <a:cs typeface="Segoe UI" pitchFamily="34" charset="-120"/>
+              </a:rPr>
+              <a:t>4</a:t>
+            </a:r>
+            <a:endParaRPr lang="en-US" sz="1250" dirty="0"/>
+          </a:p>
+        </p:txBody>
+      </p:sp>
+      <p:sp>
+        <p:nvSpPr>
+          <p:cNvPr id="61" name="Text 59"/>
+          <p:cNvSpPr/>
+          <p:nvPr/>
+        </p:nvSpPr>
+        <p:spPr>
+          <a:xfrm>
+            <a:off x="9537192" y="5550408"/>
+            <a:ext cx="1828800" cy="274320"/>
+          </a:xfrm>
+          <a:prstGeom prst="rect">
+            <a:avLst/>
+          </a:prstGeom>
+          <a:noFill/>
+          <a:ln/>
+        </p:spPr>
+        <p:txBody>
+          <a:bodyPr wrap="square" rtlCol="0" anchor="ctr"/>
+          <a:lstStyle/>
+          <a:p>
+            <a:pPr indent="0" marL="0">
+              <a:buNone/>
+            </a:pPr>
+            <a:r>
+              <a:rPr lang="en-US" sz="1150" b="1" dirty="0">
+                <a:solidFill>
+                  <a:srgbClr val="15803D"/>
+                </a:solidFill>
+                <a:latin typeface="Segoe UI" pitchFamily="34" charset="0"/>
+                <a:ea typeface="Segoe UI" pitchFamily="34" charset="-122"/>
+                <a:cs typeface="Segoe UI" pitchFamily="34" charset="-120"/>
+              </a:rPr>
+              <a:t>Job list - as expected</a:t>
+            </a:r>
+            <a:endParaRPr lang="en-US" sz="1150" dirty="0"/>
+          </a:p>
+        </p:txBody>
+      </p:sp>
+      <p:sp>
+        <p:nvSpPr>
+          <p:cNvPr id="62" name="Text 60"/>
+          <p:cNvSpPr/>
+          <p:nvPr/>
+        </p:nvSpPr>
+        <p:spPr>
+          <a:xfrm>
+            <a:off x="566928" y="6291072"/>
+            <a:ext cx="11057839" cy="320040"/>
+          </a:xfrm>
+          <a:prstGeom prst="rect">
+            <a:avLst/>
+          </a:prstGeom>
+          <a:noFill/>
+          <a:ln/>
+        </p:spPr>
+        <p:txBody>
+          <a:bodyPr wrap="square" rtlCol="0" anchor="ctr"/>
+          <a:lstStyle/>
+          <a:p>
+            <a:pPr indent="0" marL="0">
+              <a:buNone/>
+            </a:pPr>
+            <a:r>
+              <a:rPr lang="en-US" sz="1250" i="1" dirty="0">
+                <a:solidFill>
+                  <a:srgbClr val="71717A"/>
+                </a:solidFill>
+                <a:latin typeface="Segoe UI" pitchFamily="34" charset="0"/>
+                <a:ea typeface="Segoe UI" pitchFamily="34" charset="-122"/>
+                <a:cs typeface="Segoe UI" pitchFamily="34" charset="-120"/>
+              </a:rPr>
+              <a:t>Four written steps, run against the real site, with a video and screenshots kept as proof. Step 4 is the one that matters - it is where the test decides pass or fail.</a:t>
+            </a:r>
+            <a:endParaRPr lang="en-US" sz="1250" dirty="0"/>
           </a:p>
         </p:txBody>
       </p:sp>

</xml_diff>

<commit_message>
Playwright deck: make the findings slide plain - cascade diagram plus what/why table
</commit_message>
<xml_diff>
--- a/presentations/Web_Test_Automation_Playwright.pptx
+++ b/presentations/Web_Test_Automation_Playwright.pptx
@@ -2479,7 +2479,7 @@
         <p:spPr>
           <a:xfrm>
             <a:off x="566928" y="1627632"/>
-            <a:ext cx="11057839" cy="4023360"/>
+            <a:ext cx="11057839" cy="274320"/>
           </a:xfrm>
           <a:prstGeom prst="rect">
             <a:avLst/>
@@ -2488,21 +2488,14 @@
           <a:ln/>
         </p:spPr>
         <p:txBody>
-          <a:bodyPr wrap="square" rtlCol="0" anchor="t"/>
-          <a:lstStyle/>
-          <a:p>
-            <a:pPr marL="342900" indent="-342900">
-              <a:lnSpc>
-                <a:spcPct val="115000"/>
-              </a:lnSpc>
-              <a:spcAft>
-                <a:spcPts val="200"/>
-              </a:spcAft>
-              <a:buSzPct val="100000"/>
-              <a:buChar char="•"/>
-            </a:pPr>
-            <a:r>
-              <a:rPr lang="en-US" sz="1400" b="1" dirty="0">
+          <a:bodyPr wrap="square" rtlCol="0" anchor="ctr"/>
+          <a:lstStyle/>
+          <a:p>
+            <a:pPr indent="0" marL="0">
+              <a:buNone/>
+            </a:pPr>
+            <a:r>
+              <a:rPr lang="en-US" sz="1350" b="1" dirty="0">
                 <a:solidFill>
                   <a:srgbClr val="1A1A1E"/>
                 </a:solidFill>
@@ -2510,46 +2503,65 @@
                 <a:ea typeface="Segoe UI" pitchFamily="34" charset="-122"/>
                 <a:cs typeface="Segoe UI" pitchFamily="34" charset="-120"/>
               </a:rPr>
-              <a:t>Job creation depends on a data chain nobody had written down</a:t>
-            </a:r>
-            <a:endParaRPr lang="en-US" sz="1400" dirty="0"/>
-          </a:p>
-          <a:p>
-            <a:pPr lvl="1" indent="0" marL="0">
-              <a:lnSpc>
-                <a:spcPct val="115000"/>
-              </a:lnSpc>
-              <a:spcAft>
-                <a:spcPts val="1000"/>
-              </a:spcAft>
-              <a:buNone/>
-            </a:pPr>
-            <a:r>
-              <a:rPr lang="en-US" sz="1150" dirty="0">
-                <a:solidFill>
-                  <a:srgbClr val="3F3F46"/>
-                </a:solidFill>
-                <a:latin typeface="Segoe UI" pitchFamily="34" charset="0"/>
-                <a:ea typeface="Segoe UI" pitchFamily="34" charset="-122"/>
-                <a:cs typeface="Segoe UI" pitchFamily="34" charset="-120"/>
-              </a:rPr>
-              <a:t>client → program → customer tier → privilege → service type, each loaded by a separate ajax call. On UAT only the test programs (HOT UAT, Meo, Vit, Duck) have a privilege at all - Honda’s real programs have none, so a job cannot be created with them</a:t>
-            </a:r>
-            <a:endParaRPr lang="en-US" sz="1400" dirty="0"/>
-          </a:p>
-          <a:p>
-            <a:pPr marL="342900" indent="-342900">
-              <a:lnSpc>
-                <a:spcPct val="115000"/>
-              </a:lnSpc>
-              <a:spcAft>
-                <a:spcPts val="200"/>
-              </a:spcAft>
-              <a:buSzPct val="100000"/>
-              <a:buChar char="•"/>
-            </a:pPr>
-            <a:r>
-              <a:rPr lang="en-US" sz="1400" b="1" dirty="0">
+              <a:t>To create one job, five dropdowns must be filled in this exact order:</a:t>
+            </a:r>
+            <a:endParaRPr lang="en-US" sz="1350" dirty="0"/>
+          </a:p>
+        </p:txBody>
+      </p:sp>
+      <p:sp>
+        <p:nvSpPr>
+          <p:cNvPr id="6" name="Shape 4"/>
+          <p:cNvSpPr/>
+          <p:nvPr/>
+        </p:nvSpPr>
+        <p:spPr>
+          <a:xfrm>
+            <a:off x="566928" y="1956816"/>
+            <a:ext cx="1962851" cy="658368"/>
+          </a:xfrm>
+          <a:prstGeom prst="roundRect">
+            <a:avLst>
+              <a:gd name="adj" fmla="val 11111"/>
+            </a:avLst>
+          </a:prstGeom>
+          <a:solidFill>
+            <a:srgbClr val="E8F0F8"/>
+          </a:solidFill>
+          <a:ln w="12700">
+            <a:solidFill>
+              <a:srgbClr val="C9DAEA"/>
+            </a:solidFill>
+            <a:prstDash val="solid"/>
+          </a:ln>
+        </p:spPr>
+      </p:sp>
+      <p:sp>
+        <p:nvSpPr>
+          <p:cNvPr id="7" name="Text 5"/>
+          <p:cNvSpPr/>
+          <p:nvPr/>
+        </p:nvSpPr>
+        <p:spPr>
+          <a:xfrm>
+            <a:off x="640080" y="2011680"/>
+            <a:ext cx="1816547" cy="548640"/>
+          </a:xfrm>
+          <a:prstGeom prst="rect">
+            <a:avLst/>
+          </a:prstGeom>
+          <a:noFill/>
+          <a:ln/>
+        </p:spPr>
+        <p:txBody>
+          <a:bodyPr wrap="square" rtlCol="0" anchor="ctr"/>
+          <a:lstStyle/>
+          <a:p>
+            <a:pPr algn="ctr" indent="0" marL="0">
+              <a:buNone/>
+            </a:pPr>
+            <a:r>
+              <a:rPr lang="en-US" sz="1300" b="1" dirty="0">
                 <a:solidFill>
                   <a:srgbClr val="1A1A1E"/>
                 </a:solidFill>
@@ -2557,46 +2569,104 @@
                 <a:ea typeface="Segoe UI" pitchFamily="34" charset="-122"/>
                 <a:cs typeface="Segoe UI" pitchFamily="34" charset="-120"/>
               </a:rPr>
-              <a:t>A rejected save answers HTTP 200</a:t>
-            </a:r>
-            <a:endParaRPr lang="en-US" sz="1400" dirty="0"/>
-          </a:p>
-          <a:p>
-            <a:pPr lvl="1" indent="0" marL="0">
-              <a:lnSpc>
-                <a:spcPct val="115000"/>
-              </a:lnSpc>
-              <a:spcAft>
-                <a:spcPts val="1000"/>
-              </a:spcAft>
-              <a:buNone/>
-            </a:pPr>
-            <a:r>
-              <a:rPr lang="en-US" sz="1150" dirty="0">
-                <a:solidFill>
-                  <a:srgbClr val="3F3F46"/>
-                </a:solidFill>
-                <a:latin typeface="Segoe UI" pitchFamily="34" charset="0"/>
-                <a:ea typeface="Segoe UI" pitchFamily="34" charset="-122"/>
-                <a:cs typeface="Segoe UI" pitchFamily="34" charset="-120"/>
-              </a:rPr>
-              <a:t>{"success":false,"error":"Privilege is required"} plus a browser alert(). The test captures the dialog so the failure message names the real reason</a:t>
-            </a:r>
-            <a:endParaRPr lang="en-US" sz="1400" dirty="0"/>
-          </a:p>
-          <a:p>
-            <a:pPr marL="342900" indent="-342900">
-              <a:lnSpc>
-                <a:spcPct val="115000"/>
-              </a:lnSpc>
-              <a:spcAft>
-                <a:spcPts val="200"/>
-              </a:spcAft>
-              <a:buSzPct val="100000"/>
-              <a:buChar char="•"/>
-            </a:pPr>
-            <a:r>
-              <a:rPr lang="en-US" sz="1400" b="1" dirty="0">
+              <a:t>Client</a:t>
+            </a:r>
+            <a:endParaRPr lang="en-US" sz="1300" dirty="0"/>
+          </a:p>
+        </p:txBody>
+      </p:sp>
+      <p:sp>
+        <p:nvSpPr>
+          <p:cNvPr id="8" name="Text 6"/>
+          <p:cNvSpPr/>
+          <p:nvPr/>
+        </p:nvSpPr>
+        <p:spPr>
+          <a:xfrm>
+            <a:off x="2529779" y="1956816"/>
+            <a:ext cx="310896" cy="658368"/>
+          </a:xfrm>
+          <a:prstGeom prst="rect">
+            <a:avLst/>
+          </a:prstGeom>
+          <a:noFill/>
+          <a:ln/>
+        </p:spPr>
+        <p:txBody>
+          <a:bodyPr wrap="square" rtlCol="0" anchor="ctr"/>
+          <a:lstStyle/>
+          <a:p>
+            <a:pPr algn="ctr" indent="0" marL="0">
+              <a:buNone/>
+            </a:pPr>
+            <a:r>
+              <a:rPr lang="en-US" sz="1700" b="1" dirty="0">
+                <a:solidFill>
+                  <a:srgbClr val="71717A"/>
+                </a:solidFill>
+                <a:latin typeface="Segoe UI" pitchFamily="34" charset="0"/>
+                <a:ea typeface="Segoe UI" pitchFamily="34" charset="-122"/>
+                <a:cs typeface="Segoe UI" pitchFamily="34" charset="-120"/>
+              </a:rPr>
+              <a:t>→</a:t>
+            </a:r>
+            <a:endParaRPr lang="en-US" sz="1700" dirty="0"/>
+          </a:p>
+        </p:txBody>
+      </p:sp>
+      <p:sp>
+        <p:nvSpPr>
+          <p:cNvPr id="9" name="Shape 7"/>
+          <p:cNvSpPr/>
+          <p:nvPr/>
+        </p:nvSpPr>
+        <p:spPr>
+          <a:xfrm>
+            <a:off x="2840675" y="1956816"/>
+            <a:ext cx="1962851" cy="658368"/>
+          </a:xfrm>
+          <a:prstGeom prst="roundRect">
+            <a:avLst>
+              <a:gd name="adj" fmla="val 11111"/>
+            </a:avLst>
+          </a:prstGeom>
+          <a:solidFill>
+            <a:srgbClr val="E8F0F8"/>
+          </a:solidFill>
+          <a:ln w="12700">
+            <a:solidFill>
+              <a:srgbClr val="C9DAEA"/>
+            </a:solidFill>
+            <a:prstDash val="solid"/>
+          </a:ln>
+        </p:spPr>
+      </p:sp>
+      <p:sp>
+        <p:nvSpPr>
+          <p:cNvPr id="10" name="Text 8"/>
+          <p:cNvSpPr/>
+          <p:nvPr/>
+        </p:nvSpPr>
+        <p:spPr>
+          <a:xfrm>
+            <a:off x="2913827" y="2011680"/>
+            <a:ext cx="1816547" cy="548640"/>
+          </a:xfrm>
+          <a:prstGeom prst="rect">
+            <a:avLst/>
+          </a:prstGeom>
+          <a:noFill/>
+          <a:ln/>
+        </p:spPr>
+        <p:txBody>
+          <a:bodyPr wrap="square" rtlCol="0" anchor="ctr"/>
+          <a:lstStyle/>
+          <a:p>
+            <a:pPr algn="ctr" indent="0" marL="0">
+              <a:buNone/>
+            </a:pPr>
+            <a:r>
+              <a:rPr lang="en-US" sz="1300" b="1" dirty="0">
                 <a:solidFill>
                   <a:srgbClr val="1A1A1E"/>
                 </a:solidFill>
@@ -2604,46 +2674,104 @@
                 <a:ea typeface="Segoe UI" pitchFamily="34" charset="-122"/>
                 <a:cs typeface="Segoe UI" pitchFamily="34" charset="-120"/>
               </a:rPr>
-              <a:t>The dealer detail page has no Save button</a:t>
-            </a:r>
-            <a:endParaRPr lang="en-US" sz="1400" dirty="0"/>
-          </a:p>
-          <a:p>
-            <a:pPr lvl="1" indent="0" marL="0">
-              <a:lnSpc>
-                <a:spcPct val="115000"/>
-              </a:lnSpc>
-              <a:spcAft>
-                <a:spcPts val="1000"/>
-              </a:spcAft>
-              <a:buNone/>
-            </a:pPr>
-            <a:r>
-              <a:rPr lang="en-US" sz="1150" dirty="0">
-                <a:solidFill>
-                  <a:srgbClr val="3F3F46"/>
-                </a:solidFill>
-                <a:latin typeface="Segoe UI" pitchFamily="34" charset="0"/>
-                <a:ea typeface="Segoe UI" pitchFamily="34" charset="-122"/>
-                <a:cs typeface="Segoe UI" pitchFamily="34" charset="-120"/>
-              </a:rPr>
-              <a:t>It is commented out in the view - dealers come from the CMS sync. The test asserts what the page really is, not what we assumed</a:t>
-            </a:r>
-            <a:endParaRPr lang="en-US" sz="1400" dirty="0"/>
-          </a:p>
-          <a:p>
-            <a:pPr marL="342900" indent="-342900">
-              <a:lnSpc>
-                <a:spcPct val="115000"/>
-              </a:lnSpc>
-              <a:spcAft>
-                <a:spcPts val="200"/>
-              </a:spcAft>
-              <a:buSzPct val="100000"/>
-              <a:buChar char="•"/>
-            </a:pPr>
-            <a:r>
-              <a:rPr lang="en-US" sz="1400" b="1" dirty="0">
+              <a:t>Program</a:t>
+            </a:r>
+            <a:endParaRPr lang="en-US" sz="1300" dirty="0"/>
+          </a:p>
+        </p:txBody>
+      </p:sp>
+      <p:sp>
+        <p:nvSpPr>
+          <p:cNvPr id="11" name="Text 9"/>
+          <p:cNvSpPr/>
+          <p:nvPr/>
+        </p:nvSpPr>
+        <p:spPr>
+          <a:xfrm>
+            <a:off x="4803526" y="1956816"/>
+            <a:ext cx="310896" cy="658368"/>
+          </a:xfrm>
+          <a:prstGeom prst="rect">
+            <a:avLst/>
+          </a:prstGeom>
+          <a:noFill/>
+          <a:ln/>
+        </p:spPr>
+        <p:txBody>
+          <a:bodyPr wrap="square" rtlCol="0" anchor="ctr"/>
+          <a:lstStyle/>
+          <a:p>
+            <a:pPr algn="ctr" indent="0" marL="0">
+              <a:buNone/>
+            </a:pPr>
+            <a:r>
+              <a:rPr lang="en-US" sz="1700" b="1" dirty="0">
+                <a:solidFill>
+                  <a:srgbClr val="71717A"/>
+                </a:solidFill>
+                <a:latin typeface="Segoe UI" pitchFamily="34" charset="0"/>
+                <a:ea typeface="Segoe UI" pitchFamily="34" charset="-122"/>
+                <a:cs typeface="Segoe UI" pitchFamily="34" charset="-120"/>
+              </a:rPr>
+              <a:t>→</a:t>
+            </a:r>
+            <a:endParaRPr lang="en-US" sz="1700" dirty="0"/>
+          </a:p>
+        </p:txBody>
+      </p:sp>
+      <p:sp>
+        <p:nvSpPr>
+          <p:cNvPr id="12" name="Shape 10"/>
+          <p:cNvSpPr/>
+          <p:nvPr/>
+        </p:nvSpPr>
+        <p:spPr>
+          <a:xfrm>
+            <a:off x="5114422" y="1956816"/>
+            <a:ext cx="1962851" cy="658368"/>
+          </a:xfrm>
+          <a:prstGeom prst="roundRect">
+            <a:avLst>
+              <a:gd name="adj" fmla="val 11111"/>
+            </a:avLst>
+          </a:prstGeom>
+          <a:solidFill>
+            <a:srgbClr val="E8F0F8"/>
+          </a:solidFill>
+          <a:ln w="12700">
+            <a:solidFill>
+              <a:srgbClr val="C9DAEA"/>
+            </a:solidFill>
+            <a:prstDash val="solid"/>
+          </a:ln>
+        </p:spPr>
+      </p:sp>
+      <p:sp>
+        <p:nvSpPr>
+          <p:cNvPr id="13" name="Text 11"/>
+          <p:cNvSpPr/>
+          <p:nvPr/>
+        </p:nvSpPr>
+        <p:spPr>
+          <a:xfrm>
+            <a:off x="5187574" y="2011680"/>
+            <a:ext cx="1816547" cy="548640"/>
+          </a:xfrm>
+          <a:prstGeom prst="rect">
+            <a:avLst/>
+          </a:prstGeom>
+          <a:noFill/>
+          <a:ln/>
+        </p:spPr>
+        <p:txBody>
+          <a:bodyPr wrap="square" rtlCol="0" anchor="ctr"/>
+          <a:lstStyle/>
+          <a:p>
+            <a:pPr algn="ctr" indent="0" marL="0">
+              <a:buNone/>
+            </a:pPr>
+            <a:r>
+              <a:rPr lang="en-US" sz="1300" b="1" dirty="0">
                 <a:solidFill>
                   <a:srgbClr val="1A1A1E"/>
                 </a:solidFill>
@@ -2651,32 +2779,1017 @@
                 <a:ea typeface="Segoe UI" pitchFamily="34" charset="-122"/>
                 <a:cs typeface="Segoe UI" pitchFamily="34" charset="-120"/>
               </a:rPr>
-              <a:t>The client dropdown label is inconsistent</a:t>
-            </a:r>
-            <a:endParaRPr lang="en-US" sz="1400" dirty="0"/>
-          </a:p>
-          <a:p>
-            <a:pPr lvl="1" indent="0" marL="0">
-              <a:lnSpc>
-                <a:spcPct val="115000"/>
-              </a:lnSpc>
-              <a:spcAft>
-                <a:spcPts val="1000"/>
-              </a:spcAft>
-              <a:buNone/>
-            </a:pPr>
-            <a:r>
-              <a:rPr lang="en-US" sz="1150" dirty="0">
-                <a:solidFill>
-                  <a:srgbClr val="3F3F46"/>
-                </a:solidFill>
-                <a:latin typeface="Segoe UI" pitchFamily="34" charset="0"/>
-                <a:ea typeface="Segoe UI" pitchFamily="34" charset="-122"/>
-                <a:cs typeface="Segoe UI" pitchFamily="34" charset="-120"/>
-              </a:rPr>
-              <a:t>Sometimes "Honda Automobile (Thailand) Co., Ltd. (380)", sometimes without the id - the one flake we hit, now normalised in the assertion</a:t>
-            </a:r>
-            <a:endParaRPr lang="en-US" sz="1400" dirty="0"/>
+              <a:t>Customer tier</a:t>
+            </a:r>
+            <a:endParaRPr lang="en-US" sz="1300" dirty="0"/>
+          </a:p>
+        </p:txBody>
+      </p:sp>
+      <p:sp>
+        <p:nvSpPr>
+          <p:cNvPr id="14" name="Text 12"/>
+          <p:cNvSpPr/>
+          <p:nvPr/>
+        </p:nvSpPr>
+        <p:spPr>
+          <a:xfrm>
+            <a:off x="7077273" y="1956816"/>
+            <a:ext cx="310896" cy="658368"/>
+          </a:xfrm>
+          <a:prstGeom prst="rect">
+            <a:avLst/>
+          </a:prstGeom>
+          <a:noFill/>
+          <a:ln/>
+        </p:spPr>
+        <p:txBody>
+          <a:bodyPr wrap="square" rtlCol="0" anchor="ctr"/>
+          <a:lstStyle/>
+          <a:p>
+            <a:pPr algn="ctr" indent="0" marL="0">
+              <a:buNone/>
+            </a:pPr>
+            <a:r>
+              <a:rPr lang="en-US" sz="1700" b="1" dirty="0">
+                <a:solidFill>
+                  <a:srgbClr val="71717A"/>
+                </a:solidFill>
+                <a:latin typeface="Segoe UI" pitchFamily="34" charset="0"/>
+                <a:ea typeface="Segoe UI" pitchFamily="34" charset="-122"/>
+                <a:cs typeface="Segoe UI" pitchFamily="34" charset="-120"/>
+              </a:rPr>
+              <a:t>→</a:t>
+            </a:r>
+            <a:endParaRPr lang="en-US" sz="1700" dirty="0"/>
+          </a:p>
+        </p:txBody>
+      </p:sp>
+      <p:sp>
+        <p:nvSpPr>
+          <p:cNvPr id="15" name="Shape 13"/>
+          <p:cNvSpPr/>
+          <p:nvPr/>
+        </p:nvSpPr>
+        <p:spPr>
+          <a:xfrm>
+            <a:off x="7388169" y="1956816"/>
+            <a:ext cx="1962851" cy="658368"/>
+          </a:xfrm>
+          <a:prstGeom prst="roundRect">
+            <a:avLst>
+              <a:gd name="adj" fmla="val 11111"/>
+            </a:avLst>
+          </a:prstGeom>
+          <a:solidFill>
+            <a:srgbClr val="0B5FA5"/>
+          </a:solidFill>
+          <a:ln w="12700">
+            <a:solidFill>
+              <a:srgbClr val="0B5FA5"/>
+            </a:solidFill>
+            <a:prstDash val="solid"/>
+          </a:ln>
+        </p:spPr>
+      </p:sp>
+      <p:sp>
+        <p:nvSpPr>
+          <p:cNvPr id="16" name="Text 14"/>
+          <p:cNvSpPr/>
+          <p:nvPr/>
+        </p:nvSpPr>
+        <p:spPr>
+          <a:xfrm>
+            <a:off x="7461321" y="2011680"/>
+            <a:ext cx="1816547" cy="548640"/>
+          </a:xfrm>
+          <a:prstGeom prst="rect">
+            <a:avLst/>
+          </a:prstGeom>
+          <a:noFill/>
+          <a:ln/>
+        </p:spPr>
+        <p:txBody>
+          <a:bodyPr wrap="square" rtlCol="0" anchor="ctr"/>
+          <a:lstStyle/>
+          <a:p>
+            <a:pPr algn="ctr" indent="0" marL="0">
+              <a:buNone/>
+            </a:pPr>
+            <a:r>
+              <a:rPr lang="en-US" sz="1300" b="1" dirty="0">
+                <a:solidFill>
+                  <a:srgbClr val="FFFFFF"/>
+                </a:solidFill>
+                <a:latin typeface="Segoe UI" pitchFamily="34" charset="0"/>
+                <a:ea typeface="Segoe UI" pitchFamily="34" charset="-122"/>
+                <a:cs typeface="Segoe UI" pitchFamily="34" charset="-120"/>
+              </a:rPr>
+              <a:t>Privilege</a:t>
+            </a:r>
+            <a:endParaRPr lang="en-US" sz="1300" dirty="0"/>
+          </a:p>
+        </p:txBody>
+      </p:sp>
+      <p:sp>
+        <p:nvSpPr>
+          <p:cNvPr id="17" name="Text 15"/>
+          <p:cNvSpPr/>
+          <p:nvPr/>
+        </p:nvSpPr>
+        <p:spPr>
+          <a:xfrm>
+            <a:off x="9351020" y="1956816"/>
+            <a:ext cx="310896" cy="658368"/>
+          </a:xfrm>
+          <a:prstGeom prst="rect">
+            <a:avLst/>
+          </a:prstGeom>
+          <a:noFill/>
+          <a:ln/>
+        </p:spPr>
+        <p:txBody>
+          <a:bodyPr wrap="square" rtlCol="0" anchor="ctr"/>
+          <a:lstStyle/>
+          <a:p>
+            <a:pPr algn="ctr" indent="0" marL="0">
+              <a:buNone/>
+            </a:pPr>
+            <a:r>
+              <a:rPr lang="en-US" sz="1700" b="1" dirty="0">
+                <a:solidFill>
+                  <a:srgbClr val="71717A"/>
+                </a:solidFill>
+                <a:latin typeface="Segoe UI" pitchFamily="34" charset="0"/>
+                <a:ea typeface="Segoe UI" pitchFamily="34" charset="-122"/>
+                <a:cs typeface="Segoe UI" pitchFamily="34" charset="-120"/>
+              </a:rPr>
+              <a:t>→</a:t>
+            </a:r>
+            <a:endParaRPr lang="en-US" sz="1700" dirty="0"/>
+          </a:p>
+        </p:txBody>
+      </p:sp>
+      <p:sp>
+        <p:nvSpPr>
+          <p:cNvPr id="18" name="Shape 16"/>
+          <p:cNvSpPr/>
+          <p:nvPr/>
+        </p:nvSpPr>
+        <p:spPr>
+          <a:xfrm>
+            <a:off x="9661916" y="1956816"/>
+            <a:ext cx="1962851" cy="658368"/>
+          </a:xfrm>
+          <a:prstGeom prst="roundRect">
+            <a:avLst>
+              <a:gd name="adj" fmla="val 11111"/>
+            </a:avLst>
+          </a:prstGeom>
+          <a:solidFill>
+            <a:srgbClr val="E8F0F8"/>
+          </a:solidFill>
+          <a:ln w="12700">
+            <a:solidFill>
+              <a:srgbClr val="C9DAEA"/>
+            </a:solidFill>
+            <a:prstDash val="solid"/>
+          </a:ln>
+        </p:spPr>
+      </p:sp>
+      <p:sp>
+        <p:nvSpPr>
+          <p:cNvPr id="19" name="Text 17"/>
+          <p:cNvSpPr/>
+          <p:nvPr/>
+        </p:nvSpPr>
+        <p:spPr>
+          <a:xfrm>
+            <a:off x="9735068" y="2011680"/>
+            <a:ext cx="1816547" cy="548640"/>
+          </a:xfrm>
+          <a:prstGeom prst="rect">
+            <a:avLst/>
+          </a:prstGeom>
+          <a:noFill/>
+          <a:ln/>
+        </p:spPr>
+        <p:txBody>
+          <a:bodyPr wrap="square" rtlCol="0" anchor="ctr"/>
+          <a:lstStyle/>
+          <a:p>
+            <a:pPr algn="ctr" indent="0" marL="0">
+              <a:buNone/>
+            </a:pPr>
+            <a:r>
+              <a:rPr lang="en-US" sz="1300" b="1" dirty="0">
+                <a:solidFill>
+                  <a:srgbClr val="1A1A1E"/>
+                </a:solidFill>
+                <a:latin typeface="Segoe UI" pitchFamily="34" charset="0"/>
+                <a:ea typeface="Segoe UI" pitchFamily="34" charset="-122"/>
+                <a:cs typeface="Segoe UI" pitchFamily="34" charset="-120"/>
+              </a:rPr>
+              <a:t>Service type</a:t>
+            </a:r>
+            <a:endParaRPr lang="en-US" sz="1300" dirty="0"/>
+          </a:p>
+        </p:txBody>
+      </p:sp>
+      <p:sp>
+        <p:nvSpPr>
+          <p:cNvPr id="20" name="Text 18"/>
+          <p:cNvSpPr/>
+          <p:nvPr/>
+        </p:nvSpPr>
+        <p:spPr>
+          <a:xfrm>
+            <a:off x="566928" y="2670048"/>
+            <a:ext cx="11057839" cy="274320"/>
+          </a:xfrm>
+          <a:prstGeom prst="rect">
+            <a:avLst/>
+          </a:prstGeom>
+          <a:noFill/>
+          <a:ln/>
+        </p:spPr>
+        <p:txBody>
+          <a:bodyPr wrap="square" rtlCol="0" anchor="ctr"/>
+          <a:lstStyle/>
+          <a:p>
+            <a:pPr indent="0" marL="0">
+              <a:buNone/>
+            </a:pPr>
+            <a:r>
+              <a:rPr lang="en-US" sz="1200" i="1" dirty="0">
+                <a:solidFill>
+                  <a:srgbClr val="71717A"/>
+                </a:solidFill>
+                <a:latin typeface="Segoe UI" pitchFamily="34" charset="0"/>
+                <a:ea typeface="Segoe UI" pitchFamily="34" charset="-122"/>
+                <a:cs typeface="Segoe UI" pitchFamily="34" charset="-120"/>
+              </a:rPr>
+              <a:t>Each one stays empty until the one before it is chosen - and if the privilege is missing, the job simply cannot be saved.</a:t>
+            </a:r>
+            <a:endParaRPr lang="en-US" sz="1200" dirty="0"/>
+          </a:p>
+        </p:txBody>
+      </p:sp>
+      <p:graphicFrame>
+        <p:nvGraphicFramePr>
+          <p:cNvPr id="11" name="Table 0"/>
+          <p:cNvGraphicFramePr>
+            <a:graphicFrameLocks noGrp="1"/>
+          </p:cNvGraphicFramePr>
+          <p:nvPr>
+            <p:extLst>
+              <p:ext uri="{D42A27DB-BD31-4B8C-83A1-F6EECF244321}">
+                <p14:modId xmlns:p14="http://schemas.microsoft.com/office/powerpoint/2010/main" val="1579011935"/>
+              </p:ext>
+            </p:extLst>
+          </p:nvPr>
+        </p:nvGraphicFramePr>
+        <p:xfrm>
+          <a:off x="566928" y="3108960"/>
+          <a:ext cx="11055096" cy="914400"/>
+        </p:xfrm>
+        <a:graphic>
+          <a:graphicData uri="http://schemas.openxmlformats.org/drawingml/2006/table">
+            <a:tbl>
+              <a:tblPr/>
+              <a:tblGrid>
+                <a:gridCol w="5120640"/>
+                <a:gridCol w="5934456"/>
+              </a:tblGrid>
+              <a:tr h="329184">
+                <a:tc>
+                  <a:txBody>
+                    <a:bodyPr/>
+                    <a:lstStyle/>
+                    <a:p>
+                      <a:pPr indent="0" marL="0">
+                        <a:buNone/>
+                      </a:pPr>
+                      <a:r>
+                        <a:rPr lang="en-US" sz="1250" b="1" dirty="0">
+                          <a:solidFill>
+                            <a:srgbClr val="FFFFFF"/>
+                          </a:solidFill>
+                          <a:latin typeface="Segoe UI" pitchFamily="34" charset="0"/>
+                          <a:ea typeface="Segoe UI" pitchFamily="34" charset="-122"/>
+                          <a:cs typeface="Segoe UI" pitchFamily="34" charset="-120"/>
+                        </a:rPr>
+                        <a:t>What we found</a:t>
+                      </a:r>
+                      <a:endParaRPr lang="en-US" sz="1250" dirty="0">
+                        <a:latin typeface="Segoe UI" charset="0"/>
+                        <a:ea typeface="Segoe UI" charset="0"/>
+                        <a:cs typeface="Segoe UI" charset="0"/>
+                      </a:endParaRPr>
+                    </a:p>
+                  </a:txBody>
+                  <a:tcPr marL="73152" marR="73152" marT="73152" marB="73152" anchor="ctr">
+                    <a:lnL w="6350" cap="flat" cmpd="sng" algn="ctr">
+                      <a:solidFill>
+                        <a:srgbClr val="D9D9DE"/>
+                      </a:solidFill>
+                      <a:prstDash val="solid"/>
+                      <a:round/>
+                      <a:headEnd type="none" w="med" len="med"/>
+                      <a:tailEnd type="none" w="med" len="med"/>
+                    </a:lnL>
+                    <a:lnR w="6350" cap="flat" cmpd="sng" algn="ctr">
+                      <a:solidFill>
+                        <a:srgbClr val="D9D9DE"/>
+                      </a:solidFill>
+                      <a:prstDash val="solid"/>
+                      <a:round/>
+                      <a:headEnd type="none" w="med" len="med"/>
+                      <a:tailEnd type="none" w="med" len="med"/>
+                    </a:lnR>
+                    <a:lnT w="6350" cap="flat" cmpd="sng" algn="ctr">
+                      <a:solidFill>
+                        <a:srgbClr val="D9D9DE"/>
+                      </a:solidFill>
+                      <a:prstDash val="solid"/>
+                      <a:round/>
+                      <a:headEnd type="none" w="med" len="med"/>
+                      <a:tailEnd type="none" w="med" len="med"/>
+                    </a:lnT>
+                    <a:lnB w="6350" cap="flat" cmpd="sng" algn="ctr">
+                      <a:solidFill>
+                        <a:srgbClr val="D9D9DE"/>
+                      </a:solidFill>
+                      <a:prstDash val="solid"/>
+                      <a:round/>
+                      <a:headEnd type="none" w="med" len="med"/>
+                      <a:tailEnd type="none" w="med" len="med"/>
+                    </a:lnB>
+                    <a:solidFill>
+                      <a:srgbClr val="0B5FA5"/>
+                    </a:solidFill>
+                  </a:tcPr>
+                </a:tc>
+                <a:tc>
+                  <a:txBody>
+                    <a:bodyPr/>
+                    <a:lstStyle/>
+                    <a:p>
+                      <a:pPr indent="0" marL="0">
+                        <a:buNone/>
+                      </a:pPr>
+                      <a:r>
+                        <a:rPr lang="en-US" sz="1250" b="1" dirty="0">
+                          <a:solidFill>
+                            <a:srgbClr val="FFFFFF"/>
+                          </a:solidFill>
+                          <a:latin typeface="Segoe UI" pitchFamily="34" charset="0"/>
+                          <a:ea typeface="Segoe UI" pitchFamily="34" charset="-122"/>
+                          <a:cs typeface="Segoe UI" pitchFamily="34" charset="-120"/>
+                        </a:rPr>
+                        <a:t>Why it matters</a:t>
+                      </a:r>
+                      <a:endParaRPr lang="en-US" sz="1250" dirty="0">
+                        <a:latin typeface="Segoe UI" charset="0"/>
+                        <a:ea typeface="Segoe UI" charset="0"/>
+                        <a:cs typeface="Segoe UI" charset="0"/>
+                      </a:endParaRPr>
+                    </a:p>
+                  </a:txBody>
+                  <a:tcPr marL="73152" marR="73152" marT="73152" marB="73152" anchor="ctr">
+                    <a:lnL w="6350" cap="flat" cmpd="sng" algn="ctr">
+                      <a:solidFill>
+                        <a:srgbClr val="D9D9DE"/>
+                      </a:solidFill>
+                      <a:prstDash val="solid"/>
+                      <a:round/>
+                      <a:headEnd type="none" w="med" len="med"/>
+                      <a:tailEnd type="none" w="med" len="med"/>
+                    </a:lnL>
+                    <a:lnR w="6350" cap="flat" cmpd="sng" algn="ctr">
+                      <a:solidFill>
+                        <a:srgbClr val="D9D9DE"/>
+                      </a:solidFill>
+                      <a:prstDash val="solid"/>
+                      <a:round/>
+                      <a:headEnd type="none" w="med" len="med"/>
+                      <a:tailEnd type="none" w="med" len="med"/>
+                    </a:lnR>
+                    <a:lnT w="6350" cap="flat" cmpd="sng" algn="ctr">
+                      <a:solidFill>
+                        <a:srgbClr val="D9D9DE"/>
+                      </a:solidFill>
+                      <a:prstDash val="solid"/>
+                      <a:round/>
+                      <a:headEnd type="none" w="med" len="med"/>
+                      <a:tailEnd type="none" w="med" len="med"/>
+                    </a:lnT>
+                    <a:lnB w="6350" cap="flat" cmpd="sng" algn="ctr">
+                      <a:solidFill>
+                        <a:srgbClr val="D9D9DE"/>
+                      </a:solidFill>
+                      <a:prstDash val="solid"/>
+                      <a:round/>
+                      <a:headEnd type="none" w="med" len="med"/>
+                      <a:tailEnd type="none" w="med" len="med"/>
+                    </a:lnB>
+                    <a:solidFill>
+                      <a:srgbClr val="0B5FA5"/>
+                    </a:solidFill>
+                  </a:tcPr>
+                </a:tc>
+              </a:tr>
+              <a:tr h="329184">
+                <a:tc>
+                  <a:txBody>
+                    <a:bodyPr/>
+                    <a:lstStyle/>
+                    <a:p>
+                      <a:pPr indent="0" marL="0">
+                        <a:buNone/>
+                      </a:pPr>
+                      <a:r>
+                        <a:rPr lang="en-US" sz="1250" dirty="0">
+                          <a:solidFill>
+                            <a:srgbClr val="1A1A1E"/>
+                          </a:solidFill>
+                          <a:latin typeface="Segoe UI" pitchFamily="34" charset="0"/>
+                          <a:ea typeface="Segoe UI" pitchFamily="34" charset="-122"/>
+                          <a:cs typeface="Segoe UI" pitchFamily="34" charset="-120"/>
+                        </a:rPr>
+                        <a:t>Nobody had written that chain down</a:t>
+                      </a:r>
+                      <a:endParaRPr lang="en-US" sz="1250" dirty="0">
+                        <a:latin typeface="Segoe UI" charset="0"/>
+                        <a:ea typeface="Segoe UI" charset="0"/>
+                        <a:cs typeface="Segoe UI" charset="0"/>
+                      </a:endParaRPr>
+                    </a:p>
+                  </a:txBody>
+                  <a:tcPr marL="73152" marR="73152" marT="73152" marB="73152" anchor="ctr">
+                    <a:lnL w="6350" cap="flat" cmpd="sng" algn="ctr">
+                      <a:solidFill>
+                        <a:srgbClr val="D9D9DE"/>
+                      </a:solidFill>
+                      <a:prstDash val="solid"/>
+                      <a:round/>
+                      <a:headEnd type="none" w="med" len="med"/>
+                      <a:tailEnd type="none" w="med" len="med"/>
+                    </a:lnL>
+                    <a:lnR w="6350" cap="flat" cmpd="sng" algn="ctr">
+                      <a:solidFill>
+                        <a:srgbClr val="D9D9DE"/>
+                      </a:solidFill>
+                      <a:prstDash val="solid"/>
+                      <a:round/>
+                      <a:headEnd type="none" w="med" len="med"/>
+                      <a:tailEnd type="none" w="med" len="med"/>
+                    </a:lnR>
+                    <a:lnT w="6350" cap="flat" cmpd="sng" algn="ctr">
+                      <a:solidFill>
+                        <a:srgbClr val="D9D9DE"/>
+                      </a:solidFill>
+                      <a:prstDash val="solid"/>
+                      <a:round/>
+                      <a:headEnd type="none" w="med" len="med"/>
+                      <a:tailEnd type="none" w="med" len="med"/>
+                    </a:lnT>
+                    <a:lnB w="6350" cap="flat" cmpd="sng" algn="ctr">
+                      <a:solidFill>
+                        <a:srgbClr val="D9D9DE"/>
+                      </a:solidFill>
+                      <a:prstDash val="solid"/>
+                      <a:round/>
+                      <a:headEnd type="none" w="med" len="med"/>
+                      <a:tailEnd type="none" w="med" len="med"/>
+                    </a:lnB>
+                    <a:solidFill>
+                      <a:srgbClr val="FFFFFF"/>
+                    </a:solidFill>
+                  </a:tcPr>
+                </a:tc>
+                <a:tc>
+                  <a:txBody>
+                    <a:bodyPr/>
+                    <a:lstStyle/>
+                    <a:p>
+                      <a:pPr indent="0" marL="0">
+                        <a:buNone/>
+                      </a:pPr>
+                      <a:r>
+                        <a:rPr lang="en-US" sz="1250" dirty="0">
+                          <a:solidFill>
+                            <a:srgbClr val="1A1A1E"/>
+                          </a:solidFill>
+                          <a:latin typeface="Segoe UI" pitchFamily="34" charset="0"/>
+                          <a:ea typeface="Segoe UI" pitchFamily="34" charset="-122"/>
+                          <a:cs typeface="Segoe UI" pitchFamily="34" charset="-120"/>
+                        </a:rPr>
+                        <a:t>A new developer or tester finds it out by failing. It is now in the test, so the next person inherits it</a:t>
+                      </a:r>
+                      <a:endParaRPr lang="en-US" sz="1250" dirty="0">
+                        <a:latin typeface="Segoe UI" charset="0"/>
+                        <a:ea typeface="Segoe UI" charset="0"/>
+                        <a:cs typeface="Segoe UI" charset="0"/>
+                      </a:endParaRPr>
+                    </a:p>
+                  </a:txBody>
+                  <a:tcPr marL="73152" marR="73152" marT="73152" marB="73152" anchor="ctr">
+                    <a:lnL w="6350" cap="flat" cmpd="sng" algn="ctr">
+                      <a:solidFill>
+                        <a:srgbClr val="D9D9DE"/>
+                      </a:solidFill>
+                      <a:prstDash val="solid"/>
+                      <a:round/>
+                      <a:headEnd type="none" w="med" len="med"/>
+                      <a:tailEnd type="none" w="med" len="med"/>
+                    </a:lnL>
+                    <a:lnR w="6350" cap="flat" cmpd="sng" algn="ctr">
+                      <a:solidFill>
+                        <a:srgbClr val="D9D9DE"/>
+                      </a:solidFill>
+                      <a:prstDash val="solid"/>
+                      <a:round/>
+                      <a:headEnd type="none" w="med" len="med"/>
+                      <a:tailEnd type="none" w="med" len="med"/>
+                    </a:lnR>
+                    <a:lnT w="6350" cap="flat" cmpd="sng" algn="ctr">
+                      <a:solidFill>
+                        <a:srgbClr val="D9D9DE"/>
+                      </a:solidFill>
+                      <a:prstDash val="solid"/>
+                      <a:round/>
+                      <a:headEnd type="none" w="med" len="med"/>
+                      <a:tailEnd type="none" w="med" len="med"/>
+                    </a:lnT>
+                    <a:lnB w="6350" cap="flat" cmpd="sng" algn="ctr">
+                      <a:solidFill>
+                        <a:srgbClr val="D9D9DE"/>
+                      </a:solidFill>
+                      <a:prstDash val="solid"/>
+                      <a:round/>
+                      <a:headEnd type="none" w="med" len="med"/>
+                      <a:tailEnd type="none" w="med" len="med"/>
+                    </a:lnB>
+                    <a:solidFill>
+                      <a:srgbClr val="FFFFFF"/>
+                    </a:solidFill>
+                  </a:tcPr>
+                </a:tc>
+              </a:tr>
+              <a:tr h="329184">
+                <a:tc>
+                  <a:txBody>
+                    <a:bodyPr/>
+                    <a:lstStyle/>
+                    <a:p>
+                      <a:pPr indent="0" marL="0">
+                        <a:buNone/>
+                      </a:pPr>
+                      <a:r>
+                        <a:rPr lang="en-US" sz="1250" dirty="0">
+                          <a:solidFill>
+                            <a:srgbClr val="1A1A1E"/>
+                          </a:solidFill>
+                          <a:latin typeface="Segoe UI" pitchFamily="34" charset="0"/>
+                          <a:ea typeface="Segoe UI" pitchFamily="34" charset="-122"/>
+                          <a:cs typeface="Segoe UI" pitchFamily="34" charset="-120"/>
+                        </a:rPr>
+                        <a:t>On UAT, only the four test programs can create a job</a:t>
+                      </a:r>
+                      <a:endParaRPr lang="en-US" sz="1250" dirty="0">
+                        <a:latin typeface="Segoe UI" charset="0"/>
+                        <a:ea typeface="Segoe UI" charset="0"/>
+                        <a:cs typeface="Segoe UI" charset="0"/>
+                      </a:endParaRPr>
+                    </a:p>
+                  </a:txBody>
+                  <a:tcPr marL="73152" marR="73152" marT="73152" marB="73152" anchor="ctr">
+                    <a:lnL w="6350" cap="flat" cmpd="sng" algn="ctr">
+                      <a:solidFill>
+                        <a:srgbClr val="D9D9DE"/>
+                      </a:solidFill>
+                      <a:prstDash val="solid"/>
+                      <a:round/>
+                      <a:headEnd type="none" w="med" len="med"/>
+                      <a:tailEnd type="none" w="med" len="med"/>
+                    </a:lnL>
+                    <a:lnR w="6350" cap="flat" cmpd="sng" algn="ctr">
+                      <a:solidFill>
+                        <a:srgbClr val="D9D9DE"/>
+                      </a:solidFill>
+                      <a:prstDash val="solid"/>
+                      <a:round/>
+                      <a:headEnd type="none" w="med" len="med"/>
+                      <a:tailEnd type="none" w="med" len="med"/>
+                    </a:lnR>
+                    <a:lnT w="6350" cap="flat" cmpd="sng" algn="ctr">
+                      <a:solidFill>
+                        <a:srgbClr val="D9D9DE"/>
+                      </a:solidFill>
+                      <a:prstDash val="solid"/>
+                      <a:round/>
+                      <a:headEnd type="none" w="med" len="med"/>
+                      <a:tailEnd type="none" w="med" len="med"/>
+                    </a:lnT>
+                    <a:lnB w="6350" cap="flat" cmpd="sng" algn="ctr">
+                      <a:solidFill>
+                        <a:srgbClr val="D9D9DE"/>
+                      </a:solidFill>
+                      <a:prstDash val="solid"/>
+                      <a:round/>
+                      <a:headEnd type="none" w="med" len="med"/>
+                      <a:tailEnd type="none" w="med" len="med"/>
+                    </a:lnB>
+                    <a:solidFill>
+                      <a:srgbClr val="F6F7F9"/>
+                    </a:solidFill>
+                  </a:tcPr>
+                </a:tc>
+                <a:tc>
+                  <a:txBody>
+                    <a:bodyPr/>
+                    <a:lstStyle/>
+                    <a:p>
+                      <a:pPr indent="0" marL="0">
+                        <a:buNone/>
+                      </a:pPr>
+                      <a:r>
+                        <a:rPr lang="en-US" sz="1250" dirty="0">
+                          <a:solidFill>
+                            <a:srgbClr val="1A1A1E"/>
+                          </a:solidFill>
+                          <a:latin typeface="Segoe UI" pitchFamily="34" charset="0"/>
+                          <a:ea typeface="Segoe UI" pitchFamily="34" charset="-122"/>
+                          <a:cs typeface="Segoe UI" pitchFamily="34" charset="-120"/>
+                        </a:rPr>
+                        <a:t>Honda’s real programs have no privilege attached - so a test that "fails" there is a data problem, not a code problem</a:t>
+                      </a:r>
+                      <a:endParaRPr lang="en-US" sz="1250" dirty="0">
+                        <a:latin typeface="Segoe UI" charset="0"/>
+                        <a:ea typeface="Segoe UI" charset="0"/>
+                        <a:cs typeface="Segoe UI" charset="0"/>
+                      </a:endParaRPr>
+                    </a:p>
+                  </a:txBody>
+                  <a:tcPr marL="73152" marR="73152" marT="73152" marB="73152" anchor="ctr">
+                    <a:lnL w="6350" cap="flat" cmpd="sng" algn="ctr">
+                      <a:solidFill>
+                        <a:srgbClr val="D9D9DE"/>
+                      </a:solidFill>
+                      <a:prstDash val="solid"/>
+                      <a:round/>
+                      <a:headEnd type="none" w="med" len="med"/>
+                      <a:tailEnd type="none" w="med" len="med"/>
+                    </a:lnL>
+                    <a:lnR w="6350" cap="flat" cmpd="sng" algn="ctr">
+                      <a:solidFill>
+                        <a:srgbClr val="D9D9DE"/>
+                      </a:solidFill>
+                      <a:prstDash val="solid"/>
+                      <a:round/>
+                      <a:headEnd type="none" w="med" len="med"/>
+                      <a:tailEnd type="none" w="med" len="med"/>
+                    </a:lnR>
+                    <a:lnT w="6350" cap="flat" cmpd="sng" algn="ctr">
+                      <a:solidFill>
+                        <a:srgbClr val="D9D9DE"/>
+                      </a:solidFill>
+                      <a:prstDash val="solid"/>
+                      <a:round/>
+                      <a:headEnd type="none" w="med" len="med"/>
+                      <a:tailEnd type="none" w="med" len="med"/>
+                    </a:lnT>
+                    <a:lnB w="6350" cap="flat" cmpd="sng" algn="ctr">
+                      <a:solidFill>
+                        <a:srgbClr val="D9D9DE"/>
+                      </a:solidFill>
+                      <a:prstDash val="solid"/>
+                      <a:round/>
+                      <a:headEnd type="none" w="med" len="med"/>
+                      <a:tailEnd type="none" w="med" len="med"/>
+                    </a:lnB>
+                    <a:solidFill>
+                      <a:srgbClr val="F6F7F9"/>
+                    </a:solidFill>
+                  </a:tcPr>
+                </a:tc>
+              </a:tr>
+              <a:tr h="329184">
+                <a:tc>
+                  <a:txBody>
+                    <a:bodyPr/>
+                    <a:lstStyle/>
+                    <a:p>
+                      <a:pPr indent="0" marL="0">
+                        <a:buNone/>
+                      </a:pPr>
+                      <a:r>
+                        <a:rPr lang="en-US" sz="1250" dirty="0">
+                          <a:solidFill>
+                            <a:srgbClr val="1A1A1E"/>
+                          </a:solidFill>
+                          <a:latin typeface="Segoe UI" pitchFamily="34" charset="0"/>
+                          <a:ea typeface="Segoe UI" pitchFamily="34" charset="-122"/>
+                          <a:cs typeface="Segoe UI" pitchFamily="34" charset="-120"/>
+                        </a:rPr>
+                        <a:t>A rejected save still answers "OK"</a:t>
+                      </a:r>
+                      <a:endParaRPr lang="en-US" sz="1250" dirty="0">
+                        <a:latin typeface="Segoe UI" charset="0"/>
+                        <a:ea typeface="Segoe UI" charset="0"/>
+                        <a:cs typeface="Segoe UI" charset="0"/>
+                      </a:endParaRPr>
+                    </a:p>
+                  </a:txBody>
+                  <a:tcPr marL="73152" marR="73152" marT="73152" marB="73152" anchor="ctr">
+                    <a:lnL w="6350" cap="flat" cmpd="sng" algn="ctr">
+                      <a:solidFill>
+                        <a:srgbClr val="D9D9DE"/>
+                      </a:solidFill>
+                      <a:prstDash val="solid"/>
+                      <a:round/>
+                      <a:headEnd type="none" w="med" len="med"/>
+                      <a:tailEnd type="none" w="med" len="med"/>
+                    </a:lnL>
+                    <a:lnR w="6350" cap="flat" cmpd="sng" algn="ctr">
+                      <a:solidFill>
+                        <a:srgbClr val="D9D9DE"/>
+                      </a:solidFill>
+                      <a:prstDash val="solid"/>
+                      <a:round/>
+                      <a:headEnd type="none" w="med" len="med"/>
+                      <a:tailEnd type="none" w="med" len="med"/>
+                    </a:lnR>
+                    <a:lnT w="6350" cap="flat" cmpd="sng" algn="ctr">
+                      <a:solidFill>
+                        <a:srgbClr val="D9D9DE"/>
+                      </a:solidFill>
+                      <a:prstDash val="solid"/>
+                      <a:round/>
+                      <a:headEnd type="none" w="med" len="med"/>
+                      <a:tailEnd type="none" w="med" len="med"/>
+                    </a:lnT>
+                    <a:lnB w="6350" cap="flat" cmpd="sng" algn="ctr">
+                      <a:solidFill>
+                        <a:srgbClr val="D9D9DE"/>
+                      </a:solidFill>
+                      <a:prstDash val="solid"/>
+                      <a:round/>
+                      <a:headEnd type="none" w="med" len="med"/>
+                      <a:tailEnd type="none" w="med" len="med"/>
+                    </a:lnB>
+                    <a:solidFill>
+                      <a:srgbClr val="FFFFFF"/>
+                    </a:solidFill>
+                  </a:tcPr>
+                </a:tc>
+                <a:tc>
+                  <a:txBody>
+                    <a:bodyPr/>
+                    <a:lstStyle/>
+                    <a:p>
+                      <a:pPr indent="0" marL="0">
+                        <a:buNone/>
+                      </a:pPr>
+                      <a:r>
+                        <a:rPr lang="en-US" sz="1250" dirty="0">
+                          <a:solidFill>
+                            <a:srgbClr val="1A1A1E"/>
+                          </a:solidFill>
+                          <a:latin typeface="Segoe UI" pitchFamily="34" charset="0"/>
+                          <a:ea typeface="Segoe UI" pitchFamily="34" charset="-122"/>
+                          <a:cs typeface="Segoe UI" pitchFamily="34" charset="-120"/>
+                        </a:rPr>
+                        <a:t>The real reason only appears in a pop-up. Easy for a person to miss, and it makes a failure look like the wrong thing</a:t>
+                      </a:r>
+                      <a:endParaRPr lang="en-US" sz="1250" dirty="0">
+                        <a:latin typeface="Segoe UI" charset="0"/>
+                        <a:ea typeface="Segoe UI" charset="0"/>
+                        <a:cs typeface="Segoe UI" charset="0"/>
+                      </a:endParaRPr>
+                    </a:p>
+                  </a:txBody>
+                  <a:tcPr marL="73152" marR="73152" marT="73152" marB="73152" anchor="ctr">
+                    <a:lnL w="6350" cap="flat" cmpd="sng" algn="ctr">
+                      <a:solidFill>
+                        <a:srgbClr val="D9D9DE"/>
+                      </a:solidFill>
+                      <a:prstDash val="solid"/>
+                      <a:round/>
+                      <a:headEnd type="none" w="med" len="med"/>
+                      <a:tailEnd type="none" w="med" len="med"/>
+                    </a:lnL>
+                    <a:lnR w="6350" cap="flat" cmpd="sng" algn="ctr">
+                      <a:solidFill>
+                        <a:srgbClr val="D9D9DE"/>
+                      </a:solidFill>
+                      <a:prstDash val="solid"/>
+                      <a:round/>
+                      <a:headEnd type="none" w="med" len="med"/>
+                      <a:tailEnd type="none" w="med" len="med"/>
+                    </a:lnR>
+                    <a:lnT w="6350" cap="flat" cmpd="sng" algn="ctr">
+                      <a:solidFill>
+                        <a:srgbClr val="D9D9DE"/>
+                      </a:solidFill>
+                      <a:prstDash val="solid"/>
+                      <a:round/>
+                      <a:headEnd type="none" w="med" len="med"/>
+                      <a:tailEnd type="none" w="med" len="med"/>
+                    </a:lnT>
+                    <a:lnB w="6350" cap="flat" cmpd="sng" algn="ctr">
+                      <a:solidFill>
+                        <a:srgbClr val="D9D9DE"/>
+                      </a:solidFill>
+                      <a:prstDash val="solid"/>
+                      <a:round/>
+                      <a:headEnd type="none" w="med" len="med"/>
+                      <a:tailEnd type="none" w="med" len="med"/>
+                    </a:lnB>
+                    <a:solidFill>
+                      <a:srgbClr val="FFFFFF"/>
+                    </a:solidFill>
+                  </a:tcPr>
+                </a:tc>
+              </a:tr>
+              <a:tr h="329184">
+                <a:tc>
+                  <a:txBody>
+                    <a:bodyPr/>
+                    <a:lstStyle/>
+                    <a:p>
+                      <a:pPr indent="0" marL="0">
+                        <a:buNone/>
+                      </a:pPr>
+                      <a:r>
+                        <a:rPr lang="en-US" sz="1250" dirty="0">
+                          <a:solidFill>
+                            <a:srgbClr val="1A1A1E"/>
+                          </a:solidFill>
+                          <a:latin typeface="Segoe UI" pitchFamily="34" charset="0"/>
+                          <a:ea typeface="Segoe UI" pitchFamily="34" charset="-122"/>
+                          <a:cs typeface="Segoe UI" pitchFamily="34" charset="-120"/>
+                        </a:rPr>
+                        <a:t>The dealer page cannot be edited at all</a:t>
+                      </a:r>
+                      <a:endParaRPr lang="en-US" sz="1250" dirty="0">
+                        <a:latin typeface="Segoe UI" charset="0"/>
+                        <a:ea typeface="Segoe UI" charset="0"/>
+                        <a:cs typeface="Segoe UI" charset="0"/>
+                      </a:endParaRPr>
+                    </a:p>
+                  </a:txBody>
+                  <a:tcPr marL="73152" marR="73152" marT="73152" marB="73152" anchor="ctr">
+                    <a:lnL w="6350" cap="flat" cmpd="sng" algn="ctr">
+                      <a:solidFill>
+                        <a:srgbClr val="D9D9DE"/>
+                      </a:solidFill>
+                      <a:prstDash val="solid"/>
+                      <a:round/>
+                      <a:headEnd type="none" w="med" len="med"/>
+                      <a:tailEnd type="none" w="med" len="med"/>
+                    </a:lnL>
+                    <a:lnR w="6350" cap="flat" cmpd="sng" algn="ctr">
+                      <a:solidFill>
+                        <a:srgbClr val="D9D9DE"/>
+                      </a:solidFill>
+                      <a:prstDash val="solid"/>
+                      <a:round/>
+                      <a:headEnd type="none" w="med" len="med"/>
+                      <a:tailEnd type="none" w="med" len="med"/>
+                    </a:lnR>
+                    <a:lnT w="6350" cap="flat" cmpd="sng" algn="ctr">
+                      <a:solidFill>
+                        <a:srgbClr val="D9D9DE"/>
+                      </a:solidFill>
+                      <a:prstDash val="solid"/>
+                      <a:round/>
+                      <a:headEnd type="none" w="med" len="med"/>
+                      <a:tailEnd type="none" w="med" len="med"/>
+                    </a:lnT>
+                    <a:lnB w="6350" cap="flat" cmpd="sng" algn="ctr">
+                      <a:solidFill>
+                        <a:srgbClr val="D9D9DE"/>
+                      </a:solidFill>
+                      <a:prstDash val="solid"/>
+                      <a:round/>
+                      <a:headEnd type="none" w="med" len="med"/>
+                      <a:tailEnd type="none" w="med" len="med"/>
+                    </a:lnB>
+                    <a:solidFill>
+                      <a:srgbClr val="F6F7F9"/>
+                    </a:solidFill>
+                  </a:tcPr>
+                </a:tc>
+                <a:tc>
+                  <a:txBody>
+                    <a:bodyPr/>
+                    <a:lstStyle/>
+                    <a:p>
+                      <a:pPr indent="0" marL="0">
+                        <a:buNone/>
+                      </a:pPr>
+                      <a:r>
+                        <a:rPr lang="en-US" sz="1250" dirty="0">
+                          <a:solidFill>
+                            <a:srgbClr val="1A1A1E"/>
+                          </a:solidFill>
+                          <a:latin typeface="Segoe UI" pitchFamily="34" charset="0"/>
+                          <a:ea typeface="Segoe UI" pitchFamily="34" charset="-122"/>
+                          <a:cs typeface="Segoe UI" pitchFamily="34" charset="-120"/>
+                        </a:rPr>
+                        <a:t>The Save button was removed - that data comes from the CMS. We assumed it was editable; it is not</a:t>
+                      </a:r>
+                      <a:endParaRPr lang="en-US" sz="1250" dirty="0">
+                        <a:latin typeface="Segoe UI" charset="0"/>
+                        <a:ea typeface="Segoe UI" charset="0"/>
+                        <a:cs typeface="Segoe UI" charset="0"/>
+                      </a:endParaRPr>
+                    </a:p>
+                  </a:txBody>
+                  <a:tcPr marL="73152" marR="73152" marT="73152" marB="73152" anchor="ctr">
+                    <a:lnL w="6350" cap="flat" cmpd="sng" algn="ctr">
+                      <a:solidFill>
+                        <a:srgbClr val="D9D9DE"/>
+                      </a:solidFill>
+                      <a:prstDash val="solid"/>
+                      <a:round/>
+                      <a:headEnd type="none" w="med" len="med"/>
+                      <a:tailEnd type="none" w="med" len="med"/>
+                    </a:lnL>
+                    <a:lnR w="6350" cap="flat" cmpd="sng" algn="ctr">
+                      <a:solidFill>
+                        <a:srgbClr val="D9D9DE"/>
+                      </a:solidFill>
+                      <a:prstDash val="solid"/>
+                      <a:round/>
+                      <a:headEnd type="none" w="med" len="med"/>
+                      <a:tailEnd type="none" w="med" len="med"/>
+                    </a:lnR>
+                    <a:lnT w="6350" cap="flat" cmpd="sng" algn="ctr">
+                      <a:solidFill>
+                        <a:srgbClr val="D9D9DE"/>
+                      </a:solidFill>
+                      <a:prstDash val="solid"/>
+                      <a:round/>
+                      <a:headEnd type="none" w="med" len="med"/>
+                      <a:tailEnd type="none" w="med" len="med"/>
+                    </a:lnT>
+                    <a:lnB w="6350" cap="flat" cmpd="sng" algn="ctr">
+                      <a:solidFill>
+                        <a:srgbClr val="D9D9DE"/>
+                      </a:solidFill>
+                      <a:prstDash val="solid"/>
+                      <a:round/>
+                      <a:headEnd type="none" w="med" len="med"/>
+                      <a:tailEnd type="none" w="med" len="med"/>
+                    </a:lnB>
+                    <a:solidFill>
+                      <a:srgbClr val="F6F7F9"/>
+                    </a:solidFill>
+                  </a:tcPr>
+                </a:tc>
+              </a:tr>
+            </a:tbl>
+          </a:graphicData>
+        </a:graphic>
+      </p:graphicFrame>
+      <p:sp>
+        <p:nvSpPr>
+          <p:cNvPr id="22" name="Text 19"/>
+          <p:cNvSpPr/>
+          <p:nvPr/>
+        </p:nvSpPr>
+        <p:spPr>
+          <a:xfrm>
+            <a:off x="566928" y="5989320"/>
+            <a:ext cx="11057839" cy="365760"/>
+          </a:xfrm>
+          <a:prstGeom prst="rect">
+            <a:avLst/>
+          </a:prstGeom>
+          <a:noFill/>
+          <a:ln/>
+        </p:spPr>
+        <p:txBody>
+          <a:bodyPr wrap="square" rtlCol="0" anchor="ctr"/>
+          <a:lstStyle/>
+          <a:p>
+            <a:pPr indent="0" marL="0">
+              <a:buNone/>
+            </a:pPr>
+            <a:r>
+              <a:rPr lang="en-US" sz="1250" i="1" dirty="0">
+                <a:solidFill>
+                  <a:srgbClr val="71717A"/>
+                </a:solidFill>
+                <a:latin typeface="Segoe UI" pitchFamily="34" charset="0"/>
+                <a:ea typeface="Segoe UI" pitchFamily="34" charset="-122"/>
+                <a:cs typeface="Segoe UI" pitchFamily="34" charset="-120"/>
+              </a:rPr>
+              <a:t>None of this was in a document. It came out of pointing the tests at the real system - which is the argument for doing it against UAT rather than a mock.</a:t>
+            </a:r>
+            <a:endParaRPr lang="en-US" sz="1250" dirty="0"/>
           </a:p>
         </p:txBody>
       </p:sp>

</xml_diff>

<commit_message>
Playwright deck: plain-language AI slide plus a worked example of the agent solving a problem
</commit_message>
<xml_diff>
--- a/presentations/Web_Test_Automation_Playwright.pptx
+++ b/presentations/Web_Test_Automation_Playwright.pptx
@@ -20,9 +20,10 @@
     <p:sldId id="268" r:id="rId14"/>
     <p:sldId id="269" r:id="rId15"/>
     <p:sldId id="270" r:id="rId16"/>
+    <p:sldId id="271" r:id="rId17"/>
   </p:sldIdLst>
   <p:notesMasterIdLst>
-    <p:notesMasterId r:id="rId17"/>
+    <p:notesMasterId r:id="rId18"/>
   </p:notesMasterIdLst>
   <p:sldSz cx="12192000" cy="6858000"/>
   <p:notesSz cx="6858000" cy="12192000"/>
@@ -1068,6 +1069,94 @@
             <a:fld id="{F7021451-1387-4CA6-816F-3879F97B5CBC}" type="slidenum">
               <a:rPr lang="en-US"/>
               <a:t>15</a:t>
+            </a:fld>
+            <a:endParaRPr lang="en-US"/>
+          </a:p>
+        </p:txBody>
+      </p:sp>
+    </p:spTree>
+    <p:extLst>
+      <p:ext uri="{BB962C8B-B14F-4D97-AF65-F5344CB8AC3E}">
+        <p14:creationId xmlns:p14="http://schemas.microsoft.com/office/powerpoint/2010/main" val="1024086991"/>
+      </p:ext>
+    </p:extLst>
+  </p:cSld>
+  <p:clrMapOvr>
+    <a:masterClrMapping/>
+  </p:clrMapOvr>
+</p:notes>
+</file>
+
+<file path=ppt/notesSlides/notesSlide16.xml><?xml version="1.0" encoding="utf-8"?>
+<p:notes xmlns:a="http://schemas.openxmlformats.org/drawingml/2006/main" xmlns:r="http://schemas.openxmlformats.org/officeDocument/2006/relationships" xmlns:p="http://schemas.openxmlformats.org/presentationml/2006/main">
+  <p:cSld>
+    <p:spTree>
+      <p:nvGrpSpPr>
+        <p:cNvPr id="1" name=""/>
+        <p:cNvGrpSpPr/>
+        <p:nvPr/>
+      </p:nvGrpSpPr>
+      <p:grpSpPr>
+        <a:xfrm>
+          <a:off x="0" y="0"/>
+          <a:ext cx="0" cy="0"/>
+          <a:chOff x="0" y="0"/>
+          <a:chExt cx="0" cy="0"/>
+        </a:xfrm>
+      </p:grpSpPr>
+      <p:sp>
+        <p:nvSpPr>
+          <p:cNvPr id="2" name="Slide Image Placeholder 1"/>
+          <p:cNvSpPr>
+            <a:spLocks noGrp="1" noRot="1" noChangeAspect="1"/>
+          </p:cNvSpPr>
+          <p:nvPr>
+            <p:ph type="sldImg"/>
+          </p:nvPr>
+        </p:nvSpPr>
+        <p:spPr/>
+      </p:sp>
+      <p:sp>
+        <p:nvSpPr>
+          <p:cNvPr id="3" name="Notes Placeholder 2"/>
+          <p:cNvSpPr>
+            <a:spLocks noGrp="1"/>
+          </p:cNvSpPr>
+          <p:nvPr>
+            <p:ph type="body" idx="1"/>
+          </p:nvPr>
+        </p:nvSpPr>
+        <p:spPr/>
+        <p:txBody>
+          <a:bodyPr/>
+          <a:lstStyle/>
+          <a:p>
+            <a:r>
+              <a:rPr lang="en-US" dirty="0"/>
+              <a:t/>
+            </a:r>
+            <a:endParaRPr lang="en-US" dirty="0"/>
+          </a:p>
+        </p:txBody>
+      </p:sp>
+      <p:sp>
+        <p:nvSpPr>
+          <p:cNvPr id="4" name="Slide Number Placeholder 3"/>
+          <p:cNvSpPr>
+            <a:spLocks noGrp="1"/>
+          </p:cNvSpPr>
+          <p:nvPr>
+            <p:ph type="sldNum" sz="quarter" idx="10"/>
+          </p:nvPr>
+        </p:nvSpPr>
+        <p:spPr/>
+        <p:txBody>
+          <a:bodyPr/>
+          <a:lstStyle/>
+          <a:p>
+            <a:fld id="{F7021451-1387-4CA6-816F-3879F97B5CBC}" type="slidenum">
+              <a:rPr lang="en-US"/>
+              <a:t>16</a:t>
             </a:fld>
             <a:endParaRPr lang="en-US"/>
           </a:p>
@@ -4137,7 +4226,7 @@
                 <a:ea typeface="Segoe UI" pitchFamily="34" charset="-122"/>
                 <a:cs typeface="Segoe UI" pitchFamily="34" charset="-120"/>
               </a:rPr>
-              <a:t>Read the</a:t>
+              <a:t>Read the app’s</a:t>
             </a:r>
             <a:endParaRPr lang="en-US" sz="1200" dirty="0"/>
           </a:p>
@@ -4154,7 +4243,7 @@
                 <a:ea typeface="Segoe UI" pitchFamily="34" charset="-122"/>
                 <a:cs typeface="Segoe UI" pitchFamily="34" charset="-120"/>
               </a:rPr>
-              <a:t>MVC views</a:t>
+              <a:t>own screens</a:t>
             </a:r>
             <a:endParaRPr lang="en-US" sz="1200" dirty="0"/>
           </a:p>
@@ -4259,7 +4348,7 @@
                 <a:ea typeface="Segoe UI" pitchFamily="34" charset="-122"/>
                 <a:cs typeface="Segoe UI" pitchFamily="34" charset="-120"/>
               </a:rPr>
-              <a:t>Derive the</a:t>
+              <a:t>Write the</a:t>
             </a:r>
             <a:endParaRPr lang="en-US" sz="1200" dirty="0"/>
           </a:p>
@@ -4276,7 +4365,7 @@
                 <a:ea typeface="Segoe UI" pitchFamily="34" charset="-122"/>
                 <a:cs typeface="Segoe UI" pitchFamily="34" charset="-120"/>
               </a:rPr>
-              <a:t>selectors</a:t>
+              <a:t>tests</a:t>
             </a:r>
             <a:endParaRPr lang="en-US" sz="1200" dirty="0"/>
           </a:p>
@@ -4330,6 +4419,128 @@
         <p:spPr>
           <a:xfrm>
             <a:off x="5114422" y="1627632"/>
+            <a:ext cx="1962851" cy="868680"/>
+          </a:xfrm>
+          <a:prstGeom prst="roundRect">
+            <a:avLst>
+              <a:gd name="adj" fmla="val 8421"/>
+            </a:avLst>
+          </a:prstGeom>
+          <a:solidFill>
+            <a:srgbClr val="0B5FA5"/>
+          </a:solidFill>
+          <a:ln w="12700">
+            <a:solidFill>
+              <a:srgbClr val="0B5FA5"/>
+            </a:solidFill>
+            <a:prstDash val="solid"/>
+          </a:ln>
+        </p:spPr>
+      </p:sp>
+      <p:sp>
+        <p:nvSpPr>
+          <p:cNvPr id="12" name="Text 10"/>
+          <p:cNvSpPr/>
+          <p:nvPr/>
+        </p:nvSpPr>
+        <p:spPr>
+          <a:xfrm>
+            <a:off x="5187574" y="1682496"/>
+            <a:ext cx="1816547" cy="758952"/>
+          </a:xfrm>
+          <a:prstGeom prst="rect">
+            <a:avLst/>
+          </a:prstGeom>
+          <a:noFill/>
+          <a:ln/>
+        </p:spPr>
+        <p:txBody>
+          <a:bodyPr wrap="square" rtlCol="0" anchor="ctr"/>
+          <a:lstStyle/>
+          <a:p>
+            <a:pPr algn="ctr" indent="0" marL="0">
+              <a:buNone/>
+            </a:pPr>
+            <a:r>
+              <a:rPr lang="en-US" sz="1200" b="1" dirty="0">
+                <a:solidFill>
+                  <a:srgbClr val="FFFFFF"/>
+                </a:solidFill>
+                <a:latin typeface="Segoe UI" pitchFamily="34" charset="0"/>
+                <a:ea typeface="Segoe UI" pitchFamily="34" charset="-122"/>
+                <a:cs typeface="Segoe UI" pitchFamily="34" charset="-120"/>
+              </a:rPr>
+              <a:t>Run them</a:t>
+            </a:r>
+            <a:endParaRPr lang="en-US" sz="1200" dirty="0"/>
+          </a:p>
+          <a:p>
+            <a:pPr algn="ctr" indent="0" marL="0">
+              <a:buNone/>
+            </a:pPr>
+            <a:r>
+              <a:rPr lang="en-US" sz="1200" b="1" dirty="0">
+                <a:solidFill>
+                  <a:srgbClr val="FFFFFF"/>
+                </a:solidFill>
+                <a:latin typeface="Segoe UI" pitchFamily="34" charset="0"/>
+                <a:ea typeface="Segoe UI" pitchFamily="34" charset="-122"/>
+                <a:cs typeface="Segoe UI" pitchFamily="34" charset="-120"/>
+              </a:rPr>
+              <a:t>on UAT</a:t>
+            </a:r>
+            <a:endParaRPr lang="en-US" sz="1200" dirty="0"/>
+          </a:p>
+        </p:txBody>
+      </p:sp>
+      <p:sp>
+        <p:nvSpPr>
+          <p:cNvPr id="13" name="Text 11"/>
+          <p:cNvSpPr/>
+          <p:nvPr/>
+        </p:nvSpPr>
+        <p:spPr>
+          <a:xfrm>
+            <a:off x="7077273" y="1627632"/>
+            <a:ext cx="310896" cy="868680"/>
+          </a:xfrm>
+          <a:prstGeom prst="rect">
+            <a:avLst/>
+          </a:prstGeom>
+          <a:noFill/>
+          <a:ln/>
+        </p:spPr>
+        <p:txBody>
+          <a:bodyPr wrap="square" rtlCol="0" anchor="ctr"/>
+          <a:lstStyle/>
+          <a:p>
+            <a:pPr algn="ctr" indent="0" marL="0">
+              <a:buNone/>
+            </a:pPr>
+            <a:r>
+              <a:rPr lang="en-US" sz="1700" b="1" dirty="0">
+                <a:solidFill>
+                  <a:srgbClr val="71717A"/>
+                </a:solidFill>
+                <a:latin typeface="Segoe UI" pitchFamily="34" charset="0"/>
+                <a:ea typeface="Segoe UI" pitchFamily="34" charset="-122"/>
+                <a:cs typeface="Segoe UI" pitchFamily="34" charset="-120"/>
+              </a:rPr>
+              <a:t>→</a:t>
+            </a:r>
+            <a:endParaRPr lang="en-US" sz="1700" dirty="0"/>
+          </a:p>
+        </p:txBody>
+      </p:sp>
+      <p:sp>
+        <p:nvSpPr>
+          <p:cNvPr id="14" name="Shape 12"/>
+          <p:cNvSpPr/>
+          <p:nvPr/>
+        </p:nvSpPr>
+        <p:spPr>
+          <a:xfrm>
+            <a:off x="7388169" y="1627632"/>
             <a:ext cx="1962851" cy="868680"/>
           </a:xfrm>
           <a:prstGeom prst="roundRect">
@@ -4350,128 +4561,6 @@
       </p:sp>
       <p:sp>
         <p:nvSpPr>
-          <p:cNvPr id="12" name="Text 10"/>
-          <p:cNvSpPr/>
-          <p:nvPr/>
-        </p:nvSpPr>
-        <p:spPr>
-          <a:xfrm>
-            <a:off x="5187574" y="1682496"/>
-            <a:ext cx="1816547" cy="758952"/>
-          </a:xfrm>
-          <a:prstGeom prst="rect">
-            <a:avLst/>
-          </a:prstGeom>
-          <a:noFill/>
-          <a:ln/>
-        </p:spPr>
-        <p:txBody>
-          <a:bodyPr wrap="square" rtlCol="0" anchor="ctr"/>
-          <a:lstStyle/>
-          <a:p>
-            <a:pPr algn="ctr" indent="0" marL="0">
-              <a:buNone/>
-            </a:pPr>
-            <a:r>
-              <a:rPr lang="en-US" sz="1200" b="1" dirty="0">
-                <a:solidFill>
-                  <a:srgbClr val="1A1A1E"/>
-                </a:solidFill>
-                <a:latin typeface="Segoe UI" pitchFamily="34" charset="0"/>
-                <a:ea typeface="Segoe UI" pitchFamily="34" charset="-122"/>
-                <a:cs typeface="Segoe UI" pitchFamily="34" charset="-120"/>
-              </a:rPr>
-              <a:t>Write pages</a:t>
-            </a:r>
-            <a:endParaRPr lang="en-US" sz="1200" dirty="0"/>
-          </a:p>
-          <a:p>
-            <a:pPr algn="ctr" indent="0" marL="0">
-              <a:buNone/>
-            </a:pPr>
-            <a:r>
-              <a:rPr lang="en-US" sz="1200" b="1" dirty="0">
-                <a:solidFill>
-                  <a:srgbClr val="1A1A1E"/>
-                </a:solidFill>
-                <a:latin typeface="Segoe UI" pitchFamily="34" charset="0"/>
-                <a:ea typeface="Segoe UI" pitchFamily="34" charset="-122"/>
-                <a:cs typeface="Segoe UI" pitchFamily="34" charset="-120"/>
-              </a:rPr>
-              <a:t>+ specs</a:t>
-            </a:r>
-            <a:endParaRPr lang="en-US" sz="1200" dirty="0"/>
-          </a:p>
-        </p:txBody>
-      </p:sp>
-      <p:sp>
-        <p:nvSpPr>
-          <p:cNvPr id="13" name="Text 11"/>
-          <p:cNvSpPr/>
-          <p:nvPr/>
-        </p:nvSpPr>
-        <p:spPr>
-          <a:xfrm>
-            <a:off x="7077273" y="1627632"/>
-            <a:ext cx="310896" cy="868680"/>
-          </a:xfrm>
-          <a:prstGeom prst="rect">
-            <a:avLst/>
-          </a:prstGeom>
-          <a:noFill/>
-          <a:ln/>
-        </p:spPr>
-        <p:txBody>
-          <a:bodyPr wrap="square" rtlCol="0" anchor="ctr"/>
-          <a:lstStyle/>
-          <a:p>
-            <a:pPr algn="ctr" indent="0" marL="0">
-              <a:buNone/>
-            </a:pPr>
-            <a:r>
-              <a:rPr lang="en-US" sz="1700" b="1" dirty="0">
-                <a:solidFill>
-                  <a:srgbClr val="71717A"/>
-                </a:solidFill>
-                <a:latin typeface="Segoe UI" pitchFamily="34" charset="0"/>
-                <a:ea typeface="Segoe UI" pitchFamily="34" charset="-122"/>
-                <a:cs typeface="Segoe UI" pitchFamily="34" charset="-120"/>
-              </a:rPr>
-              <a:t>→</a:t>
-            </a:r>
-            <a:endParaRPr lang="en-US" sz="1700" dirty="0"/>
-          </a:p>
-        </p:txBody>
-      </p:sp>
-      <p:sp>
-        <p:nvSpPr>
-          <p:cNvPr id="14" name="Shape 12"/>
-          <p:cNvSpPr/>
-          <p:nvPr/>
-        </p:nvSpPr>
-        <p:spPr>
-          <a:xfrm>
-            <a:off x="7388169" y="1627632"/>
-            <a:ext cx="1962851" cy="868680"/>
-          </a:xfrm>
-          <a:prstGeom prst="roundRect">
-            <a:avLst>
-              <a:gd name="adj" fmla="val 8421"/>
-            </a:avLst>
-          </a:prstGeom>
-          <a:solidFill>
-            <a:srgbClr val="0B5FA5"/>
-          </a:solidFill>
-          <a:ln w="12700">
-            <a:solidFill>
-              <a:srgbClr val="0B5FA5"/>
-            </a:solidFill>
-            <a:prstDash val="solid"/>
-          </a:ln>
-        </p:spPr>
-      </p:sp>
-      <p:sp>
-        <p:nvSpPr>
           <p:cNvPr id="15" name="Text 13"/>
           <p:cNvSpPr/>
           <p:nvPr/>
@@ -4497,13 +4586,13 @@
             <a:r>
               <a:rPr lang="en-US" sz="1200" b="1" dirty="0">
                 <a:solidFill>
-                  <a:srgbClr val="FFFFFF"/>
-                </a:solidFill>
-                <a:latin typeface="Segoe UI" pitchFamily="34" charset="0"/>
-                <a:ea typeface="Segoe UI" pitchFamily="34" charset="-122"/>
-                <a:cs typeface="Segoe UI" pitchFamily="34" charset="-120"/>
-              </a:rPr>
-              <a:t>Run against</a:t>
+                  <a:srgbClr val="1A1A1E"/>
+                </a:solidFill>
+                <a:latin typeface="Segoe UI" pitchFamily="34" charset="0"/>
+                <a:ea typeface="Segoe UI" pitchFamily="34" charset="-122"/>
+                <a:cs typeface="Segoe UI" pitchFamily="34" charset="-120"/>
+              </a:rPr>
+              <a:t>Read each failure,</a:t>
             </a:r>
             <a:endParaRPr lang="en-US" sz="1200" dirty="0"/>
           </a:p>
@@ -4514,13 +4603,13 @@
             <a:r>
               <a:rPr lang="en-US" sz="1200" b="1" dirty="0">
                 <a:solidFill>
-                  <a:srgbClr val="FFFFFF"/>
-                </a:solidFill>
-                <a:latin typeface="Segoe UI" pitchFamily="34" charset="0"/>
-                <a:ea typeface="Segoe UI" pitchFamily="34" charset="-122"/>
-                <a:cs typeface="Segoe UI" pitchFamily="34" charset="-120"/>
-              </a:rPr>
-              <a:t>UAT</a:t>
+                  <a:srgbClr val="1A1A1E"/>
+                </a:solidFill>
+                <a:latin typeface="Segoe UI" pitchFamily="34" charset="0"/>
+                <a:ea typeface="Segoe UI" pitchFamily="34" charset="-122"/>
+                <a:cs typeface="Segoe UI" pitchFamily="34" charset="-120"/>
+              </a:rPr>
+              <a:t>fix, run again</a:t>
             </a:r>
             <a:endParaRPr lang="en-US" sz="1200" dirty="0"/>
           </a:p>
@@ -4625,7 +4714,7 @@
                 <a:ea typeface="Segoe UI" pitchFamily="34" charset="-122"/>
                 <a:cs typeface="Segoe UI" pitchFamily="34" charset="-120"/>
               </a:rPr>
-              <a:t>Read failures,</a:t>
+              <a:t>Write down</a:t>
             </a:r>
             <a:endParaRPr lang="en-US" sz="1200" dirty="0"/>
           </a:p>
@@ -4642,7 +4731,7 @@
                 <a:ea typeface="Segoe UI" pitchFamily="34" charset="-122"/>
                 <a:cs typeface="Segoe UI" pitchFamily="34" charset="-120"/>
               </a:rPr>
-              <a:t>fix, re-run</a:t>
+              <a:t>what it learned</a:t>
             </a:r>
             <a:endParaRPr lang="en-US" sz="1200" dirty="0"/>
           </a:p>
@@ -4688,7 +4777,7 @@
                 <a:ea typeface="Segoe UI" pitchFamily="34" charset="-122"/>
                 <a:cs typeface="Segoe UI" pitchFamily="34" charset="-120"/>
               </a:rPr>
-              <a:t>It read the application, it did not guess</a:t>
+              <a:t>It looked at the real pages instead of guessing</a:t>
             </a:r>
             <a:endParaRPr lang="en-US" sz="1450" dirty="0"/>
           </a:p>
@@ -4711,7 +4800,7 @@
                 <a:ea typeface="Segoe UI" pitchFamily="34" charset="-122"/>
                 <a:cs typeface="Segoe UI" pitchFamily="34" charset="-120"/>
               </a:rPr>
-              <a:t>Selectors came from JobLst.cshtml, Job.cshtml, DealerList.cshtml - real ids like #tbMain, #btnSearch, select[name="clientProgram"]</a:t>
+              <a:t>The field names in the tests came out of the application’s own screens - so the tests match what is actually there, not what someone remembered</a:t>
             </a:r>
             <a:endParaRPr lang="en-US" sz="1450" dirty="0"/>
           </a:p>
@@ -4735,7 +4824,7 @@
                 <a:ea typeface="Segoe UI" pitchFamily="34" charset="-122"/>
                 <a:cs typeface="Segoe UI" pitchFamily="34" charset="-120"/>
               </a:rPr>
-              <a:t>It probed the live app to answer its own questions</a:t>
+              <a:t>It ran everything it wrote</a:t>
             </a:r>
             <a:endParaRPr lang="en-US" sz="1450" dirty="0"/>
           </a:p>
@@ -4758,7 +4847,7 @@
                 <a:ea typeface="Segoe UI" pitchFamily="34" charset="-122"/>
                 <a:cs typeface="Segoe UI" pitchFamily="34" charset="-120"/>
               </a:rPr>
-              <a:t>When job creation failed with "Privilege is required", it enumerated every program/tier combination on UAT and found which ones actually have a privilege</a:t>
+              <a:t>Nothing was left as "probably fine". Every check was executed against the live UAT site before it counted as done</a:t>
             </a:r>
             <a:endParaRPr lang="en-US" sz="1450" dirty="0"/>
           </a:p>
@@ -4782,7 +4871,7 @@
                 <a:ea typeface="Segoe UI" pitchFamily="34" charset="-122"/>
                 <a:cs typeface="Segoe UI" pitchFamily="34" charset="-120"/>
               </a:rPr>
-              <a:t>Failures became knowledge, not guesswork</a:t>
+              <a:t>Every failure was investigated, not retried</a:t>
             </a:r>
             <a:endParaRPr lang="en-US" sz="1450" dirty="0"/>
           </a:p>
@@ -4805,7 +4894,7 @@
                 <a:ea typeface="Segoe UI" pitchFamily="34" charset="-122"/>
                 <a:cs typeface="Segoe UI" pitchFamily="34" charset="-120"/>
               </a:rPr>
-              <a:t>Each red run was read, diagnosed and fixed; the reasons are written into the README so the next person does not rediscover them</a:t>
+              <a:t>When something went red it went and found out why - and the reason was written into the README so nobody has to rediscover it</a:t>
             </a:r>
             <a:endParaRPr lang="en-US" sz="1450" dirty="0"/>
           </a:p>
@@ -4910,7 +4999,7 @@
                 <a:ea typeface="Segoe UI" pitchFamily="34" charset="-122"/>
                 <a:cs typeface="Segoe UI" pitchFamily="34" charset="-120"/>
               </a:rPr>
-              <a:t>from empty folder to 13 green checks</a:t>
+              <a:t>from empty folder to a working suite</a:t>
             </a:r>
             <a:endParaRPr lang="en-US" sz="1150" dirty="0"/>
           </a:p>
@@ -5015,7 +5104,7 @@
                 <a:ea typeface="Segoe UI" pitchFamily="34" charset="-122"/>
                 <a:cs typeface="Segoe UI" pitchFamily="34" charset="-120"/>
               </a:rPr>
-              <a:t>checks, all verified on UAT</a:t>
+              <a:t>checks, every one run on UAT</a:t>
             </a:r>
             <a:endParaRPr lang="en-US" sz="1150" dirty="0"/>
           </a:p>
@@ -5081,7 +5170,7 @@
                 <a:ea typeface="Segoe UI" pitchFamily="34" charset="-122"/>
                 <a:cs typeface="Segoe UI" pitchFamily="34" charset="-120"/>
               </a:rPr>
-              <a:t>3×</a:t>
+              <a:t>546</a:t>
             </a:r>
             <a:endParaRPr lang="en-US" sz="3000" dirty="0"/>
           </a:p>
@@ -5120,7 +5209,7 @@
                 <a:ea typeface="Segoe UI" pitchFamily="34" charset="-122"/>
                 <a:cs typeface="Segoe UI" pitchFamily="34" charset="-120"/>
               </a:rPr>
-              <a:t>full-suite runs to prove stability</a:t>
+              <a:t>lines of test code written</a:t>
             </a:r>
             <a:endParaRPr lang="en-US" sz="1150" dirty="0"/>
           </a:p>
@@ -5186,7 +5275,7 @@
                 <a:ea typeface="Segoe UI" pitchFamily="34" charset="-122"/>
                 <a:cs typeface="Segoe UI" pitchFamily="34" charset="-120"/>
               </a:rPr>
-              <a:t>1</a:t>
+              <a:t>3×</a:t>
             </a:r>
             <a:endParaRPr lang="en-US" sz="3000" dirty="0"/>
           </a:p>
@@ -5225,7 +5314,7 @@
                 <a:ea typeface="Segoe UI" pitchFamily="34" charset="-122"/>
                 <a:cs typeface="Segoe UI" pitchFamily="34" charset="-120"/>
               </a:rPr>
-              <a:t>flake found and fixed</a:t>
+              <a:t>full runs to prove it was stable</a:t>
             </a:r>
             <a:endParaRPr lang="en-US" sz="1150" dirty="0"/>
           </a:p>
@@ -5296,7 +5385,7 @@
                 <a:ea typeface="Segoe UI" pitchFamily="34" charset="-122"/>
                 <a:cs typeface="Segoe UI" pitchFamily="34" charset="-120"/>
               </a:rPr>
-              <a:t>Where the human time still goes</a:t>
+              <a:t>One example: the puzzle it solved by itself</a:t>
             </a:r>
             <a:endParaRPr lang="en-US" sz="2600" dirty="0"/>
           </a:p>
@@ -5335,7 +5424,7 @@
                 <a:ea typeface="Segoe UI" pitchFamily="34" charset="-122"/>
                 <a:cs typeface="Segoe UI" pitchFamily="34" charset="-120"/>
               </a:rPr>
-              <a:t>The agent is fast at the mechanical work; judgement stays with us</a:t>
+              <a:t>The job-creation test failed. Instead of guessing, it went and found the answer.</a:t>
             </a:r>
             <a:endParaRPr lang="en-US" sz="1400" dirty="0"/>
           </a:p>
@@ -5370,11 +5459,477 @@
         <p:spPr>
           <a:xfrm>
             <a:off x="566928" y="1627632"/>
-            <a:ext cx="5300320" cy="3474720"/>
+            <a:ext cx="2531288" cy="960120"/>
           </a:xfrm>
           <a:prstGeom prst="roundRect">
             <a:avLst>
-              <a:gd name="adj" fmla="val 2105"/>
+              <a:gd name="adj" fmla="val 7619"/>
+            </a:avLst>
+          </a:prstGeom>
+          <a:solidFill>
+            <a:srgbClr val="E8F0F8"/>
+          </a:solidFill>
+          <a:ln w="12700">
+            <a:solidFill>
+              <a:srgbClr val="C9DAEA"/>
+            </a:solidFill>
+            <a:prstDash val="solid"/>
+          </a:ln>
+        </p:spPr>
+      </p:sp>
+      <p:sp>
+        <p:nvSpPr>
+          <p:cNvPr id="6" name="Text 4"/>
+          <p:cNvSpPr/>
+          <p:nvPr/>
+        </p:nvSpPr>
+        <p:spPr>
+          <a:xfrm>
+            <a:off x="640080" y="1682496"/>
+            <a:ext cx="2384984" cy="850392"/>
+          </a:xfrm>
+          <a:prstGeom prst="rect">
+            <a:avLst/>
+          </a:prstGeom>
+          <a:noFill/>
+          <a:ln/>
+        </p:spPr>
+        <p:txBody>
+          <a:bodyPr wrap="square" rtlCol="0" anchor="ctr"/>
+          <a:lstStyle/>
+          <a:p>
+            <a:pPr algn="ctr" indent="0" marL="0">
+              <a:buNone/>
+            </a:pPr>
+            <a:r>
+              <a:rPr lang="en-US" sz="1200" b="1" dirty="0">
+                <a:solidFill>
+                  <a:srgbClr val="1A1A1E"/>
+                </a:solidFill>
+                <a:latin typeface="Segoe UI" pitchFamily="34" charset="0"/>
+                <a:ea typeface="Segoe UI" pitchFamily="34" charset="-122"/>
+                <a:cs typeface="Segoe UI" pitchFamily="34" charset="-120"/>
+              </a:rPr>
+              <a:t>Test fails:</a:t>
+            </a:r>
+            <a:endParaRPr lang="en-US" sz="1200" dirty="0"/>
+          </a:p>
+          <a:p>
+            <a:pPr algn="ctr" indent="0" marL="0">
+              <a:buNone/>
+            </a:pPr>
+            <a:r>
+              <a:rPr lang="en-US" sz="1200" b="1" dirty="0">
+                <a:solidFill>
+                  <a:srgbClr val="1A1A1E"/>
+                </a:solidFill>
+                <a:latin typeface="Segoe UI" pitchFamily="34" charset="0"/>
+                <a:ea typeface="Segoe UI" pitchFamily="34" charset="-122"/>
+                <a:cs typeface="Segoe UI" pitchFamily="34" charset="-120"/>
+              </a:rPr>
+              <a:t>"Privilege is required"</a:t>
+            </a:r>
+            <a:endParaRPr lang="en-US" sz="1200" dirty="0"/>
+          </a:p>
+        </p:txBody>
+      </p:sp>
+      <p:sp>
+        <p:nvSpPr>
+          <p:cNvPr id="7" name="Text 5"/>
+          <p:cNvSpPr/>
+          <p:nvPr/>
+        </p:nvSpPr>
+        <p:spPr>
+          <a:xfrm>
+            <a:off x="3098216" y="1627632"/>
+            <a:ext cx="310896" cy="960120"/>
+          </a:xfrm>
+          <a:prstGeom prst="rect">
+            <a:avLst/>
+          </a:prstGeom>
+          <a:noFill/>
+          <a:ln/>
+        </p:spPr>
+        <p:txBody>
+          <a:bodyPr wrap="square" rtlCol="0" anchor="ctr"/>
+          <a:lstStyle/>
+          <a:p>
+            <a:pPr algn="ctr" indent="0" marL="0">
+              <a:buNone/>
+            </a:pPr>
+            <a:r>
+              <a:rPr lang="en-US" sz="1700" b="1" dirty="0">
+                <a:solidFill>
+                  <a:srgbClr val="71717A"/>
+                </a:solidFill>
+                <a:latin typeface="Segoe UI" pitchFamily="34" charset="0"/>
+                <a:ea typeface="Segoe UI" pitchFamily="34" charset="-122"/>
+                <a:cs typeface="Segoe UI" pitchFamily="34" charset="-120"/>
+              </a:rPr>
+              <a:t>→</a:t>
+            </a:r>
+            <a:endParaRPr lang="en-US" sz="1700" dirty="0"/>
+          </a:p>
+        </p:txBody>
+      </p:sp>
+      <p:sp>
+        <p:nvSpPr>
+          <p:cNvPr id="8" name="Shape 6"/>
+          <p:cNvSpPr/>
+          <p:nvPr/>
+        </p:nvSpPr>
+        <p:spPr>
+          <a:xfrm>
+            <a:off x="3409112" y="1627632"/>
+            <a:ext cx="2531288" cy="960120"/>
+          </a:xfrm>
+          <a:prstGeom prst="roundRect">
+            <a:avLst>
+              <a:gd name="adj" fmla="val 7619"/>
+            </a:avLst>
+          </a:prstGeom>
+          <a:solidFill>
+            <a:srgbClr val="0B5FA5"/>
+          </a:solidFill>
+          <a:ln w="12700">
+            <a:solidFill>
+              <a:srgbClr val="0B5FA5"/>
+            </a:solidFill>
+            <a:prstDash val="solid"/>
+          </a:ln>
+        </p:spPr>
+      </p:sp>
+      <p:sp>
+        <p:nvSpPr>
+          <p:cNvPr id="9" name="Text 7"/>
+          <p:cNvSpPr/>
+          <p:nvPr/>
+        </p:nvSpPr>
+        <p:spPr>
+          <a:xfrm>
+            <a:off x="3482264" y="1682496"/>
+            <a:ext cx="2384984" cy="850392"/>
+          </a:xfrm>
+          <a:prstGeom prst="rect">
+            <a:avLst/>
+          </a:prstGeom>
+          <a:noFill/>
+          <a:ln/>
+        </p:spPr>
+        <p:txBody>
+          <a:bodyPr wrap="square" rtlCol="0" anchor="ctr"/>
+          <a:lstStyle/>
+          <a:p>
+            <a:pPr algn="ctr" indent="0" marL="0">
+              <a:buNone/>
+            </a:pPr>
+            <a:r>
+              <a:rPr lang="en-US" sz="1200" b="1" dirty="0">
+                <a:solidFill>
+                  <a:srgbClr val="FFFFFF"/>
+                </a:solidFill>
+                <a:latin typeface="Segoe UI" pitchFamily="34" charset="0"/>
+                <a:ea typeface="Segoe UI" pitchFamily="34" charset="-122"/>
+                <a:cs typeface="Segoe UI" pitchFamily="34" charset="-120"/>
+              </a:rPr>
+              <a:t>Checks every program</a:t>
+            </a:r>
+            <a:endParaRPr lang="en-US" sz="1200" dirty="0"/>
+          </a:p>
+          <a:p>
+            <a:pPr algn="ctr" indent="0" marL="0">
+              <a:buNone/>
+            </a:pPr>
+            <a:r>
+              <a:rPr lang="en-US" sz="1200" b="1" dirty="0">
+                <a:solidFill>
+                  <a:srgbClr val="FFFFFF"/>
+                </a:solidFill>
+                <a:latin typeface="Segoe UI" pitchFamily="34" charset="0"/>
+                <a:ea typeface="Segoe UI" pitchFamily="34" charset="-122"/>
+                <a:cs typeface="Segoe UI" pitchFamily="34" charset="-120"/>
+              </a:rPr>
+              <a:t>and tier on UAT</a:t>
+            </a:r>
+            <a:endParaRPr lang="en-US" sz="1200" dirty="0"/>
+          </a:p>
+        </p:txBody>
+      </p:sp>
+      <p:sp>
+        <p:nvSpPr>
+          <p:cNvPr id="10" name="Text 8"/>
+          <p:cNvSpPr/>
+          <p:nvPr/>
+        </p:nvSpPr>
+        <p:spPr>
+          <a:xfrm>
+            <a:off x="5940400" y="1627632"/>
+            <a:ext cx="310896" cy="960120"/>
+          </a:xfrm>
+          <a:prstGeom prst="rect">
+            <a:avLst/>
+          </a:prstGeom>
+          <a:noFill/>
+          <a:ln/>
+        </p:spPr>
+        <p:txBody>
+          <a:bodyPr wrap="square" rtlCol="0" anchor="ctr"/>
+          <a:lstStyle/>
+          <a:p>
+            <a:pPr algn="ctr" indent="0" marL="0">
+              <a:buNone/>
+            </a:pPr>
+            <a:r>
+              <a:rPr lang="en-US" sz="1700" b="1" dirty="0">
+                <a:solidFill>
+                  <a:srgbClr val="71717A"/>
+                </a:solidFill>
+                <a:latin typeface="Segoe UI" pitchFamily="34" charset="0"/>
+                <a:ea typeface="Segoe UI" pitchFamily="34" charset="-122"/>
+                <a:cs typeface="Segoe UI" pitchFamily="34" charset="-120"/>
+              </a:rPr>
+              <a:t>→</a:t>
+            </a:r>
+            <a:endParaRPr lang="en-US" sz="1700" dirty="0"/>
+          </a:p>
+        </p:txBody>
+      </p:sp>
+      <p:sp>
+        <p:nvSpPr>
+          <p:cNvPr id="11" name="Shape 9"/>
+          <p:cNvSpPr/>
+          <p:nvPr/>
+        </p:nvSpPr>
+        <p:spPr>
+          <a:xfrm>
+            <a:off x="6251296" y="1627632"/>
+            <a:ext cx="2531288" cy="960120"/>
+          </a:xfrm>
+          <a:prstGeom prst="roundRect">
+            <a:avLst>
+              <a:gd name="adj" fmla="val 7619"/>
+            </a:avLst>
+          </a:prstGeom>
+          <a:solidFill>
+            <a:srgbClr val="E8F0F8"/>
+          </a:solidFill>
+          <a:ln w="12700">
+            <a:solidFill>
+              <a:srgbClr val="C9DAEA"/>
+            </a:solidFill>
+            <a:prstDash val="solid"/>
+          </a:ln>
+        </p:spPr>
+      </p:sp>
+      <p:sp>
+        <p:nvSpPr>
+          <p:cNvPr id="12" name="Text 10"/>
+          <p:cNvSpPr/>
+          <p:nvPr/>
+        </p:nvSpPr>
+        <p:spPr>
+          <a:xfrm>
+            <a:off x="6324448" y="1682496"/>
+            <a:ext cx="2384984" cy="850392"/>
+          </a:xfrm>
+          <a:prstGeom prst="rect">
+            <a:avLst/>
+          </a:prstGeom>
+          <a:noFill/>
+          <a:ln/>
+        </p:spPr>
+        <p:txBody>
+          <a:bodyPr wrap="square" rtlCol="0" anchor="ctr"/>
+          <a:lstStyle/>
+          <a:p>
+            <a:pPr algn="ctr" indent="0" marL="0">
+              <a:buNone/>
+            </a:pPr>
+            <a:r>
+              <a:rPr lang="en-US" sz="1200" b="1" dirty="0">
+                <a:solidFill>
+                  <a:srgbClr val="1A1A1E"/>
+                </a:solidFill>
+                <a:latin typeface="Segoe UI" pitchFamily="34" charset="0"/>
+                <a:ea typeface="Segoe UI" pitchFamily="34" charset="-122"/>
+                <a:cs typeface="Segoe UI" pitchFamily="34" charset="-120"/>
+              </a:rPr>
+              <a:t>Finds only 4 of 15</a:t>
+            </a:r>
+            <a:endParaRPr lang="en-US" sz="1200" dirty="0"/>
+          </a:p>
+          <a:p>
+            <a:pPr algn="ctr" indent="0" marL="0">
+              <a:buNone/>
+            </a:pPr>
+            <a:r>
+              <a:rPr lang="en-US" sz="1200" b="1" dirty="0">
+                <a:solidFill>
+                  <a:srgbClr val="1A1A1E"/>
+                </a:solidFill>
+                <a:latin typeface="Segoe UI" pitchFamily="34" charset="0"/>
+                <a:ea typeface="Segoe UI" pitchFamily="34" charset="-122"/>
+                <a:cs typeface="Segoe UI" pitchFamily="34" charset="-120"/>
+              </a:rPr>
+              <a:t>programs can work</a:t>
+            </a:r>
+            <a:endParaRPr lang="en-US" sz="1200" dirty="0"/>
+          </a:p>
+        </p:txBody>
+      </p:sp>
+      <p:sp>
+        <p:nvSpPr>
+          <p:cNvPr id="13" name="Text 11"/>
+          <p:cNvSpPr/>
+          <p:nvPr/>
+        </p:nvSpPr>
+        <p:spPr>
+          <a:xfrm>
+            <a:off x="8782583" y="1627632"/>
+            <a:ext cx="310896" cy="960120"/>
+          </a:xfrm>
+          <a:prstGeom prst="rect">
+            <a:avLst/>
+          </a:prstGeom>
+          <a:noFill/>
+          <a:ln/>
+        </p:spPr>
+        <p:txBody>
+          <a:bodyPr wrap="square" rtlCol="0" anchor="ctr"/>
+          <a:lstStyle/>
+          <a:p>
+            <a:pPr algn="ctr" indent="0" marL="0">
+              <a:buNone/>
+            </a:pPr>
+            <a:r>
+              <a:rPr lang="en-US" sz="1700" b="1" dirty="0">
+                <a:solidFill>
+                  <a:srgbClr val="71717A"/>
+                </a:solidFill>
+                <a:latin typeface="Segoe UI" pitchFamily="34" charset="0"/>
+                <a:ea typeface="Segoe UI" pitchFamily="34" charset="-122"/>
+                <a:cs typeface="Segoe UI" pitchFamily="34" charset="-120"/>
+              </a:rPr>
+              <a:t>→</a:t>
+            </a:r>
+            <a:endParaRPr lang="en-US" sz="1700" dirty="0"/>
+          </a:p>
+        </p:txBody>
+      </p:sp>
+      <p:sp>
+        <p:nvSpPr>
+          <p:cNvPr id="14" name="Shape 12"/>
+          <p:cNvSpPr/>
+          <p:nvPr/>
+        </p:nvSpPr>
+        <p:spPr>
+          <a:xfrm>
+            <a:off x="9093479" y="1627632"/>
+            <a:ext cx="2531288" cy="960120"/>
+          </a:xfrm>
+          <a:prstGeom prst="roundRect">
+            <a:avLst>
+              <a:gd name="adj" fmla="val 7619"/>
+            </a:avLst>
+          </a:prstGeom>
+          <a:solidFill>
+            <a:srgbClr val="E8F0F8"/>
+          </a:solidFill>
+          <a:ln w="12700">
+            <a:solidFill>
+              <a:srgbClr val="C9DAEA"/>
+            </a:solidFill>
+            <a:prstDash val="solid"/>
+          </a:ln>
+        </p:spPr>
+      </p:sp>
+      <p:sp>
+        <p:nvSpPr>
+          <p:cNvPr id="15" name="Text 13"/>
+          <p:cNvSpPr/>
+          <p:nvPr/>
+        </p:nvSpPr>
+        <p:spPr>
+          <a:xfrm>
+            <a:off x="9166631" y="1682496"/>
+            <a:ext cx="2384984" cy="850392"/>
+          </a:xfrm>
+          <a:prstGeom prst="rect">
+            <a:avLst/>
+          </a:prstGeom>
+          <a:noFill/>
+          <a:ln/>
+        </p:spPr>
+        <p:txBody>
+          <a:bodyPr wrap="square" rtlCol="0" anchor="ctr"/>
+          <a:lstStyle/>
+          <a:p>
+            <a:pPr algn="ctr" indent="0" marL="0">
+              <a:buNone/>
+            </a:pPr>
+            <a:r>
+              <a:rPr lang="en-US" sz="1200" b="1" dirty="0">
+                <a:solidFill>
+                  <a:srgbClr val="1A1A1E"/>
+                </a:solidFill>
+                <a:latin typeface="Segoe UI" pitchFamily="34" charset="0"/>
+                <a:ea typeface="Segoe UI" pitchFamily="34" charset="-122"/>
+                <a:cs typeface="Segoe UI" pitchFamily="34" charset="-120"/>
+              </a:rPr>
+              <a:t>Test picks a working</a:t>
+            </a:r>
+            <a:endParaRPr lang="en-US" sz="1200" dirty="0"/>
+          </a:p>
+          <a:p>
+            <a:pPr algn="ctr" indent="0" marL="0">
+              <a:buNone/>
+            </a:pPr>
+            <a:r>
+              <a:rPr lang="en-US" sz="1200" b="1" dirty="0">
+                <a:solidFill>
+                  <a:srgbClr val="1A1A1E"/>
+                </a:solidFill>
+                <a:latin typeface="Segoe UI" pitchFamily="34" charset="0"/>
+                <a:ea typeface="Segoe UI" pitchFamily="34" charset="-122"/>
+                <a:cs typeface="Segoe UI" pitchFamily="34" charset="-120"/>
+              </a:rPr>
+              <a:t>one - and it is</a:t>
+            </a:r>
+            <a:endParaRPr lang="en-US" sz="1200" dirty="0"/>
+          </a:p>
+          <a:p>
+            <a:pPr algn="ctr" indent="0" marL="0">
+              <a:buNone/>
+            </a:pPr>
+            <a:r>
+              <a:rPr lang="en-US" sz="1200" b="1" dirty="0">
+                <a:solidFill>
+                  <a:srgbClr val="1A1A1E"/>
+                </a:solidFill>
+                <a:latin typeface="Segoe UI" pitchFamily="34" charset="0"/>
+                <a:ea typeface="Segoe UI" pitchFamily="34" charset="-122"/>
+                <a:cs typeface="Segoe UI" pitchFamily="34" charset="-120"/>
+              </a:rPr>
+              <a:t>written down</a:t>
+            </a:r>
+            <a:endParaRPr lang="en-US" sz="1200" dirty="0"/>
+          </a:p>
+        </p:txBody>
+      </p:sp>
+      <p:sp>
+        <p:nvSpPr>
+          <p:cNvPr id="16" name="Shape 14"/>
+          <p:cNvSpPr/>
+          <p:nvPr/>
+        </p:nvSpPr>
+        <p:spPr>
+          <a:xfrm>
+            <a:off x="566928" y="2953512"/>
+            <a:ext cx="5300320" cy="2743200"/>
+          </a:xfrm>
+          <a:prstGeom prst="roundRect">
+            <a:avLst>
+              <a:gd name="adj" fmla="val 2667"/>
             </a:avLst>
           </a:prstGeom>
           <a:solidFill>
@@ -5390,13 +5945,13 @@
       </p:sp>
       <p:sp>
         <p:nvSpPr>
-          <p:cNvPr id="6" name="Text 4"/>
-          <p:cNvSpPr/>
-          <p:nvPr/>
-        </p:nvSpPr>
-        <p:spPr>
-          <a:xfrm>
-            <a:off x="786384" y="1810512"/>
+          <p:cNvPr id="17" name="Text 15"/>
+          <p:cNvSpPr/>
+          <p:nvPr/>
+        </p:nvSpPr>
+        <p:spPr>
+          <a:xfrm>
+            <a:off x="786384" y="3136392"/>
             <a:ext cx="4861408" cy="365760"/>
           </a:xfrm>
           <a:prstGeom prst="rect">
@@ -5415,13 +5970,13 @@
             <a:r>
               <a:rPr lang="en-US" sz="1500" b="1" dirty="0">
                 <a:solidFill>
-                  <a:srgbClr val="15803D"/>
-                </a:solidFill>
-                <a:latin typeface="Segoe UI" pitchFamily="34" charset="0"/>
-                <a:ea typeface="Segoe UI" pitchFamily="34" charset="-122"/>
-                <a:cs typeface="Segoe UI" pitchFamily="34" charset="-120"/>
-              </a:rPr>
-              <a:t>The agent is good at</a:t>
+                  <a:srgbClr val="B91C1C"/>
+                </a:solidFill>
+                <a:latin typeface="Segoe UI" pitchFamily="34" charset="0"/>
+                <a:ea typeface="Segoe UI" pitchFamily="34" charset="-122"/>
+                <a:cs typeface="Segoe UI" pitchFamily="34" charset="-120"/>
+              </a:rPr>
+              <a:t>The usual ways this goes</a:t>
             </a:r>
             <a:endParaRPr lang="en-US" sz="1500" dirty="0"/>
           </a:p>
@@ -5429,14 +5984,14 @@
       </p:sp>
       <p:sp>
         <p:nvSpPr>
-          <p:cNvPr id="7" name="Text 5"/>
-          <p:cNvSpPr/>
-          <p:nvPr/>
-        </p:nvSpPr>
-        <p:spPr>
-          <a:xfrm>
-            <a:off x="786384" y="2231136"/>
-            <a:ext cx="4861408" cy="2651760"/>
+          <p:cNvPr id="18" name="Text 16"/>
+          <p:cNvSpPr/>
+          <p:nvPr/>
+        </p:nvSpPr>
+        <p:spPr>
+          <a:xfrm>
+            <a:off x="786384" y="3557016"/>
+            <a:ext cx="4861408" cy="1920240"/>
           </a:xfrm>
           <a:prstGeom prst="rect">
             <a:avLst/>
@@ -5464,7 +6019,7 @@
                 <a:ea typeface="Segoe UI" pitchFamily="34" charset="-122"/>
                 <a:cs typeface="Segoe UI" pitchFamily="34" charset="-120"/>
               </a:rPr>
-              <a:t>Reading the application to find real selectors</a:t>
+              <a:t>Ask around until someone remembers</a:t>
             </a:r>
             <a:endParaRPr lang="en-US" sz="1300" dirty="0"/>
           </a:p>
@@ -5485,7 +6040,7 @@
                 <a:ea typeface="Segoe UI" pitchFamily="34" charset="-122"/>
                 <a:cs typeface="Segoe UI" pitchFamily="34" charset="-120"/>
               </a:rPr>
-              <a:t>Writing page objects and specs in a consistent shape</a:t>
+              <a:t>Try a few by hand and stop at the first that works</a:t>
             </a:r>
             <a:endParaRPr lang="en-US" sz="1300" dirty="0"/>
           </a:p>
@@ -5506,7 +6061,7 @@
                 <a:ea typeface="Segoe UI" pitchFamily="34" charset="-122"/>
                 <a:cs typeface="Segoe UI" pitchFamily="34" charset="-120"/>
               </a:rPr>
-              <a:t>Running, reading the failure, fixing, re-running</a:t>
+              <a:t>Hard-code an id that quietly breaks on the next environment</a:t>
             </a:r>
             <a:endParaRPr lang="en-US" sz="1300" dirty="0"/>
           </a:p>
@@ -5527,47 +6082,26 @@
                 <a:ea typeface="Segoe UI" pitchFamily="34" charset="-122"/>
                 <a:cs typeface="Segoe UI" pitchFamily="34" charset="-120"/>
               </a:rPr>
-              <a:t>Probing the environment to answer factual questions</a:t>
+              <a:t>Or simply give up on automating job creation</a:t>
             </a:r>
             <a:endParaRPr lang="en-US" sz="1300" dirty="0"/>
           </a:p>
-          <a:p>
-            <a:pPr marL="342900" indent="-342900">
-              <a:spcAft>
-                <a:spcPts val="700"/>
-              </a:spcAft>
-              <a:buSzPct val="100000"/>
-              <a:buChar char="•"/>
-            </a:pPr>
-            <a:r>
-              <a:rPr lang="en-US" sz="1300" dirty="0">
-                <a:solidFill>
-                  <a:srgbClr val="3F3F46"/>
-                </a:solidFill>
-                <a:latin typeface="Segoe UI" pitchFamily="34" charset="0"/>
-                <a:ea typeface="Segoe UI" pitchFamily="34" charset="-122"/>
-                <a:cs typeface="Segoe UI" pitchFamily="34" charset="-120"/>
-              </a:rPr>
-              <a:t>Writing down what it learned so it is not lost</a:t>
-            </a:r>
-            <a:endParaRPr lang="en-US" sz="1300" dirty="0"/>
-          </a:p>
-        </p:txBody>
-      </p:sp>
-      <p:sp>
-        <p:nvSpPr>
-          <p:cNvPr id="8" name="Shape 6"/>
-          <p:cNvSpPr/>
-          <p:nvPr/>
-        </p:nvSpPr>
-        <p:spPr>
-          <a:xfrm>
-            <a:off x="6324448" y="1627632"/>
-            <a:ext cx="5300320" cy="3474720"/>
+        </p:txBody>
+      </p:sp>
+      <p:sp>
+        <p:nvSpPr>
+          <p:cNvPr id="19" name="Shape 17"/>
+          <p:cNvSpPr/>
+          <p:nvPr/>
+        </p:nvSpPr>
+        <p:spPr>
+          <a:xfrm>
+            <a:off x="6324448" y="2953512"/>
+            <a:ext cx="5300320" cy="2743200"/>
           </a:xfrm>
           <a:prstGeom prst="roundRect">
             <a:avLst>
-              <a:gd name="adj" fmla="val 2105"/>
+              <a:gd name="adj" fmla="val 2667"/>
             </a:avLst>
           </a:prstGeom>
           <a:solidFill>
@@ -5583,13 +6117,13 @@
       </p:sp>
       <p:sp>
         <p:nvSpPr>
-          <p:cNvPr id="9" name="Text 7"/>
-          <p:cNvSpPr/>
-          <p:nvPr/>
-        </p:nvSpPr>
-        <p:spPr>
-          <a:xfrm>
-            <a:off x="6543904" y="1810512"/>
+          <p:cNvPr id="20" name="Text 18"/>
+          <p:cNvSpPr/>
+          <p:nvPr/>
+        </p:nvSpPr>
+        <p:spPr>
+          <a:xfrm>
+            <a:off x="6543904" y="3136392"/>
             <a:ext cx="4861408" cy="365760"/>
           </a:xfrm>
           <a:prstGeom prst="rect">
@@ -5608,13 +6142,13 @@
             <a:r>
               <a:rPr lang="en-US" sz="1500" b="1" dirty="0">
                 <a:solidFill>
-                  <a:srgbClr val="0B5FA5"/>
-                </a:solidFill>
-                <a:latin typeface="Segoe UI" pitchFamily="34" charset="0"/>
-                <a:ea typeface="Segoe UI" pitchFamily="34" charset="-122"/>
-                <a:cs typeface="Segoe UI" pitchFamily="34" charset="-120"/>
-              </a:rPr>
-              <a:t>We still decide</a:t>
+                  <a:srgbClr val="15803D"/>
+                </a:solidFill>
+                <a:latin typeface="Segoe UI" pitchFamily="34" charset="0"/>
+                <a:ea typeface="Segoe UI" pitchFamily="34" charset="-122"/>
+                <a:cs typeface="Segoe UI" pitchFamily="34" charset="-120"/>
+              </a:rPr>
+              <a:t>What actually happened</a:t>
             </a:r>
             <a:endParaRPr lang="en-US" sz="1500" dirty="0"/>
           </a:p>
@@ -5622,14 +6156,14 @@
       </p:sp>
       <p:sp>
         <p:nvSpPr>
-          <p:cNvPr id="10" name="Text 8"/>
-          <p:cNvSpPr/>
-          <p:nvPr/>
-        </p:nvSpPr>
-        <p:spPr>
-          <a:xfrm>
-            <a:off x="6543904" y="2231136"/>
-            <a:ext cx="4861408" cy="2651760"/>
+          <p:cNvPr id="21" name="Text 19"/>
+          <p:cNvSpPr/>
+          <p:nvPr/>
+        </p:nvSpPr>
+        <p:spPr>
+          <a:xfrm>
+            <a:off x="6543904" y="3557016"/>
+            <a:ext cx="4861408" cy="1920240"/>
           </a:xfrm>
           <a:prstGeom prst="rect">
             <a:avLst/>
@@ -5657,7 +6191,7 @@
                 <a:ea typeface="Segoe UI" pitchFamily="34" charset="-122"/>
                 <a:cs typeface="Segoe UI" pitchFamily="34" charset="-120"/>
               </a:rPr>
-              <a:t>Which journeys matter enough to automate</a:t>
+              <a:t>It walked all 15 programs and their tiers in one run</a:t>
             </a:r>
             <a:endParaRPr lang="en-US" sz="1300" dirty="0"/>
           </a:p>
@@ -5678,7 +6212,7 @@
                 <a:ea typeface="Segoe UI" pitchFamily="34" charset="-122"/>
                 <a:cs typeface="Segoe UI" pitchFamily="34" charset="-120"/>
               </a:rPr>
-              <a:t>What counts as acceptable test data on a shared environment</a:t>
+              <a:t>It reported exactly which ones have a privilege attached:</a:t>
             </a:r>
             <a:endParaRPr lang="en-US" sz="1300" dirty="0"/>
           </a:p>
@@ -5699,7 +6233,7 @@
                 <a:ea typeface="Segoe UI" pitchFamily="34" charset="-122"/>
                 <a:cs typeface="Segoe UI" pitchFamily="34" charset="-120"/>
               </a:rPr>
-              <a:t>Whether a failure is a test bug or a product bug</a:t>
+              <a:t>HOT UAT Program  ·  Meo Roadside program</a:t>
             </a:r>
             <a:endParaRPr lang="en-US" sz="1300" dirty="0"/>
           </a:p>
@@ -5720,7 +6254,7 @@
                 <a:ea typeface="Segoe UI" pitchFamily="34" charset="-122"/>
                 <a:cs typeface="Segoe UI" pitchFamily="34" charset="-120"/>
               </a:rPr>
-              <a:t>What may touch production, and what may never</a:t>
+              <a:t>Vit roadside program  ·  Duck program</a:t>
             </a:r>
             <a:endParaRPr lang="en-US" sz="1300" dirty="0"/>
           </a:p>
@@ -5741,7 +6275,7 @@
                 <a:ea typeface="Segoe UI" pitchFamily="34" charset="-122"/>
                 <a:cs typeface="Segoe UI" pitchFamily="34" charset="-120"/>
               </a:rPr>
-              <a:t>Review before anything is merged - same PR bar as any code</a:t>
+              <a:t>The test now selects a program by name, so a different environment does not break it</a:t>
             </a:r>
             <a:endParaRPr lang="en-US" sz="1300" dirty="0"/>
           </a:p>
@@ -5749,13 +6283,13 @@
       </p:sp>
       <p:sp>
         <p:nvSpPr>
-          <p:cNvPr id="11" name="Text 9"/>
-          <p:cNvSpPr/>
-          <p:nvPr/>
-        </p:nvSpPr>
-        <p:spPr>
-          <a:xfrm>
-            <a:off x="566928" y="5760720"/>
+          <p:cNvPr id="22" name="Text 20"/>
+          <p:cNvSpPr/>
+          <p:nvPr/>
+        </p:nvSpPr>
+        <p:spPr>
+          <a:xfrm>
+            <a:off x="566928" y="6035040"/>
             <a:ext cx="11057839" cy="365760"/>
           </a:xfrm>
           <a:prstGeom prst="rect">
@@ -5780,7 +6314,7 @@
                 <a:ea typeface="Segoe UI" pitchFamily="34" charset="-122"/>
                 <a:cs typeface="Segoe UI" pitchFamily="34" charset="-120"/>
               </a:rPr>
-              <a:t>The workshop point: the cost of an automated check has dropped far enough that "we do not have time to automate it" is no longer the real constraint.</a:t>
+              <a:t>"Which programs can actually create a job on UAT?" had no answer anywhere - not in a document, not in the code. Now it does, and it took one run to get it.</a:t>
             </a:r>
             <a:endParaRPr lang="en-US" sz="1300" dirty="0"/>
           </a:p>
@@ -5851,7 +6385,7 @@
                 <a:ea typeface="Segoe UI" pitchFamily="34" charset="-122"/>
                 <a:cs typeface="Segoe UI" pitchFamily="34" charset="-120"/>
               </a:rPr>
-              <a:t>Running it in CI</a:t>
+              <a:t>Where the human time still goes</a:t>
             </a:r>
             <a:endParaRPr lang="en-US" sz="2600" dirty="0"/>
           </a:p>
@@ -5890,7 +6424,7 @@
                 <a:ea typeface="Segoe UI" pitchFamily="34" charset="-122"/>
                 <a:cs typeface="Segoe UI" pitchFamily="34" charset="-120"/>
               </a:rPr>
-              <a:t>The same command a developer runs is the command the pipeline runs</a:t>
+              <a:t>The agent is fast at the mechanical work; judgement stays with us</a:t>
             </a:r>
             <a:endParaRPr lang="en-US" sz="1400" dirty="0"/>
           </a:p>
@@ -5925,19 +6459,19 @@
         <p:spPr>
           <a:xfrm>
             <a:off x="566928" y="1627632"/>
-            <a:ext cx="11057839" cy="2011680"/>
+            <a:ext cx="5300320" cy="3474720"/>
           </a:xfrm>
           <a:prstGeom prst="roundRect">
             <a:avLst>
-              <a:gd name="adj" fmla="val 2727"/>
+              <a:gd name="adj" fmla="val 2105"/>
             </a:avLst>
           </a:prstGeom>
           <a:solidFill>
-            <a:srgbClr val="1E1E24"/>
+            <a:srgbClr val="F6F7F9"/>
           </a:solidFill>
           <a:ln w="12700">
             <a:solidFill>
-              <a:srgbClr val="1E1E24"/>
+              <a:srgbClr val="D9D9DE"/>
             </a:solidFill>
             <a:prstDash val="solid"/>
           </a:ln>
@@ -5951,8 +6485,8 @@
         </p:nvSpPr>
         <p:spPr>
           <a:xfrm>
-            <a:off x="768096" y="1773936"/>
-            <a:ext cx="10655503" cy="1719072"/>
+            <a:off x="786384" y="1810512"/>
+            <a:ext cx="4861408" cy="365760"/>
           </a:xfrm>
           <a:prstGeom prst="rect">
             <a:avLst/>
@@ -5961,249 +6495,383 @@
           <a:ln/>
         </p:spPr>
         <p:txBody>
+          <a:bodyPr wrap="square" rtlCol="0" anchor="ctr"/>
+          <a:lstStyle/>
+          <a:p>
+            <a:pPr indent="0" marL="0">
+              <a:buNone/>
+            </a:pPr>
+            <a:r>
+              <a:rPr lang="en-US" sz="1500" b="1" dirty="0">
+                <a:solidFill>
+                  <a:srgbClr val="15803D"/>
+                </a:solidFill>
+                <a:latin typeface="Segoe UI" pitchFamily="34" charset="0"/>
+                <a:ea typeface="Segoe UI" pitchFamily="34" charset="-122"/>
+                <a:cs typeface="Segoe UI" pitchFamily="34" charset="-120"/>
+              </a:rPr>
+              <a:t>The agent is good at</a:t>
+            </a:r>
+            <a:endParaRPr lang="en-US" sz="1500" dirty="0"/>
+          </a:p>
+        </p:txBody>
+      </p:sp>
+      <p:sp>
+        <p:nvSpPr>
+          <p:cNvPr id="7" name="Text 5"/>
+          <p:cNvSpPr/>
+          <p:nvPr/>
+        </p:nvSpPr>
+        <p:spPr>
+          <a:xfrm>
+            <a:off x="786384" y="2231136"/>
+            <a:ext cx="4861408" cy="2651760"/>
+          </a:xfrm>
+          <a:prstGeom prst="rect">
+            <a:avLst/>
+          </a:prstGeom>
+          <a:noFill/>
+          <a:ln/>
+        </p:spPr>
+        <p:txBody>
           <a:bodyPr wrap="square" rtlCol="0" anchor="t"/>
           <a:lstStyle/>
           <a:p>
-            <a:pPr indent="0" marL="0">
-              <a:lnSpc>
-                <a:spcPct val="112000"/>
-              </a:lnSpc>
-              <a:buNone/>
-            </a:pPr>
-            <a:r>
-              <a:rPr lang="en-US" sz="1150" dirty="0">
-                <a:solidFill>
-                  <a:srgbClr val="E8E8EC"/>
-                </a:solidFill>
-                <a:latin typeface="Consolas" pitchFamily="34" charset="0"/>
-                <a:ea typeface="Consolas" pitchFamily="34" charset="-122"/>
-                <a:cs typeface="Consolas" pitchFamily="34" charset="-120"/>
-              </a:rPr>
-              <a:t># any CI runner - CodeBuild, Bitbucket Pipelines, GitHub Actions</a:t>
-            </a:r>
-            <a:endParaRPr lang="en-US" sz="1150" dirty="0"/>
-          </a:p>
-          <a:p>
-            <a:pPr indent="0" marL="0">
-              <a:lnSpc>
-                <a:spcPct val="112000"/>
-              </a:lnSpc>
-              <a:buNone/>
-            </a:pPr>
-            <a:r>
-              <a:rPr lang="en-US" sz="1150" dirty="0">
-                <a:solidFill>
-                  <a:srgbClr val="E8E8EC"/>
-                </a:solidFill>
-                <a:latin typeface="Consolas" pitchFamily="34" charset="0"/>
-                <a:ea typeface="Consolas" pitchFamily="34" charset="-122"/>
-                <a:cs typeface="Consolas" pitchFamily="34" charset="-120"/>
-              </a:rPr>
-              <a:t>npm ci</a:t>
-            </a:r>
-            <a:endParaRPr lang="en-US" sz="1150" dirty="0"/>
-          </a:p>
-          <a:p>
-            <a:pPr indent="0" marL="0">
-              <a:lnSpc>
-                <a:spcPct val="112000"/>
-              </a:lnSpc>
-              <a:buNone/>
-            </a:pPr>
-            <a:r>
-              <a:rPr lang="en-US" sz="1150" dirty="0">
-                <a:solidFill>
-                  <a:srgbClr val="E8E8EC"/>
-                </a:solidFill>
-                <a:latin typeface="Consolas" pitchFamily="34" charset="0"/>
-                <a:ea typeface="Consolas" pitchFamily="34" charset="-122"/>
-                <a:cs typeface="Consolas" pitchFamily="34" charset="-120"/>
-              </a:rPr>
-              <a:t>npx playwright install --with-deps chromium</a:t>
-            </a:r>
-            <a:endParaRPr lang="en-US" sz="1150" dirty="0"/>
-          </a:p>
-          <a:p>
-            <a:pPr indent="0" marL="0">
-              <a:lnSpc>
-                <a:spcPct val="112000"/>
-              </a:lnSpc>
-              <a:buNone/>
-            </a:pPr>
-            <a:r>
-              <a:rPr lang="en-US" sz="1150" dirty="0">
-                <a:solidFill>
-                  <a:srgbClr val="E8E8EC"/>
-                </a:solidFill>
-                <a:latin typeface="Consolas" pitchFamily="34" charset="0"/>
-                <a:ea typeface="Consolas" pitchFamily="34" charset="-122"/>
-                <a:cs typeface="Consolas" pitchFamily="34" charset="-120"/>
-              </a:rPr>
-              <a:t>npm test                       # retries once on CI, serial, ~1 minute</a:t>
-            </a:r>
-            <a:endParaRPr lang="en-US" sz="1150" dirty="0"/>
-          </a:p>
-          <a:p>
-            <a:pPr indent="0" marL="0">
-              <a:lnSpc>
-                <a:spcPct val="112000"/>
-              </a:lnSpc>
-              <a:buNone/>
-            </a:pPr>
-            <a:endParaRPr lang="en-US" sz="1150" dirty="0"/>
-          </a:p>
-          <a:p>
-            <a:pPr indent="0" marL="0">
-              <a:lnSpc>
-                <a:spcPct val="112000"/>
-              </a:lnSpc>
-              <a:buNone/>
-            </a:pPr>
-            <a:r>
-              <a:rPr lang="en-US" sz="1150" dirty="0">
-                <a:solidFill>
-                  <a:srgbClr val="E8E8EC"/>
-                </a:solidFill>
-                <a:latin typeface="Consolas" pitchFamily="34" charset="0"/>
-                <a:ea typeface="Consolas" pitchFamily="34" charset="-122"/>
-                <a:cs typeface="Consolas" pitchFamily="34" charset="-120"/>
-              </a:rPr>
-              <a:t># artefacts to keep: playwright-report/  reports/junit.xml</a:t>
-            </a:r>
-            <a:endParaRPr lang="en-US" sz="1150" dirty="0"/>
-          </a:p>
-        </p:txBody>
-      </p:sp>
-      <p:sp>
-        <p:nvSpPr>
-          <p:cNvPr id="7" name="Text 5"/>
-          <p:cNvSpPr/>
-          <p:nvPr/>
-        </p:nvSpPr>
-        <p:spPr>
-          <a:xfrm>
-            <a:off x="566928" y="3694176"/>
-            <a:ext cx="11057839" cy="274320"/>
-          </a:xfrm>
-          <a:prstGeom prst="rect">
-            <a:avLst/>
-          </a:prstGeom>
-          <a:noFill/>
-          <a:ln/>
-        </p:spPr>
-        <p:txBody>
-          <a:bodyPr wrap="square" rtlCol="0" anchor="ctr"/>
-          <a:lstStyle/>
-          <a:p>
-            <a:pPr indent="0" marL="0">
-              <a:buNone/>
-            </a:pPr>
-            <a:r>
-              <a:rPr lang="en-US" sz="1100" i="1" dirty="0">
-                <a:solidFill>
-                  <a:srgbClr val="71717A"/>
-                </a:solidFill>
-                <a:latin typeface="Segoe UI" pitchFamily="34" charset="0"/>
-                <a:ea typeface="Segoe UI" pitchFamily="34" charset="-122"/>
-                <a:cs typeface="Segoe UI" pitchFamily="34" charset="-120"/>
-              </a:rPr>
-              <a:t>JUnit XML is what a CI dashboard reads; the HTML report is what a human opens.</a:t>
-            </a:r>
-            <a:endParaRPr lang="en-US" sz="1100" dirty="0"/>
-          </a:p>
-        </p:txBody>
-      </p:sp>
-      <p:sp>
-        <p:nvSpPr>
-          <p:cNvPr id="8" name="Text 6"/>
-          <p:cNvSpPr/>
-          <p:nvPr/>
-        </p:nvSpPr>
-        <p:spPr>
-          <a:xfrm>
-            <a:off x="566928" y="4142232"/>
-            <a:ext cx="11057839" cy="4023360"/>
-          </a:xfrm>
-          <a:prstGeom prst="rect">
-            <a:avLst/>
-          </a:prstGeom>
-          <a:noFill/>
-          <a:ln/>
-        </p:spPr>
-        <p:txBody>
-          <a:bodyPr wrap="square" rtlCol="0" anchor="t"/>
-          <a:lstStyle/>
-          <a:p>
             <a:pPr marL="342900" indent="-342900">
-              <a:lnSpc>
-                <a:spcPct val="115000"/>
-              </a:lnSpc>
               <a:spcAft>
-                <a:spcPts val="1000"/>
+                <a:spcPts val="700"/>
               </a:spcAft>
               <a:buSzPct val="100000"/>
               <a:buChar char="•"/>
             </a:pPr>
             <a:r>
-              <a:rPr lang="en-US" sz="1450" dirty="0">
-                <a:solidFill>
-                  <a:srgbClr val="1A1A1E"/>
-                </a:solidFill>
-                <a:latin typeface="Segoe UI" pitchFamily="34" charset="0"/>
-                <a:ea typeface="Segoe UI" pitchFamily="34" charset="-122"/>
-                <a:cs typeface="Segoe UI" pitchFamily="34" charset="-120"/>
-              </a:rPr>
-              <a:t>Run on every pull request against the target branch, and nightly against UAT</a:t>
-            </a:r>
-            <a:endParaRPr lang="en-US" sz="1450" dirty="0"/>
+              <a:rPr lang="en-US" sz="1300" dirty="0">
+                <a:solidFill>
+                  <a:srgbClr val="3F3F46"/>
+                </a:solidFill>
+                <a:latin typeface="Segoe UI" pitchFamily="34" charset="0"/>
+                <a:ea typeface="Segoe UI" pitchFamily="34" charset="-122"/>
+                <a:cs typeface="Segoe UI" pitchFamily="34" charset="-120"/>
+              </a:rPr>
+              <a:t>Reading the application to find real selectors</a:t>
+            </a:r>
+            <a:endParaRPr lang="en-US" sz="1300" dirty="0"/>
           </a:p>
           <a:p>
             <a:pPr marL="342900" indent="-342900">
-              <a:lnSpc>
-                <a:spcPct val="115000"/>
-              </a:lnSpc>
               <a:spcAft>
-                <a:spcPts val="1000"/>
+                <a:spcPts val="700"/>
               </a:spcAft>
               <a:buSzPct val="100000"/>
               <a:buChar char="•"/>
             </a:pPr>
             <a:r>
-              <a:rPr lang="en-US" sz="1450" dirty="0">
-                <a:solidFill>
-                  <a:srgbClr val="1A1A1E"/>
-                </a:solidFill>
-                <a:latin typeface="Segoe UI" pitchFamily="34" charset="0"/>
-                <a:ea typeface="Segoe UI" pitchFamily="34" charset="-122"/>
-                <a:cs typeface="Segoe UI" pitchFamily="34" charset="-120"/>
-              </a:rPr>
-              <a:t>A red suite blocks the merge - that is the whole point of the investment</a:t>
-            </a:r>
-            <a:endParaRPr lang="en-US" sz="1450" dirty="0"/>
+              <a:rPr lang="en-US" sz="1300" dirty="0">
+                <a:solidFill>
+                  <a:srgbClr val="3F3F46"/>
+                </a:solidFill>
+                <a:latin typeface="Segoe UI" pitchFamily="34" charset="0"/>
+                <a:ea typeface="Segoe UI" pitchFamily="34" charset="-122"/>
+                <a:cs typeface="Segoe UI" pitchFamily="34" charset="-120"/>
+              </a:rPr>
+              <a:t>Writing page objects and specs in a consistent shape</a:t>
+            </a:r>
+            <a:endParaRPr lang="en-US" sz="1300" dirty="0"/>
           </a:p>
           <a:p>
             <a:pPr marL="342900" indent="-342900">
-              <a:lnSpc>
-                <a:spcPct val="115000"/>
-              </a:lnSpc>
               <a:spcAft>
-                <a:spcPts val="1000"/>
+                <a:spcPts val="700"/>
               </a:spcAft>
               <a:buSzPct val="100000"/>
               <a:buChar char="•"/>
             </a:pPr>
             <a:r>
-              <a:rPr lang="en-US" sz="1450" dirty="0">
-                <a:solidFill>
-                  <a:srgbClr val="1A1A1E"/>
-                </a:solidFill>
-                <a:latin typeface="Segoe UI" pitchFamily="34" charset="0"/>
-                <a:ea typeface="Segoe UI" pitchFamily="34" charset="-122"/>
-                <a:cs typeface="Segoe UI" pitchFamily="34" charset="-120"/>
-              </a:rPr>
-              <a:t>Still to arrange: CI credentials and a stable non-production account that does not rotate</a:t>
-            </a:r>
-            <a:endParaRPr lang="en-US" sz="1450" dirty="0"/>
+              <a:rPr lang="en-US" sz="1300" dirty="0">
+                <a:solidFill>
+                  <a:srgbClr val="3F3F46"/>
+                </a:solidFill>
+                <a:latin typeface="Segoe UI" pitchFamily="34" charset="0"/>
+                <a:ea typeface="Segoe UI" pitchFamily="34" charset="-122"/>
+                <a:cs typeface="Segoe UI" pitchFamily="34" charset="-120"/>
+              </a:rPr>
+              <a:t>Running, reading the failure, fixing, re-running</a:t>
+            </a:r>
+            <a:endParaRPr lang="en-US" sz="1300" dirty="0"/>
+          </a:p>
+          <a:p>
+            <a:pPr marL="342900" indent="-342900">
+              <a:spcAft>
+                <a:spcPts val="700"/>
+              </a:spcAft>
+              <a:buSzPct val="100000"/>
+              <a:buChar char="•"/>
+            </a:pPr>
+            <a:r>
+              <a:rPr lang="en-US" sz="1300" dirty="0">
+                <a:solidFill>
+                  <a:srgbClr val="3F3F46"/>
+                </a:solidFill>
+                <a:latin typeface="Segoe UI" pitchFamily="34" charset="0"/>
+                <a:ea typeface="Segoe UI" pitchFamily="34" charset="-122"/>
+                <a:cs typeface="Segoe UI" pitchFamily="34" charset="-120"/>
+              </a:rPr>
+              <a:t>Probing the environment to answer factual questions</a:t>
+            </a:r>
+            <a:endParaRPr lang="en-US" sz="1300" dirty="0"/>
+          </a:p>
+          <a:p>
+            <a:pPr marL="342900" indent="-342900">
+              <a:spcAft>
+                <a:spcPts val="700"/>
+              </a:spcAft>
+              <a:buSzPct val="100000"/>
+              <a:buChar char="•"/>
+            </a:pPr>
+            <a:r>
+              <a:rPr lang="en-US" sz="1300" dirty="0">
+                <a:solidFill>
+                  <a:srgbClr val="3F3F46"/>
+                </a:solidFill>
+                <a:latin typeface="Segoe UI" pitchFamily="34" charset="0"/>
+                <a:ea typeface="Segoe UI" pitchFamily="34" charset="-122"/>
+                <a:cs typeface="Segoe UI" pitchFamily="34" charset="-120"/>
+              </a:rPr>
+              <a:t>Writing down what it learned so it is not lost</a:t>
+            </a:r>
+            <a:endParaRPr lang="en-US" sz="1300" dirty="0"/>
+          </a:p>
+        </p:txBody>
+      </p:sp>
+      <p:sp>
+        <p:nvSpPr>
+          <p:cNvPr id="8" name="Shape 6"/>
+          <p:cNvSpPr/>
+          <p:nvPr/>
+        </p:nvSpPr>
+        <p:spPr>
+          <a:xfrm>
+            <a:off x="6324448" y="1627632"/>
+            <a:ext cx="5300320" cy="3474720"/>
+          </a:xfrm>
+          <a:prstGeom prst="roundRect">
+            <a:avLst>
+              <a:gd name="adj" fmla="val 2105"/>
+            </a:avLst>
+          </a:prstGeom>
+          <a:solidFill>
+            <a:srgbClr val="F6F7F9"/>
+          </a:solidFill>
+          <a:ln w="12700">
+            <a:solidFill>
+              <a:srgbClr val="D9D9DE"/>
+            </a:solidFill>
+            <a:prstDash val="solid"/>
+          </a:ln>
+        </p:spPr>
+      </p:sp>
+      <p:sp>
+        <p:nvSpPr>
+          <p:cNvPr id="9" name="Text 7"/>
+          <p:cNvSpPr/>
+          <p:nvPr/>
+        </p:nvSpPr>
+        <p:spPr>
+          <a:xfrm>
+            <a:off x="6543904" y="1810512"/>
+            <a:ext cx="4861408" cy="365760"/>
+          </a:xfrm>
+          <a:prstGeom prst="rect">
+            <a:avLst/>
+          </a:prstGeom>
+          <a:noFill/>
+          <a:ln/>
+        </p:spPr>
+        <p:txBody>
+          <a:bodyPr wrap="square" rtlCol="0" anchor="ctr"/>
+          <a:lstStyle/>
+          <a:p>
+            <a:pPr indent="0" marL="0">
+              <a:buNone/>
+            </a:pPr>
+            <a:r>
+              <a:rPr lang="en-US" sz="1500" b="1" dirty="0">
+                <a:solidFill>
+                  <a:srgbClr val="0B5FA5"/>
+                </a:solidFill>
+                <a:latin typeface="Segoe UI" pitchFamily="34" charset="0"/>
+                <a:ea typeface="Segoe UI" pitchFamily="34" charset="-122"/>
+                <a:cs typeface="Segoe UI" pitchFamily="34" charset="-120"/>
+              </a:rPr>
+              <a:t>We still decide</a:t>
+            </a:r>
+            <a:endParaRPr lang="en-US" sz="1500" dirty="0"/>
+          </a:p>
+        </p:txBody>
+      </p:sp>
+      <p:sp>
+        <p:nvSpPr>
+          <p:cNvPr id="10" name="Text 8"/>
+          <p:cNvSpPr/>
+          <p:nvPr/>
+        </p:nvSpPr>
+        <p:spPr>
+          <a:xfrm>
+            <a:off x="6543904" y="2231136"/>
+            <a:ext cx="4861408" cy="2651760"/>
+          </a:xfrm>
+          <a:prstGeom prst="rect">
+            <a:avLst/>
+          </a:prstGeom>
+          <a:noFill/>
+          <a:ln/>
+        </p:spPr>
+        <p:txBody>
+          <a:bodyPr wrap="square" rtlCol="0" anchor="t"/>
+          <a:lstStyle/>
+          <a:p>
+            <a:pPr marL="342900" indent="-342900">
+              <a:spcAft>
+                <a:spcPts val="700"/>
+              </a:spcAft>
+              <a:buSzPct val="100000"/>
+              <a:buChar char="•"/>
+            </a:pPr>
+            <a:r>
+              <a:rPr lang="en-US" sz="1300" dirty="0">
+                <a:solidFill>
+                  <a:srgbClr val="3F3F46"/>
+                </a:solidFill>
+                <a:latin typeface="Segoe UI" pitchFamily="34" charset="0"/>
+                <a:ea typeface="Segoe UI" pitchFamily="34" charset="-122"/>
+                <a:cs typeface="Segoe UI" pitchFamily="34" charset="-120"/>
+              </a:rPr>
+              <a:t>Which journeys matter enough to automate</a:t>
+            </a:r>
+            <a:endParaRPr lang="en-US" sz="1300" dirty="0"/>
+          </a:p>
+          <a:p>
+            <a:pPr marL="342900" indent="-342900">
+              <a:spcAft>
+                <a:spcPts val="700"/>
+              </a:spcAft>
+              <a:buSzPct val="100000"/>
+              <a:buChar char="•"/>
+            </a:pPr>
+            <a:r>
+              <a:rPr lang="en-US" sz="1300" dirty="0">
+                <a:solidFill>
+                  <a:srgbClr val="3F3F46"/>
+                </a:solidFill>
+                <a:latin typeface="Segoe UI" pitchFamily="34" charset="0"/>
+                <a:ea typeface="Segoe UI" pitchFamily="34" charset="-122"/>
+                <a:cs typeface="Segoe UI" pitchFamily="34" charset="-120"/>
+              </a:rPr>
+              <a:t>What counts as acceptable test data on a shared environment</a:t>
+            </a:r>
+            <a:endParaRPr lang="en-US" sz="1300" dirty="0"/>
+          </a:p>
+          <a:p>
+            <a:pPr marL="342900" indent="-342900">
+              <a:spcAft>
+                <a:spcPts val="700"/>
+              </a:spcAft>
+              <a:buSzPct val="100000"/>
+              <a:buChar char="•"/>
+            </a:pPr>
+            <a:r>
+              <a:rPr lang="en-US" sz="1300" dirty="0">
+                <a:solidFill>
+                  <a:srgbClr val="3F3F46"/>
+                </a:solidFill>
+                <a:latin typeface="Segoe UI" pitchFamily="34" charset="0"/>
+                <a:ea typeface="Segoe UI" pitchFamily="34" charset="-122"/>
+                <a:cs typeface="Segoe UI" pitchFamily="34" charset="-120"/>
+              </a:rPr>
+              <a:t>Whether a failure is a test bug or a product bug</a:t>
+            </a:r>
+            <a:endParaRPr lang="en-US" sz="1300" dirty="0"/>
+          </a:p>
+          <a:p>
+            <a:pPr marL="342900" indent="-342900">
+              <a:spcAft>
+                <a:spcPts val="700"/>
+              </a:spcAft>
+              <a:buSzPct val="100000"/>
+              <a:buChar char="•"/>
+            </a:pPr>
+            <a:r>
+              <a:rPr lang="en-US" sz="1300" dirty="0">
+                <a:solidFill>
+                  <a:srgbClr val="3F3F46"/>
+                </a:solidFill>
+                <a:latin typeface="Segoe UI" pitchFamily="34" charset="0"/>
+                <a:ea typeface="Segoe UI" pitchFamily="34" charset="-122"/>
+                <a:cs typeface="Segoe UI" pitchFamily="34" charset="-120"/>
+              </a:rPr>
+              <a:t>What may touch production, and what may never</a:t>
+            </a:r>
+            <a:endParaRPr lang="en-US" sz="1300" dirty="0"/>
+          </a:p>
+          <a:p>
+            <a:pPr marL="342900" indent="-342900">
+              <a:spcAft>
+                <a:spcPts val="700"/>
+              </a:spcAft>
+              <a:buSzPct val="100000"/>
+              <a:buChar char="•"/>
+            </a:pPr>
+            <a:r>
+              <a:rPr lang="en-US" sz="1300" dirty="0">
+                <a:solidFill>
+                  <a:srgbClr val="3F3F46"/>
+                </a:solidFill>
+                <a:latin typeface="Segoe UI" pitchFamily="34" charset="0"/>
+                <a:ea typeface="Segoe UI" pitchFamily="34" charset="-122"/>
+                <a:cs typeface="Segoe UI" pitchFamily="34" charset="-120"/>
+              </a:rPr>
+              <a:t>Review before anything is merged - same PR bar as any code</a:t>
+            </a:r>
+            <a:endParaRPr lang="en-US" sz="1300" dirty="0"/>
+          </a:p>
+        </p:txBody>
+      </p:sp>
+      <p:sp>
+        <p:nvSpPr>
+          <p:cNvPr id="11" name="Text 9"/>
+          <p:cNvSpPr/>
+          <p:nvPr/>
+        </p:nvSpPr>
+        <p:spPr>
+          <a:xfrm>
+            <a:off x="566928" y="5760720"/>
+            <a:ext cx="11057839" cy="365760"/>
+          </a:xfrm>
+          <a:prstGeom prst="rect">
+            <a:avLst/>
+          </a:prstGeom>
+          <a:noFill/>
+          <a:ln/>
+        </p:spPr>
+        <p:txBody>
+          <a:bodyPr wrap="square" rtlCol="0" anchor="ctr"/>
+          <a:lstStyle/>
+          <a:p>
+            <a:pPr indent="0" marL="0">
+              <a:buNone/>
+            </a:pPr>
+            <a:r>
+              <a:rPr lang="en-US" sz="1300" i="1" dirty="0">
+                <a:solidFill>
+                  <a:srgbClr val="71717A"/>
+                </a:solidFill>
+                <a:latin typeface="Segoe UI" pitchFamily="34" charset="0"/>
+                <a:ea typeface="Segoe UI" pitchFamily="34" charset="-122"/>
+                <a:cs typeface="Segoe UI" pitchFamily="34" charset="-120"/>
+              </a:rPr>
+              <a:t>The workshop point: the cost of an automated check has dropped far enough that "we do not have time to automate it" is no longer the real constraint.</a:t>
+            </a:r>
+            <a:endParaRPr lang="en-US" sz="1300" dirty="0"/>
           </a:p>
         </p:txBody>
       </p:sp>
@@ -6218,6 +6886,427 @@
 <file path=ppt/slides/slide15.xml><?xml version="1.0" encoding="utf-8"?>
 <p:sld xmlns:a="http://schemas.openxmlformats.org/drawingml/2006/main" xmlns:r="http://schemas.openxmlformats.org/officeDocument/2006/relationships" xmlns:p="http://schemas.openxmlformats.org/presentationml/2006/main">
   <p:cSld name="Slide 15">
+    <p:bg>
+      <p:bgPr>
+        <a:solidFill>
+          <a:srgbClr val="FFFFFF"/>
+        </a:solidFill>
+      </p:bgPr>
+    </p:bg>
+    <p:spTree>
+      <p:nvGrpSpPr>
+        <p:cNvPr id="1" name=""/>
+        <p:cNvGrpSpPr/>
+        <p:nvPr/>
+      </p:nvGrpSpPr>
+      <p:grpSpPr>
+        <a:xfrm>
+          <a:off x="0" y="0"/>
+          <a:ext cx="0" cy="0"/>
+          <a:chOff x="0" y="0"/>
+          <a:chExt cx="0" cy="0"/>
+        </a:xfrm>
+      </p:grpSpPr>
+      <p:sp>
+        <p:nvSpPr>
+          <p:cNvPr id="2" name="Text 0"/>
+          <p:cNvSpPr/>
+          <p:nvPr/>
+        </p:nvSpPr>
+        <p:spPr>
+          <a:xfrm>
+            <a:off x="566928" y="384048"/>
+            <a:ext cx="11057839" cy="548640"/>
+          </a:xfrm>
+          <a:prstGeom prst="rect">
+            <a:avLst/>
+          </a:prstGeom>
+          <a:noFill/>
+          <a:ln/>
+        </p:spPr>
+        <p:txBody>
+          <a:bodyPr wrap="square" rtlCol="0" anchor="ctr"/>
+          <a:lstStyle/>
+          <a:p>
+            <a:pPr indent="0" marL="0">
+              <a:buNone/>
+            </a:pPr>
+            <a:r>
+              <a:rPr lang="en-US" sz="2600" b="1" dirty="0">
+                <a:solidFill>
+                  <a:srgbClr val="1A1A1E"/>
+                </a:solidFill>
+                <a:latin typeface="Segoe UI" pitchFamily="34" charset="0"/>
+                <a:ea typeface="Segoe UI" pitchFamily="34" charset="-122"/>
+                <a:cs typeface="Segoe UI" pitchFamily="34" charset="-120"/>
+              </a:rPr>
+              <a:t>Running it in CI</a:t>
+            </a:r>
+            <a:endParaRPr lang="en-US" sz="2600" dirty="0"/>
+          </a:p>
+        </p:txBody>
+      </p:sp>
+      <p:sp>
+        <p:nvSpPr>
+          <p:cNvPr id="3" name="Text 1"/>
+          <p:cNvSpPr/>
+          <p:nvPr/>
+        </p:nvSpPr>
+        <p:spPr>
+          <a:xfrm>
+            <a:off x="566928" y="932688"/>
+            <a:ext cx="11057839" cy="365760"/>
+          </a:xfrm>
+          <a:prstGeom prst="rect">
+            <a:avLst/>
+          </a:prstGeom>
+          <a:noFill/>
+          <a:ln/>
+        </p:spPr>
+        <p:txBody>
+          <a:bodyPr wrap="square" rtlCol="0" anchor="ctr"/>
+          <a:lstStyle/>
+          <a:p>
+            <a:pPr indent="0" marL="0">
+              <a:buNone/>
+            </a:pPr>
+            <a:r>
+              <a:rPr lang="en-US" sz="1400" dirty="0">
+                <a:solidFill>
+                  <a:srgbClr val="71717A"/>
+                </a:solidFill>
+                <a:latin typeface="Segoe UI" pitchFamily="34" charset="0"/>
+                <a:ea typeface="Segoe UI" pitchFamily="34" charset="-122"/>
+                <a:cs typeface="Segoe UI" pitchFamily="34" charset="-120"/>
+              </a:rPr>
+              <a:t>The same command a developer runs is the command the pipeline runs</a:t>
+            </a:r>
+            <a:endParaRPr lang="en-US" sz="1400" dirty="0"/>
+          </a:p>
+        </p:txBody>
+      </p:sp>
+      <p:sp>
+        <p:nvSpPr>
+          <p:cNvPr id="4" name="Shape 2"/>
+          <p:cNvSpPr/>
+          <p:nvPr/>
+        </p:nvSpPr>
+        <p:spPr>
+          <a:xfrm>
+            <a:off x="566928" y="1371600"/>
+            <a:ext cx="11057839" cy="18288"/>
+          </a:xfrm>
+          <a:prstGeom prst="rect">
+            <a:avLst/>
+          </a:prstGeom>
+          <a:solidFill>
+            <a:srgbClr val="D9D9DE"/>
+          </a:solidFill>
+          <a:ln/>
+        </p:spPr>
+      </p:sp>
+      <p:sp>
+        <p:nvSpPr>
+          <p:cNvPr id="5" name="Shape 3"/>
+          <p:cNvSpPr/>
+          <p:nvPr/>
+        </p:nvSpPr>
+        <p:spPr>
+          <a:xfrm>
+            <a:off x="566928" y="1627632"/>
+            <a:ext cx="11057839" cy="2011680"/>
+          </a:xfrm>
+          <a:prstGeom prst="roundRect">
+            <a:avLst>
+              <a:gd name="adj" fmla="val 2727"/>
+            </a:avLst>
+          </a:prstGeom>
+          <a:solidFill>
+            <a:srgbClr val="1E1E24"/>
+          </a:solidFill>
+          <a:ln w="12700">
+            <a:solidFill>
+              <a:srgbClr val="1E1E24"/>
+            </a:solidFill>
+            <a:prstDash val="solid"/>
+          </a:ln>
+        </p:spPr>
+      </p:sp>
+      <p:sp>
+        <p:nvSpPr>
+          <p:cNvPr id="6" name="Text 4"/>
+          <p:cNvSpPr/>
+          <p:nvPr/>
+        </p:nvSpPr>
+        <p:spPr>
+          <a:xfrm>
+            <a:off x="768096" y="1773936"/>
+            <a:ext cx="10655503" cy="1719072"/>
+          </a:xfrm>
+          <a:prstGeom prst="rect">
+            <a:avLst/>
+          </a:prstGeom>
+          <a:noFill/>
+          <a:ln/>
+        </p:spPr>
+        <p:txBody>
+          <a:bodyPr wrap="square" rtlCol="0" anchor="t"/>
+          <a:lstStyle/>
+          <a:p>
+            <a:pPr indent="0" marL="0">
+              <a:lnSpc>
+                <a:spcPct val="112000"/>
+              </a:lnSpc>
+              <a:buNone/>
+            </a:pPr>
+            <a:r>
+              <a:rPr lang="en-US" sz="1150" dirty="0">
+                <a:solidFill>
+                  <a:srgbClr val="E8E8EC"/>
+                </a:solidFill>
+                <a:latin typeface="Consolas" pitchFamily="34" charset="0"/>
+                <a:ea typeface="Consolas" pitchFamily="34" charset="-122"/>
+                <a:cs typeface="Consolas" pitchFamily="34" charset="-120"/>
+              </a:rPr>
+              <a:t># any CI runner - CodeBuild, Bitbucket Pipelines, GitHub Actions</a:t>
+            </a:r>
+            <a:endParaRPr lang="en-US" sz="1150" dirty="0"/>
+          </a:p>
+          <a:p>
+            <a:pPr indent="0" marL="0">
+              <a:lnSpc>
+                <a:spcPct val="112000"/>
+              </a:lnSpc>
+              <a:buNone/>
+            </a:pPr>
+            <a:r>
+              <a:rPr lang="en-US" sz="1150" dirty="0">
+                <a:solidFill>
+                  <a:srgbClr val="E8E8EC"/>
+                </a:solidFill>
+                <a:latin typeface="Consolas" pitchFamily="34" charset="0"/>
+                <a:ea typeface="Consolas" pitchFamily="34" charset="-122"/>
+                <a:cs typeface="Consolas" pitchFamily="34" charset="-120"/>
+              </a:rPr>
+              <a:t>npm ci</a:t>
+            </a:r>
+            <a:endParaRPr lang="en-US" sz="1150" dirty="0"/>
+          </a:p>
+          <a:p>
+            <a:pPr indent="0" marL="0">
+              <a:lnSpc>
+                <a:spcPct val="112000"/>
+              </a:lnSpc>
+              <a:buNone/>
+            </a:pPr>
+            <a:r>
+              <a:rPr lang="en-US" sz="1150" dirty="0">
+                <a:solidFill>
+                  <a:srgbClr val="E8E8EC"/>
+                </a:solidFill>
+                <a:latin typeface="Consolas" pitchFamily="34" charset="0"/>
+                <a:ea typeface="Consolas" pitchFamily="34" charset="-122"/>
+                <a:cs typeface="Consolas" pitchFamily="34" charset="-120"/>
+              </a:rPr>
+              <a:t>npx playwright install --with-deps chromium</a:t>
+            </a:r>
+            <a:endParaRPr lang="en-US" sz="1150" dirty="0"/>
+          </a:p>
+          <a:p>
+            <a:pPr indent="0" marL="0">
+              <a:lnSpc>
+                <a:spcPct val="112000"/>
+              </a:lnSpc>
+              <a:buNone/>
+            </a:pPr>
+            <a:r>
+              <a:rPr lang="en-US" sz="1150" dirty="0">
+                <a:solidFill>
+                  <a:srgbClr val="E8E8EC"/>
+                </a:solidFill>
+                <a:latin typeface="Consolas" pitchFamily="34" charset="0"/>
+                <a:ea typeface="Consolas" pitchFamily="34" charset="-122"/>
+                <a:cs typeface="Consolas" pitchFamily="34" charset="-120"/>
+              </a:rPr>
+              <a:t>npm test                       # retries once on CI, serial, ~1 minute</a:t>
+            </a:r>
+            <a:endParaRPr lang="en-US" sz="1150" dirty="0"/>
+          </a:p>
+          <a:p>
+            <a:pPr indent="0" marL="0">
+              <a:lnSpc>
+                <a:spcPct val="112000"/>
+              </a:lnSpc>
+              <a:buNone/>
+            </a:pPr>
+            <a:endParaRPr lang="en-US" sz="1150" dirty="0"/>
+          </a:p>
+          <a:p>
+            <a:pPr indent="0" marL="0">
+              <a:lnSpc>
+                <a:spcPct val="112000"/>
+              </a:lnSpc>
+              <a:buNone/>
+            </a:pPr>
+            <a:r>
+              <a:rPr lang="en-US" sz="1150" dirty="0">
+                <a:solidFill>
+                  <a:srgbClr val="E8E8EC"/>
+                </a:solidFill>
+                <a:latin typeface="Consolas" pitchFamily="34" charset="0"/>
+                <a:ea typeface="Consolas" pitchFamily="34" charset="-122"/>
+                <a:cs typeface="Consolas" pitchFamily="34" charset="-120"/>
+              </a:rPr>
+              <a:t># artefacts to keep: playwright-report/  reports/junit.xml</a:t>
+            </a:r>
+            <a:endParaRPr lang="en-US" sz="1150" dirty="0"/>
+          </a:p>
+        </p:txBody>
+      </p:sp>
+      <p:sp>
+        <p:nvSpPr>
+          <p:cNvPr id="7" name="Text 5"/>
+          <p:cNvSpPr/>
+          <p:nvPr/>
+        </p:nvSpPr>
+        <p:spPr>
+          <a:xfrm>
+            <a:off x="566928" y="3694176"/>
+            <a:ext cx="11057839" cy="274320"/>
+          </a:xfrm>
+          <a:prstGeom prst="rect">
+            <a:avLst/>
+          </a:prstGeom>
+          <a:noFill/>
+          <a:ln/>
+        </p:spPr>
+        <p:txBody>
+          <a:bodyPr wrap="square" rtlCol="0" anchor="ctr"/>
+          <a:lstStyle/>
+          <a:p>
+            <a:pPr indent="0" marL="0">
+              <a:buNone/>
+            </a:pPr>
+            <a:r>
+              <a:rPr lang="en-US" sz="1100" i="1" dirty="0">
+                <a:solidFill>
+                  <a:srgbClr val="71717A"/>
+                </a:solidFill>
+                <a:latin typeface="Segoe UI" pitchFamily="34" charset="0"/>
+                <a:ea typeface="Segoe UI" pitchFamily="34" charset="-122"/>
+                <a:cs typeface="Segoe UI" pitchFamily="34" charset="-120"/>
+              </a:rPr>
+              <a:t>JUnit XML is what a CI dashboard reads; the HTML report is what a human opens.</a:t>
+            </a:r>
+            <a:endParaRPr lang="en-US" sz="1100" dirty="0"/>
+          </a:p>
+        </p:txBody>
+      </p:sp>
+      <p:sp>
+        <p:nvSpPr>
+          <p:cNvPr id="8" name="Text 6"/>
+          <p:cNvSpPr/>
+          <p:nvPr/>
+        </p:nvSpPr>
+        <p:spPr>
+          <a:xfrm>
+            <a:off x="566928" y="4142232"/>
+            <a:ext cx="11057839" cy="4023360"/>
+          </a:xfrm>
+          <a:prstGeom prst="rect">
+            <a:avLst/>
+          </a:prstGeom>
+          <a:noFill/>
+          <a:ln/>
+        </p:spPr>
+        <p:txBody>
+          <a:bodyPr wrap="square" rtlCol="0" anchor="t"/>
+          <a:lstStyle/>
+          <a:p>
+            <a:pPr marL="342900" indent="-342900">
+              <a:lnSpc>
+                <a:spcPct val="115000"/>
+              </a:lnSpc>
+              <a:spcAft>
+                <a:spcPts val="1000"/>
+              </a:spcAft>
+              <a:buSzPct val="100000"/>
+              <a:buChar char="•"/>
+            </a:pPr>
+            <a:r>
+              <a:rPr lang="en-US" sz="1450" dirty="0">
+                <a:solidFill>
+                  <a:srgbClr val="1A1A1E"/>
+                </a:solidFill>
+                <a:latin typeface="Segoe UI" pitchFamily="34" charset="0"/>
+                <a:ea typeface="Segoe UI" pitchFamily="34" charset="-122"/>
+                <a:cs typeface="Segoe UI" pitchFamily="34" charset="-120"/>
+              </a:rPr>
+              <a:t>Run on every pull request against the target branch, and nightly against UAT</a:t>
+            </a:r>
+            <a:endParaRPr lang="en-US" sz="1450" dirty="0"/>
+          </a:p>
+          <a:p>
+            <a:pPr marL="342900" indent="-342900">
+              <a:lnSpc>
+                <a:spcPct val="115000"/>
+              </a:lnSpc>
+              <a:spcAft>
+                <a:spcPts val="1000"/>
+              </a:spcAft>
+              <a:buSzPct val="100000"/>
+              <a:buChar char="•"/>
+            </a:pPr>
+            <a:r>
+              <a:rPr lang="en-US" sz="1450" dirty="0">
+                <a:solidFill>
+                  <a:srgbClr val="1A1A1E"/>
+                </a:solidFill>
+                <a:latin typeface="Segoe UI" pitchFamily="34" charset="0"/>
+                <a:ea typeface="Segoe UI" pitchFamily="34" charset="-122"/>
+                <a:cs typeface="Segoe UI" pitchFamily="34" charset="-120"/>
+              </a:rPr>
+              <a:t>A red suite blocks the merge - that is the whole point of the investment</a:t>
+            </a:r>
+            <a:endParaRPr lang="en-US" sz="1450" dirty="0"/>
+          </a:p>
+          <a:p>
+            <a:pPr marL="342900" indent="-342900">
+              <a:lnSpc>
+                <a:spcPct val="115000"/>
+              </a:lnSpc>
+              <a:spcAft>
+                <a:spcPts val="1000"/>
+              </a:spcAft>
+              <a:buSzPct val="100000"/>
+              <a:buChar char="•"/>
+            </a:pPr>
+            <a:r>
+              <a:rPr lang="en-US" sz="1450" dirty="0">
+                <a:solidFill>
+                  <a:srgbClr val="1A1A1E"/>
+                </a:solidFill>
+                <a:latin typeface="Segoe UI" pitchFamily="34" charset="0"/>
+                <a:ea typeface="Segoe UI" pitchFamily="34" charset="-122"/>
+                <a:cs typeface="Segoe UI" pitchFamily="34" charset="-120"/>
+              </a:rPr>
+              <a:t>Still to arrange: CI credentials and a stable non-production account that does not rotate</a:t>
+            </a:r>
+            <a:endParaRPr lang="en-US" sz="1450" dirty="0"/>
+          </a:p>
+        </p:txBody>
+      </p:sp>
+    </p:spTree>
+  </p:cSld>
+  <p:clrMapOvr>
+    <a:masterClrMapping/>
+  </p:clrMapOvr>
+</p:sld>
+</file>
+
+<file path=ppt/slides/slide16.xml><?xml version="1.0" encoding="utf-8"?>
+<p:sld xmlns:a="http://schemas.openxmlformats.org/drawingml/2006/main" xmlns:r="http://schemas.openxmlformats.org/officeDocument/2006/relationships" xmlns:p="http://schemas.openxmlformats.org/presentationml/2006/main">
+  <p:cSld name="Slide 16">
     <p:bg>
       <p:bgPr>
         <a:solidFill>

</xml_diff>

<commit_message>
Playwright deck: cut the AI section back to a demo lead-in
</commit_message>
<xml_diff>
--- a/presentations/Web_Test_Automation_Playwright.pptx
+++ b/presentations/Web_Test_Automation_Playwright.pptx
@@ -19,11 +19,9 @@
     <p:sldId id="267" r:id="rId13"/>
     <p:sldId id="268" r:id="rId14"/>
     <p:sldId id="269" r:id="rId15"/>
-    <p:sldId id="270" r:id="rId16"/>
-    <p:sldId id="271" r:id="rId17"/>
   </p:sldIdLst>
   <p:notesMasterIdLst>
-    <p:notesMasterId r:id="rId18"/>
+    <p:notesMasterId r:id="rId16"/>
   </p:notesMasterIdLst>
   <p:sldSz cx="12192000" cy="6858000"/>
   <p:notesSz cx="6858000" cy="12192000"/>
@@ -981,182 +979,6 @@
             <a:fld id="{F7021451-1387-4CA6-816F-3879F97B5CBC}" type="slidenum">
               <a:rPr lang="en-US"/>
               <a:t>14</a:t>
-            </a:fld>
-            <a:endParaRPr lang="en-US"/>
-          </a:p>
-        </p:txBody>
-      </p:sp>
-    </p:spTree>
-    <p:extLst>
-      <p:ext uri="{BB962C8B-B14F-4D97-AF65-F5344CB8AC3E}">
-        <p14:creationId xmlns:p14="http://schemas.microsoft.com/office/powerpoint/2010/main" val="1024086991"/>
-      </p:ext>
-    </p:extLst>
-  </p:cSld>
-  <p:clrMapOvr>
-    <a:masterClrMapping/>
-  </p:clrMapOvr>
-</p:notes>
-</file>
-
-<file path=ppt/notesSlides/notesSlide15.xml><?xml version="1.0" encoding="utf-8"?>
-<p:notes xmlns:a="http://schemas.openxmlformats.org/drawingml/2006/main" xmlns:r="http://schemas.openxmlformats.org/officeDocument/2006/relationships" xmlns:p="http://schemas.openxmlformats.org/presentationml/2006/main">
-  <p:cSld>
-    <p:spTree>
-      <p:nvGrpSpPr>
-        <p:cNvPr id="1" name=""/>
-        <p:cNvGrpSpPr/>
-        <p:nvPr/>
-      </p:nvGrpSpPr>
-      <p:grpSpPr>
-        <a:xfrm>
-          <a:off x="0" y="0"/>
-          <a:ext cx="0" cy="0"/>
-          <a:chOff x="0" y="0"/>
-          <a:chExt cx="0" cy="0"/>
-        </a:xfrm>
-      </p:grpSpPr>
-      <p:sp>
-        <p:nvSpPr>
-          <p:cNvPr id="2" name="Slide Image Placeholder 1"/>
-          <p:cNvSpPr>
-            <a:spLocks noGrp="1" noRot="1" noChangeAspect="1"/>
-          </p:cNvSpPr>
-          <p:nvPr>
-            <p:ph type="sldImg"/>
-          </p:nvPr>
-        </p:nvSpPr>
-        <p:spPr/>
-      </p:sp>
-      <p:sp>
-        <p:nvSpPr>
-          <p:cNvPr id="3" name="Notes Placeholder 2"/>
-          <p:cNvSpPr>
-            <a:spLocks noGrp="1"/>
-          </p:cNvSpPr>
-          <p:nvPr>
-            <p:ph type="body" idx="1"/>
-          </p:nvPr>
-        </p:nvSpPr>
-        <p:spPr/>
-        <p:txBody>
-          <a:bodyPr/>
-          <a:lstStyle/>
-          <a:p>
-            <a:r>
-              <a:rPr lang="en-US" dirty="0"/>
-              <a:t/>
-            </a:r>
-            <a:endParaRPr lang="en-US" dirty="0"/>
-          </a:p>
-        </p:txBody>
-      </p:sp>
-      <p:sp>
-        <p:nvSpPr>
-          <p:cNvPr id="4" name="Slide Number Placeholder 3"/>
-          <p:cNvSpPr>
-            <a:spLocks noGrp="1"/>
-          </p:cNvSpPr>
-          <p:nvPr>
-            <p:ph type="sldNum" sz="quarter" idx="10"/>
-          </p:nvPr>
-        </p:nvSpPr>
-        <p:spPr/>
-        <p:txBody>
-          <a:bodyPr/>
-          <a:lstStyle/>
-          <a:p>
-            <a:fld id="{F7021451-1387-4CA6-816F-3879F97B5CBC}" type="slidenum">
-              <a:rPr lang="en-US"/>
-              <a:t>15</a:t>
-            </a:fld>
-            <a:endParaRPr lang="en-US"/>
-          </a:p>
-        </p:txBody>
-      </p:sp>
-    </p:spTree>
-    <p:extLst>
-      <p:ext uri="{BB962C8B-B14F-4D97-AF65-F5344CB8AC3E}">
-        <p14:creationId xmlns:p14="http://schemas.microsoft.com/office/powerpoint/2010/main" val="1024086991"/>
-      </p:ext>
-    </p:extLst>
-  </p:cSld>
-  <p:clrMapOvr>
-    <a:masterClrMapping/>
-  </p:clrMapOvr>
-</p:notes>
-</file>
-
-<file path=ppt/notesSlides/notesSlide16.xml><?xml version="1.0" encoding="utf-8"?>
-<p:notes xmlns:a="http://schemas.openxmlformats.org/drawingml/2006/main" xmlns:r="http://schemas.openxmlformats.org/officeDocument/2006/relationships" xmlns:p="http://schemas.openxmlformats.org/presentationml/2006/main">
-  <p:cSld>
-    <p:spTree>
-      <p:nvGrpSpPr>
-        <p:cNvPr id="1" name=""/>
-        <p:cNvGrpSpPr/>
-        <p:nvPr/>
-      </p:nvGrpSpPr>
-      <p:grpSpPr>
-        <a:xfrm>
-          <a:off x="0" y="0"/>
-          <a:ext cx="0" cy="0"/>
-          <a:chOff x="0" y="0"/>
-          <a:chExt cx="0" cy="0"/>
-        </a:xfrm>
-      </p:grpSpPr>
-      <p:sp>
-        <p:nvSpPr>
-          <p:cNvPr id="2" name="Slide Image Placeholder 1"/>
-          <p:cNvSpPr>
-            <a:spLocks noGrp="1" noRot="1" noChangeAspect="1"/>
-          </p:cNvSpPr>
-          <p:nvPr>
-            <p:ph type="sldImg"/>
-          </p:nvPr>
-        </p:nvSpPr>
-        <p:spPr/>
-      </p:sp>
-      <p:sp>
-        <p:nvSpPr>
-          <p:cNvPr id="3" name="Notes Placeholder 2"/>
-          <p:cNvSpPr>
-            <a:spLocks noGrp="1"/>
-          </p:cNvSpPr>
-          <p:nvPr>
-            <p:ph type="body" idx="1"/>
-          </p:nvPr>
-        </p:nvSpPr>
-        <p:spPr/>
-        <p:txBody>
-          <a:bodyPr/>
-          <a:lstStyle/>
-          <a:p>
-            <a:r>
-              <a:rPr lang="en-US" dirty="0"/>
-              <a:t/>
-            </a:r>
-            <a:endParaRPr lang="en-US" dirty="0"/>
-          </a:p>
-        </p:txBody>
-      </p:sp>
-      <p:sp>
-        <p:nvSpPr>
-          <p:cNvPr id="4" name="Slide Number Placeholder 3"/>
-          <p:cNvSpPr>
-            <a:spLocks noGrp="1"/>
-          </p:cNvSpPr>
-          <p:nvPr>
-            <p:ph type="sldNum" sz="quarter" idx="10"/>
-          </p:nvPr>
-        </p:nvSpPr>
-        <p:spPr/>
-        <p:txBody>
-          <a:bodyPr/>
-          <a:lstStyle/>
-          <a:p>
-            <a:fld id="{F7021451-1387-4CA6-816F-3879F97B5CBC}" type="slidenum">
-              <a:rPr lang="en-US"/>
-              <a:t>16</a:t>
             </a:fld>
             <a:endParaRPr lang="en-US"/>
           </a:p>
@@ -2722,11 +2544,11 @@
         <p:spPr>
           <a:xfrm>
             <a:off x="566928" y="1627632"/>
-            <a:ext cx="2065264" cy="1280160"/>
+            <a:ext cx="2627300" cy="1371600"/>
           </a:xfrm>
           <a:prstGeom prst="roundRect">
             <a:avLst>
-              <a:gd name="adj" fmla="val 5714"/>
+              <a:gd name="adj" fmla="val 5333"/>
             </a:avLst>
           </a:prstGeom>
           <a:solidFill>
@@ -2749,7 +2571,7 @@
         <p:spPr>
           <a:xfrm>
             <a:off x="566928" y="1755648"/>
-            <a:ext cx="2065264" cy="548640"/>
+            <a:ext cx="2627300" cy="548640"/>
           </a:xfrm>
           <a:prstGeom prst="rect">
             <a:avLst/>
@@ -2788,7 +2610,7 @@
         <p:spPr>
           <a:xfrm>
             <a:off x="658368" y="2304288"/>
-            <a:ext cx="1882384" cy="384048"/>
+            <a:ext cx="2444420" cy="384048"/>
           </a:xfrm>
           <a:prstGeom prst="rect">
             <a:avLst/>
@@ -2826,12 +2648,12 @@
         </p:nvSpPr>
         <p:spPr>
           <a:xfrm>
-            <a:off x="2815072" y="1627632"/>
-            <a:ext cx="2065264" cy="1280160"/>
+            <a:off x="3377108" y="1627632"/>
+            <a:ext cx="2627300" cy="1371600"/>
           </a:xfrm>
           <a:prstGeom prst="roundRect">
             <a:avLst>
-              <a:gd name="adj" fmla="val 5714"/>
+              <a:gd name="adj" fmla="val 5333"/>
             </a:avLst>
           </a:prstGeom>
           <a:solidFill>
@@ -2853,8 +2675,8 @@
         </p:nvSpPr>
         <p:spPr>
           <a:xfrm>
-            <a:off x="2815072" y="1755648"/>
-            <a:ext cx="2065264" cy="548640"/>
+            <a:off x="3377108" y="1755648"/>
+            <a:ext cx="2627300" cy="548640"/>
           </a:xfrm>
           <a:prstGeom prst="rect">
             <a:avLst/>
@@ -2892,8 +2714,8 @@
         </p:nvSpPr>
         <p:spPr>
           <a:xfrm>
-            <a:off x="2906512" y="2304288"/>
-            <a:ext cx="1882384" cy="384048"/>
+            <a:off x="3468548" y="2304288"/>
+            <a:ext cx="2444420" cy="384048"/>
           </a:xfrm>
           <a:prstGeom prst="rect">
             <a:avLst/>
@@ -2931,12 +2753,12 @@
         </p:nvSpPr>
         <p:spPr>
           <a:xfrm>
-            <a:off x="5063216" y="1627632"/>
-            <a:ext cx="2065264" cy="1280160"/>
+            <a:off x="6187288" y="1627632"/>
+            <a:ext cx="2627300" cy="1371600"/>
           </a:xfrm>
           <a:prstGeom prst="roundRect">
             <a:avLst>
-              <a:gd name="adj" fmla="val 5714"/>
+              <a:gd name="adj" fmla="val 5333"/>
             </a:avLst>
           </a:prstGeom>
           <a:solidFill>
@@ -2958,8 +2780,8 @@
         </p:nvSpPr>
         <p:spPr>
           <a:xfrm>
-            <a:off x="5063216" y="1755648"/>
-            <a:ext cx="2065264" cy="548640"/>
+            <a:off x="6187288" y="1755648"/>
+            <a:ext cx="2627300" cy="548640"/>
           </a:xfrm>
           <a:prstGeom prst="rect">
             <a:avLst/>
@@ -2997,8 +2819,8 @@
         </p:nvSpPr>
         <p:spPr>
           <a:xfrm>
-            <a:off x="5154656" y="2304288"/>
-            <a:ext cx="1882384" cy="384048"/>
+            <a:off x="6278728" y="2304288"/>
+            <a:ext cx="2444420" cy="384048"/>
           </a:xfrm>
           <a:prstGeom prst="rect">
             <a:avLst/>
@@ -3022,7 +2844,7 @@
                 <a:ea typeface="Segoe UI" pitchFamily="34" charset="-122"/>
                 <a:cs typeface="Segoe UI" pitchFamily="34" charset="-120"/>
               </a:rPr>
-              <a:t>start to a working suite</a:t>
+              <a:t>to build the whole suite</a:t>
             </a:r>
             <a:endParaRPr lang="en-US" sz="1150" dirty="0"/>
           </a:p>
@@ -3036,12 +2858,12 @@
         </p:nvSpPr>
         <p:spPr>
           <a:xfrm>
-            <a:off x="7311360" y="1627632"/>
-            <a:ext cx="2065264" cy="1280160"/>
+            <a:off x="8997467" y="1627632"/>
+            <a:ext cx="2627300" cy="1371600"/>
           </a:xfrm>
           <a:prstGeom prst="roundRect">
             <a:avLst>
-              <a:gd name="adj" fmla="val 5714"/>
+              <a:gd name="adj" fmla="val 5333"/>
             </a:avLst>
           </a:prstGeom>
           <a:solidFill>
@@ -3063,8 +2885,8 @@
         </p:nvSpPr>
         <p:spPr>
           <a:xfrm>
-            <a:off x="7311360" y="1755648"/>
-            <a:ext cx="2065264" cy="548640"/>
+            <a:off x="8997467" y="1755648"/>
+            <a:ext cx="2627300" cy="548640"/>
           </a:xfrm>
           <a:prstGeom prst="rect">
             <a:avLst/>
@@ -3088,7 +2910,7 @@
                 <a:ea typeface="Segoe UI" pitchFamily="34" charset="-122"/>
                 <a:cs typeface="Segoe UI" pitchFamily="34" charset="-120"/>
               </a:rPr>
-              <a:t>3×</a:t>
+              <a:t>~1 min</a:t>
             </a:r>
             <a:endParaRPr lang="en-US" sz="3000" dirty="0"/>
           </a:p>
@@ -3102,8 +2924,8 @@
         </p:nvSpPr>
         <p:spPr>
           <a:xfrm>
-            <a:off x="7402800" y="2304288"/>
-            <a:ext cx="1882384" cy="384048"/>
+            <a:off x="9088907" y="2304288"/>
+            <a:ext cx="2444420" cy="384048"/>
           </a:xfrm>
           <a:prstGeom prst="rect">
             <a:avLst/>
@@ -3127,7 +2949,7 @@
                 <a:ea typeface="Segoe UI" pitchFamily="34" charset="-122"/>
                 <a:cs typeface="Segoe UI" pitchFamily="34" charset="-120"/>
               </a:rPr>
-              <a:t>clean full runs, to prove it holds</a:t>
+              <a:t>to run it, start to finish</a:t>
             </a:r>
             <a:endParaRPr lang="en-US" sz="1150" dirty="0"/>
           </a:p>
@@ -3141,117 +2963,12 @@
         </p:nvSpPr>
         <p:spPr>
           <a:xfrm>
-            <a:off x="9559503" y="1627632"/>
-            <a:ext cx="2065264" cy="1280160"/>
+            <a:off x="566928" y="3456432"/>
+            <a:ext cx="2531288" cy="960120"/>
           </a:xfrm>
           <a:prstGeom prst="roundRect">
             <a:avLst>
-              <a:gd name="adj" fmla="val 5714"/>
-            </a:avLst>
-          </a:prstGeom>
-          <a:solidFill>
-            <a:srgbClr val="E8F0F8"/>
-          </a:solidFill>
-          <a:ln w="12700">
-            <a:solidFill>
-              <a:srgbClr val="E8F0F8"/>
-            </a:solidFill>
-            <a:prstDash val="solid"/>
-          </a:ln>
-        </p:spPr>
-      </p:sp>
-      <p:sp>
-        <p:nvSpPr>
-          <p:cNvPr id="18" name="Text 16"/>
-          <p:cNvSpPr/>
-          <p:nvPr/>
-        </p:nvSpPr>
-        <p:spPr>
-          <a:xfrm>
-            <a:off x="9559503" y="1755648"/>
-            <a:ext cx="2065264" cy="548640"/>
-          </a:xfrm>
-          <a:prstGeom prst="rect">
-            <a:avLst/>
-          </a:prstGeom>
-          <a:noFill/>
-          <a:ln/>
-        </p:spPr>
-        <p:txBody>
-          <a:bodyPr wrap="square" rtlCol="0" anchor="ctr"/>
-          <a:lstStyle/>
-          <a:p>
-            <a:pPr algn="ctr" indent="0" marL="0">
-              <a:buNone/>
-            </a:pPr>
-            <a:r>
-              <a:rPr lang="en-US" sz="3000" b="1" dirty="0">
-                <a:solidFill>
-                  <a:srgbClr val="0B5FA5"/>
-                </a:solidFill>
-                <a:latin typeface="Segoe UI" pitchFamily="34" charset="0"/>
-                <a:ea typeface="Segoe UI" pitchFamily="34" charset="-122"/>
-                <a:cs typeface="Segoe UI" pitchFamily="34" charset="-120"/>
-              </a:rPr>
-              <a:t>1</a:t>
-            </a:r>
-            <a:endParaRPr lang="en-US" sz="3000" dirty="0"/>
-          </a:p>
-        </p:txBody>
-      </p:sp>
-      <p:sp>
-        <p:nvSpPr>
-          <p:cNvPr id="19" name="Text 17"/>
-          <p:cNvSpPr/>
-          <p:nvPr/>
-        </p:nvSpPr>
-        <p:spPr>
-          <a:xfrm>
-            <a:off x="9650943" y="2304288"/>
-            <a:ext cx="1882384" cy="384048"/>
-          </a:xfrm>
-          <a:prstGeom prst="rect">
-            <a:avLst/>
-          </a:prstGeom>
-          <a:noFill/>
-          <a:ln/>
-        </p:spPr>
-        <p:txBody>
-          <a:bodyPr wrap="square" rtlCol="0" anchor="ctr"/>
-          <a:lstStyle/>
-          <a:p>
-            <a:pPr algn="ctr" indent="0" marL="0">
-              <a:buNone/>
-            </a:pPr>
-            <a:r>
-              <a:rPr lang="en-US" sz="1150" dirty="0">
-                <a:solidFill>
-                  <a:srgbClr val="3F3F46"/>
-                </a:solidFill>
-                <a:latin typeface="Segoe UI" pitchFamily="34" charset="0"/>
-                <a:ea typeface="Segoe UI" pitchFamily="34" charset="-122"/>
-                <a:cs typeface="Segoe UI" pitchFamily="34" charset="-120"/>
-              </a:rPr>
-              <a:t>data problem nobody knew about</a:t>
-            </a:r>
-            <a:endParaRPr lang="en-US" sz="1150" dirty="0"/>
-          </a:p>
-        </p:txBody>
-      </p:sp>
-      <p:sp>
-        <p:nvSpPr>
-          <p:cNvPr id="20" name="Shape 18"/>
-          <p:cNvSpPr/>
-          <p:nvPr/>
-        </p:nvSpPr>
-        <p:spPr>
-          <a:xfrm>
-            <a:off x="566928" y="3319272"/>
-            <a:ext cx="1962851" cy="868680"/>
-          </a:xfrm>
-          <a:prstGeom prst="roundRect">
-            <a:avLst>
-              <a:gd name="adj" fmla="val 8421"/>
+              <a:gd name="adj" fmla="val 7619"/>
             </a:avLst>
           </a:prstGeom>
           <a:solidFill>
@@ -3267,14 +2984,14 @@
       </p:sp>
       <p:sp>
         <p:nvSpPr>
-          <p:cNvPr id="21" name="Text 19"/>
-          <p:cNvSpPr/>
-          <p:nvPr/>
-        </p:nvSpPr>
-        <p:spPr>
-          <a:xfrm>
-            <a:off x="640080" y="3374136"/>
-            <a:ext cx="1816547" cy="758952"/>
+          <p:cNvPr id="18" name="Text 16"/>
+          <p:cNvSpPr/>
+          <p:nvPr/>
+        </p:nvSpPr>
+        <p:spPr>
+          <a:xfrm>
+            <a:off x="640080" y="3511296"/>
+            <a:ext cx="2384984" cy="850392"/>
           </a:xfrm>
           <a:prstGeom prst="rect">
             <a:avLst/>
@@ -3306,14 +3023,14 @@
       </p:sp>
       <p:sp>
         <p:nvSpPr>
-          <p:cNvPr id="22" name="Text 20"/>
-          <p:cNvSpPr/>
-          <p:nvPr/>
-        </p:nvSpPr>
-        <p:spPr>
-          <a:xfrm>
-            <a:off x="2529779" y="3319272"/>
-            <a:ext cx="310896" cy="868680"/>
+          <p:cNvPr id="19" name="Text 17"/>
+          <p:cNvSpPr/>
+          <p:nvPr/>
+        </p:nvSpPr>
+        <p:spPr>
+          <a:xfrm>
+            <a:off x="3098216" y="3456432"/>
+            <a:ext cx="310896" cy="960120"/>
           </a:xfrm>
           <a:prstGeom prst="rect">
             <a:avLst/>
@@ -3345,18 +3062,18 @@
       </p:sp>
       <p:sp>
         <p:nvSpPr>
-          <p:cNvPr id="23" name="Shape 21"/>
-          <p:cNvSpPr/>
-          <p:nvPr/>
-        </p:nvSpPr>
-        <p:spPr>
-          <a:xfrm>
-            <a:off x="2840675" y="3319272"/>
-            <a:ext cx="1962851" cy="868680"/>
+          <p:cNvPr id="20" name="Shape 18"/>
+          <p:cNvSpPr/>
+          <p:nvPr/>
+        </p:nvSpPr>
+        <p:spPr>
+          <a:xfrm>
+            <a:off x="3409112" y="3456432"/>
+            <a:ext cx="2531288" cy="960120"/>
           </a:xfrm>
           <a:prstGeom prst="roundRect">
             <a:avLst>
-              <a:gd name="adj" fmla="val 8421"/>
+              <a:gd name="adj" fmla="val 7619"/>
             </a:avLst>
           </a:prstGeom>
           <a:solidFill>
@@ -3372,14 +3089,14 @@
       </p:sp>
       <p:sp>
         <p:nvSpPr>
-          <p:cNvPr id="24" name="Text 22"/>
-          <p:cNvSpPr/>
-          <p:nvPr/>
-        </p:nvSpPr>
-        <p:spPr>
-          <a:xfrm>
-            <a:off x="2913827" y="3374136"/>
-            <a:ext cx="1816547" cy="758952"/>
+          <p:cNvPr id="21" name="Text 19"/>
+          <p:cNvSpPr/>
+          <p:nvPr/>
+        </p:nvSpPr>
+        <p:spPr>
+          <a:xfrm>
+            <a:off x="3482264" y="3511296"/>
+            <a:ext cx="2384984" cy="850392"/>
           </a:xfrm>
           <a:prstGeom prst="rect">
             <a:avLst/>
@@ -3403,7 +3120,7 @@
                 <a:ea typeface="Segoe UI" pitchFamily="34" charset="-122"/>
                 <a:cs typeface="Segoe UI" pitchFamily="34" charset="-120"/>
               </a:rPr>
-              <a:t>First test</a:t>
+              <a:t>First test passing</a:t>
             </a:r>
             <a:endParaRPr lang="en-US" sz="1200" dirty="0"/>
           </a:p>
@@ -3420,7 +3137,7 @@
                 <a:ea typeface="Segoe UI" pitchFamily="34" charset="-122"/>
                 <a:cs typeface="Segoe UI" pitchFamily="34" charset="-120"/>
               </a:rPr>
-              <a:t>passing on UAT</a:t>
+              <a:t>on the real site</a:t>
             </a:r>
             <a:endParaRPr lang="en-US" sz="1200" dirty="0"/>
           </a:p>
@@ -3428,14 +3145,14 @@
       </p:sp>
       <p:sp>
         <p:nvSpPr>
-          <p:cNvPr id="25" name="Text 23"/>
-          <p:cNvSpPr/>
-          <p:nvPr/>
-        </p:nvSpPr>
-        <p:spPr>
-          <a:xfrm>
-            <a:off x="4803526" y="3319272"/>
-            <a:ext cx="310896" cy="868680"/>
+          <p:cNvPr id="22" name="Text 20"/>
+          <p:cNvSpPr/>
+          <p:nvPr/>
+        </p:nvSpPr>
+        <p:spPr>
+          <a:xfrm>
+            <a:off x="5940400" y="3456432"/>
+            <a:ext cx="310896" cy="960120"/>
           </a:xfrm>
           <a:prstGeom prst="rect">
             <a:avLst/>
@@ -3467,18 +3184,18 @@
       </p:sp>
       <p:sp>
         <p:nvSpPr>
-          <p:cNvPr id="26" name="Shape 24"/>
-          <p:cNvSpPr/>
-          <p:nvPr/>
-        </p:nvSpPr>
-        <p:spPr>
-          <a:xfrm>
-            <a:off x="5114422" y="3319272"/>
-            <a:ext cx="1962851" cy="868680"/>
+          <p:cNvPr id="23" name="Shape 21"/>
+          <p:cNvSpPr/>
+          <p:nvPr/>
+        </p:nvSpPr>
+        <p:spPr>
+          <a:xfrm>
+            <a:off x="6251296" y="3456432"/>
+            <a:ext cx="2531288" cy="960120"/>
           </a:xfrm>
           <a:prstGeom prst="roundRect">
             <a:avLst>
-              <a:gd name="adj" fmla="val 8421"/>
+              <a:gd name="adj" fmla="val 7619"/>
             </a:avLst>
           </a:prstGeom>
           <a:solidFill>
@@ -3494,14 +3211,14 @@
       </p:sp>
       <p:sp>
         <p:nvSpPr>
-          <p:cNvPr id="27" name="Text 25"/>
-          <p:cNvSpPr/>
-          <p:nvPr/>
-        </p:nvSpPr>
-        <p:spPr>
-          <a:xfrm>
-            <a:off x="5187574" y="3374136"/>
-            <a:ext cx="1816547" cy="758952"/>
+          <p:cNvPr id="24" name="Text 22"/>
+          <p:cNvSpPr/>
+          <p:nvPr/>
+        </p:nvSpPr>
+        <p:spPr>
+          <a:xfrm>
+            <a:off x="6324448" y="3511296"/>
+            <a:ext cx="2384984" cy="850392"/>
           </a:xfrm>
           <a:prstGeom prst="rect">
             <a:avLst/>
@@ -3525,54 +3242,37 @@
                 <a:ea typeface="Segoe UI" pitchFamily="34" charset="-122"/>
                 <a:cs typeface="Segoe UI" pitchFamily="34" charset="-120"/>
               </a:rPr>
-              <a:t>All 13 checks</a:t>
+              <a:t>All 13 checks green</a:t>
             </a:r>
             <a:endParaRPr lang="en-US" sz="1200" dirty="0"/>
           </a:p>
+        </p:txBody>
+      </p:sp>
+      <p:sp>
+        <p:nvSpPr>
+          <p:cNvPr id="25" name="Text 23"/>
+          <p:cNvSpPr/>
+          <p:nvPr/>
+        </p:nvSpPr>
+        <p:spPr>
+          <a:xfrm>
+            <a:off x="8782583" y="3456432"/>
+            <a:ext cx="310896" cy="960120"/>
+          </a:xfrm>
+          <a:prstGeom prst="rect">
+            <a:avLst/>
+          </a:prstGeom>
+          <a:noFill/>
+          <a:ln/>
+        </p:spPr>
+        <p:txBody>
+          <a:bodyPr wrap="square" rtlCol="0" anchor="ctr"/>
+          <a:lstStyle/>
           <a:p>
             <a:pPr algn="ctr" indent="0" marL="0">
               <a:buNone/>
             </a:pPr>
             <a:r>
-              <a:rPr lang="en-US" sz="1200" b="1" dirty="0">
-                <a:solidFill>
-                  <a:srgbClr val="FFFFFF"/>
-                </a:solidFill>
-                <a:latin typeface="Segoe UI" pitchFamily="34" charset="0"/>
-                <a:ea typeface="Segoe UI" pitchFamily="34" charset="-122"/>
-                <a:cs typeface="Segoe UI" pitchFamily="34" charset="-120"/>
-              </a:rPr>
-              <a:t>green</a:t>
-            </a:r>
-            <a:endParaRPr lang="en-US" sz="1200" dirty="0"/>
-          </a:p>
-        </p:txBody>
-      </p:sp>
-      <p:sp>
-        <p:nvSpPr>
-          <p:cNvPr id="28" name="Text 26"/>
-          <p:cNvSpPr/>
-          <p:nvPr/>
-        </p:nvSpPr>
-        <p:spPr>
-          <a:xfrm>
-            <a:off x="7077273" y="3319272"/>
-            <a:ext cx="310896" cy="868680"/>
-          </a:xfrm>
-          <a:prstGeom prst="rect">
-            <a:avLst/>
-          </a:prstGeom>
-          <a:noFill/>
-          <a:ln/>
-        </p:spPr>
-        <p:txBody>
-          <a:bodyPr wrap="square" rtlCol="0" anchor="ctr"/>
-          <a:lstStyle/>
-          <a:p>
-            <a:pPr algn="ctr" indent="0" marL="0">
-              <a:buNone/>
-            </a:pPr>
-            <a:r>
               <a:rPr lang="en-US" sz="1700" b="1" dirty="0">
                 <a:solidFill>
                   <a:srgbClr val="71717A"/>
@@ -3589,18 +3289,18 @@
       </p:sp>
       <p:sp>
         <p:nvSpPr>
-          <p:cNvPr id="29" name="Shape 27"/>
-          <p:cNvSpPr/>
-          <p:nvPr/>
-        </p:nvSpPr>
-        <p:spPr>
-          <a:xfrm>
-            <a:off x="7388169" y="3319272"/>
-            <a:ext cx="1962851" cy="868680"/>
+          <p:cNvPr id="26" name="Shape 24"/>
+          <p:cNvSpPr/>
+          <p:nvPr/>
+        </p:nvSpPr>
+        <p:spPr>
+          <a:xfrm>
+            <a:off x="9093479" y="3456432"/>
+            <a:ext cx="2531288" cy="960120"/>
           </a:xfrm>
           <a:prstGeom prst="roundRect">
             <a:avLst>
-              <a:gd name="adj" fmla="val 8421"/>
+              <a:gd name="adj" fmla="val 7619"/>
             </a:avLst>
           </a:prstGeom>
           <a:solidFill>
@@ -3616,14 +3316,14 @@
       </p:sp>
       <p:sp>
         <p:nvSpPr>
-          <p:cNvPr id="30" name="Text 28"/>
-          <p:cNvSpPr/>
-          <p:nvPr/>
-        </p:nvSpPr>
-        <p:spPr>
-          <a:xfrm>
-            <a:off x="7461321" y="3374136"/>
-            <a:ext cx="1816547" cy="758952"/>
+          <p:cNvPr id="27" name="Text 25"/>
+          <p:cNvSpPr/>
+          <p:nvPr/>
+        </p:nvSpPr>
+        <p:spPr>
+          <a:xfrm>
+            <a:off x="9166631" y="3511296"/>
+            <a:ext cx="2384984" cy="850392"/>
           </a:xfrm>
           <a:prstGeom prst="rect">
             <a:avLst/>
@@ -3647,7 +3347,7 @@
                 <a:ea typeface="Segoe UI" pitchFamily="34" charset="-122"/>
                 <a:cs typeface="Segoe UI" pitchFamily="34" charset="-120"/>
               </a:rPr>
-              <a:t>Found the</a:t>
+              <a:t>Same result on</a:t>
             </a:r>
             <a:endParaRPr lang="en-US" sz="1200" dirty="0"/>
           </a:p>
@@ -3664,7 +3364,7 @@
                 <a:ea typeface="Segoe UI" pitchFamily="34" charset="-122"/>
                 <a:cs typeface="Segoe UI" pitchFamily="34" charset="-120"/>
               </a:rPr>
-              <a:t>data dead end</a:t>
+              <a:t>three full runs</a:t>
             </a:r>
             <a:endParaRPr lang="en-US" sz="1200" dirty="0"/>
           </a:p>
@@ -3672,135 +3372,13 @@
       </p:sp>
       <p:sp>
         <p:nvSpPr>
-          <p:cNvPr id="31" name="Text 29"/>
-          <p:cNvSpPr/>
-          <p:nvPr/>
-        </p:nvSpPr>
-        <p:spPr>
-          <a:xfrm>
-            <a:off x="9351020" y="3319272"/>
-            <a:ext cx="310896" cy="868680"/>
-          </a:xfrm>
-          <a:prstGeom prst="rect">
-            <a:avLst/>
-          </a:prstGeom>
-          <a:noFill/>
-          <a:ln/>
-        </p:spPr>
-        <p:txBody>
-          <a:bodyPr wrap="square" rtlCol="0" anchor="ctr"/>
-          <a:lstStyle/>
-          <a:p>
-            <a:pPr algn="ctr" indent="0" marL="0">
-              <a:buNone/>
-            </a:pPr>
-            <a:r>
-              <a:rPr lang="en-US" sz="1700" b="1" dirty="0">
-                <a:solidFill>
-                  <a:srgbClr val="71717A"/>
-                </a:solidFill>
-                <a:latin typeface="Segoe UI" pitchFamily="34" charset="0"/>
-                <a:ea typeface="Segoe UI" pitchFamily="34" charset="-122"/>
-                <a:cs typeface="Segoe UI" pitchFamily="34" charset="-120"/>
-              </a:rPr>
-              <a:t>→</a:t>
-            </a:r>
-            <a:endParaRPr lang="en-US" sz="1700" dirty="0"/>
-          </a:p>
-        </p:txBody>
-      </p:sp>
-      <p:sp>
-        <p:nvSpPr>
-          <p:cNvPr id="32" name="Shape 30"/>
-          <p:cNvSpPr/>
-          <p:nvPr/>
-        </p:nvSpPr>
-        <p:spPr>
-          <a:xfrm>
-            <a:off x="9661916" y="3319272"/>
-            <a:ext cx="1962851" cy="868680"/>
-          </a:xfrm>
-          <a:prstGeom prst="roundRect">
-            <a:avLst>
-              <a:gd name="adj" fmla="val 8421"/>
-            </a:avLst>
-          </a:prstGeom>
-          <a:solidFill>
-            <a:srgbClr val="E8F0F8"/>
-          </a:solidFill>
-          <a:ln w="12700">
-            <a:solidFill>
-              <a:srgbClr val="C9DAEA"/>
-            </a:solidFill>
-            <a:prstDash val="solid"/>
-          </a:ln>
-        </p:spPr>
-      </p:sp>
-      <p:sp>
-        <p:nvSpPr>
-          <p:cNvPr id="33" name="Text 31"/>
-          <p:cNvSpPr/>
-          <p:nvPr/>
-        </p:nvSpPr>
-        <p:spPr>
-          <a:xfrm>
-            <a:off x="9735068" y="3374136"/>
-            <a:ext cx="1816547" cy="758952"/>
-          </a:xfrm>
-          <a:prstGeom prst="rect">
-            <a:avLst/>
-          </a:prstGeom>
-          <a:noFill/>
-          <a:ln/>
-        </p:spPr>
-        <p:txBody>
-          <a:bodyPr wrap="square" rtlCol="0" anchor="ctr"/>
-          <a:lstStyle/>
-          <a:p>
-            <a:pPr algn="ctr" indent="0" marL="0">
-              <a:buNone/>
-            </a:pPr>
-            <a:r>
-              <a:rPr lang="en-US" sz="1200" b="1" dirty="0">
-                <a:solidFill>
-                  <a:srgbClr val="1A1A1E"/>
-                </a:solidFill>
-                <a:latin typeface="Segoe UI" pitchFamily="34" charset="0"/>
-                <a:ea typeface="Segoe UI" pitchFamily="34" charset="-122"/>
-                <a:cs typeface="Segoe UI" pitchFamily="34" charset="-120"/>
-              </a:rPr>
-              <a:t>Stable across</a:t>
-            </a:r>
-            <a:endParaRPr lang="en-US" sz="1200" dirty="0"/>
-          </a:p>
-          <a:p>
-            <a:pPr algn="ctr" indent="0" marL="0">
-              <a:buNone/>
-            </a:pPr>
-            <a:r>
-              <a:rPr lang="en-US" sz="1200" b="1" dirty="0">
-                <a:solidFill>
-                  <a:srgbClr val="1A1A1E"/>
-                </a:solidFill>
-                <a:latin typeface="Segoe UI" pitchFamily="34" charset="0"/>
-                <a:ea typeface="Segoe UI" pitchFamily="34" charset="-122"/>
-                <a:cs typeface="Segoe UI" pitchFamily="34" charset="-120"/>
-              </a:rPr>
-              <a:t>three full runs</a:t>
-            </a:r>
-            <a:endParaRPr lang="en-US" sz="1200" dirty="0"/>
-          </a:p>
-        </p:txBody>
-      </p:sp>
-      <p:sp>
-        <p:nvSpPr>
-          <p:cNvPr id="34" name="Shape 32"/>
-          <p:cNvSpPr/>
-          <p:nvPr/>
-        </p:nvSpPr>
-        <p:spPr>
-          <a:xfrm>
-            <a:off x="566928" y="4462272"/>
+          <p:cNvPr id="28" name="Shape 26"/>
+          <p:cNvSpPr/>
+          <p:nvPr/>
+        </p:nvSpPr>
+        <p:spPr>
+          <a:xfrm>
+            <a:off x="566928" y="4782312"/>
             <a:ext cx="11057839" cy="731520"/>
           </a:xfrm>
           <a:prstGeom prst="roundRect">
@@ -3821,13 +3399,13 @@
       </p:sp>
       <p:sp>
         <p:nvSpPr>
-          <p:cNvPr id="35" name="Shape 33"/>
-          <p:cNvSpPr/>
-          <p:nvPr/>
-        </p:nvSpPr>
-        <p:spPr>
-          <a:xfrm>
-            <a:off x="566928" y="4462272"/>
+          <p:cNvPr id="29" name="Shape 27"/>
+          <p:cNvSpPr/>
+          <p:nvPr/>
+        </p:nvSpPr>
+        <p:spPr>
+          <a:xfrm>
+            <a:off x="566928" y="4782312"/>
             <a:ext cx="64008" cy="731520"/>
           </a:xfrm>
           <a:prstGeom prst="rect">
@@ -3846,13 +3424,13 @@
       </p:sp>
       <p:sp>
         <p:nvSpPr>
-          <p:cNvPr id="36" name="Text 34"/>
-          <p:cNvSpPr/>
-          <p:nvPr/>
-        </p:nvSpPr>
-        <p:spPr>
-          <a:xfrm>
-            <a:off x="822960" y="4462272"/>
+          <p:cNvPr id="30" name="Text 28"/>
+          <p:cNvSpPr/>
+          <p:nvPr/>
+        </p:nvSpPr>
+        <p:spPr>
+          <a:xfrm>
+            <a:off x="822960" y="4782312"/>
             <a:ext cx="10600639" cy="731520"/>
           </a:xfrm>
           <a:prstGeom prst="rect">
@@ -3877,7 +3455,7 @@
                 <a:ea typeface="Segoe UI" pitchFamily="34" charset="-122"/>
                 <a:cs typeface="Segoe UI" pitchFamily="34" charset="-120"/>
               </a:rPr>
-              <a:t>The part that matters for next time: the expensive pieces - sign-in, the page objects, the evidence and the reporting - are now built. The next check costs minutes, not days.</a:t>
+              <a:t>The expensive part is done. Sign-in, the screens, the evidence and the report already exist - so the next check is minutes of work, not days.</a:t>
             </a:r>
             <a:endParaRPr lang="en-US" sz="1350" dirty="0"/>
           </a:p>
@@ -3885,14 +3463,14 @@
       </p:sp>
       <p:sp>
         <p:nvSpPr>
-          <p:cNvPr id="37" name="Text 35"/>
-          <p:cNvSpPr/>
-          <p:nvPr/>
-        </p:nvSpPr>
-        <p:spPr>
-          <a:xfrm>
-            <a:off x="566928" y="5422392"/>
-            <a:ext cx="11057839" cy="365760"/>
+          <p:cNvPr id="31" name="Text 29"/>
+          <p:cNvSpPr/>
+          <p:nvPr/>
+        </p:nvSpPr>
+        <p:spPr>
+          <a:xfrm>
+            <a:off x="566928" y="5742432"/>
+            <a:ext cx="11057839" cy="411480"/>
           </a:xfrm>
           <a:prstGeom prst="rect">
             <a:avLst/>
@@ -3908,17 +3486,17 @@
               <a:buNone/>
             </a:pPr>
             <a:r>
-              <a:rPr lang="en-US" sz="1300" i="1" dirty="0">
-                <a:solidFill>
-                  <a:srgbClr val="71717A"/>
-                </a:solidFill>
-                <a:latin typeface="Segoe UI" pitchFamily="34" charset="0"/>
-                <a:ea typeface="Segoe UI" pitchFamily="34" charset="-122"/>
-                <a:cs typeface="Segoe UI" pitchFamily="34" charset="-120"/>
-              </a:rPr>
-              <a:t>Everything on this slide was measured during the session, not estimated afterwards. The suite runs on demand - you can watch it happen.</a:t>
-            </a:r>
-            <a:endParaRPr lang="en-US" sz="1300" dirty="0"/>
+              <a:rPr lang="en-US" sz="1700" b="1" dirty="0">
+                <a:solidFill>
+                  <a:srgbClr val="0B5FA5"/>
+                </a:solidFill>
+                <a:latin typeface="Segoe UI" pitchFamily="34" charset="0"/>
+                <a:ea typeface="Segoe UI" pitchFamily="34" charset="-122"/>
+                <a:cs typeface="Segoe UI" pitchFamily="34" charset="-120"/>
+              </a:rPr>
+              <a:t>Next: the suite running live, against UAT.</a:t>
+            </a:r>
+            <a:endParaRPr lang="en-US" sz="1700" dirty="0"/>
           </a:p>
         </p:txBody>
       </p:sp>
@@ -3987,7 +3565,7 @@
                 <a:ea typeface="Segoe UI" pitchFamily="34" charset="-122"/>
                 <a:cs typeface="Segoe UI" pitchFamily="34" charset="-120"/>
               </a:rPr>
-              <a:t>The parts that were not typing</a:t>
+              <a:t>Where the human time still goes</a:t>
             </a:r>
             <a:endParaRPr lang="en-US" sz="2600" dirty="0"/>
           </a:p>
@@ -4026,7 +3604,7 @@
                 <a:ea typeface="Segoe UI" pitchFamily="34" charset="-122"/>
                 <a:cs typeface="Segoe UI" pitchFamily="34" charset="-120"/>
               </a:rPr>
-              <a:t>Claude Code, working in the repository and against the live UAT site</a:t>
+              <a:t>The agent is fast at the mechanical work; judgement stays with us</a:t>
             </a:r>
             <a:endParaRPr lang="en-US" sz="1400" dirty="0"/>
           </a:p>
@@ -4054,57 +3632,18 @@
       </p:sp>
       <p:sp>
         <p:nvSpPr>
-          <p:cNvPr id="5" name="Text 3"/>
+          <p:cNvPr id="5" name="Shape 3"/>
           <p:cNvSpPr/>
           <p:nvPr/>
         </p:nvSpPr>
         <p:spPr>
           <a:xfrm>
             <a:off x="566928" y="1627632"/>
-            <a:ext cx="11057839" cy="365760"/>
-          </a:xfrm>
-          <a:prstGeom prst="rect">
-            <a:avLst/>
-          </a:prstGeom>
-          <a:noFill/>
-          <a:ln/>
-        </p:spPr>
-        <p:txBody>
-          <a:bodyPr wrap="square" rtlCol="0" anchor="ctr"/>
-          <a:lstStyle/>
-          <a:p>
-            <a:pPr indent="0" marL="0">
-              <a:buNone/>
-            </a:pPr>
-            <a:r>
-              <a:rPr lang="en-US" sz="1350" dirty="0">
-                <a:solidFill>
-                  <a:srgbClr val="3F3F46"/>
-                </a:solidFill>
-                <a:latin typeface="Segoe UI" pitchFamily="34" charset="0"/>
-                <a:ea typeface="Segoe UI" pitchFamily="34" charset="-122"/>
-                <a:cs typeface="Segoe UI" pitchFamily="34" charset="-120"/>
-              </a:rPr>
-              <a:t>Writing test code is the easy half. These three are the ones that make teams abandon automation - and each was found and solved during the session, not designed in advance.</a:t>
-            </a:r>
-            <a:endParaRPr lang="en-US" sz="1350" dirty="0"/>
-          </a:p>
-        </p:txBody>
-      </p:sp>
-      <p:sp>
-        <p:nvSpPr>
-          <p:cNvPr id="6" name="Shape 4"/>
-          <p:cNvSpPr/>
-          <p:nvPr/>
-        </p:nvSpPr>
-        <p:spPr>
-          <a:xfrm>
-            <a:off x="566928" y="2157984"/>
-            <a:ext cx="3515258" cy="3200400"/>
+            <a:ext cx="5300320" cy="3474720"/>
           </a:xfrm>
           <a:prstGeom prst="roundRect">
             <a:avLst>
-              <a:gd name="adj" fmla="val 2286"/>
+              <a:gd name="adj" fmla="val 2105"/>
             </a:avLst>
           </a:prstGeom>
           <a:solidFill>
@@ -4120,39 +3659,14 @@
       </p:sp>
       <p:sp>
         <p:nvSpPr>
-          <p:cNvPr id="7" name="Shape 5"/>
-          <p:cNvSpPr/>
-          <p:nvPr/>
-        </p:nvSpPr>
-        <p:spPr>
-          <a:xfrm>
-            <a:off x="566928" y="2157984"/>
-            <a:ext cx="3515258" cy="54864"/>
-          </a:xfrm>
-          <a:prstGeom prst="rect">
-            <a:avLst/>
-          </a:prstGeom>
-          <a:solidFill>
-            <a:srgbClr val="B91C1C"/>
-          </a:solidFill>
-          <a:ln w="12700">
-            <a:solidFill>
-              <a:srgbClr val="B91C1C"/>
-            </a:solidFill>
-            <a:prstDash val="solid"/>
-          </a:ln>
-        </p:spPr>
-      </p:sp>
-      <p:sp>
-        <p:nvSpPr>
-          <p:cNvPr id="8" name="Text 6"/>
-          <p:cNvSpPr/>
-          <p:nvPr/>
-        </p:nvSpPr>
-        <p:spPr>
-          <a:xfrm>
-            <a:off x="768096" y="2322576"/>
-            <a:ext cx="3112922" cy="475488"/>
+          <p:cNvPr id="6" name="Text 4"/>
+          <p:cNvSpPr/>
+          <p:nvPr/>
+        </p:nvSpPr>
+        <p:spPr>
+          <a:xfrm>
+            <a:off x="786384" y="1810512"/>
+            <a:ext cx="4861408" cy="365760"/>
           </a:xfrm>
           <a:prstGeom prst="rect">
             <a:avLst/>
@@ -4161,76 +3675,37 @@
           <a:ln/>
         </p:spPr>
         <p:txBody>
-          <a:bodyPr wrap="square" rtlCol="0" anchor="t"/>
+          <a:bodyPr wrap="square" rtlCol="0" anchor="ctr"/>
           <a:lstStyle/>
           <a:p>
             <a:pPr indent="0" marL="0">
               <a:buNone/>
             </a:pPr>
             <a:r>
-              <a:rPr lang="en-US" sz="1450" b="1" dirty="0">
-                <a:solidFill>
-                  <a:srgbClr val="1A1A1E"/>
-                </a:solidFill>
-                <a:latin typeface="Segoe UI" pitchFamily="34" charset="0"/>
-                <a:ea typeface="Segoe UI" pitchFamily="34" charset="-122"/>
-                <a:cs typeface="Segoe UI" pitchFamily="34" charset="-120"/>
-              </a:rPr>
-              <a:t>The save that said "OK"</a:t>
-            </a:r>
-            <a:endParaRPr lang="en-US" sz="1450" dirty="0"/>
-          </a:p>
-        </p:txBody>
-      </p:sp>
-      <p:sp>
-        <p:nvSpPr>
-          <p:cNvPr id="9" name="Text 7"/>
-          <p:cNvSpPr/>
-          <p:nvPr/>
-        </p:nvSpPr>
-        <p:spPr>
-          <a:xfrm>
-            <a:off x="768096" y="2852928"/>
-            <a:ext cx="3112922" cy="731520"/>
-          </a:xfrm>
-          <a:prstGeom prst="rect">
-            <a:avLst/>
-          </a:prstGeom>
-          <a:noFill/>
-          <a:ln/>
-        </p:spPr>
-        <p:txBody>
-          <a:bodyPr wrap="square" rtlCol="0" anchor="t"/>
-          <a:lstStyle/>
-          <a:p>
-            <a:pPr indent="0" marL="0">
-              <a:buNone/>
-            </a:pPr>
-            <a:r>
-              <a:rPr lang="en-US" sz="1200" i="1" dirty="0">
-                <a:solidFill>
-                  <a:srgbClr val="71717A"/>
-                </a:solidFill>
-                <a:latin typeface="Segoe UI" pitchFamily="34" charset="0"/>
-                <a:ea typeface="Segoe UI" pitchFamily="34" charset="-122"/>
-                <a:cs typeface="Segoe UI" pitchFamily="34" charset="-120"/>
-              </a:rPr>
-              <a:t>The test saved a job. The server answered success - and nothing happened.</a:t>
-            </a:r>
-            <a:endParaRPr lang="en-US" sz="1200" dirty="0"/>
-          </a:p>
-        </p:txBody>
-      </p:sp>
-      <p:sp>
-        <p:nvSpPr>
-          <p:cNvPr id="10" name="Text 8"/>
-          <p:cNvSpPr/>
-          <p:nvPr/>
-        </p:nvSpPr>
-        <p:spPr>
-          <a:xfrm>
-            <a:off x="768096" y="3621024"/>
-            <a:ext cx="3112922" cy="1600200"/>
+              <a:rPr lang="en-US" sz="1500" b="1" dirty="0">
+                <a:solidFill>
+                  <a:srgbClr val="15803D"/>
+                </a:solidFill>
+                <a:latin typeface="Segoe UI" pitchFamily="34" charset="0"/>
+                <a:ea typeface="Segoe UI" pitchFamily="34" charset="-122"/>
+                <a:cs typeface="Segoe UI" pitchFamily="34" charset="-120"/>
+              </a:rPr>
+              <a:t>The agent does the work</a:t>
+            </a:r>
+            <a:endParaRPr lang="en-US" sz="1500" dirty="0"/>
+          </a:p>
+        </p:txBody>
+      </p:sp>
+      <p:sp>
+        <p:nvSpPr>
+          <p:cNvPr id="7" name="Text 5"/>
+          <p:cNvSpPr/>
+          <p:nvPr/>
+        </p:nvSpPr>
+        <p:spPr>
+          <a:xfrm>
+            <a:off x="786384" y="2231136"/>
+            <a:ext cx="4861408" cy="2651760"/>
           </a:xfrm>
           <a:prstGeom prst="rect">
             <a:avLst/>
@@ -4244,13 +3719,13 @@
           <a:p>
             <a:pPr marL="342900" indent="-342900">
               <a:spcAft>
-                <a:spcPts val="600"/>
+                <a:spcPts val="700"/>
               </a:spcAft>
               <a:buSzPct val="100000"/>
               <a:buChar char="•"/>
             </a:pPr>
             <a:r>
-              <a:rPr lang="en-US" sz="1200" dirty="0">
+              <a:rPr lang="en-US" sz="1300" dirty="0">
                 <a:solidFill>
                   <a:srgbClr val="3F3F46"/>
                 </a:solidFill>
@@ -4258,20 +3733,20 @@
                 <a:ea typeface="Segoe UI" pitchFamily="34" charset="-122"/>
                 <a:cs typeface="Segoe UI" pitchFamily="34" charset="-120"/>
               </a:rPr>
-              <a:t>The rejection was hidden in a pop-up the browser closes automatically</a:t>
-            </a:r>
-            <a:endParaRPr lang="en-US" sz="1200" dirty="0"/>
+              <a:t>Writes the tests</a:t>
+            </a:r>
+            <a:endParaRPr lang="en-US" sz="1300" dirty="0"/>
           </a:p>
           <a:p>
             <a:pPr marL="342900" indent="-342900">
               <a:spcAft>
-                <a:spcPts val="600"/>
+                <a:spcPts val="700"/>
               </a:spcAft>
               <a:buSzPct val="100000"/>
               <a:buChar char="•"/>
             </a:pPr>
             <a:r>
-              <a:rPr lang="en-US" sz="1200" dirty="0">
+              <a:rPr lang="en-US" sz="1300" dirty="0">
                 <a:solidFill>
                   <a:srgbClr val="3F3F46"/>
                 </a:solidFill>
@@ -4279,20 +3754,20 @@
                 <a:ea typeface="Segoe UI" pitchFamily="34" charset="-122"/>
                 <a:cs typeface="Segoe UI" pitchFamily="34" charset="-120"/>
               </a:rPr>
-              <a:t>It read the application’s own script, found where the message is raised, and made the test capture it</a:t>
-            </a:r>
-            <a:endParaRPr lang="en-US" sz="1200" dirty="0"/>
+              <a:t>Runs them and reads what failed</a:t>
+            </a:r>
+            <a:endParaRPr lang="en-US" sz="1300" dirty="0"/>
           </a:p>
           <a:p>
             <a:pPr marL="342900" indent="-342900">
               <a:spcAft>
-                <a:spcPts val="600"/>
+                <a:spcPts val="700"/>
               </a:spcAft>
               <a:buSzPct val="100000"/>
               <a:buChar char="•"/>
             </a:pPr>
             <a:r>
-              <a:rPr lang="en-US" sz="1200" dirty="0">
+              <a:rPr lang="en-US" sz="1300" dirty="0">
                 <a:solidFill>
                   <a:srgbClr val="3F3F46"/>
                 </a:solidFill>
@@ -4300,26 +3775,47 @@
                 <a:ea typeface="Segoe UI" pitchFamily="34" charset="-122"/>
                 <a:cs typeface="Segoe UI" pitchFamily="34" charset="-120"/>
               </a:rPr>
-              <a:t>Failures now say "Privilege is required" instead of "the page did not change"</a:t>
-            </a:r>
-            <a:endParaRPr lang="en-US" sz="1200" dirty="0"/>
-          </a:p>
-        </p:txBody>
-      </p:sp>
-      <p:sp>
-        <p:nvSpPr>
-          <p:cNvPr id="11" name="Shape 9"/>
-          <p:cNvSpPr/>
-          <p:nvPr/>
-        </p:nvSpPr>
-        <p:spPr>
-          <a:xfrm>
-            <a:off x="4338218" y="2157984"/>
-            <a:ext cx="3515258" cy="3200400"/>
+              <a:t>Fixes and runs again until they pass</a:t>
+            </a:r>
+            <a:endParaRPr lang="en-US" sz="1300" dirty="0"/>
+          </a:p>
+          <a:p>
+            <a:pPr marL="342900" indent="-342900">
+              <a:spcAft>
+                <a:spcPts val="700"/>
+              </a:spcAft>
+              <a:buSzPct val="100000"/>
+              <a:buChar char="•"/>
+            </a:pPr>
+            <a:r>
+              <a:rPr lang="en-US" sz="1300" dirty="0">
+                <a:solidFill>
+                  <a:srgbClr val="3F3F46"/>
+                </a:solidFill>
+                <a:latin typeface="Segoe UI" pitchFamily="34" charset="0"/>
+                <a:ea typeface="Segoe UI" pitchFamily="34" charset="-122"/>
+                <a:cs typeface="Segoe UI" pitchFamily="34" charset="-120"/>
+              </a:rPr>
+              <a:t>Writes down what it learned</a:t>
+            </a:r>
+            <a:endParaRPr lang="en-US" sz="1300" dirty="0"/>
+          </a:p>
+        </p:txBody>
+      </p:sp>
+      <p:sp>
+        <p:nvSpPr>
+          <p:cNvPr id="8" name="Shape 6"/>
+          <p:cNvSpPr/>
+          <p:nvPr/>
+        </p:nvSpPr>
+        <p:spPr>
+          <a:xfrm>
+            <a:off x="6324448" y="1627632"/>
+            <a:ext cx="5300320" cy="3474720"/>
           </a:xfrm>
           <a:prstGeom prst="roundRect">
             <a:avLst>
-              <a:gd name="adj" fmla="val 2286"/>
+              <a:gd name="adj" fmla="val 2105"/>
             </a:avLst>
           </a:prstGeom>
           <a:solidFill>
@@ -4335,39 +3831,14 @@
       </p:sp>
       <p:sp>
         <p:nvSpPr>
-          <p:cNvPr id="12" name="Shape 10"/>
-          <p:cNvSpPr/>
-          <p:nvPr/>
-        </p:nvSpPr>
-        <p:spPr>
-          <a:xfrm>
-            <a:off x="4338218" y="2157984"/>
-            <a:ext cx="3515258" cy="54864"/>
-          </a:xfrm>
-          <a:prstGeom prst="rect">
-            <a:avLst/>
-          </a:prstGeom>
-          <a:solidFill>
-            <a:srgbClr val="B45309"/>
-          </a:solidFill>
-          <a:ln w="12700">
-            <a:solidFill>
-              <a:srgbClr val="B45309"/>
-            </a:solidFill>
-            <a:prstDash val="solid"/>
-          </a:ln>
-        </p:spPr>
-      </p:sp>
-      <p:sp>
-        <p:nvSpPr>
-          <p:cNvPr id="13" name="Text 11"/>
-          <p:cNvSpPr/>
-          <p:nvPr/>
-        </p:nvSpPr>
-        <p:spPr>
-          <a:xfrm>
-            <a:off x="4539386" y="2322576"/>
-            <a:ext cx="3112922" cy="475488"/>
+          <p:cNvPr id="9" name="Text 7"/>
+          <p:cNvSpPr/>
+          <p:nvPr/>
+        </p:nvSpPr>
+        <p:spPr>
+          <a:xfrm>
+            <a:off x="6543904" y="1810512"/>
+            <a:ext cx="4861408" cy="365760"/>
           </a:xfrm>
           <a:prstGeom prst="rect">
             <a:avLst/>
@@ -4376,76 +3847,37 @@
           <a:ln/>
         </p:spPr>
         <p:txBody>
-          <a:bodyPr wrap="square" rtlCol="0" anchor="t"/>
+          <a:bodyPr wrap="square" rtlCol="0" anchor="ctr"/>
           <a:lstStyle/>
           <a:p>
             <a:pPr indent="0" marL="0">
               <a:buNone/>
             </a:pPr>
             <a:r>
-              <a:rPr lang="en-US" sz="1450" b="1" dirty="0">
-                <a:solidFill>
-                  <a:srgbClr val="1A1A1E"/>
-                </a:solidFill>
-                <a:latin typeface="Segoe UI" pitchFamily="34" charset="0"/>
-                <a:ea typeface="Segoe UI" pitchFamily="34" charset="-122"/>
-                <a:cs typeface="Segoe UI" pitchFamily="34" charset="-120"/>
-              </a:rPr>
-              <a:t>The dropdowns that were never ready</a:t>
-            </a:r>
-            <a:endParaRPr lang="en-US" sz="1450" dirty="0"/>
-          </a:p>
-        </p:txBody>
-      </p:sp>
-      <p:sp>
-        <p:nvSpPr>
-          <p:cNvPr id="14" name="Text 12"/>
-          <p:cNvSpPr/>
-          <p:nvPr/>
-        </p:nvSpPr>
-        <p:spPr>
-          <a:xfrm>
-            <a:off x="4539386" y="2852928"/>
-            <a:ext cx="3112922" cy="731520"/>
-          </a:xfrm>
-          <a:prstGeom prst="rect">
-            <a:avLst/>
-          </a:prstGeom>
-          <a:noFill/>
-          <a:ln/>
-        </p:spPr>
-        <p:txBody>
-          <a:bodyPr wrap="square" rtlCol="0" anchor="t"/>
-          <a:lstStyle/>
-          <a:p>
-            <a:pPr indent="0" marL="0">
-              <a:buNone/>
-            </a:pPr>
-            <a:r>
-              <a:rPr lang="en-US" sz="1200" i="1" dirty="0">
-                <a:solidFill>
-                  <a:srgbClr val="71717A"/>
-                </a:solidFill>
-                <a:latin typeface="Segoe UI" pitchFamily="34" charset="0"/>
-                <a:ea typeface="Segoe UI" pitchFamily="34" charset="-122"/>
-                <a:cs typeface="Segoe UI" pitchFamily="34" charset="-120"/>
-              </a:rPr>
-              <a:t>Five dropdowns, each filled by its own background request.</a:t>
-            </a:r>
-            <a:endParaRPr lang="en-US" sz="1200" dirty="0"/>
-          </a:p>
-        </p:txBody>
-      </p:sp>
-      <p:sp>
-        <p:nvSpPr>
-          <p:cNvPr id="15" name="Text 13"/>
-          <p:cNvSpPr/>
-          <p:nvPr/>
-        </p:nvSpPr>
-        <p:spPr>
-          <a:xfrm>
-            <a:off x="4539386" y="3621024"/>
-            <a:ext cx="3112922" cy="1600200"/>
+              <a:rPr lang="en-US" sz="1500" b="1" dirty="0">
+                <a:solidFill>
+                  <a:srgbClr val="0B5FA5"/>
+                </a:solidFill>
+                <a:latin typeface="Segoe UI" pitchFamily="34" charset="0"/>
+                <a:ea typeface="Segoe UI" pitchFamily="34" charset="-122"/>
+                <a:cs typeface="Segoe UI" pitchFamily="34" charset="-120"/>
+              </a:rPr>
+              <a:t>We still decide</a:t>
+            </a:r>
+            <a:endParaRPr lang="en-US" sz="1500" dirty="0"/>
+          </a:p>
+        </p:txBody>
+      </p:sp>
+      <p:sp>
+        <p:nvSpPr>
+          <p:cNvPr id="10" name="Text 8"/>
+          <p:cNvSpPr/>
+          <p:nvPr/>
+        </p:nvSpPr>
+        <p:spPr>
+          <a:xfrm>
+            <a:off x="6543904" y="2231136"/>
+            <a:ext cx="4861408" cy="2651760"/>
           </a:xfrm>
           <a:prstGeom prst="rect">
             <a:avLst/>
@@ -4459,13 +3891,13 @@
           <a:p>
             <a:pPr marL="342900" indent="-342900">
               <a:spcAft>
-                <a:spcPts val="600"/>
+                <a:spcPts val="700"/>
               </a:spcAft>
               <a:buSzPct val="100000"/>
               <a:buChar char="•"/>
             </a:pPr>
             <a:r>
-              <a:rPr lang="en-US" sz="1200" dirty="0">
+              <a:rPr lang="en-US" sz="1300" dirty="0">
                 <a:solidFill>
                   <a:srgbClr val="3F3F46"/>
                 </a:solidFill>
@@ -4473,20 +3905,20 @@
                 <a:ea typeface="Segoe UI" pitchFamily="34" charset="-122"/>
                 <a:cs typeface="Segoe UI" pitchFamily="34" charset="-120"/>
               </a:rPr>
-              <a:t>Waiting for "the page to look finished" was not enough - the page reloads one list while you fill the next</a:t>
-            </a:r>
-            <a:endParaRPr lang="en-US" sz="1200" dirty="0"/>
+              <a:t>Which journeys are worth automating</a:t>
+            </a:r>
+            <a:endParaRPr lang="en-US" sz="1300" dirty="0"/>
           </a:p>
           <a:p>
             <a:pPr marL="342900" indent="-342900">
               <a:spcAft>
-                <a:spcPts val="600"/>
+                <a:spcPts val="700"/>
               </a:spcAft>
               <a:buSzPct val="100000"/>
               <a:buChar char="•"/>
             </a:pPr>
             <a:r>
-              <a:rPr lang="en-US" sz="1200" dirty="0">
+              <a:rPr lang="en-US" sz="1300" dirty="0">
                 <a:solidFill>
                   <a:srgbClr val="3F3F46"/>
                 </a:solidFill>
@@ -4494,20 +3926,20 @@
                 <a:ea typeface="Segoe UI" pitchFamily="34" charset="-122"/>
                 <a:cs typeface="Segoe UI" pitchFamily="34" charset="-120"/>
               </a:rPr>
-              <a:t>It identified the four specific requests and waits for the right one each time</a:t>
-            </a:r>
-            <a:endParaRPr lang="en-US" sz="1200" dirty="0"/>
+              <a:t>Whether a failure is a test problem or a real bug</a:t>
+            </a:r>
+            <a:endParaRPr lang="en-US" sz="1300" dirty="0"/>
           </a:p>
           <a:p>
             <a:pPr marL="342900" indent="-342900">
               <a:spcAft>
-                <a:spcPts val="600"/>
+                <a:spcPts val="700"/>
               </a:spcAft>
               <a:buSzPct val="100000"/>
               <a:buChar char="•"/>
             </a:pPr>
             <a:r>
-              <a:rPr lang="en-US" sz="1200" dirty="0">
+              <a:rPr lang="en-US" sz="1300" dirty="0">
                 <a:solidFill>
                   <a:srgbClr val="3F3F46"/>
                 </a:solidFill>
@@ -4515,172 +3947,20 @@
                 <a:ea typeface="Segoe UI" pitchFamily="34" charset="-122"/>
                 <a:cs typeface="Segoe UI" pitchFamily="34" charset="-120"/>
               </a:rPr>
-              <a:t>This is the single most common cause of tests that pass locally and fail in CI</a:t>
-            </a:r>
-            <a:endParaRPr lang="en-US" sz="1200" dirty="0"/>
-          </a:p>
-        </p:txBody>
-      </p:sp>
-      <p:sp>
-        <p:nvSpPr>
-          <p:cNvPr id="16" name="Shape 14"/>
-          <p:cNvSpPr/>
-          <p:nvPr/>
-        </p:nvSpPr>
-        <p:spPr>
-          <a:xfrm>
-            <a:off x="8109509" y="2157984"/>
-            <a:ext cx="3515258" cy="3200400"/>
-          </a:xfrm>
-          <a:prstGeom prst="roundRect">
-            <a:avLst>
-              <a:gd name="adj" fmla="val 2286"/>
-            </a:avLst>
-          </a:prstGeom>
-          <a:solidFill>
-            <a:srgbClr val="F6F7F9"/>
-          </a:solidFill>
-          <a:ln w="12700">
-            <a:solidFill>
-              <a:srgbClr val="D9D9DE"/>
-            </a:solidFill>
-            <a:prstDash val="solid"/>
-          </a:ln>
-        </p:spPr>
-      </p:sp>
-      <p:sp>
-        <p:nvSpPr>
-          <p:cNvPr id="17" name="Shape 15"/>
-          <p:cNvSpPr/>
-          <p:nvPr/>
-        </p:nvSpPr>
-        <p:spPr>
-          <a:xfrm>
-            <a:off x="8109509" y="2157984"/>
-            <a:ext cx="3515258" cy="54864"/>
-          </a:xfrm>
-          <a:prstGeom prst="rect">
-            <a:avLst/>
-          </a:prstGeom>
-          <a:solidFill>
-            <a:srgbClr val="0B5FA5"/>
-          </a:solidFill>
-          <a:ln w="12700">
-            <a:solidFill>
-              <a:srgbClr val="0B5FA5"/>
-            </a:solidFill>
-            <a:prstDash val="solid"/>
-          </a:ln>
-        </p:spPr>
-      </p:sp>
-      <p:sp>
-        <p:nvSpPr>
-          <p:cNvPr id="18" name="Text 16"/>
-          <p:cNvSpPr/>
-          <p:nvPr/>
-        </p:nvSpPr>
-        <p:spPr>
-          <a:xfrm>
-            <a:off x="8310677" y="2322576"/>
-            <a:ext cx="3112922" cy="475488"/>
-          </a:xfrm>
-          <a:prstGeom prst="rect">
-            <a:avLst/>
-          </a:prstGeom>
-          <a:noFill/>
-          <a:ln/>
-        </p:spPr>
-        <p:txBody>
-          <a:bodyPr wrap="square" rtlCol="0" anchor="t"/>
-          <a:lstStyle/>
-          <a:p>
-            <a:pPr indent="0" marL="0">
-              <a:buNone/>
-            </a:pPr>
-            <a:r>
-              <a:rPr lang="en-US" sz="1450" b="1" dirty="0">
-                <a:solidFill>
-                  <a:srgbClr val="1A1A1E"/>
-                </a:solidFill>
-                <a:latin typeface="Segoe UI" pitchFamily="34" charset="0"/>
-                <a:ea typeface="Segoe UI" pitchFamily="34" charset="-122"/>
-                <a:cs typeface="Segoe UI" pitchFamily="34" charset="-120"/>
-              </a:rPr>
-              <a:t>The dead end in the data</a:t>
-            </a:r>
-            <a:endParaRPr lang="en-US" sz="1450" dirty="0"/>
-          </a:p>
-        </p:txBody>
-      </p:sp>
-      <p:sp>
-        <p:nvSpPr>
-          <p:cNvPr id="19" name="Text 17"/>
-          <p:cNvSpPr/>
-          <p:nvPr/>
-        </p:nvSpPr>
-        <p:spPr>
-          <a:xfrm>
-            <a:off x="8310677" y="2852928"/>
-            <a:ext cx="3112922" cy="731520"/>
-          </a:xfrm>
-          <a:prstGeom prst="rect">
-            <a:avLst/>
-          </a:prstGeom>
-          <a:noFill/>
-          <a:ln/>
-        </p:spPr>
-        <p:txBody>
-          <a:bodyPr wrap="square" rtlCol="0" anchor="t"/>
-          <a:lstStyle/>
-          <a:p>
-            <a:pPr indent="0" marL="0">
-              <a:buNone/>
-            </a:pPr>
-            <a:r>
-              <a:rPr lang="en-US" sz="1200" i="1" dirty="0">
-                <a:solidFill>
-                  <a:srgbClr val="71717A"/>
-                </a:solidFill>
-                <a:latin typeface="Segoe UI" pitchFamily="34" charset="0"/>
-                <a:ea typeface="Segoe UI" pitchFamily="34" charset="-122"/>
-                <a:cs typeface="Segoe UI" pitchFamily="34" charset="-120"/>
-              </a:rPr>
-              <a:t>The job could not be created with any obvious programme.</a:t>
-            </a:r>
-            <a:endParaRPr lang="en-US" sz="1200" dirty="0"/>
-          </a:p>
-        </p:txBody>
-      </p:sp>
-      <p:sp>
-        <p:nvSpPr>
-          <p:cNvPr id="20" name="Text 18"/>
-          <p:cNvSpPr/>
-          <p:nvPr/>
-        </p:nvSpPr>
-        <p:spPr>
-          <a:xfrm>
-            <a:off x="8310677" y="3621024"/>
-            <a:ext cx="3112922" cy="1600200"/>
-          </a:xfrm>
-          <a:prstGeom prst="rect">
-            <a:avLst/>
-          </a:prstGeom>
-          <a:noFill/>
-          <a:ln/>
-        </p:spPr>
-        <p:txBody>
-          <a:bodyPr wrap="square" rtlCol="0" anchor="t"/>
-          <a:lstStyle/>
+              <a:t>What may touch production, and what may never</a:t>
+            </a:r>
+            <a:endParaRPr lang="en-US" sz="1300" dirty="0"/>
+          </a:p>
           <a:p>
             <a:pPr marL="342900" indent="-342900">
               <a:spcAft>
-                <a:spcPts val="600"/>
+                <a:spcPts val="700"/>
               </a:spcAft>
               <a:buSzPct val="100000"/>
               <a:buChar char="•"/>
             </a:pPr>
             <a:r>
-              <a:rPr lang="en-US" sz="1200" dirty="0">
+              <a:rPr lang="en-US" sz="1300" dirty="0">
                 <a:solidFill>
                   <a:srgbClr val="3F3F46"/>
                 </a:solidFill>
@@ -4688,116 +3968,22 @@
                 <a:ea typeface="Segoe UI" pitchFamily="34" charset="-122"/>
                 <a:cs typeface="Segoe UI" pitchFamily="34" charset="-120"/>
               </a:rPr>
-              <a:t>Rather than guess, it checked all 15 programmes and their tiers on UAT</a:t>
-            </a:r>
-            <a:endParaRPr lang="en-US" sz="1200" dirty="0"/>
-          </a:p>
-          <a:p>
-            <a:pPr marL="342900" indent="-342900">
-              <a:spcAft>
-                <a:spcPts val="600"/>
-              </a:spcAft>
-              <a:buSzPct val="100000"/>
-              <a:buChar char="•"/>
-            </a:pPr>
-            <a:r>
-              <a:rPr lang="en-US" sz="1200" dirty="0">
-                <a:solidFill>
-                  <a:srgbClr val="3F3F46"/>
-                </a:solidFill>
-                <a:latin typeface="Segoe UI" pitchFamily="34" charset="0"/>
-                <a:ea typeface="Segoe UI" pitchFamily="34" charset="-122"/>
-                <a:cs typeface="Segoe UI" pitchFamily="34" charset="-120"/>
-              </a:rPr>
-              <a:t>Found the 4 that work and made the test ask for one by name</a:t>
-            </a:r>
-            <a:endParaRPr lang="en-US" sz="1200" dirty="0"/>
-          </a:p>
-          <a:p>
-            <a:pPr marL="342900" indent="-342900">
-              <a:spcAft>
-                <a:spcPts val="600"/>
-              </a:spcAft>
-              <a:buSzPct val="100000"/>
-              <a:buChar char="•"/>
-            </a:pPr>
-            <a:r>
-              <a:rPr lang="en-US" sz="1200" dirty="0">
-                <a:solidFill>
-                  <a:srgbClr val="3F3F46"/>
-                </a:solidFill>
-                <a:latin typeface="Segoe UI" pitchFamily="34" charset="0"/>
-                <a:ea typeface="Segoe UI" pitchFamily="34" charset="-122"/>
-                <a:cs typeface="Segoe UI" pitchFamily="34" charset="-120"/>
-              </a:rPr>
-              <a:t>Answered a question that was not written down anywhere (next slide)</a:t>
-            </a:r>
-            <a:endParaRPr lang="en-US" sz="1200" dirty="0"/>
-          </a:p>
-        </p:txBody>
-      </p:sp>
-      <p:sp>
-        <p:nvSpPr>
-          <p:cNvPr id="21" name="Shape 19"/>
-          <p:cNvSpPr/>
-          <p:nvPr/>
-        </p:nvSpPr>
-        <p:spPr>
-          <a:xfrm>
-            <a:off x="566928" y="5541264"/>
-            <a:ext cx="11057839" cy="731520"/>
-          </a:xfrm>
-          <a:prstGeom prst="roundRect">
-            <a:avLst>
-              <a:gd name="adj" fmla="val 7500"/>
-            </a:avLst>
-          </a:prstGeom>
-          <a:solidFill>
-            <a:srgbClr val="FDF6E7"/>
-          </a:solidFill>
-          <a:ln w="12700">
-            <a:solidFill>
-              <a:srgbClr val="EBD9AE"/>
-            </a:solidFill>
-            <a:prstDash val="solid"/>
-          </a:ln>
-        </p:spPr>
-      </p:sp>
-      <p:sp>
-        <p:nvSpPr>
-          <p:cNvPr id="22" name="Shape 20"/>
-          <p:cNvSpPr/>
-          <p:nvPr/>
-        </p:nvSpPr>
-        <p:spPr>
-          <a:xfrm>
-            <a:off x="566928" y="5541264"/>
-            <a:ext cx="64008" cy="731520"/>
-          </a:xfrm>
-          <a:prstGeom prst="rect">
-            <a:avLst/>
-          </a:prstGeom>
-          <a:solidFill>
-            <a:srgbClr val="B45309"/>
-          </a:solidFill>
-          <a:ln w="12700">
-            <a:solidFill>
-              <a:srgbClr val="B45309"/>
-            </a:solidFill>
-            <a:prstDash val="solid"/>
-          </a:ln>
-        </p:spPr>
-      </p:sp>
-      <p:sp>
-        <p:nvSpPr>
-          <p:cNvPr id="23" name="Text 21"/>
-          <p:cNvSpPr/>
-          <p:nvPr/>
-        </p:nvSpPr>
-        <p:spPr>
-          <a:xfrm>
-            <a:off x="822960" y="5541264"/>
-            <a:ext cx="10600639" cy="731520"/>
+              <a:t>Nothing merges without a review - same bar as any code</a:t>
+            </a:r>
+            <a:endParaRPr lang="en-US" sz="1300" dirty="0"/>
+          </a:p>
+        </p:txBody>
+      </p:sp>
+      <p:sp>
+        <p:nvSpPr>
+          <p:cNvPr id="11" name="Text 9"/>
+          <p:cNvSpPr/>
+          <p:nvPr/>
+        </p:nvSpPr>
+        <p:spPr>
+          <a:xfrm>
+            <a:off x="566928" y="5760720"/>
+            <a:ext cx="11057839" cy="365760"/>
           </a:xfrm>
           <a:prstGeom prst="rect">
             <a:avLst/>
@@ -4813,17 +3999,17 @@
               <a:buNone/>
             </a:pPr>
             <a:r>
-              <a:rPr lang="en-US" sz="1350" dirty="0">
-                <a:solidFill>
-                  <a:srgbClr val="1A1A1E"/>
-                </a:solidFill>
-                <a:latin typeface="Segoe UI" pitchFamily="34" charset="0"/>
-                <a:ea typeface="Segoe UI" pitchFamily="34" charset="-122"/>
-                <a:cs typeface="Segoe UI" pitchFamily="34" charset="-120"/>
-              </a:rPr>
-              <a:t>None of these are typing problems. They are the judgement calls that decide whether a suite is trusted or quietly switched off six months later.</a:t>
-            </a:r>
-            <a:endParaRPr lang="en-US" sz="1350" dirty="0"/>
+              <a:rPr lang="en-US" sz="1300" i="1" dirty="0">
+                <a:solidFill>
+                  <a:srgbClr val="71717A"/>
+                </a:solidFill>
+                <a:latin typeface="Segoe UI" pitchFamily="34" charset="0"/>
+                <a:ea typeface="Segoe UI" pitchFamily="34" charset="-122"/>
+                <a:cs typeface="Segoe UI" pitchFamily="34" charset="-120"/>
+              </a:rPr>
+              <a:t>The workshop point: the cost of an automated check has dropped far enough that "we do not have time to automate it" is no longer the real constraint.</a:t>
+            </a:r>
+            <a:endParaRPr lang="en-US" sz="1300" dirty="0"/>
           </a:p>
         </p:txBody>
       </p:sp>
@@ -4892,7 +4078,7 @@
                 <a:ea typeface="Segoe UI" pitchFamily="34" charset="-122"/>
                 <a:cs typeface="Segoe UI" pitchFamily="34" charset="-120"/>
               </a:rPr>
-              <a:t>One example: the puzzle it solved by itself</a:t>
+              <a:t>Running it in CI</a:t>
             </a:r>
             <a:endParaRPr lang="en-US" sz="2600" dirty="0"/>
           </a:p>
@@ -4931,7 +4117,7 @@
                 <a:ea typeface="Segoe UI" pitchFamily="34" charset="-122"/>
                 <a:cs typeface="Segoe UI" pitchFamily="34" charset="-120"/>
               </a:rPr>
-              <a:t>The job-creation test failed. Instead of guessing, it went and found the answer.</a:t>
+              <a:t>The same command a developer runs is the command the pipeline runs</a:t>
             </a:r>
             <a:endParaRPr lang="en-US" sz="1400" dirty="0"/>
           </a:p>
@@ -4966,19 +4152,19 @@
         <p:spPr>
           <a:xfrm>
             <a:off x="566928" y="1627632"/>
-            <a:ext cx="2531288" cy="960120"/>
+            <a:ext cx="11057839" cy="2011680"/>
           </a:xfrm>
           <a:prstGeom prst="roundRect">
             <a:avLst>
-              <a:gd name="adj" fmla="val 7619"/>
+              <a:gd name="adj" fmla="val 2727"/>
             </a:avLst>
           </a:prstGeom>
           <a:solidFill>
-            <a:srgbClr val="E8F0F8"/>
+            <a:srgbClr val="1E1E24"/>
           </a:solidFill>
           <a:ln w="12700">
             <a:solidFill>
-              <a:srgbClr val="C9DAEA"/>
+              <a:srgbClr val="1E1E24"/>
             </a:solidFill>
             <a:prstDash val="solid"/>
           </a:ln>
@@ -4992,8 +4178,8 @@
         </p:nvSpPr>
         <p:spPr>
           <a:xfrm>
-            <a:off x="640080" y="1682496"/>
-            <a:ext cx="2384984" cy="850392"/>
+            <a:off x="768096" y="1773936"/>
+            <a:ext cx="10655503" cy="1719072"/>
           </a:xfrm>
           <a:prstGeom prst="rect">
             <a:avLst/>
@@ -5002,54 +4188,168 @@
           <a:ln/>
         </p:spPr>
         <p:txBody>
+          <a:bodyPr wrap="square" rtlCol="0" anchor="t"/>
+          <a:lstStyle/>
+          <a:p>
+            <a:pPr indent="0" marL="0">
+              <a:lnSpc>
+                <a:spcPct val="112000"/>
+              </a:lnSpc>
+              <a:buNone/>
+            </a:pPr>
+            <a:r>
+              <a:rPr lang="en-US" sz="1150" dirty="0">
+                <a:solidFill>
+                  <a:srgbClr val="E8E8EC"/>
+                </a:solidFill>
+                <a:latin typeface="Consolas" pitchFamily="34" charset="0"/>
+                <a:ea typeface="Consolas" pitchFamily="34" charset="-122"/>
+                <a:cs typeface="Consolas" pitchFamily="34" charset="-120"/>
+              </a:rPr>
+              <a:t># any CI runner - CodeBuild, Bitbucket Pipelines, GitHub Actions</a:t>
+            </a:r>
+            <a:endParaRPr lang="en-US" sz="1150" dirty="0"/>
+          </a:p>
+          <a:p>
+            <a:pPr indent="0" marL="0">
+              <a:lnSpc>
+                <a:spcPct val="112000"/>
+              </a:lnSpc>
+              <a:buNone/>
+            </a:pPr>
+            <a:r>
+              <a:rPr lang="en-US" sz="1150" dirty="0">
+                <a:solidFill>
+                  <a:srgbClr val="E8E8EC"/>
+                </a:solidFill>
+                <a:latin typeface="Consolas" pitchFamily="34" charset="0"/>
+                <a:ea typeface="Consolas" pitchFamily="34" charset="-122"/>
+                <a:cs typeface="Consolas" pitchFamily="34" charset="-120"/>
+              </a:rPr>
+              <a:t>npm ci</a:t>
+            </a:r>
+            <a:endParaRPr lang="en-US" sz="1150" dirty="0"/>
+          </a:p>
+          <a:p>
+            <a:pPr indent="0" marL="0">
+              <a:lnSpc>
+                <a:spcPct val="112000"/>
+              </a:lnSpc>
+              <a:buNone/>
+            </a:pPr>
+            <a:r>
+              <a:rPr lang="en-US" sz="1150" dirty="0">
+                <a:solidFill>
+                  <a:srgbClr val="E8E8EC"/>
+                </a:solidFill>
+                <a:latin typeface="Consolas" pitchFamily="34" charset="0"/>
+                <a:ea typeface="Consolas" pitchFamily="34" charset="-122"/>
+                <a:cs typeface="Consolas" pitchFamily="34" charset="-120"/>
+              </a:rPr>
+              <a:t>npx playwright install --with-deps chromium</a:t>
+            </a:r>
+            <a:endParaRPr lang="en-US" sz="1150" dirty="0"/>
+          </a:p>
+          <a:p>
+            <a:pPr indent="0" marL="0">
+              <a:lnSpc>
+                <a:spcPct val="112000"/>
+              </a:lnSpc>
+              <a:buNone/>
+            </a:pPr>
+            <a:r>
+              <a:rPr lang="en-US" sz="1150" dirty="0">
+                <a:solidFill>
+                  <a:srgbClr val="E8E8EC"/>
+                </a:solidFill>
+                <a:latin typeface="Consolas" pitchFamily="34" charset="0"/>
+                <a:ea typeface="Consolas" pitchFamily="34" charset="-122"/>
+                <a:cs typeface="Consolas" pitchFamily="34" charset="-120"/>
+              </a:rPr>
+              <a:t>npm test                       # retries once on CI, serial, ~1 minute</a:t>
+            </a:r>
+            <a:endParaRPr lang="en-US" sz="1150" dirty="0"/>
+          </a:p>
+          <a:p>
+            <a:pPr indent="0" marL="0">
+              <a:lnSpc>
+                <a:spcPct val="112000"/>
+              </a:lnSpc>
+              <a:buNone/>
+            </a:pPr>
+            <a:endParaRPr lang="en-US" sz="1150" dirty="0"/>
+          </a:p>
+          <a:p>
+            <a:pPr indent="0" marL="0">
+              <a:lnSpc>
+                <a:spcPct val="112000"/>
+              </a:lnSpc>
+              <a:buNone/>
+            </a:pPr>
+            <a:r>
+              <a:rPr lang="en-US" sz="1150" dirty="0">
+                <a:solidFill>
+                  <a:srgbClr val="E8E8EC"/>
+                </a:solidFill>
+                <a:latin typeface="Consolas" pitchFamily="34" charset="0"/>
+                <a:ea typeface="Consolas" pitchFamily="34" charset="-122"/>
+                <a:cs typeface="Consolas" pitchFamily="34" charset="-120"/>
+              </a:rPr>
+              <a:t># artefacts to keep: playwright-report/  reports/junit.xml</a:t>
+            </a:r>
+            <a:endParaRPr lang="en-US" sz="1150" dirty="0"/>
+          </a:p>
+        </p:txBody>
+      </p:sp>
+      <p:sp>
+        <p:nvSpPr>
+          <p:cNvPr id="7" name="Text 5"/>
+          <p:cNvSpPr/>
+          <p:nvPr/>
+        </p:nvSpPr>
+        <p:spPr>
+          <a:xfrm>
+            <a:off x="566928" y="3694176"/>
+            <a:ext cx="11057839" cy="274320"/>
+          </a:xfrm>
+          <a:prstGeom prst="rect">
+            <a:avLst/>
+          </a:prstGeom>
+          <a:noFill/>
+          <a:ln/>
+        </p:spPr>
+        <p:txBody>
           <a:bodyPr wrap="square" rtlCol="0" anchor="ctr"/>
           <a:lstStyle/>
           <a:p>
-            <a:pPr algn="ctr" indent="0" marL="0">
-              <a:buNone/>
-            </a:pPr>
-            <a:r>
-              <a:rPr lang="en-US" sz="1200" b="1" dirty="0">
-                <a:solidFill>
-                  <a:srgbClr val="1A1A1E"/>
-                </a:solidFill>
-                <a:latin typeface="Segoe UI" pitchFamily="34" charset="0"/>
-                <a:ea typeface="Segoe UI" pitchFamily="34" charset="-122"/>
-                <a:cs typeface="Segoe UI" pitchFamily="34" charset="-120"/>
-              </a:rPr>
-              <a:t>Test fails:</a:t>
-            </a:r>
-            <a:endParaRPr lang="en-US" sz="1200" dirty="0"/>
-          </a:p>
-          <a:p>
-            <a:pPr algn="ctr" indent="0" marL="0">
-              <a:buNone/>
-            </a:pPr>
-            <a:r>
-              <a:rPr lang="en-US" sz="1200" b="1" dirty="0">
-                <a:solidFill>
-                  <a:srgbClr val="1A1A1E"/>
-                </a:solidFill>
-                <a:latin typeface="Segoe UI" pitchFamily="34" charset="0"/>
-                <a:ea typeface="Segoe UI" pitchFamily="34" charset="-122"/>
-                <a:cs typeface="Segoe UI" pitchFamily="34" charset="-120"/>
-              </a:rPr>
-              <a:t>"Privilege is required"</a:t>
-            </a:r>
-            <a:endParaRPr lang="en-US" sz="1200" dirty="0"/>
-          </a:p>
-        </p:txBody>
-      </p:sp>
-      <p:sp>
-        <p:nvSpPr>
-          <p:cNvPr id="7" name="Text 5"/>
-          <p:cNvSpPr/>
-          <p:nvPr/>
-        </p:nvSpPr>
-        <p:spPr>
-          <a:xfrm>
-            <a:off x="3098216" y="1627632"/>
-            <a:ext cx="310896" cy="960120"/>
+            <a:pPr indent="0" marL="0">
+              <a:buNone/>
+            </a:pPr>
+            <a:r>
+              <a:rPr lang="en-US" sz="1100" i="1" dirty="0">
+                <a:solidFill>
+                  <a:srgbClr val="71717A"/>
+                </a:solidFill>
+                <a:latin typeface="Segoe UI" pitchFamily="34" charset="0"/>
+                <a:ea typeface="Segoe UI" pitchFamily="34" charset="-122"/>
+                <a:cs typeface="Segoe UI" pitchFamily="34" charset="-120"/>
+              </a:rPr>
+              <a:t>JUnit XML is what a CI dashboard reads; the HTML report is what a human opens.</a:t>
+            </a:r>
+            <a:endParaRPr lang="en-US" sz="1100" dirty="0"/>
+          </a:p>
+        </p:txBody>
+      </p:sp>
+      <p:sp>
+        <p:nvSpPr>
+          <p:cNvPr id="8" name="Text 6"/>
+          <p:cNvSpPr/>
+          <p:nvPr/>
+        </p:nvSpPr>
+        <p:spPr>
+          <a:xfrm>
+            <a:off x="566928" y="4142232"/>
+            <a:ext cx="11057839" cy="4023360"/>
           </a:xfrm>
           <a:prstGeom prst="rect">
             <a:avLst/>
@@ -5058,772 +4358,79 @@
           <a:ln/>
         </p:spPr>
         <p:txBody>
-          <a:bodyPr wrap="square" rtlCol="0" anchor="ctr"/>
-          <a:lstStyle/>
-          <a:p>
-            <a:pPr algn="ctr" indent="0" marL="0">
-              <a:buNone/>
-            </a:pPr>
-            <a:r>
-              <a:rPr lang="en-US" sz="1700" b="1" dirty="0">
-                <a:solidFill>
-                  <a:srgbClr val="71717A"/>
-                </a:solidFill>
-                <a:latin typeface="Segoe UI" pitchFamily="34" charset="0"/>
-                <a:ea typeface="Segoe UI" pitchFamily="34" charset="-122"/>
-                <a:cs typeface="Segoe UI" pitchFamily="34" charset="-120"/>
-              </a:rPr>
-              <a:t>→</a:t>
-            </a:r>
-            <a:endParaRPr lang="en-US" sz="1700" dirty="0"/>
-          </a:p>
-        </p:txBody>
-      </p:sp>
-      <p:sp>
-        <p:nvSpPr>
-          <p:cNvPr id="8" name="Shape 6"/>
-          <p:cNvSpPr/>
-          <p:nvPr/>
-        </p:nvSpPr>
-        <p:spPr>
-          <a:xfrm>
-            <a:off x="3409112" y="1627632"/>
-            <a:ext cx="2531288" cy="960120"/>
-          </a:xfrm>
-          <a:prstGeom prst="roundRect">
-            <a:avLst>
-              <a:gd name="adj" fmla="val 7619"/>
-            </a:avLst>
-          </a:prstGeom>
-          <a:solidFill>
-            <a:srgbClr val="0B5FA5"/>
-          </a:solidFill>
-          <a:ln w="12700">
-            <a:solidFill>
-              <a:srgbClr val="0B5FA5"/>
-            </a:solidFill>
-            <a:prstDash val="solid"/>
-          </a:ln>
-        </p:spPr>
-      </p:sp>
-      <p:sp>
-        <p:nvSpPr>
-          <p:cNvPr id="9" name="Text 7"/>
-          <p:cNvSpPr/>
-          <p:nvPr/>
-        </p:nvSpPr>
-        <p:spPr>
-          <a:xfrm>
-            <a:off x="3482264" y="1682496"/>
-            <a:ext cx="2384984" cy="850392"/>
-          </a:xfrm>
-          <a:prstGeom prst="rect">
-            <a:avLst/>
-          </a:prstGeom>
-          <a:noFill/>
-          <a:ln/>
-        </p:spPr>
-        <p:txBody>
-          <a:bodyPr wrap="square" rtlCol="0" anchor="ctr"/>
-          <a:lstStyle/>
-          <a:p>
-            <a:pPr algn="ctr" indent="0" marL="0">
-              <a:buNone/>
-            </a:pPr>
-            <a:r>
-              <a:rPr lang="en-US" sz="1200" b="1" dirty="0">
-                <a:solidFill>
-                  <a:srgbClr val="FFFFFF"/>
-                </a:solidFill>
-                <a:latin typeface="Segoe UI" pitchFamily="34" charset="0"/>
-                <a:ea typeface="Segoe UI" pitchFamily="34" charset="-122"/>
-                <a:cs typeface="Segoe UI" pitchFamily="34" charset="-120"/>
-              </a:rPr>
-              <a:t>Checks every program</a:t>
-            </a:r>
-            <a:endParaRPr lang="en-US" sz="1200" dirty="0"/>
-          </a:p>
-          <a:p>
-            <a:pPr algn="ctr" indent="0" marL="0">
-              <a:buNone/>
-            </a:pPr>
-            <a:r>
-              <a:rPr lang="en-US" sz="1200" b="1" dirty="0">
-                <a:solidFill>
-                  <a:srgbClr val="FFFFFF"/>
-                </a:solidFill>
-                <a:latin typeface="Segoe UI" pitchFamily="34" charset="0"/>
-                <a:ea typeface="Segoe UI" pitchFamily="34" charset="-122"/>
-                <a:cs typeface="Segoe UI" pitchFamily="34" charset="-120"/>
-              </a:rPr>
-              <a:t>and tier on UAT</a:t>
-            </a:r>
-            <a:endParaRPr lang="en-US" sz="1200" dirty="0"/>
-          </a:p>
-        </p:txBody>
-      </p:sp>
-      <p:sp>
-        <p:nvSpPr>
-          <p:cNvPr id="10" name="Text 8"/>
-          <p:cNvSpPr/>
-          <p:nvPr/>
-        </p:nvSpPr>
-        <p:spPr>
-          <a:xfrm>
-            <a:off x="5940400" y="1627632"/>
-            <a:ext cx="310896" cy="960120"/>
-          </a:xfrm>
-          <a:prstGeom prst="rect">
-            <a:avLst/>
-          </a:prstGeom>
-          <a:noFill/>
-          <a:ln/>
-        </p:spPr>
-        <p:txBody>
-          <a:bodyPr wrap="square" rtlCol="0" anchor="ctr"/>
-          <a:lstStyle/>
-          <a:p>
-            <a:pPr algn="ctr" indent="0" marL="0">
-              <a:buNone/>
-            </a:pPr>
-            <a:r>
-              <a:rPr lang="en-US" sz="1700" b="1" dirty="0">
-                <a:solidFill>
-                  <a:srgbClr val="71717A"/>
-                </a:solidFill>
-                <a:latin typeface="Segoe UI" pitchFamily="34" charset="0"/>
-                <a:ea typeface="Segoe UI" pitchFamily="34" charset="-122"/>
-                <a:cs typeface="Segoe UI" pitchFamily="34" charset="-120"/>
-              </a:rPr>
-              <a:t>→</a:t>
-            </a:r>
-            <a:endParaRPr lang="en-US" sz="1700" dirty="0"/>
-          </a:p>
-        </p:txBody>
-      </p:sp>
-      <p:sp>
-        <p:nvSpPr>
-          <p:cNvPr id="11" name="Shape 9"/>
-          <p:cNvSpPr/>
-          <p:nvPr/>
-        </p:nvSpPr>
-        <p:spPr>
-          <a:xfrm>
-            <a:off x="6251296" y="1627632"/>
-            <a:ext cx="2531288" cy="960120"/>
-          </a:xfrm>
-          <a:prstGeom prst="roundRect">
-            <a:avLst>
-              <a:gd name="adj" fmla="val 7619"/>
-            </a:avLst>
-          </a:prstGeom>
-          <a:solidFill>
-            <a:srgbClr val="E8F0F8"/>
-          </a:solidFill>
-          <a:ln w="12700">
-            <a:solidFill>
-              <a:srgbClr val="C9DAEA"/>
-            </a:solidFill>
-            <a:prstDash val="solid"/>
-          </a:ln>
-        </p:spPr>
-      </p:sp>
-      <p:sp>
-        <p:nvSpPr>
-          <p:cNvPr id="12" name="Text 10"/>
-          <p:cNvSpPr/>
-          <p:nvPr/>
-        </p:nvSpPr>
-        <p:spPr>
-          <a:xfrm>
-            <a:off x="6324448" y="1682496"/>
-            <a:ext cx="2384984" cy="850392"/>
-          </a:xfrm>
-          <a:prstGeom prst="rect">
-            <a:avLst/>
-          </a:prstGeom>
-          <a:noFill/>
-          <a:ln/>
-        </p:spPr>
-        <p:txBody>
-          <a:bodyPr wrap="square" rtlCol="0" anchor="ctr"/>
-          <a:lstStyle/>
-          <a:p>
-            <a:pPr algn="ctr" indent="0" marL="0">
-              <a:buNone/>
-            </a:pPr>
-            <a:r>
-              <a:rPr lang="en-US" sz="1200" b="1" dirty="0">
-                <a:solidFill>
-                  <a:srgbClr val="1A1A1E"/>
-                </a:solidFill>
-                <a:latin typeface="Segoe UI" pitchFamily="34" charset="0"/>
-                <a:ea typeface="Segoe UI" pitchFamily="34" charset="-122"/>
-                <a:cs typeface="Segoe UI" pitchFamily="34" charset="-120"/>
-              </a:rPr>
-              <a:t>Finds only 4 of 15</a:t>
-            </a:r>
-            <a:endParaRPr lang="en-US" sz="1200" dirty="0"/>
-          </a:p>
-          <a:p>
-            <a:pPr algn="ctr" indent="0" marL="0">
-              <a:buNone/>
-            </a:pPr>
-            <a:r>
-              <a:rPr lang="en-US" sz="1200" b="1" dirty="0">
-                <a:solidFill>
-                  <a:srgbClr val="1A1A1E"/>
-                </a:solidFill>
-                <a:latin typeface="Segoe UI" pitchFamily="34" charset="0"/>
-                <a:ea typeface="Segoe UI" pitchFamily="34" charset="-122"/>
-                <a:cs typeface="Segoe UI" pitchFamily="34" charset="-120"/>
-              </a:rPr>
-              <a:t>programs can work</a:t>
-            </a:r>
-            <a:endParaRPr lang="en-US" sz="1200" dirty="0"/>
-          </a:p>
-        </p:txBody>
-      </p:sp>
-      <p:sp>
-        <p:nvSpPr>
-          <p:cNvPr id="13" name="Text 11"/>
-          <p:cNvSpPr/>
-          <p:nvPr/>
-        </p:nvSpPr>
-        <p:spPr>
-          <a:xfrm>
-            <a:off x="8782583" y="1627632"/>
-            <a:ext cx="310896" cy="960120"/>
-          </a:xfrm>
-          <a:prstGeom prst="rect">
-            <a:avLst/>
-          </a:prstGeom>
-          <a:noFill/>
-          <a:ln/>
-        </p:spPr>
-        <p:txBody>
-          <a:bodyPr wrap="square" rtlCol="0" anchor="ctr"/>
-          <a:lstStyle/>
-          <a:p>
-            <a:pPr algn="ctr" indent="0" marL="0">
-              <a:buNone/>
-            </a:pPr>
-            <a:r>
-              <a:rPr lang="en-US" sz="1700" b="1" dirty="0">
-                <a:solidFill>
-                  <a:srgbClr val="71717A"/>
-                </a:solidFill>
-                <a:latin typeface="Segoe UI" pitchFamily="34" charset="0"/>
-                <a:ea typeface="Segoe UI" pitchFamily="34" charset="-122"/>
-                <a:cs typeface="Segoe UI" pitchFamily="34" charset="-120"/>
-              </a:rPr>
-              <a:t>→</a:t>
-            </a:r>
-            <a:endParaRPr lang="en-US" sz="1700" dirty="0"/>
-          </a:p>
-        </p:txBody>
-      </p:sp>
-      <p:sp>
-        <p:nvSpPr>
-          <p:cNvPr id="14" name="Shape 12"/>
-          <p:cNvSpPr/>
-          <p:nvPr/>
-        </p:nvSpPr>
-        <p:spPr>
-          <a:xfrm>
-            <a:off x="9093479" y="1627632"/>
-            <a:ext cx="2531288" cy="960120"/>
-          </a:xfrm>
-          <a:prstGeom prst="roundRect">
-            <a:avLst>
-              <a:gd name="adj" fmla="val 7619"/>
-            </a:avLst>
-          </a:prstGeom>
-          <a:solidFill>
-            <a:srgbClr val="E8F0F8"/>
-          </a:solidFill>
-          <a:ln w="12700">
-            <a:solidFill>
-              <a:srgbClr val="C9DAEA"/>
-            </a:solidFill>
-            <a:prstDash val="solid"/>
-          </a:ln>
-        </p:spPr>
-      </p:sp>
-      <p:sp>
-        <p:nvSpPr>
-          <p:cNvPr id="15" name="Text 13"/>
-          <p:cNvSpPr/>
-          <p:nvPr/>
-        </p:nvSpPr>
-        <p:spPr>
-          <a:xfrm>
-            <a:off x="9166631" y="1682496"/>
-            <a:ext cx="2384984" cy="850392"/>
-          </a:xfrm>
-          <a:prstGeom prst="rect">
-            <a:avLst/>
-          </a:prstGeom>
-          <a:noFill/>
-          <a:ln/>
-        </p:spPr>
-        <p:txBody>
-          <a:bodyPr wrap="square" rtlCol="0" anchor="ctr"/>
-          <a:lstStyle/>
-          <a:p>
-            <a:pPr algn="ctr" indent="0" marL="0">
-              <a:buNone/>
-            </a:pPr>
-            <a:r>
-              <a:rPr lang="en-US" sz="1200" b="1" dirty="0">
-                <a:solidFill>
-                  <a:srgbClr val="1A1A1E"/>
-                </a:solidFill>
-                <a:latin typeface="Segoe UI" pitchFamily="34" charset="0"/>
-                <a:ea typeface="Segoe UI" pitchFamily="34" charset="-122"/>
-                <a:cs typeface="Segoe UI" pitchFamily="34" charset="-120"/>
-              </a:rPr>
-              <a:t>Test picks a working</a:t>
-            </a:r>
-            <a:endParaRPr lang="en-US" sz="1200" dirty="0"/>
-          </a:p>
-          <a:p>
-            <a:pPr algn="ctr" indent="0" marL="0">
-              <a:buNone/>
-            </a:pPr>
-            <a:r>
-              <a:rPr lang="en-US" sz="1200" b="1" dirty="0">
-                <a:solidFill>
-                  <a:srgbClr val="1A1A1E"/>
-                </a:solidFill>
-                <a:latin typeface="Segoe UI" pitchFamily="34" charset="0"/>
-                <a:ea typeface="Segoe UI" pitchFamily="34" charset="-122"/>
-                <a:cs typeface="Segoe UI" pitchFamily="34" charset="-120"/>
-              </a:rPr>
-              <a:t>one - and it is</a:t>
-            </a:r>
-            <a:endParaRPr lang="en-US" sz="1200" dirty="0"/>
-          </a:p>
-          <a:p>
-            <a:pPr algn="ctr" indent="0" marL="0">
-              <a:buNone/>
-            </a:pPr>
-            <a:r>
-              <a:rPr lang="en-US" sz="1200" b="1" dirty="0">
-                <a:solidFill>
-                  <a:srgbClr val="1A1A1E"/>
-                </a:solidFill>
-                <a:latin typeface="Segoe UI" pitchFamily="34" charset="0"/>
-                <a:ea typeface="Segoe UI" pitchFamily="34" charset="-122"/>
-                <a:cs typeface="Segoe UI" pitchFamily="34" charset="-120"/>
-              </a:rPr>
-              <a:t>written down</a:t>
-            </a:r>
-            <a:endParaRPr lang="en-US" sz="1200" dirty="0"/>
-          </a:p>
-        </p:txBody>
-      </p:sp>
-      <p:sp>
-        <p:nvSpPr>
-          <p:cNvPr id="16" name="Shape 14"/>
-          <p:cNvSpPr/>
-          <p:nvPr/>
-        </p:nvSpPr>
-        <p:spPr>
-          <a:xfrm>
-            <a:off x="566928" y="2953512"/>
-            <a:ext cx="5300320" cy="2743200"/>
-          </a:xfrm>
-          <a:prstGeom prst="roundRect">
-            <a:avLst>
-              <a:gd name="adj" fmla="val 2667"/>
-            </a:avLst>
-          </a:prstGeom>
-          <a:solidFill>
-            <a:srgbClr val="F6F7F9"/>
-          </a:solidFill>
-          <a:ln w="12700">
-            <a:solidFill>
-              <a:srgbClr val="D9D9DE"/>
-            </a:solidFill>
-            <a:prstDash val="solid"/>
-          </a:ln>
-        </p:spPr>
-      </p:sp>
-      <p:sp>
-        <p:nvSpPr>
-          <p:cNvPr id="17" name="Text 15"/>
-          <p:cNvSpPr/>
-          <p:nvPr/>
-        </p:nvSpPr>
-        <p:spPr>
-          <a:xfrm>
-            <a:off x="786384" y="3136392"/>
-            <a:ext cx="4861408" cy="365760"/>
-          </a:xfrm>
-          <a:prstGeom prst="rect">
-            <a:avLst/>
-          </a:prstGeom>
-          <a:noFill/>
-          <a:ln/>
-        </p:spPr>
-        <p:txBody>
-          <a:bodyPr wrap="square" rtlCol="0" anchor="ctr"/>
-          <a:lstStyle/>
-          <a:p>
-            <a:pPr indent="0" marL="0">
-              <a:buNone/>
-            </a:pPr>
-            <a:r>
-              <a:rPr lang="en-US" sz="1500" b="1" dirty="0">
-                <a:solidFill>
-                  <a:srgbClr val="B91C1C"/>
-                </a:solidFill>
-                <a:latin typeface="Segoe UI" pitchFamily="34" charset="0"/>
-                <a:ea typeface="Segoe UI" pitchFamily="34" charset="-122"/>
-                <a:cs typeface="Segoe UI" pitchFamily="34" charset="-120"/>
-              </a:rPr>
-              <a:t>The usual ways this goes</a:t>
-            </a:r>
-            <a:endParaRPr lang="en-US" sz="1500" dirty="0"/>
-          </a:p>
-        </p:txBody>
-      </p:sp>
-      <p:sp>
-        <p:nvSpPr>
-          <p:cNvPr id="18" name="Text 16"/>
-          <p:cNvSpPr/>
-          <p:nvPr/>
-        </p:nvSpPr>
-        <p:spPr>
-          <a:xfrm>
-            <a:off x="786384" y="3557016"/>
-            <a:ext cx="4861408" cy="1920240"/>
-          </a:xfrm>
-          <a:prstGeom prst="rect">
-            <a:avLst/>
-          </a:prstGeom>
-          <a:noFill/>
-          <a:ln/>
-        </p:spPr>
-        <p:txBody>
           <a:bodyPr wrap="square" rtlCol="0" anchor="t"/>
           <a:lstStyle/>
           <a:p>
             <a:pPr marL="342900" indent="-342900">
+              <a:lnSpc>
+                <a:spcPct val="115000"/>
+              </a:lnSpc>
               <a:spcAft>
-                <a:spcPts val="700"/>
+                <a:spcPts val="1000"/>
               </a:spcAft>
               <a:buSzPct val="100000"/>
               <a:buChar char="•"/>
             </a:pPr>
             <a:r>
-              <a:rPr lang="en-US" sz="1300" dirty="0">
-                <a:solidFill>
-                  <a:srgbClr val="3F3F46"/>
-                </a:solidFill>
-                <a:latin typeface="Segoe UI" pitchFamily="34" charset="0"/>
-                <a:ea typeface="Segoe UI" pitchFamily="34" charset="-122"/>
-                <a:cs typeface="Segoe UI" pitchFamily="34" charset="-120"/>
-              </a:rPr>
-              <a:t>Ask around until someone remembers</a:t>
-            </a:r>
-            <a:endParaRPr lang="en-US" sz="1300" dirty="0"/>
+              <a:rPr lang="en-US" sz="1450" dirty="0">
+                <a:solidFill>
+                  <a:srgbClr val="1A1A1E"/>
+                </a:solidFill>
+                <a:latin typeface="Segoe UI" pitchFamily="34" charset="0"/>
+                <a:ea typeface="Segoe UI" pitchFamily="34" charset="-122"/>
+                <a:cs typeface="Segoe UI" pitchFamily="34" charset="-120"/>
+              </a:rPr>
+              <a:t>Run on every pull request against the target branch, and nightly against UAT</a:t>
+            </a:r>
+            <a:endParaRPr lang="en-US" sz="1450" dirty="0"/>
           </a:p>
           <a:p>
             <a:pPr marL="342900" indent="-342900">
+              <a:lnSpc>
+                <a:spcPct val="115000"/>
+              </a:lnSpc>
               <a:spcAft>
-                <a:spcPts val="700"/>
+                <a:spcPts val="1000"/>
               </a:spcAft>
               <a:buSzPct val="100000"/>
               <a:buChar char="•"/>
             </a:pPr>
             <a:r>
-              <a:rPr lang="en-US" sz="1300" dirty="0">
-                <a:solidFill>
-                  <a:srgbClr val="3F3F46"/>
-                </a:solidFill>
-                <a:latin typeface="Segoe UI" pitchFamily="34" charset="0"/>
-                <a:ea typeface="Segoe UI" pitchFamily="34" charset="-122"/>
-                <a:cs typeface="Segoe UI" pitchFamily="34" charset="-120"/>
-              </a:rPr>
-              <a:t>Try a few by hand and stop at the first that works</a:t>
-            </a:r>
-            <a:endParaRPr lang="en-US" sz="1300" dirty="0"/>
+              <a:rPr lang="en-US" sz="1450" dirty="0">
+                <a:solidFill>
+                  <a:srgbClr val="1A1A1E"/>
+                </a:solidFill>
+                <a:latin typeface="Segoe UI" pitchFamily="34" charset="0"/>
+                <a:ea typeface="Segoe UI" pitchFamily="34" charset="-122"/>
+                <a:cs typeface="Segoe UI" pitchFamily="34" charset="-120"/>
+              </a:rPr>
+              <a:t>A red suite blocks the merge - that is the whole point of the investment</a:t>
+            </a:r>
+            <a:endParaRPr lang="en-US" sz="1450" dirty="0"/>
           </a:p>
           <a:p>
             <a:pPr marL="342900" indent="-342900">
+              <a:lnSpc>
+                <a:spcPct val="115000"/>
+              </a:lnSpc>
               <a:spcAft>
-                <a:spcPts val="700"/>
+                <a:spcPts val="1000"/>
               </a:spcAft>
               <a:buSzPct val="100000"/>
               <a:buChar char="•"/>
             </a:pPr>
             <a:r>
-              <a:rPr lang="en-US" sz="1300" dirty="0">
-                <a:solidFill>
-                  <a:srgbClr val="3F3F46"/>
-                </a:solidFill>
-                <a:latin typeface="Segoe UI" pitchFamily="34" charset="0"/>
-                <a:ea typeface="Segoe UI" pitchFamily="34" charset="-122"/>
-                <a:cs typeface="Segoe UI" pitchFamily="34" charset="-120"/>
-              </a:rPr>
-              <a:t>Hard-code an id that quietly breaks on the next environment</a:t>
-            </a:r>
-            <a:endParaRPr lang="en-US" sz="1300" dirty="0"/>
-          </a:p>
-          <a:p>
-            <a:pPr marL="342900" indent="-342900">
-              <a:spcAft>
-                <a:spcPts val="700"/>
-              </a:spcAft>
-              <a:buSzPct val="100000"/>
-              <a:buChar char="•"/>
-            </a:pPr>
-            <a:r>
-              <a:rPr lang="en-US" sz="1300" dirty="0">
-                <a:solidFill>
-                  <a:srgbClr val="3F3F46"/>
-                </a:solidFill>
-                <a:latin typeface="Segoe UI" pitchFamily="34" charset="0"/>
-                <a:ea typeface="Segoe UI" pitchFamily="34" charset="-122"/>
-                <a:cs typeface="Segoe UI" pitchFamily="34" charset="-120"/>
-              </a:rPr>
-              <a:t>Or simply give up on automating job creation</a:t>
-            </a:r>
-            <a:endParaRPr lang="en-US" sz="1300" dirty="0"/>
-          </a:p>
-        </p:txBody>
-      </p:sp>
-      <p:sp>
-        <p:nvSpPr>
-          <p:cNvPr id="19" name="Shape 17"/>
-          <p:cNvSpPr/>
-          <p:nvPr/>
-        </p:nvSpPr>
-        <p:spPr>
-          <a:xfrm>
-            <a:off x="6324448" y="2953512"/>
-            <a:ext cx="5300320" cy="2743200"/>
-          </a:xfrm>
-          <a:prstGeom prst="roundRect">
-            <a:avLst>
-              <a:gd name="adj" fmla="val 2667"/>
-            </a:avLst>
-          </a:prstGeom>
-          <a:solidFill>
-            <a:srgbClr val="F6F7F9"/>
-          </a:solidFill>
-          <a:ln w="12700">
-            <a:solidFill>
-              <a:srgbClr val="D9D9DE"/>
-            </a:solidFill>
-            <a:prstDash val="solid"/>
-          </a:ln>
-        </p:spPr>
-      </p:sp>
-      <p:sp>
-        <p:nvSpPr>
-          <p:cNvPr id="20" name="Text 18"/>
-          <p:cNvSpPr/>
-          <p:nvPr/>
-        </p:nvSpPr>
-        <p:spPr>
-          <a:xfrm>
-            <a:off x="6543904" y="3136392"/>
-            <a:ext cx="4861408" cy="365760"/>
-          </a:xfrm>
-          <a:prstGeom prst="rect">
-            <a:avLst/>
-          </a:prstGeom>
-          <a:noFill/>
-          <a:ln/>
-        </p:spPr>
-        <p:txBody>
-          <a:bodyPr wrap="square" rtlCol="0" anchor="ctr"/>
-          <a:lstStyle/>
-          <a:p>
-            <a:pPr indent="0" marL="0">
-              <a:buNone/>
-            </a:pPr>
-            <a:r>
-              <a:rPr lang="en-US" sz="1500" b="1" dirty="0">
-                <a:solidFill>
-                  <a:srgbClr val="15803D"/>
-                </a:solidFill>
-                <a:latin typeface="Segoe UI" pitchFamily="34" charset="0"/>
-                <a:ea typeface="Segoe UI" pitchFamily="34" charset="-122"/>
-                <a:cs typeface="Segoe UI" pitchFamily="34" charset="-120"/>
-              </a:rPr>
-              <a:t>What actually happened</a:t>
-            </a:r>
-            <a:endParaRPr lang="en-US" sz="1500" dirty="0"/>
-          </a:p>
-        </p:txBody>
-      </p:sp>
-      <p:sp>
-        <p:nvSpPr>
-          <p:cNvPr id="21" name="Text 19"/>
-          <p:cNvSpPr/>
-          <p:nvPr/>
-        </p:nvSpPr>
-        <p:spPr>
-          <a:xfrm>
-            <a:off x="6543904" y="3557016"/>
-            <a:ext cx="4861408" cy="1920240"/>
-          </a:xfrm>
-          <a:prstGeom prst="rect">
-            <a:avLst/>
-          </a:prstGeom>
-          <a:noFill/>
-          <a:ln/>
-        </p:spPr>
-        <p:txBody>
-          <a:bodyPr wrap="square" rtlCol="0" anchor="t"/>
-          <a:lstStyle/>
-          <a:p>
-            <a:pPr marL="342900" indent="-342900">
-              <a:spcAft>
-                <a:spcPts val="700"/>
-              </a:spcAft>
-              <a:buSzPct val="100000"/>
-              <a:buChar char="•"/>
-            </a:pPr>
-            <a:r>
-              <a:rPr lang="en-US" sz="1300" dirty="0">
-                <a:solidFill>
-                  <a:srgbClr val="3F3F46"/>
-                </a:solidFill>
-                <a:latin typeface="Segoe UI" pitchFamily="34" charset="0"/>
-                <a:ea typeface="Segoe UI" pitchFamily="34" charset="-122"/>
-                <a:cs typeface="Segoe UI" pitchFamily="34" charset="-120"/>
-              </a:rPr>
-              <a:t>It walked all 15 programs and their tiers in one run</a:t>
-            </a:r>
-            <a:endParaRPr lang="en-US" sz="1300" dirty="0"/>
-          </a:p>
-          <a:p>
-            <a:pPr marL="342900" indent="-342900">
-              <a:spcAft>
-                <a:spcPts val="700"/>
-              </a:spcAft>
-              <a:buSzPct val="100000"/>
-              <a:buChar char="•"/>
-            </a:pPr>
-            <a:r>
-              <a:rPr lang="en-US" sz="1300" dirty="0">
-                <a:solidFill>
-                  <a:srgbClr val="3F3F46"/>
-                </a:solidFill>
-                <a:latin typeface="Segoe UI" pitchFamily="34" charset="0"/>
-                <a:ea typeface="Segoe UI" pitchFamily="34" charset="-122"/>
-                <a:cs typeface="Segoe UI" pitchFamily="34" charset="-120"/>
-              </a:rPr>
-              <a:t>It reported exactly which ones have a privilege attached:</a:t>
-            </a:r>
-            <a:endParaRPr lang="en-US" sz="1300" dirty="0"/>
-          </a:p>
-          <a:p>
-            <a:pPr marL="342900" indent="-342900">
-              <a:spcAft>
-                <a:spcPts val="700"/>
-              </a:spcAft>
-              <a:buSzPct val="100000"/>
-              <a:buChar char="•"/>
-            </a:pPr>
-            <a:r>
-              <a:rPr lang="en-US" sz="1300" dirty="0">
-                <a:solidFill>
-                  <a:srgbClr val="3F3F46"/>
-                </a:solidFill>
-                <a:latin typeface="Segoe UI" pitchFamily="34" charset="0"/>
-                <a:ea typeface="Segoe UI" pitchFamily="34" charset="-122"/>
-                <a:cs typeface="Segoe UI" pitchFamily="34" charset="-120"/>
-              </a:rPr>
-              <a:t>HOT UAT Program  ·  Meo Roadside program</a:t>
-            </a:r>
-            <a:endParaRPr lang="en-US" sz="1300" dirty="0"/>
-          </a:p>
-          <a:p>
-            <a:pPr marL="342900" indent="-342900">
-              <a:spcAft>
-                <a:spcPts val="700"/>
-              </a:spcAft>
-              <a:buSzPct val="100000"/>
-              <a:buChar char="•"/>
-            </a:pPr>
-            <a:r>
-              <a:rPr lang="en-US" sz="1300" dirty="0">
-                <a:solidFill>
-                  <a:srgbClr val="3F3F46"/>
-                </a:solidFill>
-                <a:latin typeface="Segoe UI" pitchFamily="34" charset="0"/>
-                <a:ea typeface="Segoe UI" pitchFamily="34" charset="-122"/>
-                <a:cs typeface="Segoe UI" pitchFamily="34" charset="-120"/>
-              </a:rPr>
-              <a:t>Vit roadside program  ·  Duck program</a:t>
-            </a:r>
-            <a:endParaRPr lang="en-US" sz="1300" dirty="0"/>
-          </a:p>
-          <a:p>
-            <a:pPr marL="342900" indent="-342900">
-              <a:spcAft>
-                <a:spcPts val="700"/>
-              </a:spcAft>
-              <a:buSzPct val="100000"/>
-              <a:buChar char="•"/>
-            </a:pPr>
-            <a:r>
-              <a:rPr lang="en-US" sz="1300" dirty="0">
-                <a:solidFill>
-                  <a:srgbClr val="3F3F46"/>
-                </a:solidFill>
-                <a:latin typeface="Segoe UI" pitchFamily="34" charset="0"/>
-                <a:ea typeface="Segoe UI" pitchFamily="34" charset="-122"/>
-                <a:cs typeface="Segoe UI" pitchFamily="34" charset="-120"/>
-              </a:rPr>
-              <a:t>The test now selects a program by name, so a different environment does not break it</a:t>
-            </a:r>
-            <a:endParaRPr lang="en-US" sz="1300" dirty="0"/>
-          </a:p>
-        </p:txBody>
-      </p:sp>
-      <p:sp>
-        <p:nvSpPr>
-          <p:cNvPr id="22" name="Text 20"/>
-          <p:cNvSpPr/>
-          <p:nvPr/>
-        </p:nvSpPr>
-        <p:spPr>
-          <a:xfrm>
-            <a:off x="566928" y="6035040"/>
-            <a:ext cx="11057839" cy="365760"/>
-          </a:xfrm>
-          <a:prstGeom prst="rect">
-            <a:avLst/>
-          </a:prstGeom>
-          <a:noFill/>
-          <a:ln/>
-        </p:spPr>
-        <p:txBody>
-          <a:bodyPr wrap="square" rtlCol="0" anchor="ctr"/>
-          <a:lstStyle/>
-          <a:p>
-            <a:pPr indent="0" marL="0">
-              <a:buNone/>
-            </a:pPr>
-            <a:r>
-              <a:rPr lang="en-US" sz="1300" i="1" dirty="0">
-                <a:solidFill>
-                  <a:srgbClr val="71717A"/>
-                </a:solidFill>
-                <a:latin typeface="Segoe UI" pitchFamily="34" charset="0"/>
-                <a:ea typeface="Segoe UI" pitchFamily="34" charset="-122"/>
-                <a:cs typeface="Segoe UI" pitchFamily="34" charset="-120"/>
-              </a:rPr>
-              <a:t>"Which programs can actually create a job on UAT?" had no answer anywhere - not in a document, not in the code. Now it does, and it took one run to get it.</a:t>
-            </a:r>
-            <a:endParaRPr lang="en-US" sz="1300" dirty="0"/>
+              <a:rPr lang="en-US" sz="1450" dirty="0">
+                <a:solidFill>
+                  <a:srgbClr val="1A1A1E"/>
+                </a:solidFill>
+                <a:latin typeface="Segoe UI" pitchFamily="34" charset="0"/>
+                <a:ea typeface="Segoe UI" pitchFamily="34" charset="-122"/>
+                <a:cs typeface="Segoe UI" pitchFamily="34" charset="-120"/>
+              </a:rPr>
+              <a:t>Still to arrange: CI credentials and a stable non-production account that does not rotate</a:t>
+            </a:r>
+            <a:endParaRPr lang="en-US" sz="1450" dirty="0"/>
           </a:p>
         </p:txBody>
       </p:sp>
@@ -5838,982 +4445,6 @@
 <file path=ppt/slides/slide14.xml><?xml version="1.0" encoding="utf-8"?>
 <p:sld xmlns:a="http://schemas.openxmlformats.org/drawingml/2006/main" xmlns:r="http://schemas.openxmlformats.org/officeDocument/2006/relationships" xmlns:p="http://schemas.openxmlformats.org/presentationml/2006/main">
   <p:cSld name="Slide 14">
-    <p:bg>
-      <p:bgPr>
-        <a:solidFill>
-          <a:srgbClr val="FFFFFF"/>
-        </a:solidFill>
-      </p:bgPr>
-    </p:bg>
-    <p:spTree>
-      <p:nvGrpSpPr>
-        <p:cNvPr id="1" name=""/>
-        <p:cNvGrpSpPr/>
-        <p:nvPr/>
-      </p:nvGrpSpPr>
-      <p:grpSpPr>
-        <a:xfrm>
-          <a:off x="0" y="0"/>
-          <a:ext cx="0" cy="0"/>
-          <a:chOff x="0" y="0"/>
-          <a:chExt cx="0" cy="0"/>
-        </a:xfrm>
-      </p:grpSpPr>
-      <p:sp>
-        <p:nvSpPr>
-          <p:cNvPr id="2" name="Text 0"/>
-          <p:cNvSpPr/>
-          <p:nvPr/>
-        </p:nvSpPr>
-        <p:spPr>
-          <a:xfrm>
-            <a:off x="566928" y="384048"/>
-            <a:ext cx="11057839" cy="548640"/>
-          </a:xfrm>
-          <a:prstGeom prst="rect">
-            <a:avLst/>
-          </a:prstGeom>
-          <a:noFill/>
-          <a:ln/>
-        </p:spPr>
-        <p:txBody>
-          <a:bodyPr wrap="square" rtlCol="0" anchor="ctr"/>
-          <a:lstStyle/>
-          <a:p>
-            <a:pPr indent="0" marL="0">
-              <a:buNone/>
-            </a:pPr>
-            <a:r>
-              <a:rPr lang="en-US" sz="2600" b="1" dirty="0">
-                <a:solidFill>
-                  <a:srgbClr val="1A1A1E"/>
-                </a:solidFill>
-                <a:latin typeface="Segoe UI" pitchFamily="34" charset="0"/>
-                <a:ea typeface="Segoe UI" pitchFamily="34" charset="-122"/>
-                <a:cs typeface="Segoe UI" pitchFamily="34" charset="-120"/>
-              </a:rPr>
-              <a:t>Where the human time still goes</a:t>
-            </a:r>
-            <a:endParaRPr lang="en-US" sz="2600" dirty="0"/>
-          </a:p>
-        </p:txBody>
-      </p:sp>
-      <p:sp>
-        <p:nvSpPr>
-          <p:cNvPr id="3" name="Text 1"/>
-          <p:cNvSpPr/>
-          <p:nvPr/>
-        </p:nvSpPr>
-        <p:spPr>
-          <a:xfrm>
-            <a:off x="566928" y="932688"/>
-            <a:ext cx="11057839" cy="365760"/>
-          </a:xfrm>
-          <a:prstGeom prst="rect">
-            <a:avLst/>
-          </a:prstGeom>
-          <a:noFill/>
-          <a:ln/>
-        </p:spPr>
-        <p:txBody>
-          <a:bodyPr wrap="square" rtlCol="0" anchor="ctr"/>
-          <a:lstStyle/>
-          <a:p>
-            <a:pPr indent="0" marL="0">
-              <a:buNone/>
-            </a:pPr>
-            <a:r>
-              <a:rPr lang="en-US" sz="1400" dirty="0">
-                <a:solidFill>
-                  <a:srgbClr val="71717A"/>
-                </a:solidFill>
-                <a:latin typeface="Segoe UI" pitchFamily="34" charset="0"/>
-                <a:ea typeface="Segoe UI" pitchFamily="34" charset="-122"/>
-                <a:cs typeface="Segoe UI" pitchFamily="34" charset="-120"/>
-              </a:rPr>
-              <a:t>The agent is fast at the mechanical work; judgement stays with us</a:t>
-            </a:r>
-            <a:endParaRPr lang="en-US" sz="1400" dirty="0"/>
-          </a:p>
-        </p:txBody>
-      </p:sp>
-      <p:sp>
-        <p:nvSpPr>
-          <p:cNvPr id="4" name="Shape 2"/>
-          <p:cNvSpPr/>
-          <p:nvPr/>
-        </p:nvSpPr>
-        <p:spPr>
-          <a:xfrm>
-            <a:off x="566928" y="1371600"/>
-            <a:ext cx="11057839" cy="18288"/>
-          </a:xfrm>
-          <a:prstGeom prst="rect">
-            <a:avLst/>
-          </a:prstGeom>
-          <a:solidFill>
-            <a:srgbClr val="D9D9DE"/>
-          </a:solidFill>
-          <a:ln/>
-        </p:spPr>
-      </p:sp>
-      <p:sp>
-        <p:nvSpPr>
-          <p:cNvPr id="5" name="Shape 3"/>
-          <p:cNvSpPr/>
-          <p:nvPr/>
-        </p:nvSpPr>
-        <p:spPr>
-          <a:xfrm>
-            <a:off x="566928" y="1627632"/>
-            <a:ext cx="5300320" cy="3474720"/>
-          </a:xfrm>
-          <a:prstGeom prst="roundRect">
-            <a:avLst>
-              <a:gd name="adj" fmla="val 2105"/>
-            </a:avLst>
-          </a:prstGeom>
-          <a:solidFill>
-            <a:srgbClr val="F6F7F9"/>
-          </a:solidFill>
-          <a:ln w="12700">
-            <a:solidFill>
-              <a:srgbClr val="D9D9DE"/>
-            </a:solidFill>
-            <a:prstDash val="solid"/>
-          </a:ln>
-        </p:spPr>
-      </p:sp>
-      <p:sp>
-        <p:nvSpPr>
-          <p:cNvPr id="6" name="Text 4"/>
-          <p:cNvSpPr/>
-          <p:nvPr/>
-        </p:nvSpPr>
-        <p:spPr>
-          <a:xfrm>
-            <a:off x="786384" y="1810512"/>
-            <a:ext cx="4861408" cy="365760"/>
-          </a:xfrm>
-          <a:prstGeom prst="rect">
-            <a:avLst/>
-          </a:prstGeom>
-          <a:noFill/>
-          <a:ln/>
-        </p:spPr>
-        <p:txBody>
-          <a:bodyPr wrap="square" rtlCol="0" anchor="ctr"/>
-          <a:lstStyle/>
-          <a:p>
-            <a:pPr indent="0" marL="0">
-              <a:buNone/>
-            </a:pPr>
-            <a:r>
-              <a:rPr lang="en-US" sz="1500" b="1" dirty="0">
-                <a:solidFill>
-                  <a:srgbClr val="15803D"/>
-                </a:solidFill>
-                <a:latin typeface="Segoe UI" pitchFamily="34" charset="0"/>
-                <a:ea typeface="Segoe UI" pitchFamily="34" charset="-122"/>
-                <a:cs typeface="Segoe UI" pitchFamily="34" charset="-120"/>
-              </a:rPr>
-              <a:t>The agent is good at</a:t>
-            </a:r>
-            <a:endParaRPr lang="en-US" sz="1500" dirty="0"/>
-          </a:p>
-        </p:txBody>
-      </p:sp>
-      <p:sp>
-        <p:nvSpPr>
-          <p:cNvPr id="7" name="Text 5"/>
-          <p:cNvSpPr/>
-          <p:nvPr/>
-        </p:nvSpPr>
-        <p:spPr>
-          <a:xfrm>
-            <a:off x="786384" y="2231136"/>
-            <a:ext cx="4861408" cy="2651760"/>
-          </a:xfrm>
-          <a:prstGeom prst="rect">
-            <a:avLst/>
-          </a:prstGeom>
-          <a:noFill/>
-          <a:ln/>
-        </p:spPr>
-        <p:txBody>
-          <a:bodyPr wrap="square" rtlCol="0" anchor="t"/>
-          <a:lstStyle/>
-          <a:p>
-            <a:pPr marL="342900" indent="-342900">
-              <a:spcAft>
-                <a:spcPts val="700"/>
-              </a:spcAft>
-              <a:buSzPct val="100000"/>
-              <a:buChar char="•"/>
-            </a:pPr>
-            <a:r>
-              <a:rPr lang="en-US" sz="1300" dirty="0">
-                <a:solidFill>
-                  <a:srgbClr val="3F3F46"/>
-                </a:solidFill>
-                <a:latin typeface="Segoe UI" pitchFamily="34" charset="0"/>
-                <a:ea typeface="Segoe UI" pitchFamily="34" charset="-122"/>
-                <a:cs typeface="Segoe UI" pitchFamily="34" charset="-120"/>
-              </a:rPr>
-              <a:t>Reading the application to find real selectors</a:t>
-            </a:r>
-            <a:endParaRPr lang="en-US" sz="1300" dirty="0"/>
-          </a:p>
-          <a:p>
-            <a:pPr marL="342900" indent="-342900">
-              <a:spcAft>
-                <a:spcPts val="700"/>
-              </a:spcAft>
-              <a:buSzPct val="100000"/>
-              <a:buChar char="•"/>
-            </a:pPr>
-            <a:r>
-              <a:rPr lang="en-US" sz="1300" dirty="0">
-                <a:solidFill>
-                  <a:srgbClr val="3F3F46"/>
-                </a:solidFill>
-                <a:latin typeface="Segoe UI" pitchFamily="34" charset="0"/>
-                <a:ea typeface="Segoe UI" pitchFamily="34" charset="-122"/>
-                <a:cs typeface="Segoe UI" pitchFamily="34" charset="-120"/>
-              </a:rPr>
-              <a:t>Writing page objects and specs in a consistent shape</a:t>
-            </a:r>
-            <a:endParaRPr lang="en-US" sz="1300" dirty="0"/>
-          </a:p>
-          <a:p>
-            <a:pPr marL="342900" indent="-342900">
-              <a:spcAft>
-                <a:spcPts val="700"/>
-              </a:spcAft>
-              <a:buSzPct val="100000"/>
-              <a:buChar char="•"/>
-            </a:pPr>
-            <a:r>
-              <a:rPr lang="en-US" sz="1300" dirty="0">
-                <a:solidFill>
-                  <a:srgbClr val="3F3F46"/>
-                </a:solidFill>
-                <a:latin typeface="Segoe UI" pitchFamily="34" charset="0"/>
-                <a:ea typeface="Segoe UI" pitchFamily="34" charset="-122"/>
-                <a:cs typeface="Segoe UI" pitchFamily="34" charset="-120"/>
-              </a:rPr>
-              <a:t>Running, reading the failure, fixing, re-running</a:t>
-            </a:r>
-            <a:endParaRPr lang="en-US" sz="1300" dirty="0"/>
-          </a:p>
-          <a:p>
-            <a:pPr marL="342900" indent="-342900">
-              <a:spcAft>
-                <a:spcPts val="700"/>
-              </a:spcAft>
-              <a:buSzPct val="100000"/>
-              <a:buChar char="•"/>
-            </a:pPr>
-            <a:r>
-              <a:rPr lang="en-US" sz="1300" dirty="0">
-                <a:solidFill>
-                  <a:srgbClr val="3F3F46"/>
-                </a:solidFill>
-                <a:latin typeface="Segoe UI" pitchFamily="34" charset="0"/>
-                <a:ea typeface="Segoe UI" pitchFamily="34" charset="-122"/>
-                <a:cs typeface="Segoe UI" pitchFamily="34" charset="-120"/>
-              </a:rPr>
-              <a:t>Probing the environment to answer factual questions</a:t>
-            </a:r>
-            <a:endParaRPr lang="en-US" sz="1300" dirty="0"/>
-          </a:p>
-          <a:p>
-            <a:pPr marL="342900" indent="-342900">
-              <a:spcAft>
-                <a:spcPts val="700"/>
-              </a:spcAft>
-              <a:buSzPct val="100000"/>
-              <a:buChar char="•"/>
-            </a:pPr>
-            <a:r>
-              <a:rPr lang="en-US" sz="1300" dirty="0">
-                <a:solidFill>
-                  <a:srgbClr val="3F3F46"/>
-                </a:solidFill>
-                <a:latin typeface="Segoe UI" pitchFamily="34" charset="0"/>
-                <a:ea typeface="Segoe UI" pitchFamily="34" charset="-122"/>
-                <a:cs typeface="Segoe UI" pitchFamily="34" charset="-120"/>
-              </a:rPr>
-              <a:t>Writing down what it learned so it is not lost</a:t>
-            </a:r>
-            <a:endParaRPr lang="en-US" sz="1300" dirty="0"/>
-          </a:p>
-        </p:txBody>
-      </p:sp>
-      <p:sp>
-        <p:nvSpPr>
-          <p:cNvPr id="8" name="Shape 6"/>
-          <p:cNvSpPr/>
-          <p:nvPr/>
-        </p:nvSpPr>
-        <p:spPr>
-          <a:xfrm>
-            <a:off x="6324448" y="1627632"/>
-            <a:ext cx="5300320" cy="3474720"/>
-          </a:xfrm>
-          <a:prstGeom prst="roundRect">
-            <a:avLst>
-              <a:gd name="adj" fmla="val 2105"/>
-            </a:avLst>
-          </a:prstGeom>
-          <a:solidFill>
-            <a:srgbClr val="F6F7F9"/>
-          </a:solidFill>
-          <a:ln w="12700">
-            <a:solidFill>
-              <a:srgbClr val="D9D9DE"/>
-            </a:solidFill>
-            <a:prstDash val="solid"/>
-          </a:ln>
-        </p:spPr>
-      </p:sp>
-      <p:sp>
-        <p:nvSpPr>
-          <p:cNvPr id="9" name="Text 7"/>
-          <p:cNvSpPr/>
-          <p:nvPr/>
-        </p:nvSpPr>
-        <p:spPr>
-          <a:xfrm>
-            <a:off x="6543904" y="1810512"/>
-            <a:ext cx="4861408" cy="365760"/>
-          </a:xfrm>
-          <a:prstGeom prst="rect">
-            <a:avLst/>
-          </a:prstGeom>
-          <a:noFill/>
-          <a:ln/>
-        </p:spPr>
-        <p:txBody>
-          <a:bodyPr wrap="square" rtlCol="0" anchor="ctr"/>
-          <a:lstStyle/>
-          <a:p>
-            <a:pPr indent="0" marL="0">
-              <a:buNone/>
-            </a:pPr>
-            <a:r>
-              <a:rPr lang="en-US" sz="1500" b="1" dirty="0">
-                <a:solidFill>
-                  <a:srgbClr val="0B5FA5"/>
-                </a:solidFill>
-                <a:latin typeface="Segoe UI" pitchFamily="34" charset="0"/>
-                <a:ea typeface="Segoe UI" pitchFamily="34" charset="-122"/>
-                <a:cs typeface="Segoe UI" pitchFamily="34" charset="-120"/>
-              </a:rPr>
-              <a:t>We still decide</a:t>
-            </a:r>
-            <a:endParaRPr lang="en-US" sz="1500" dirty="0"/>
-          </a:p>
-        </p:txBody>
-      </p:sp>
-      <p:sp>
-        <p:nvSpPr>
-          <p:cNvPr id="10" name="Text 8"/>
-          <p:cNvSpPr/>
-          <p:nvPr/>
-        </p:nvSpPr>
-        <p:spPr>
-          <a:xfrm>
-            <a:off x="6543904" y="2231136"/>
-            <a:ext cx="4861408" cy="2651760"/>
-          </a:xfrm>
-          <a:prstGeom prst="rect">
-            <a:avLst/>
-          </a:prstGeom>
-          <a:noFill/>
-          <a:ln/>
-        </p:spPr>
-        <p:txBody>
-          <a:bodyPr wrap="square" rtlCol="0" anchor="t"/>
-          <a:lstStyle/>
-          <a:p>
-            <a:pPr marL="342900" indent="-342900">
-              <a:spcAft>
-                <a:spcPts val="700"/>
-              </a:spcAft>
-              <a:buSzPct val="100000"/>
-              <a:buChar char="•"/>
-            </a:pPr>
-            <a:r>
-              <a:rPr lang="en-US" sz="1300" dirty="0">
-                <a:solidFill>
-                  <a:srgbClr val="3F3F46"/>
-                </a:solidFill>
-                <a:latin typeface="Segoe UI" pitchFamily="34" charset="0"/>
-                <a:ea typeface="Segoe UI" pitchFamily="34" charset="-122"/>
-                <a:cs typeface="Segoe UI" pitchFamily="34" charset="-120"/>
-              </a:rPr>
-              <a:t>Which journeys matter enough to automate</a:t>
-            </a:r>
-            <a:endParaRPr lang="en-US" sz="1300" dirty="0"/>
-          </a:p>
-          <a:p>
-            <a:pPr marL="342900" indent="-342900">
-              <a:spcAft>
-                <a:spcPts val="700"/>
-              </a:spcAft>
-              <a:buSzPct val="100000"/>
-              <a:buChar char="•"/>
-            </a:pPr>
-            <a:r>
-              <a:rPr lang="en-US" sz="1300" dirty="0">
-                <a:solidFill>
-                  <a:srgbClr val="3F3F46"/>
-                </a:solidFill>
-                <a:latin typeface="Segoe UI" pitchFamily="34" charset="0"/>
-                <a:ea typeface="Segoe UI" pitchFamily="34" charset="-122"/>
-                <a:cs typeface="Segoe UI" pitchFamily="34" charset="-120"/>
-              </a:rPr>
-              <a:t>What counts as acceptable test data on a shared environment</a:t>
-            </a:r>
-            <a:endParaRPr lang="en-US" sz="1300" dirty="0"/>
-          </a:p>
-          <a:p>
-            <a:pPr marL="342900" indent="-342900">
-              <a:spcAft>
-                <a:spcPts val="700"/>
-              </a:spcAft>
-              <a:buSzPct val="100000"/>
-              <a:buChar char="•"/>
-            </a:pPr>
-            <a:r>
-              <a:rPr lang="en-US" sz="1300" dirty="0">
-                <a:solidFill>
-                  <a:srgbClr val="3F3F46"/>
-                </a:solidFill>
-                <a:latin typeface="Segoe UI" pitchFamily="34" charset="0"/>
-                <a:ea typeface="Segoe UI" pitchFamily="34" charset="-122"/>
-                <a:cs typeface="Segoe UI" pitchFamily="34" charset="-120"/>
-              </a:rPr>
-              <a:t>Whether a failure is a test bug or a product bug</a:t>
-            </a:r>
-            <a:endParaRPr lang="en-US" sz="1300" dirty="0"/>
-          </a:p>
-          <a:p>
-            <a:pPr marL="342900" indent="-342900">
-              <a:spcAft>
-                <a:spcPts val="700"/>
-              </a:spcAft>
-              <a:buSzPct val="100000"/>
-              <a:buChar char="•"/>
-            </a:pPr>
-            <a:r>
-              <a:rPr lang="en-US" sz="1300" dirty="0">
-                <a:solidFill>
-                  <a:srgbClr val="3F3F46"/>
-                </a:solidFill>
-                <a:latin typeface="Segoe UI" pitchFamily="34" charset="0"/>
-                <a:ea typeface="Segoe UI" pitchFamily="34" charset="-122"/>
-                <a:cs typeface="Segoe UI" pitchFamily="34" charset="-120"/>
-              </a:rPr>
-              <a:t>What may touch production, and what may never</a:t>
-            </a:r>
-            <a:endParaRPr lang="en-US" sz="1300" dirty="0"/>
-          </a:p>
-          <a:p>
-            <a:pPr marL="342900" indent="-342900">
-              <a:spcAft>
-                <a:spcPts val="700"/>
-              </a:spcAft>
-              <a:buSzPct val="100000"/>
-              <a:buChar char="•"/>
-            </a:pPr>
-            <a:r>
-              <a:rPr lang="en-US" sz="1300" dirty="0">
-                <a:solidFill>
-                  <a:srgbClr val="3F3F46"/>
-                </a:solidFill>
-                <a:latin typeface="Segoe UI" pitchFamily="34" charset="0"/>
-                <a:ea typeface="Segoe UI" pitchFamily="34" charset="-122"/>
-                <a:cs typeface="Segoe UI" pitchFamily="34" charset="-120"/>
-              </a:rPr>
-              <a:t>Review before anything is merged - same PR bar as any code</a:t>
-            </a:r>
-            <a:endParaRPr lang="en-US" sz="1300" dirty="0"/>
-          </a:p>
-        </p:txBody>
-      </p:sp>
-      <p:sp>
-        <p:nvSpPr>
-          <p:cNvPr id="11" name="Text 9"/>
-          <p:cNvSpPr/>
-          <p:nvPr/>
-        </p:nvSpPr>
-        <p:spPr>
-          <a:xfrm>
-            <a:off x="566928" y="5760720"/>
-            <a:ext cx="11057839" cy="365760"/>
-          </a:xfrm>
-          <a:prstGeom prst="rect">
-            <a:avLst/>
-          </a:prstGeom>
-          <a:noFill/>
-          <a:ln/>
-        </p:spPr>
-        <p:txBody>
-          <a:bodyPr wrap="square" rtlCol="0" anchor="ctr"/>
-          <a:lstStyle/>
-          <a:p>
-            <a:pPr indent="0" marL="0">
-              <a:buNone/>
-            </a:pPr>
-            <a:r>
-              <a:rPr lang="en-US" sz="1300" i="1" dirty="0">
-                <a:solidFill>
-                  <a:srgbClr val="71717A"/>
-                </a:solidFill>
-                <a:latin typeface="Segoe UI" pitchFamily="34" charset="0"/>
-                <a:ea typeface="Segoe UI" pitchFamily="34" charset="-122"/>
-                <a:cs typeface="Segoe UI" pitchFamily="34" charset="-120"/>
-              </a:rPr>
-              <a:t>The workshop point: the cost of an automated check has dropped far enough that "we do not have time to automate it" is no longer the real constraint.</a:t>
-            </a:r>
-            <a:endParaRPr lang="en-US" sz="1300" dirty="0"/>
-          </a:p>
-        </p:txBody>
-      </p:sp>
-    </p:spTree>
-  </p:cSld>
-  <p:clrMapOvr>
-    <a:masterClrMapping/>
-  </p:clrMapOvr>
-</p:sld>
-</file>
-
-<file path=ppt/slides/slide15.xml><?xml version="1.0" encoding="utf-8"?>
-<p:sld xmlns:a="http://schemas.openxmlformats.org/drawingml/2006/main" xmlns:r="http://schemas.openxmlformats.org/officeDocument/2006/relationships" xmlns:p="http://schemas.openxmlformats.org/presentationml/2006/main">
-  <p:cSld name="Slide 15">
-    <p:bg>
-      <p:bgPr>
-        <a:solidFill>
-          <a:srgbClr val="FFFFFF"/>
-        </a:solidFill>
-      </p:bgPr>
-    </p:bg>
-    <p:spTree>
-      <p:nvGrpSpPr>
-        <p:cNvPr id="1" name=""/>
-        <p:cNvGrpSpPr/>
-        <p:nvPr/>
-      </p:nvGrpSpPr>
-      <p:grpSpPr>
-        <a:xfrm>
-          <a:off x="0" y="0"/>
-          <a:ext cx="0" cy="0"/>
-          <a:chOff x="0" y="0"/>
-          <a:chExt cx="0" cy="0"/>
-        </a:xfrm>
-      </p:grpSpPr>
-      <p:sp>
-        <p:nvSpPr>
-          <p:cNvPr id="2" name="Text 0"/>
-          <p:cNvSpPr/>
-          <p:nvPr/>
-        </p:nvSpPr>
-        <p:spPr>
-          <a:xfrm>
-            <a:off x="566928" y="384048"/>
-            <a:ext cx="11057839" cy="548640"/>
-          </a:xfrm>
-          <a:prstGeom prst="rect">
-            <a:avLst/>
-          </a:prstGeom>
-          <a:noFill/>
-          <a:ln/>
-        </p:spPr>
-        <p:txBody>
-          <a:bodyPr wrap="square" rtlCol="0" anchor="ctr"/>
-          <a:lstStyle/>
-          <a:p>
-            <a:pPr indent="0" marL="0">
-              <a:buNone/>
-            </a:pPr>
-            <a:r>
-              <a:rPr lang="en-US" sz="2600" b="1" dirty="0">
-                <a:solidFill>
-                  <a:srgbClr val="1A1A1E"/>
-                </a:solidFill>
-                <a:latin typeface="Segoe UI" pitchFamily="34" charset="0"/>
-                <a:ea typeface="Segoe UI" pitchFamily="34" charset="-122"/>
-                <a:cs typeface="Segoe UI" pitchFamily="34" charset="-120"/>
-              </a:rPr>
-              <a:t>Running it in CI</a:t>
-            </a:r>
-            <a:endParaRPr lang="en-US" sz="2600" dirty="0"/>
-          </a:p>
-        </p:txBody>
-      </p:sp>
-      <p:sp>
-        <p:nvSpPr>
-          <p:cNvPr id="3" name="Text 1"/>
-          <p:cNvSpPr/>
-          <p:nvPr/>
-        </p:nvSpPr>
-        <p:spPr>
-          <a:xfrm>
-            <a:off x="566928" y="932688"/>
-            <a:ext cx="11057839" cy="365760"/>
-          </a:xfrm>
-          <a:prstGeom prst="rect">
-            <a:avLst/>
-          </a:prstGeom>
-          <a:noFill/>
-          <a:ln/>
-        </p:spPr>
-        <p:txBody>
-          <a:bodyPr wrap="square" rtlCol="0" anchor="ctr"/>
-          <a:lstStyle/>
-          <a:p>
-            <a:pPr indent="0" marL="0">
-              <a:buNone/>
-            </a:pPr>
-            <a:r>
-              <a:rPr lang="en-US" sz="1400" dirty="0">
-                <a:solidFill>
-                  <a:srgbClr val="71717A"/>
-                </a:solidFill>
-                <a:latin typeface="Segoe UI" pitchFamily="34" charset="0"/>
-                <a:ea typeface="Segoe UI" pitchFamily="34" charset="-122"/>
-                <a:cs typeface="Segoe UI" pitchFamily="34" charset="-120"/>
-              </a:rPr>
-              <a:t>The same command a developer runs is the command the pipeline runs</a:t>
-            </a:r>
-            <a:endParaRPr lang="en-US" sz="1400" dirty="0"/>
-          </a:p>
-        </p:txBody>
-      </p:sp>
-      <p:sp>
-        <p:nvSpPr>
-          <p:cNvPr id="4" name="Shape 2"/>
-          <p:cNvSpPr/>
-          <p:nvPr/>
-        </p:nvSpPr>
-        <p:spPr>
-          <a:xfrm>
-            <a:off x="566928" y="1371600"/>
-            <a:ext cx="11057839" cy="18288"/>
-          </a:xfrm>
-          <a:prstGeom prst="rect">
-            <a:avLst/>
-          </a:prstGeom>
-          <a:solidFill>
-            <a:srgbClr val="D9D9DE"/>
-          </a:solidFill>
-          <a:ln/>
-        </p:spPr>
-      </p:sp>
-      <p:sp>
-        <p:nvSpPr>
-          <p:cNvPr id="5" name="Shape 3"/>
-          <p:cNvSpPr/>
-          <p:nvPr/>
-        </p:nvSpPr>
-        <p:spPr>
-          <a:xfrm>
-            <a:off x="566928" y="1627632"/>
-            <a:ext cx="11057839" cy="2011680"/>
-          </a:xfrm>
-          <a:prstGeom prst="roundRect">
-            <a:avLst>
-              <a:gd name="adj" fmla="val 2727"/>
-            </a:avLst>
-          </a:prstGeom>
-          <a:solidFill>
-            <a:srgbClr val="1E1E24"/>
-          </a:solidFill>
-          <a:ln w="12700">
-            <a:solidFill>
-              <a:srgbClr val="1E1E24"/>
-            </a:solidFill>
-            <a:prstDash val="solid"/>
-          </a:ln>
-        </p:spPr>
-      </p:sp>
-      <p:sp>
-        <p:nvSpPr>
-          <p:cNvPr id="6" name="Text 4"/>
-          <p:cNvSpPr/>
-          <p:nvPr/>
-        </p:nvSpPr>
-        <p:spPr>
-          <a:xfrm>
-            <a:off x="768096" y="1773936"/>
-            <a:ext cx="10655503" cy="1719072"/>
-          </a:xfrm>
-          <a:prstGeom prst="rect">
-            <a:avLst/>
-          </a:prstGeom>
-          <a:noFill/>
-          <a:ln/>
-        </p:spPr>
-        <p:txBody>
-          <a:bodyPr wrap="square" rtlCol="0" anchor="t"/>
-          <a:lstStyle/>
-          <a:p>
-            <a:pPr indent="0" marL="0">
-              <a:lnSpc>
-                <a:spcPct val="112000"/>
-              </a:lnSpc>
-              <a:buNone/>
-            </a:pPr>
-            <a:r>
-              <a:rPr lang="en-US" sz="1150" dirty="0">
-                <a:solidFill>
-                  <a:srgbClr val="E8E8EC"/>
-                </a:solidFill>
-                <a:latin typeface="Consolas" pitchFamily="34" charset="0"/>
-                <a:ea typeface="Consolas" pitchFamily="34" charset="-122"/>
-                <a:cs typeface="Consolas" pitchFamily="34" charset="-120"/>
-              </a:rPr>
-              <a:t># any CI runner - CodeBuild, Bitbucket Pipelines, GitHub Actions</a:t>
-            </a:r>
-            <a:endParaRPr lang="en-US" sz="1150" dirty="0"/>
-          </a:p>
-          <a:p>
-            <a:pPr indent="0" marL="0">
-              <a:lnSpc>
-                <a:spcPct val="112000"/>
-              </a:lnSpc>
-              <a:buNone/>
-            </a:pPr>
-            <a:r>
-              <a:rPr lang="en-US" sz="1150" dirty="0">
-                <a:solidFill>
-                  <a:srgbClr val="E8E8EC"/>
-                </a:solidFill>
-                <a:latin typeface="Consolas" pitchFamily="34" charset="0"/>
-                <a:ea typeface="Consolas" pitchFamily="34" charset="-122"/>
-                <a:cs typeface="Consolas" pitchFamily="34" charset="-120"/>
-              </a:rPr>
-              <a:t>npm ci</a:t>
-            </a:r>
-            <a:endParaRPr lang="en-US" sz="1150" dirty="0"/>
-          </a:p>
-          <a:p>
-            <a:pPr indent="0" marL="0">
-              <a:lnSpc>
-                <a:spcPct val="112000"/>
-              </a:lnSpc>
-              <a:buNone/>
-            </a:pPr>
-            <a:r>
-              <a:rPr lang="en-US" sz="1150" dirty="0">
-                <a:solidFill>
-                  <a:srgbClr val="E8E8EC"/>
-                </a:solidFill>
-                <a:latin typeface="Consolas" pitchFamily="34" charset="0"/>
-                <a:ea typeface="Consolas" pitchFamily="34" charset="-122"/>
-                <a:cs typeface="Consolas" pitchFamily="34" charset="-120"/>
-              </a:rPr>
-              <a:t>npx playwright install --with-deps chromium</a:t>
-            </a:r>
-            <a:endParaRPr lang="en-US" sz="1150" dirty="0"/>
-          </a:p>
-          <a:p>
-            <a:pPr indent="0" marL="0">
-              <a:lnSpc>
-                <a:spcPct val="112000"/>
-              </a:lnSpc>
-              <a:buNone/>
-            </a:pPr>
-            <a:r>
-              <a:rPr lang="en-US" sz="1150" dirty="0">
-                <a:solidFill>
-                  <a:srgbClr val="E8E8EC"/>
-                </a:solidFill>
-                <a:latin typeface="Consolas" pitchFamily="34" charset="0"/>
-                <a:ea typeface="Consolas" pitchFamily="34" charset="-122"/>
-                <a:cs typeface="Consolas" pitchFamily="34" charset="-120"/>
-              </a:rPr>
-              <a:t>npm test                       # retries once on CI, serial, ~1 minute</a:t>
-            </a:r>
-            <a:endParaRPr lang="en-US" sz="1150" dirty="0"/>
-          </a:p>
-          <a:p>
-            <a:pPr indent="0" marL="0">
-              <a:lnSpc>
-                <a:spcPct val="112000"/>
-              </a:lnSpc>
-              <a:buNone/>
-            </a:pPr>
-            <a:endParaRPr lang="en-US" sz="1150" dirty="0"/>
-          </a:p>
-          <a:p>
-            <a:pPr indent="0" marL="0">
-              <a:lnSpc>
-                <a:spcPct val="112000"/>
-              </a:lnSpc>
-              <a:buNone/>
-            </a:pPr>
-            <a:r>
-              <a:rPr lang="en-US" sz="1150" dirty="0">
-                <a:solidFill>
-                  <a:srgbClr val="E8E8EC"/>
-                </a:solidFill>
-                <a:latin typeface="Consolas" pitchFamily="34" charset="0"/>
-                <a:ea typeface="Consolas" pitchFamily="34" charset="-122"/>
-                <a:cs typeface="Consolas" pitchFamily="34" charset="-120"/>
-              </a:rPr>
-              <a:t># artefacts to keep: playwright-report/  reports/junit.xml</a:t>
-            </a:r>
-            <a:endParaRPr lang="en-US" sz="1150" dirty="0"/>
-          </a:p>
-        </p:txBody>
-      </p:sp>
-      <p:sp>
-        <p:nvSpPr>
-          <p:cNvPr id="7" name="Text 5"/>
-          <p:cNvSpPr/>
-          <p:nvPr/>
-        </p:nvSpPr>
-        <p:spPr>
-          <a:xfrm>
-            <a:off x="566928" y="3694176"/>
-            <a:ext cx="11057839" cy="274320"/>
-          </a:xfrm>
-          <a:prstGeom prst="rect">
-            <a:avLst/>
-          </a:prstGeom>
-          <a:noFill/>
-          <a:ln/>
-        </p:spPr>
-        <p:txBody>
-          <a:bodyPr wrap="square" rtlCol="0" anchor="ctr"/>
-          <a:lstStyle/>
-          <a:p>
-            <a:pPr indent="0" marL="0">
-              <a:buNone/>
-            </a:pPr>
-            <a:r>
-              <a:rPr lang="en-US" sz="1100" i="1" dirty="0">
-                <a:solidFill>
-                  <a:srgbClr val="71717A"/>
-                </a:solidFill>
-                <a:latin typeface="Segoe UI" pitchFamily="34" charset="0"/>
-                <a:ea typeface="Segoe UI" pitchFamily="34" charset="-122"/>
-                <a:cs typeface="Segoe UI" pitchFamily="34" charset="-120"/>
-              </a:rPr>
-              <a:t>JUnit XML is what a CI dashboard reads; the HTML report is what a human opens.</a:t>
-            </a:r>
-            <a:endParaRPr lang="en-US" sz="1100" dirty="0"/>
-          </a:p>
-        </p:txBody>
-      </p:sp>
-      <p:sp>
-        <p:nvSpPr>
-          <p:cNvPr id="8" name="Text 6"/>
-          <p:cNvSpPr/>
-          <p:nvPr/>
-        </p:nvSpPr>
-        <p:spPr>
-          <a:xfrm>
-            <a:off x="566928" y="4142232"/>
-            <a:ext cx="11057839" cy="4023360"/>
-          </a:xfrm>
-          <a:prstGeom prst="rect">
-            <a:avLst/>
-          </a:prstGeom>
-          <a:noFill/>
-          <a:ln/>
-        </p:spPr>
-        <p:txBody>
-          <a:bodyPr wrap="square" rtlCol="0" anchor="t"/>
-          <a:lstStyle/>
-          <a:p>
-            <a:pPr marL="342900" indent="-342900">
-              <a:lnSpc>
-                <a:spcPct val="115000"/>
-              </a:lnSpc>
-              <a:spcAft>
-                <a:spcPts val="1000"/>
-              </a:spcAft>
-              <a:buSzPct val="100000"/>
-              <a:buChar char="•"/>
-            </a:pPr>
-            <a:r>
-              <a:rPr lang="en-US" sz="1450" dirty="0">
-                <a:solidFill>
-                  <a:srgbClr val="1A1A1E"/>
-                </a:solidFill>
-                <a:latin typeface="Segoe UI" pitchFamily="34" charset="0"/>
-                <a:ea typeface="Segoe UI" pitchFamily="34" charset="-122"/>
-                <a:cs typeface="Segoe UI" pitchFamily="34" charset="-120"/>
-              </a:rPr>
-              <a:t>Run on every pull request against the target branch, and nightly against UAT</a:t>
-            </a:r>
-            <a:endParaRPr lang="en-US" sz="1450" dirty="0"/>
-          </a:p>
-          <a:p>
-            <a:pPr marL="342900" indent="-342900">
-              <a:lnSpc>
-                <a:spcPct val="115000"/>
-              </a:lnSpc>
-              <a:spcAft>
-                <a:spcPts val="1000"/>
-              </a:spcAft>
-              <a:buSzPct val="100000"/>
-              <a:buChar char="•"/>
-            </a:pPr>
-            <a:r>
-              <a:rPr lang="en-US" sz="1450" dirty="0">
-                <a:solidFill>
-                  <a:srgbClr val="1A1A1E"/>
-                </a:solidFill>
-                <a:latin typeface="Segoe UI" pitchFamily="34" charset="0"/>
-                <a:ea typeface="Segoe UI" pitchFamily="34" charset="-122"/>
-                <a:cs typeface="Segoe UI" pitchFamily="34" charset="-120"/>
-              </a:rPr>
-              <a:t>A red suite blocks the merge - that is the whole point of the investment</a:t>
-            </a:r>
-            <a:endParaRPr lang="en-US" sz="1450" dirty="0"/>
-          </a:p>
-          <a:p>
-            <a:pPr marL="342900" indent="-342900">
-              <a:lnSpc>
-                <a:spcPct val="115000"/>
-              </a:lnSpc>
-              <a:spcAft>
-                <a:spcPts val="1000"/>
-              </a:spcAft>
-              <a:buSzPct val="100000"/>
-              <a:buChar char="•"/>
-            </a:pPr>
-            <a:r>
-              <a:rPr lang="en-US" sz="1450" dirty="0">
-                <a:solidFill>
-                  <a:srgbClr val="1A1A1E"/>
-                </a:solidFill>
-                <a:latin typeface="Segoe UI" pitchFamily="34" charset="0"/>
-                <a:ea typeface="Segoe UI" pitchFamily="34" charset="-122"/>
-                <a:cs typeface="Segoe UI" pitchFamily="34" charset="-120"/>
-              </a:rPr>
-              <a:t>Still to arrange: CI credentials and a stable non-production account that does not rotate</a:t>
-            </a:r>
-            <a:endParaRPr lang="en-US" sz="1450" dirty="0"/>
-          </a:p>
-        </p:txBody>
-      </p:sp>
-    </p:spTree>
-  </p:cSld>
-  <p:clrMapOvr>
-    <a:masterClrMapping/>
-  </p:clrMapOvr>
-</p:sld>
-</file>
-
-<file path=ppt/slides/slide16.xml><?xml version="1.0" encoding="utf-8"?>
-<p:sld xmlns:a="http://schemas.openxmlformats.org/drawingml/2006/main" xmlns:r="http://schemas.openxmlformats.org/officeDocument/2006/relationships" xmlns:p="http://schemas.openxmlformats.org/presentationml/2006/main">
-  <p:cSld name="Slide 16">
     <p:bg>
       <p:bgPr>
         <a:solidFill>

</xml_diff>

<commit_message>
Playwright deck: show the speed gap against a human and explain where it comes from
</commit_message>
<xml_diff>
--- a/presentations/Web_Test_Automation_Playwright.pptx
+++ b/presentations/Web_Test_Automation_Playwright.pptx
@@ -19,9 +19,10 @@
     <p:sldId id="267" r:id="rId13"/>
     <p:sldId id="268" r:id="rId14"/>
     <p:sldId id="269" r:id="rId15"/>
+    <p:sldId id="270" r:id="rId16"/>
   </p:sldIdLst>
   <p:notesMasterIdLst>
-    <p:notesMasterId r:id="rId16"/>
+    <p:notesMasterId r:id="rId17"/>
   </p:notesMasterIdLst>
   <p:sldSz cx="12192000" cy="6858000"/>
   <p:notesSz cx="6858000" cy="12192000"/>
@@ -979,6 +980,94 @@
             <a:fld id="{F7021451-1387-4CA6-816F-3879F97B5CBC}" type="slidenum">
               <a:rPr lang="en-US"/>
               <a:t>14</a:t>
+            </a:fld>
+            <a:endParaRPr lang="en-US"/>
+          </a:p>
+        </p:txBody>
+      </p:sp>
+    </p:spTree>
+    <p:extLst>
+      <p:ext uri="{BB962C8B-B14F-4D97-AF65-F5344CB8AC3E}">
+        <p14:creationId xmlns:p14="http://schemas.microsoft.com/office/powerpoint/2010/main" val="1024086991"/>
+      </p:ext>
+    </p:extLst>
+  </p:cSld>
+  <p:clrMapOvr>
+    <a:masterClrMapping/>
+  </p:clrMapOvr>
+</p:notes>
+</file>
+
+<file path=ppt/notesSlides/notesSlide15.xml><?xml version="1.0" encoding="utf-8"?>
+<p:notes xmlns:a="http://schemas.openxmlformats.org/drawingml/2006/main" xmlns:r="http://schemas.openxmlformats.org/officeDocument/2006/relationships" xmlns:p="http://schemas.openxmlformats.org/presentationml/2006/main">
+  <p:cSld>
+    <p:spTree>
+      <p:nvGrpSpPr>
+        <p:cNvPr id="1" name=""/>
+        <p:cNvGrpSpPr/>
+        <p:nvPr/>
+      </p:nvGrpSpPr>
+      <p:grpSpPr>
+        <a:xfrm>
+          <a:off x="0" y="0"/>
+          <a:ext cx="0" cy="0"/>
+          <a:chOff x="0" y="0"/>
+          <a:chExt cx="0" cy="0"/>
+        </a:xfrm>
+      </p:grpSpPr>
+      <p:sp>
+        <p:nvSpPr>
+          <p:cNvPr id="2" name="Slide Image Placeholder 1"/>
+          <p:cNvSpPr>
+            <a:spLocks noGrp="1" noRot="1" noChangeAspect="1"/>
+          </p:cNvSpPr>
+          <p:nvPr>
+            <p:ph type="sldImg"/>
+          </p:nvPr>
+        </p:nvSpPr>
+        <p:spPr/>
+      </p:sp>
+      <p:sp>
+        <p:nvSpPr>
+          <p:cNvPr id="3" name="Notes Placeholder 2"/>
+          <p:cNvSpPr>
+            <a:spLocks noGrp="1"/>
+          </p:cNvSpPr>
+          <p:nvPr>
+            <p:ph type="body" idx="1"/>
+          </p:nvPr>
+        </p:nvSpPr>
+        <p:spPr/>
+        <p:txBody>
+          <a:bodyPr/>
+          <a:lstStyle/>
+          <a:p>
+            <a:r>
+              <a:rPr lang="en-US" dirty="0"/>
+              <a:t/>
+            </a:r>
+            <a:endParaRPr lang="en-US" dirty="0"/>
+          </a:p>
+        </p:txBody>
+      </p:sp>
+      <p:sp>
+        <p:nvSpPr>
+          <p:cNvPr id="4" name="Slide Number Placeholder 3"/>
+          <p:cNvSpPr>
+            <a:spLocks noGrp="1"/>
+          </p:cNvSpPr>
+          <p:nvPr>
+            <p:ph type="sldNum" sz="quarter" idx="10"/>
+          </p:nvPr>
+        </p:nvSpPr>
+        <p:spPr/>
+        <p:txBody>
+          <a:bodyPr/>
+          <a:lstStyle/>
+          <a:p>
+            <a:fld id="{F7021451-1387-4CA6-816F-3879F97B5CBC}" type="slidenum">
+              <a:rPr lang="en-US"/>
+              <a:t>15</a:t>
             </a:fld>
             <a:endParaRPr lang="en-US"/>
           </a:p>
@@ -2470,7 +2559,7 @@
                 <a:ea typeface="Segoe UI" pitchFamily="34" charset="-122"/>
                 <a:cs typeface="Segoe UI" pitchFamily="34" charset="-120"/>
               </a:rPr>
-              <a:t>What one afternoon produced</a:t>
+              <a:t>By hand, or with the agent</a:t>
             </a:r>
             <a:endParaRPr lang="en-US" sz="2600" dirty="0"/>
           </a:p>
@@ -2509,7 +2598,7 @@
                 <a:ea typeface="Segoe UI" pitchFamily="34" charset="-122"/>
                 <a:cs typeface="Segoe UI" pitchFamily="34" charset="-120"/>
               </a:rPr>
-              <a:t>The RSA portal has been live for years with no automated regression at all. This is where it stood by the end of one session.</a:t>
+              <a:t>The same 13 checks, the same site, the same evidence - the only difference is how long it takes to exist</a:t>
             </a:r>
             <a:endParaRPr lang="en-US" sz="1400" dirty="0"/>
           </a:p>
@@ -2537,26 +2626,65 @@
       </p:sp>
       <p:sp>
         <p:nvSpPr>
-          <p:cNvPr id="5" name="Shape 3"/>
+          <p:cNvPr id="5" name="Text 3"/>
           <p:cNvSpPr/>
           <p:nvPr/>
         </p:nvSpPr>
         <p:spPr>
           <a:xfrm>
             <a:off x="566928" y="1627632"/>
-            <a:ext cx="2627300" cy="1371600"/>
+            <a:ext cx="2560320" cy="731520"/>
+          </a:xfrm>
+          <a:prstGeom prst="rect">
+            <a:avLst/>
+          </a:prstGeom>
+          <a:noFill/>
+          <a:ln/>
+        </p:spPr>
+        <p:txBody>
+          <a:bodyPr wrap="square" rtlCol="0" anchor="ctr"/>
+          <a:lstStyle/>
+          <a:p>
+            <a:pPr indent="0" marL="0">
+              <a:buNone/>
+            </a:pPr>
+            <a:r>
+              <a:rPr lang="en-US" sz="1400" b="1" dirty="0">
+                <a:solidFill>
+                  <a:srgbClr val="1A1A1E"/>
+                </a:solidFill>
+                <a:latin typeface="Segoe UI" pitchFamily="34" charset="0"/>
+                <a:ea typeface="Segoe UI" pitchFamily="34" charset="-122"/>
+                <a:cs typeface="Segoe UI" pitchFamily="34" charset="-120"/>
+              </a:rPr>
+              <a:t>Written by hand</a:t>
+            </a:r>
+            <a:endParaRPr lang="en-US" sz="1400" dirty="0"/>
+          </a:p>
+        </p:txBody>
+      </p:sp>
+      <p:sp>
+        <p:nvSpPr>
+          <p:cNvPr id="6" name="Shape 4"/>
+          <p:cNvSpPr/>
+          <p:nvPr/>
+        </p:nvSpPr>
+        <p:spPr>
+          <a:xfrm>
+            <a:off x="3310128" y="1627632"/>
+            <a:ext cx="6211519" cy="731520"/>
           </a:xfrm>
           <a:prstGeom prst="roundRect">
             <a:avLst>
-              <a:gd name="adj" fmla="val 5333"/>
+              <a:gd name="adj" fmla="val 6250"/>
             </a:avLst>
           </a:prstGeom>
           <a:solidFill>
-            <a:srgbClr val="E8F0F8"/>
+            <a:srgbClr val="F1F2F4"/>
           </a:solidFill>
           <a:ln w="12700">
             <a:solidFill>
-              <a:srgbClr val="E8F0F8"/>
+              <a:srgbClr val="F1F2F4"/>
             </a:solidFill>
             <a:prstDash val="solid"/>
           </a:ln>
@@ -2564,104 +2692,26 @@
       </p:sp>
       <p:sp>
         <p:nvSpPr>
-          <p:cNvPr id="6" name="Text 4"/>
-          <p:cNvSpPr/>
-          <p:nvPr/>
-        </p:nvSpPr>
-        <p:spPr>
-          <a:xfrm>
-            <a:off x="566928" y="1755648"/>
-            <a:ext cx="2627300" cy="548640"/>
-          </a:xfrm>
-          <a:prstGeom prst="rect">
-            <a:avLst/>
-          </a:prstGeom>
-          <a:noFill/>
-          <a:ln/>
-        </p:spPr>
-        <p:txBody>
-          <a:bodyPr wrap="square" rtlCol="0" anchor="ctr"/>
-          <a:lstStyle/>
-          <a:p>
-            <a:pPr algn="ctr" indent="0" marL="0">
-              <a:buNone/>
-            </a:pPr>
-            <a:r>
-              <a:rPr lang="en-US" sz="3000" b="1" dirty="0">
-                <a:solidFill>
-                  <a:srgbClr val="0B5FA5"/>
-                </a:solidFill>
-                <a:latin typeface="Segoe UI" pitchFamily="34" charset="0"/>
-                <a:ea typeface="Segoe UI" pitchFamily="34" charset="-122"/>
-                <a:cs typeface="Segoe UI" pitchFamily="34" charset="-120"/>
-              </a:rPr>
-              <a:t>0 → 13</a:t>
-            </a:r>
-            <a:endParaRPr lang="en-US" sz="3000" dirty="0"/>
-          </a:p>
-        </p:txBody>
-      </p:sp>
-      <p:sp>
-        <p:nvSpPr>
-          <p:cNvPr id="7" name="Text 5"/>
-          <p:cNvSpPr/>
-          <p:nvPr/>
-        </p:nvSpPr>
-        <p:spPr>
-          <a:xfrm>
-            <a:off x="658368" y="2304288"/>
-            <a:ext cx="2444420" cy="384048"/>
-          </a:xfrm>
-          <a:prstGeom prst="rect">
-            <a:avLst/>
-          </a:prstGeom>
-          <a:noFill/>
-          <a:ln/>
-        </p:spPr>
-        <p:txBody>
-          <a:bodyPr wrap="square" rtlCol="0" anchor="ctr"/>
-          <a:lstStyle/>
-          <a:p>
-            <a:pPr algn="ctr" indent="0" marL="0">
-              <a:buNone/>
-            </a:pPr>
-            <a:r>
-              <a:rPr lang="en-US" sz="1150" dirty="0">
-                <a:solidFill>
-                  <a:srgbClr val="3F3F46"/>
-                </a:solidFill>
-                <a:latin typeface="Segoe UI" pitchFamily="34" charset="0"/>
-                <a:ea typeface="Segoe UI" pitchFamily="34" charset="-122"/>
-                <a:cs typeface="Segoe UI" pitchFamily="34" charset="-120"/>
-              </a:rPr>
-              <a:t>automated checks, from nothing</a:t>
-            </a:r>
-            <a:endParaRPr lang="en-US" sz="1150" dirty="0"/>
-          </a:p>
-        </p:txBody>
-      </p:sp>
-      <p:sp>
-        <p:nvSpPr>
-          <p:cNvPr id="8" name="Shape 6"/>
-          <p:cNvSpPr/>
-          <p:nvPr/>
-        </p:nvSpPr>
-        <p:spPr>
-          <a:xfrm>
-            <a:off x="3377108" y="1627632"/>
-            <a:ext cx="2627300" cy="1371600"/>
+          <p:cNvPr id="7" name="Shape 5"/>
+          <p:cNvSpPr/>
+          <p:nvPr/>
+        </p:nvSpPr>
+        <p:spPr>
+          <a:xfrm>
+            <a:off x="3310128" y="1627632"/>
+            <a:ext cx="6211519" cy="731520"/>
           </a:xfrm>
           <a:prstGeom prst="roundRect">
             <a:avLst>
-              <a:gd name="adj" fmla="val 5333"/>
+              <a:gd name="adj" fmla="val 6250"/>
             </a:avLst>
           </a:prstGeom>
           <a:solidFill>
-            <a:srgbClr val="E8F0F8"/>
+            <a:srgbClr val="B91C1C"/>
           </a:solidFill>
           <a:ln w="12700">
             <a:solidFill>
-              <a:srgbClr val="E8F0F8"/>
+              <a:srgbClr val="B91C1C"/>
             </a:solidFill>
             <a:prstDash val="solid"/>
           </a:ln>
@@ -2669,14 +2719,14 @@
       </p:sp>
       <p:sp>
         <p:nvSpPr>
-          <p:cNvPr id="9" name="Text 7"/>
-          <p:cNvSpPr/>
-          <p:nvPr/>
-        </p:nvSpPr>
-        <p:spPr>
-          <a:xfrm>
-            <a:off x="3377108" y="1755648"/>
-            <a:ext cx="2627300" cy="548640"/>
+          <p:cNvPr id="8" name="Text 6"/>
+          <p:cNvSpPr/>
+          <p:nvPr/>
+        </p:nvSpPr>
+        <p:spPr>
+          <a:xfrm>
+            <a:off x="9704527" y="1627632"/>
+            <a:ext cx="1737360" cy="731520"/>
           </a:xfrm>
           <a:prstGeom prst="rect">
             <a:avLst/>
@@ -2688,34 +2738,34 @@
           <a:bodyPr wrap="square" rtlCol="0" anchor="ctr"/>
           <a:lstStyle/>
           <a:p>
-            <a:pPr algn="ctr" indent="0" marL="0">
-              <a:buNone/>
-            </a:pPr>
-            <a:r>
-              <a:rPr lang="en-US" sz="3000" b="1" dirty="0">
-                <a:solidFill>
-                  <a:srgbClr val="0B5FA5"/>
-                </a:solidFill>
-                <a:latin typeface="Segoe UI" pitchFamily="34" charset="0"/>
-                <a:ea typeface="Segoe UI" pitchFamily="34" charset="-122"/>
-                <a:cs typeface="Segoe UI" pitchFamily="34" charset="-120"/>
-              </a:rPr>
-              <a:t>5</a:t>
-            </a:r>
-            <a:endParaRPr lang="en-US" sz="3000" dirty="0"/>
-          </a:p>
-        </p:txBody>
-      </p:sp>
-      <p:sp>
-        <p:nvSpPr>
-          <p:cNvPr id="10" name="Text 8"/>
-          <p:cNvSpPr/>
-          <p:nvPr/>
-        </p:nvSpPr>
-        <p:spPr>
-          <a:xfrm>
-            <a:off x="3468548" y="2304288"/>
-            <a:ext cx="2444420" cy="384048"/>
+            <a:pPr indent="0" marL="0">
+              <a:buNone/>
+            </a:pPr>
+            <a:r>
+              <a:rPr lang="en-US" sz="1700" b="1" dirty="0">
+                <a:solidFill>
+                  <a:srgbClr val="B91C1C"/>
+                </a:solidFill>
+                <a:latin typeface="Segoe UI" pitchFamily="34" charset="0"/>
+                <a:ea typeface="Segoe UI" pitchFamily="34" charset="-122"/>
+                <a:cs typeface="Segoe UI" pitchFamily="34" charset="-120"/>
+              </a:rPr>
+              <a:t>~4 days</a:t>
+            </a:r>
+            <a:endParaRPr lang="en-US" sz="1700" dirty="0"/>
+          </a:p>
+        </p:txBody>
+      </p:sp>
+      <p:sp>
+        <p:nvSpPr>
+          <p:cNvPr id="9" name="Text 7"/>
+          <p:cNvSpPr/>
+          <p:nvPr/>
+        </p:nvSpPr>
+        <p:spPr>
+          <a:xfrm>
+            <a:off x="566928" y="2724912"/>
+            <a:ext cx="2560320" cy="731520"/>
           </a:xfrm>
           <a:prstGeom prst="rect">
             <a:avLst/>
@@ -2727,46 +2777,46 @@
           <a:bodyPr wrap="square" rtlCol="0" anchor="ctr"/>
           <a:lstStyle/>
           <a:p>
-            <a:pPr algn="ctr" indent="0" marL="0">
-              <a:buNone/>
-            </a:pPr>
-            <a:r>
-              <a:rPr lang="en-US" sz="1150" dirty="0">
-                <a:solidFill>
-                  <a:srgbClr val="3F3F46"/>
-                </a:solidFill>
-                <a:latin typeface="Segoe UI" pitchFamily="34" charset="0"/>
-                <a:ea typeface="Segoe UI" pitchFamily="34" charset="-122"/>
-                <a:cs typeface="Segoe UI" pitchFamily="34" charset="-120"/>
-              </a:rPr>
-              <a:t>screens covered</a:t>
-            </a:r>
-            <a:endParaRPr lang="en-US" sz="1150" dirty="0"/>
-          </a:p>
-        </p:txBody>
-      </p:sp>
-      <p:sp>
-        <p:nvSpPr>
-          <p:cNvPr id="11" name="Shape 9"/>
-          <p:cNvSpPr/>
-          <p:nvPr/>
-        </p:nvSpPr>
-        <p:spPr>
-          <a:xfrm>
-            <a:off x="6187288" y="1627632"/>
-            <a:ext cx="2627300" cy="1371600"/>
+            <a:pPr indent="0" marL="0">
+              <a:buNone/>
+            </a:pPr>
+            <a:r>
+              <a:rPr lang="en-US" sz="1400" b="1" dirty="0">
+                <a:solidFill>
+                  <a:srgbClr val="1A1A1E"/>
+                </a:solidFill>
+                <a:latin typeface="Segoe UI" pitchFamily="34" charset="0"/>
+                <a:ea typeface="Segoe UI" pitchFamily="34" charset="-122"/>
+                <a:cs typeface="Segoe UI" pitchFamily="34" charset="-120"/>
+              </a:rPr>
+              <a:t>With the agent</a:t>
+            </a:r>
+            <a:endParaRPr lang="en-US" sz="1400" dirty="0"/>
+          </a:p>
+        </p:txBody>
+      </p:sp>
+      <p:sp>
+        <p:nvSpPr>
+          <p:cNvPr id="10" name="Shape 8"/>
+          <p:cNvSpPr/>
+          <p:nvPr/>
+        </p:nvSpPr>
+        <p:spPr>
+          <a:xfrm>
+            <a:off x="3310128" y="2724912"/>
+            <a:ext cx="6211519" cy="731520"/>
           </a:xfrm>
           <a:prstGeom prst="roundRect">
             <a:avLst>
-              <a:gd name="adj" fmla="val 5333"/>
+              <a:gd name="adj" fmla="val 6250"/>
             </a:avLst>
           </a:prstGeom>
           <a:solidFill>
-            <a:srgbClr val="E8F0F8"/>
+            <a:srgbClr val="F1F2F4"/>
           </a:solidFill>
           <a:ln w="12700">
             <a:solidFill>
-              <a:srgbClr val="E8F0F8"/>
+              <a:srgbClr val="F1F2F4"/>
             </a:solidFill>
             <a:prstDash val="solid"/>
           </a:ln>
@@ -2774,642 +2824,19 @@
       </p:sp>
       <p:sp>
         <p:nvSpPr>
-          <p:cNvPr id="12" name="Text 10"/>
-          <p:cNvSpPr/>
-          <p:nvPr/>
-        </p:nvSpPr>
-        <p:spPr>
-          <a:xfrm>
-            <a:off x="6187288" y="1755648"/>
-            <a:ext cx="2627300" cy="548640"/>
-          </a:xfrm>
-          <a:prstGeom prst="rect">
-            <a:avLst/>
-          </a:prstGeom>
-          <a:noFill/>
-          <a:ln/>
-        </p:spPr>
-        <p:txBody>
-          <a:bodyPr wrap="square" rtlCol="0" anchor="ctr"/>
-          <a:lstStyle/>
-          <a:p>
-            <a:pPr algn="ctr" indent="0" marL="0">
-              <a:buNone/>
-            </a:pPr>
-            <a:r>
-              <a:rPr lang="en-US" sz="3000" b="1" dirty="0">
-                <a:solidFill>
-                  <a:srgbClr val="0B5FA5"/>
-                </a:solidFill>
-                <a:latin typeface="Segoe UI" pitchFamily="34" charset="0"/>
-                <a:ea typeface="Segoe UI" pitchFamily="34" charset="-122"/>
-                <a:cs typeface="Segoe UI" pitchFamily="34" charset="-120"/>
-              </a:rPr>
-              <a:t>~2 h</a:t>
-            </a:r>
-            <a:endParaRPr lang="en-US" sz="3000" dirty="0"/>
-          </a:p>
-        </p:txBody>
-      </p:sp>
-      <p:sp>
-        <p:nvSpPr>
-          <p:cNvPr id="13" name="Text 11"/>
-          <p:cNvSpPr/>
-          <p:nvPr/>
-        </p:nvSpPr>
-        <p:spPr>
-          <a:xfrm>
-            <a:off x="6278728" y="2304288"/>
-            <a:ext cx="2444420" cy="384048"/>
-          </a:xfrm>
-          <a:prstGeom prst="rect">
-            <a:avLst/>
-          </a:prstGeom>
-          <a:noFill/>
-          <a:ln/>
-        </p:spPr>
-        <p:txBody>
-          <a:bodyPr wrap="square" rtlCol="0" anchor="ctr"/>
-          <a:lstStyle/>
-          <a:p>
-            <a:pPr algn="ctr" indent="0" marL="0">
-              <a:buNone/>
-            </a:pPr>
-            <a:r>
-              <a:rPr lang="en-US" sz="1150" dirty="0">
-                <a:solidFill>
-                  <a:srgbClr val="3F3F46"/>
-                </a:solidFill>
-                <a:latin typeface="Segoe UI" pitchFamily="34" charset="0"/>
-                <a:ea typeface="Segoe UI" pitchFamily="34" charset="-122"/>
-                <a:cs typeface="Segoe UI" pitchFamily="34" charset="-120"/>
-              </a:rPr>
-              <a:t>to build the whole suite</a:t>
-            </a:r>
-            <a:endParaRPr lang="en-US" sz="1150" dirty="0"/>
-          </a:p>
-        </p:txBody>
-      </p:sp>
-      <p:sp>
-        <p:nvSpPr>
-          <p:cNvPr id="14" name="Shape 12"/>
-          <p:cNvSpPr/>
-          <p:nvPr/>
-        </p:nvSpPr>
-        <p:spPr>
-          <a:xfrm>
-            <a:off x="8997467" y="1627632"/>
-            <a:ext cx="2627300" cy="1371600"/>
+          <p:cNvPr id="11" name="Shape 9"/>
+          <p:cNvSpPr/>
+          <p:nvPr/>
+        </p:nvSpPr>
+        <p:spPr>
+          <a:xfrm>
+            <a:off x="3310128" y="2724912"/>
+            <a:ext cx="388220" cy="731520"/>
           </a:xfrm>
           <a:prstGeom prst="roundRect">
             <a:avLst>
-              <a:gd name="adj" fmla="val 5333"/>
+              <a:gd name="adj" fmla="val 11777"/>
             </a:avLst>
-          </a:prstGeom>
-          <a:solidFill>
-            <a:srgbClr val="E8F0F8"/>
-          </a:solidFill>
-          <a:ln w="12700">
-            <a:solidFill>
-              <a:srgbClr val="E8F0F8"/>
-            </a:solidFill>
-            <a:prstDash val="solid"/>
-          </a:ln>
-        </p:spPr>
-      </p:sp>
-      <p:sp>
-        <p:nvSpPr>
-          <p:cNvPr id="15" name="Text 13"/>
-          <p:cNvSpPr/>
-          <p:nvPr/>
-        </p:nvSpPr>
-        <p:spPr>
-          <a:xfrm>
-            <a:off x="8997467" y="1755648"/>
-            <a:ext cx="2627300" cy="548640"/>
-          </a:xfrm>
-          <a:prstGeom prst="rect">
-            <a:avLst/>
-          </a:prstGeom>
-          <a:noFill/>
-          <a:ln/>
-        </p:spPr>
-        <p:txBody>
-          <a:bodyPr wrap="square" rtlCol="0" anchor="ctr"/>
-          <a:lstStyle/>
-          <a:p>
-            <a:pPr algn="ctr" indent="0" marL="0">
-              <a:buNone/>
-            </a:pPr>
-            <a:r>
-              <a:rPr lang="en-US" sz="3000" b="1" dirty="0">
-                <a:solidFill>
-                  <a:srgbClr val="0B5FA5"/>
-                </a:solidFill>
-                <a:latin typeface="Segoe UI" pitchFamily="34" charset="0"/>
-                <a:ea typeface="Segoe UI" pitchFamily="34" charset="-122"/>
-                <a:cs typeface="Segoe UI" pitchFamily="34" charset="-120"/>
-              </a:rPr>
-              <a:t>~1 min</a:t>
-            </a:r>
-            <a:endParaRPr lang="en-US" sz="3000" dirty="0"/>
-          </a:p>
-        </p:txBody>
-      </p:sp>
-      <p:sp>
-        <p:nvSpPr>
-          <p:cNvPr id="16" name="Text 14"/>
-          <p:cNvSpPr/>
-          <p:nvPr/>
-        </p:nvSpPr>
-        <p:spPr>
-          <a:xfrm>
-            <a:off x="9088907" y="2304288"/>
-            <a:ext cx="2444420" cy="384048"/>
-          </a:xfrm>
-          <a:prstGeom prst="rect">
-            <a:avLst/>
-          </a:prstGeom>
-          <a:noFill/>
-          <a:ln/>
-        </p:spPr>
-        <p:txBody>
-          <a:bodyPr wrap="square" rtlCol="0" anchor="ctr"/>
-          <a:lstStyle/>
-          <a:p>
-            <a:pPr algn="ctr" indent="0" marL="0">
-              <a:buNone/>
-            </a:pPr>
-            <a:r>
-              <a:rPr lang="en-US" sz="1150" dirty="0">
-                <a:solidFill>
-                  <a:srgbClr val="3F3F46"/>
-                </a:solidFill>
-                <a:latin typeface="Segoe UI" pitchFamily="34" charset="0"/>
-                <a:ea typeface="Segoe UI" pitchFamily="34" charset="-122"/>
-                <a:cs typeface="Segoe UI" pitchFamily="34" charset="-120"/>
-              </a:rPr>
-              <a:t>to run it, start to finish</a:t>
-            </a:r>
-            <a:endParaRPr lang="en-US" sz="1150" dirty="0"/>
-          </a:p>
-        </p:txBody>
-      </p:sp>
-      <p:sp>
-        <p:nvSpPr>
-          <p:cNvPr id="17" name="Shape 15"/>
-          <p:cNvSpPr/>
-          <p:nvPr/>
-        </p:nvSpPr>
-        <p:spPr>
-          <a:xfrm>
-            <a:off x="566928" y="3456432"/>
-            <a:ext cx="2531288" cy="960120"/>
-          </a:xfrm>
-          <a:prstGeom prst="roundRect">
-            <a:avLst>
-              <a:gd name="adj" fmla="val 7619"/>
-            </a:avLst>
-          </a:prstGeom>
-          <a:solidFill>
-            <a:srgbClr val="E8F0F8"/>
-          </a:solidFill>
-          <a:ln w="12700">
-            <a:solidFill>
-              <a:srgbClr val="C9DAEA"/>
-            </a:solidFill>
-            <a:prstDash val="solid"/>
-          </a:ln>
-        </p:spPr>
-      </p:sp>
-      <p:sp>
-        <p:nvSpPr>
-          <p:cNvPr id="18" name="Text 16"/>
-          <p:cNvSpPr/>
-          <p:nvPr/>
-        </p:nvSpPr>
-        <p:spPr>
-          <a:xfrm>
-            <a:off x="640080" y="3511296"/>
-            <a:ext cx="2384984" cy="850392"/>
-          </a:xfrm>
-          <a:prstGeom prst="rect">
-            <a:avLst/>
-          </a:prstGeom>
-          <a:noFill/>
-          <a:ln/>
-        </p:spPr>
-        <p:txBody>
-          <a:bodyPr wrap="square" rtlCol="0" anchor="ctr"/>
-          <a:lstStyle/>
-          <a:p>
-            <a:pPr algn="ctr" indent="0" marL="0">
-              <a:buNone/>
-            </a:pPr>
-            <a:r>
-              <a:rPr lang="en-US" sz="1200" b="1" dirty="0">
-                <a:solidFill>
-                  <a:srgbClr val="1A1A1E"/>
-                </a:solidFill>
-                <a:latin typeface="Segoe UI" pitchFamily="34" charset="0"/>
-                <a:ea typeface="Segoe UI" pitchFamily="34" charset="-122"/>
-                <a:cs typeface="Segoe UI" pitchFamily="34" charset="-120"/>
-              </a:rPr>
-              <a:t>Empty folder</a:t>
-            </a:r>
-            <a:endParaRPr lang="en-US" sz="1200" dirty="0"/>
-          </a:p>
-        </p:txBody>
-      </p:sp>
-      <p:sp>
-        <p:nvSpPr>
-          <p:cNvPr id="19" name="Text 17"/>
-          <p:cNvSpPr/>
-          <p:nvPr/>
-        </p:nvSpPr>
-        <p:spPr>
-          <a:xfrm>
-            <a:off x="3098216" y="3456432"/>
-            <a:ext cx="310896" cy="960120"/>
-          </a:xfrm>
-          <a:prstGeom prst="rect">
-            <a:avLst/>
-          </a:prstGeom>
-          <a:noFill/>
-          <a:ln/>
-        </p:spPr>
-        <p:txBody>
-          <a:bodyPr wrap="square" rtlCol="0" anchor="ctr"/>
-          <a:lstStyle/>
-          <a:p>
-            <a:pPr algn="ctr" indent="0" marL="0">
-              <a:buNone/>
-            </a:pPr>
-            <a:r>
-              <a:rPr lang="en-US" sz="1700" b="1" dirty="0">
-                <a:solidFill>
-                  <a:srgbClr val="71717A"/>
-                </a:solidFill>
-                <a:latin typeface="Segoe UI" pitchFamily="34" charset="0"/>
-                <a:ea typeface="Segoe UI" pitchFamily="34" charset="-122"/>
-                <a:cs typeface="Segoe UI" pitchFamily="34" charset="-120"/>
-              </a:rPr>
-              <a:t>→</a:t>
-            </a:r>
-            <a:endParaRPr lang="en-US" sz="1700" dirty="0"/>
-          </a:p>
-        </p:txBody>
-      </p:sp>
-      <p:sp>
-        <p:nvSpPr>
-          <p:cNvPr id="20" name="Shape 18"/>
-          <p:cNvSpPr/>
-          <p:nvPr/>
-        </p:nvSpPr>
-        <p:spPr>
-          <a:xfrm>
-            <a:off x="3409112" y="3456432"/>
-            <a:ext cx="2531288" cy="960120"/>
-          </a:xfrm>
-          <a:prstGeom prst="roundRect">
-            <a:avLst>
-              <a:gd name="adj" fmla="val 7619"/>
-            </a:avLst>
-          </a:prstGeom>
-          <a:solidFill>
-            <a:srgbClr val="E8F0F8"/>
-          </a:solidFill>
-          <a:ln w="12700">
-            <a:solidFill>
-              <a:srgbClr val="C9DAEA"/>
-            </a:solidFill>
-            <a:prstDash val="solid"/>
-          </a:ln>
-        </p:spPr>
-      </p:sp>
-      <p:sp>
-        <p:nvSpPr>
-          <p:cNvPr id="21" name="Text 19"/>
-          <p:cNvSpPr/>
-          <p:nvPr/>
-        </p:nvSpPr>
-        <p:spPr>
-          <a:xfrm>
-            <a:off x="3482264" y="3511296"/>
-            <a:ext cx="2384984" cy="850392"/>
-          </a:xfrm>
-          <a:prstGeom prst="rect">
-            <a:avLst/>
-          </a:prstGeom>
-          <a:noFill/>
-          <a:ln/>
-        </p:spPr>
-        <p:txBody>
-          <a:bodyPr wrap="square" rtlCol="0" anchor="ctr"/>
-          <a:lstStyle/>
-          <a:p>
-            <a:pPr algn="ctr" indent="0" marL="0">
-              <a:buNone/>
-            </a:pPr>
-            <a:r>
-              <a:rPr lang="en-US" sz="1200" b="1" dirty="0">
-                <a:solidFill>
-                  <a:srgbClr val="1A1A1E"/>
-                </a:solidFill>
-                <a:latin typeface="Segoe UI" pitchFamily="34" charset="0"/>
-                <a:ea typeface="Segoe UI" pitchFamily="34" charset="-122"/>
-                <a:cs typeface="Segoe UI" pitchFamily="34" charset="-120"/>
-              </a:rPr>
-              <a:t>First test passing</a:t>
-            </a:r>
-            <a:endParaRPr lang="en-US" sz="1200" dirty="0"/>
-          </a:p>
-          <a:p>
-            <a:pPr algn="ctr" indent="0" marL="0">
-              <a:buNone/>
-            </a:pPr>
-            <a:r>
-              <a:rPr lang="en-US" sz="1200" b="1" dirty="0">
-                <a:solidFill>
-                  <a:srgbClr val="1A1A1E"/>
-                </a:solidFill>
-                <a:latin typeface="Segoe UI" pitchFamily="34" charset="0"/>
-                <a:ea typeface="Segoe UI" pitchFamily="34" charset="-122"/>
-                <a:cs typeface="Segoe UI" pitchFamily="34" charset="-120"/>
-              </a:rPr>
-              <a:t>on the real site</a:t>
-            </a:r>
-            <a:endParaRPr lang="en-US" sz="1200" dirty="0"/>
-          </a:p>
-        </p:txBody>
-      </p:sp>
-      <p:sp>
-        <p:nvSpPr>
-          <p:cNvPr id="22" name="Text 20"/>
-          <p:cNvSpPr/>
-          <p:nvPr/>
-        </p:nvSpPr>
-        <p:spPr>
-          <a:xfrm>
-            <a:off x="5940400" y="3456432"/>
-            <a:ext cx="310896" cy="960120"/>
-          </a:xfrm>
-          <a:prstGeom prst="rect">
-            <a:avLst/>
-          </a:prstGeom>
-          <a:noFill/>
-          <a:ln/>
-        </p:spPr>
-        <p:txBody>
-          <a:bodyPr wrap="square" rtlCol="0" anchor="ctr"/>
-          <a:lstStyle/>
-          <a:p>
-            <a:pPr algn="ctr" indent="0" marL="0">
-              <a:buNone/>
-            </a:pPr>
-            <a:r>
-              <a:rPr lang="en-US" sz="1700" b="1" dirty="0">
-                <a:solidFill>
-                  <a:srgbClr val="71717A"/>
-                </a:solidFill>
-                <a:latin typeface="Segoe UI" pitchFamily="34" charset="0"/>
-                <a:ea typeface="Segoe UI" pitchFamily="34" charset="-122"/>
-                <a:cs typeface="Segoe UI" pitchFamily="34" charset="-120"/>
-              </a:rPr>
-              <a:t>→</a:t>
-            </a:r>
-            <a:endParaRPr lang="en-US" sz="1700" dirty="0"/>
-          </a:p>
-        </p:txBody>
-      </p:sp>
-      <p:sp>
-        <p:nvSpPr>
-          <p:cNvPr id="23" name="Shape 21"/>
-          <p:cNvSpPr/>
-          <p:nvPr/>
-        </p:nvSpPr>
-        <p:spPr>
-          <a:xfrm>
-            <a:off x="6251296" y="3456432"/>
-            <a:ext cx="2531288" cy="960120"/>
-          </a:xfrm>
-          <a:prstGeom prst="roundRect">
-            <a:avLst>
-              <a:gd name="adj" fmla="val 7619"/>
-            </a:avLst>
-          </a:prstGeom>
-          <a:solidFill>
-            <a:srgbClr val="0B5FA5"/>
-          </a:solidFill>
-          <a:ln w="12700">
-            <a:solidFill>
-              <a:srgbClr val="0B5FA5"/>
-            </a:solidFill>
-            <a:prstDash val="solid"/>
-          </a:ln>
-        </p:spPr>
-      </p:sp>
-      <p:sp>
-        <p:nvSpPr>
-          <p:cNvPr id="24" name="Text 22"/>
-          <p:cNvSpPr/>
-          <p:nvPr/>
-        </p:nvSpPr>
-        <p:spPr>
-          <a:xfrm>
-            <a:off x="6324448" y="3511296"/>
-            <a:ext cx="2384984" cy="850392"/>
-          </a:xfrm>
-          <a:prstGeom prst="rect">
-            <a:avLst/>
-          </a:prstGeom>
-          <a:noFill/>
-          <a:ln/>
-        </p:spPr>
-        <p:txBody>
-          <a:bodyPr wrap="square" rtlCol="0" anchor="ctr"/>
-          <a:lstStyle/>
-          <a:p>
-            <a:pPr algn="ctr" indent="0" marL="0">
-              <a:buNone/>
-            </a:pPr>
-            <a:r>
-              <a:rPr lang="en-US" sz="1200" b="1" dirty="0">
-                <a:solidFill>
-                  <a:srgbClr val="FFFFFF"/>
-                </a:solidFill>
-                <a:latin typeface="Segoe UI" pitchFamily="34" charset="0"/>
-                <a:ea typeface="Segoe UI" pitchFamily="34" charset="-122"/>
-                <a:cs typeface="Segoe UI" pitchFamily="34" charset="-120"/>
-              </a:rPr>
-              <a:t>All 13 checks green</a:t>
-            </a:r>
-            <a:endParaRPr lang="en-US" sz="1200" dirty="0"/>
-          </a:p>
-        </p:txBody>
-      </p:sp>
-      <p:sp>
-        <p:nvSpPr>
-          <p:cNvPr id="25" name="Text 23"/>
-          <p:cNvSpPr/>
-          <p:nvPr/>
-        </p:nvSpPr>
-        <p:spPr>
-          <a:xfrm>
-            <a:off x="8782583" y="3456432"/>
-            <a:ext cx="310896" cy="960120"/>
-          </a:xfrm>
-          <a:prstGeom prst="rect">
-            <a:avLst/>
-          </a:prstGeom>
-          <a:noFill/>
-          <a:ln/>
-        </p:spPr>
-        <p:txBody>
-          <a:bodyPr wrap="square" rtlCol="0" anchor="ctr"/>
-          <a:lstStyle/>
-          <a:p>
-            <a:pPr algn="ctr" indent="0" marL="0">
-              <a:buNone/>
-            </a:pPr>
-            <a:r>
-              <a:rPr lang="en-US" sz="1700" b="1" dirty="0">
-                <a:solidFill>
-                  <a:srgbClr val="71717A"/>
-                </a:solidFill>
-                <a:latin typeface="Segoe UI" pitchFamily="34" charset="0"/>
-                <a:ea typeface="Segoe UI" pitchFamily="34" charset="-122"/>
-                <a:cs typeface="Segoe UI" pitchFamily="34" charset="-120"/>
-              </a:rPr>
-              <a:t>→</a:t>
-            </a:r>
-            <a:endParaRPr lang="en-US" sz="1700" dirty="0"/>
-          </a:p>
-        </p:txBody>
-      </p:sp>
-      <p:sp>
-        <p:nvSpPr>
-          <p:cNvPr id="26" name="Shape 24"/>
-          <p:cNvSpPr/>
-          <p:nvPr/>
-        </p:nvSpPr>
-        <p:spPr>
-          <a:xfrm>
-            <a:off x="9093479" y="3456432"/>
-            <a:ext cx="2531288" cy="960120"/>
-          </a:xfrm>
-          <a:prstGeom prst="roundRect">
-            <a:avLst>
-              <a:gd name="adj" fmla="val 7619"/>
-            </a:avLst>
-          </a:prstGeom>
-          <a:solidFill>
-            <a:srgbClr val="E8F0F8"/>
-          </a:solidFill>
-          <a:ln w="12700">
-            <a:solidFill>
-              <a:srgbClr val="C9DAEA"/>
-            </a:solidFill>
-            <a:prstDash val="solid"/>
-          </a:ln>
-        </p:spPr>
-      </p:sp>
-      <p:sp>
-        <p:nvSpPr>
-          <p:cNvPr id="27" name="Text 25"/>
-          <p:cNvSpPr/>
-          <p:nvPr/>
-        </p:nvSpPr>
-        <p:spPr>
-          <a:xfrm>
-            <a:off x="9166631" y="3511296"/>
-            <a:ext cx="2384984" cy="850392"/>
-          </a:xfrm>
-          <a:prstGeom prst="rect">
-            <a:avLst/>
-          </a:prstGeom>
-          <a:noFill/>
-          <a:ln/>
-        </p:spPr>
-        <p:txBody>
-          <a:bodyPr wrap="square" rtlCol="0" anchor="ctr"/>
-          <a:lstStyle/>
-          <a:p>
-            <a:pPr algn="ctr" indent="0" marL="0">
-              <a:buNone/>
-            </a:pPr>
-            <a:r>
-              <a:rPr lang="en-US" sz="1200" b="1" dirty="0">
-                <a:solidFill>
-                  <a:srgbClr val="1A1A1E"/>
-                </a:solidFill>
-                <a:latin typeface="Segoe UI" pitchFamily="34" charset="0"/>
-                <a:ea typeface="Segoe UI" pitchFamily="34" charset="-122"/>
-                <a:cs typeface="Segoe UI" pitchFamily="34" charset="-120"/>
-              </a:rPr>
-              <a:t>Same result on</a:t>
-            </a:r>
-            <a:endParaRPr lang="en-US" sz="1200" dirty="0"/>
-          </a:p>
-          <a:p>
-            <a:pPr algn="ctr" indent="0" marL="0">
-              <a:buNone/>
-            </a:pPr>
-            <a:r>
-              <a:rPr lang="en-US" sz="1200" b="1" dirty="0">
-                <a:solidFill>
-                  <a:srgbClr val="1A1A1E"/>
-                </a:solidFill>
-                <a:latin typeface="Segoe UI" pitchFamily="34" charset="0"/>
-                <a:ea typeface="Segoe UI" pitchFamily="34" charset="-122"/>
-                <a:cs typeface="Segoe UI" pitchFamily="34" charset="-120"/>
-              </a:rPr>
-              <a:t>three full runs</a:t>
-            </a:r>
-            <a:endParaRPr lang="en-US" sz="1200" dirty="0"/>
-          </a:p>
-        </p:txBody>
-      </p:sp>
-      <p:sp>
-        <p:nvSpPr>
-          <p:cNvPr id="28" name="Shape 26"/>
-          <p:cNvSpPr/>
-          <p:nvPr/>
-        </p:nvSpPr>
-        <p:spPr>
-          <a:xfrm>
-            <a:off x="566928" y="4782312"/>
-            <a:ext cx="11057839" cy="731520"/>
-          </a:xfrm>
-          <a:prstGeom prst="roundRect">
-            <a:avLst>
-              <a:gd name="adj" fmla="val 7500"/>
-            </a:avLst>
-          </a:prstGeom>
-          <a:solidFill>
-            <a:srgbClr val="FDF6E7"/>
-          </a:solidFill>
-          <a:ln w="12700">
-            <a:solidFill>
-              <a:srgbClr val="EBD9AE"/>
-            </a:solidFill>
-            <a:prstDash val="solid"/>
-          </a:ln>
-        </p:spPr>
-      </p:sp>
-      <p:sp>
-        <p:nvSpPr>
-          <p:cNvPr id="29" name="Shape 27"/>
-          <p:cNvSpPr/>
-          <p:nvPr/>
-        </p:nvSpPr>
-        <p:spPr>
-          <a:xfrm>
-            <a:off x="566928" y="4782312"/>
-            <a:ext cx="64008" cy="731520"/>
-          </a:xfrm>
-          <a:prstGeom prst="rect">
-            <a:avLst/>
           </a:prstGeom>
           <a:solidFill>
             <a:srgbClr val="15803D"/>
@@ -3424,14 +2851,14 @@
       </p:sp>
       <p:sp>
         <p:nvSpPr>
-          <p:cNvPr id="30" name="Text 28"/>
-          <p:cNvSpPr/>
-          <p:nvPr/>
-        </p:nvSpPr>
-        <p:spPr>
-          <a:xfrm>
-            <a:off x="822960" y="4782312"/>
-            <a:ext cx="10600639" cy="731520"/>
+          <p:cNvPr id="12" name="Text 10"/>
+          <p:cNvSpPr/>
+          <p:nvPr/>
+        </p:nvSpPr>
+        <p:spPr>
+          <a:xfrm>
+            <a:off x="9704527" y="2724912"/>
+            <a:ext cx="1737360" cy="731520"/>
           </a:xfrm>
           <a:prstGeom prst="rect">
             <a:avLst/>
@@ -3447,29 +2874,1129 @@
               <a:buNone/>
             </a:pPr>
             <a:r>
-              <a:rPr lang="en-US" sz="1350" dirty="0">
-                <a:solidFill>
-                  <a:srgbClr val="1A1A1E"/>
-                </a:solidFill>
-                <a:latin typeface="Segoe UI" pitchFamily="34" charset="0"/>
-                <a:ea typeface="Segoe UI" pitchFamily="34" charset="-122"/>
-                <a:cs typeface="Segoe UI" pitchFamily="34" charset="-120"/>
-              </a:rPr>
-              <a:t>The expensive part is done. Sign-in, the screens, the evidence and the report already exist - so the next check is minutes of work, not days.</a:t>
-            </a:r>
-            <a:endParaRPr lang="en-US" sz="1350" dirty="0"/>
-          </a:p>
-        </p:txBody>
-      </p:sp>
-      <p:sp>
-        <p:nvSpPr>
-          <p:cNvPr id="31" name="Text 29"/>
-          <p:cNvSpPr/>
-          <p:nvPr/>
-        </p:nvSpPr>
-        <p:spPr>
-          <a:xfrm>
-            <a:off x="566928" y="5742432"/>
+              <a:rPr lang="en-US" sz="1700" b="1" dirty="0">
+                <a:solidFill>
+                  <a:srgbClr val="15803D"/>
+                </a:solidFill>
+                <a:latin typeface="Segoe UI" pitchFamily="34" charset="0"/>
+                <a:ea typeface="Segoe UI" pitchFamily="34" charset="-122"/>
+                <a:cs typeface="Segoe UI" pitchFamily="34" charset="-120"/>
+              </a:rPr>
+              <a:t>~2 hours</a:t>
+            </a:r>
+            <a:endParaRPr lang="en-US" sz="1700" dirty="0"/>
+          </a:p>
+        </p:txBody>
+      </p:sp>
+      <p:graphicFrame>
+        <p:nvGraphicFramePr>
+          <p:cNvPr id="12" name="Table 0"/>
+          <p:cNvGraphicFramePr>
+            <a:graphicFrameLocks noGrp="1"/>
+          </p:cNvGraphicFramePr>
+          <p:nvPr>
+            <p:extLst>
+              <p:ext uri="{D42A27DB-BD31-4B8C-83A1-F6EECF244321}">
+                <p14:modId xmlns:p14="http://schemas.microsoft.com/office/powerpoint/2010/main" val="1579011935"/>
+              </p:ext>
+            </p:extLst>
+          </p:nvPr>
+        </p:nvGraphicFramePr>
+        <p:xfrm>
+          <a:off x="566928" y="3639312"/>
+          <a:ext cx="11055096" cy="914400"/>
+        </p:xfrm>
+        <a:graphic>
+          <a:graphicData uri="http://schemas.openxmlformats.org/drawingml/2006/table">
+            <a:tbl>
+              <a:tblPr/>
+              <a:tblGrid>
+                <a:gridCol w="5760720"/>
+                <a:gridCol w="2651760"/>
+                <a:gridCol w="2642616"/>
+              </a:tblGrid>
+              <a:tr h="329184">
+                <a:tc>
+                  <a:txBody>
+                    <a:bodyPr/>
+                    <a:lstStyle/>
+                    <a:p>
+                      <a:pPr indent="0" marL="0">
+                        <a:buNone/>
+                      </a:pPr>
+                      <a:r>
+                        <a:rPr lang="en-US" sz="1250" b="1" dirty="0">
+                          <a:solidFill>
+                            <a:srgbClr val="FFFFFF"/>
+                          </a:solidFill>
+                          <a:latin typeface="Segoe UI" pitchFamily="34" charset="0"/>
+                          <a:ea typeface="Segoe UI" pitchFamily="34" charset="-122"/>
+                          <a:cs typeface="Segoe UI" pitchFamily="34" charset="-120"/>
+                        </a:rPr>
+                        <a:t>The same job, step by step</a:t>
+                      </a:r>
+                      <a:endParaRPr lang="en-US" sz="1250" dirty="0">
+                        <a:latin typeface="Segoe UI" charset="0"/>
+                        <a:ea typeface="Segoe UI" charset="0"/>
+                        <a:cs typeface="Segoe UI" charset="0"/>
+                      </a:endParaRPr>
+                    </a:p>
+                  </a:txBody>
+                  <a:tcPr marL="73152" marR="73152" marT="73152" marB="73152" anchor="ctr">
+                    <a:lnL w="6350" cap="flat" cmpd="sng" algn="ctr">
+                      <a:solidFill>
+                        <a:srgbClr val="D9D9DE"/>
+                      </a:solidFill>
+                      <a:prstDash val="solid"/>
+                      <a:round/>
+                      <a:headEnd type="none" w="med" len="med"/>
+                      <a:tailEnd type="none" w="med" len="med"/>
+                    </a:lnL>
+                    <a:lnR w="6350" cap="flat" cmpd="sng" algn="ctr">
+                      <a:solidFill>
+                        <a:srgbClr val="D9D9DE"/>
+                      </a:solidFill>
+                      <a:prstDash val="solid"/>
+                      <a:round/>
+                      <a:headEnd type="none" w="med" len="med"/>
+                      <a:tailEnd type="none" w="med" len="med"/>
+                    </a:lnR>
+                    <a:lnT w="6350" cap="flat" cmpd="sng" algn="ctr">
+                      <a:solidFill>
+                        <a:srgbClr val="D9D9DE"/>
+                      </a:solidFill>
+                      <a:prstDash val="solid"/>
+                      <a:round/>
+                      <a:headEnd type="none" w="med" len="med"/>
+                      <a:tailEnd type="none" w="med" len="med"/>
+                    </a:lnT>
+                    <a:lnB w="6350" cap="flat" cmpd="sng" algn="ctr">
+                      <a:solidFill>
+                        <a:srgbClr val="D9D9DE"/>
+                      </a:solidFill>
+                      <a:prstDash val="solid"/>
+                      <a:round/>
+                      <a:headEnd type="none" w="med" len="med"/>
+                      <a:tailEnd type="none" w="med" len="med"/>
+                    </a:lnB>
+                    <a:solidFill>
+                      <a:srgbClr val="0B5FA5"/>
+                    </a:solidFill>
+                  </a:tcPr>
+                </a:tc>
+                <a:tc>
+                  <a:txBody>
+                    <a:bodyPr/>
+                    <a:lstStyle/>
+                    <a:p>
+                      <a:pPr indent="0" marL="0">
+                        <a:buNone/>
+                      </a:pPr>
+                      <a:r>
+                        <a:rPr lang="en-US" sz="1250" b="1" dirty="0">
+                          <a:solidFill>
+                            <a:srgbClr val="FFFFFF"/>
+                          </a:solidFill>
+                          <a:latin typeface="Segoe UI" pitchFamily="34" charset="0"/>
+                          <a:ea typeface="Segoe UI" pitchFamily="34" charset="-122"/>
+                          <a:cs typeface="Segoe UI" pitchFamily="34" charset="-120"/>
+                        </a:rPr>
+                        <a:t>By hand</a:t>
+                      </a:r>
+                      <a:endParaRPr lang="en-US" sz="1250" dirty="0">
+                        <a:latin typeface="Segoe UI" charset="0"/>
+                        <a:ea typeface="Segoe UI" charset="0"/>
+                        <a:cs typeface="Segoe UI" charset="0"/>
+                      </a:endParaRPr>
+                    </a:p>
+                  </a:txBody>
+                  <a:tcPr marL="73152" marR="73152" marT="73152" marB="73152" anchor="ctr">
+                    <a:lnL w="6350" cap="flat" cmpd="sng" algn="ctr">
+                      <a:solidFill>
+                        <a:srgbClr val="D9D9DE"/>
+                      </a:solidFill>
+                      <a:prstDash val="solid"/>
+                      <a:round/>
+                      <a:headEnd type="none" w="med" len="med"/>
+                      <a:tailEnd type="none" w="med" len="med"/>
+                    </a:lnL>
+                    <a:lnR w="6350" cap="flat" cmpd="sng" algn="ctr">
+                      <a:solidFill>
+                        <a:srgbClr val="D9D9DE"/>
+                      </a:solidFill>
+                      <a:prstDash val="solid"/>
+                      <a:round/>
+                      <a:headEnd type="none" w="med" len="med"/>
+                      <a:tailEnd type="none" w="med" len="med"/>
+                    </a:lnR>
+                    <a:lnT w="6350" cap="flat" cmpd="sng" algn="ctr">
+                      <a:solidFill>
+                        <a:srgbClr val="D9D9DE"/>
+                      </a:solidFill>
+                      <a:prstDash val="solid"/>
+                      <a:round/>
+                      <a:headEnd type="none" w="med" len="med"/>
+                      <a:tailEnd type="none" w="med" len="med"/>
+                    </a:lnT>
+                    <a:lnB w="6350" cap="flat" cmpd="sng" algn="ctr">
+                      <a:solidFill>
+                        <a:srgbClr val="D9D9DE"/>
+                      </a:solidFill>
+                      <a:prstDash val="solid"/>
+                      <a:round/>
+                      <a:headEnd type="none" w="med" len="med"/>
+                      <a:tailEnd type="none" w="med" len="med"/>
+                    </a:lnB>
+                    <a:solidFill>
+                      <a:srgbClr val="0B5FA5"/>
+                    </a:solidFill>
+                  </a:tcPr>
+                </a:tc>
+                <a:tc>
+                  <a:txBody>
+                    <a:bodyPr/>
+                    <a:lstStyle/>
+                    <a:p>
+                      <a:pPr indent="0" marL="0">
+                        <a:buNone/>
+                      </a:pPr>
+                      <a:r>
+                        <a:rPr lang="en-US" sz="1250" b="1" dirty="0">
+                          <a:solidFill>
+                            <a:srgbClr val="FFFFFF"/>
+                          </a:solidFill>
+                          <a:latin typeface="Segoe UI" pitchFamily="34" charset="0"/>
+                          <a:ea typeface="Segoe UI" pitchFamily="34" charset="-122"/>
+                          <a:cs typeface="Segoe UI" pitchFamily="34" charset="-120"/>
+                        </a:rPr>
+                        <a:t>With the agent</a:t>
+                      </a:r>
+                      <a:endParaRPr lang="en-US" sz="1250" dirty="0">
+                        <a:latin typeface="Segoe UI" charset="0"/>
+                        <a:ea typeface="Segoe UI" charset="0"/>
+                        <a:cs typeface="Segoe UI" charset="0"/>
+                      </a:endParaRPr>
+                    </a:p>
+                  </a:txBody>
+                  <a:tcPr marL="73152" marR="73152" marT="73152" marB="73152" anchor="ctr">
+                    <a:lnL w="6350" cap="flat" cmpd="sng" algn="ctr">
+                      <a:solidFill>
+                        <a:srgbClr val="D9D9DE"/>
+                      </a:solidFill>
+                      <a:prstDash val="solid"/>
+                      <a:round/>
+                      <a:headEnd type="none" w="med" len="med"/>
+                      <a:tailEnd type="none" w="med" len="med"/>
+                    </a:lnL>
+                    <a:lnR w="6350" cap="flat" cmpd="sng" algn="ctr">
+                      <a:solidFill>
+                        <a:srgbClr val="D9D9DE"/>
+                      </a:solidFill>
+                      <a:prstDash val="solid"/>
+                      <a:round/>
+                      <a:headEnd type="none" w="med" len="med"/>
+                      <a:tailEnd type="none" w="med" len="med"/>
+                    </a:lnR>
+                    <a:lnT w="6350" cap="flat" cmpd="sng" algn="ctr">
+                      <a:solidFill>
+                        <a:srgbClr val="D9D9DE"/>
+                      </a:solidFill>
+                      <a:prstDash val="solid"/>
+                      <a:round/>
+                      <a:headEnd type="none" w="med" len="med"/>
+                      <a:tailEnd type="none" w="med" len="med"/>
+                    </a:lnT>
+                    <a:lnB w="6350" cap="flat" cmpd="sng" algn="ctr">
+                      <a:solidFill>
+                        <a:srgbClr val="D9D9DE"/>
+                      </a:solidFill>
+                      <a:prstDash val="solid"/>
+                      <a:round/>
+                      <a:headEnd type="none" w="med" len="med"/>
+                      <a:tailEnd type="none" w="med" len="med"/>
+                    </a:lnB>
+                    <a:solidFill>
+                      <a:srgbClr val="0B5FA5"/>
+                    </a:solidFill>
+                  </a:tcPr>
+                </a:tc>
+              </a:tr>
+              <a:tr h="329184">
+                <a:tc>
+                  <a:txBody>
+                    <a:bodyPr/>
+                    <a:lstStyle/>
+                    <a:p>
+                      <a:pPr indent="0" marL="0">
+                        <a:buNone/>
+                      </a:pPr>
+                      <a:r>
+                        <a:rPr lang="en-US" sz="1250" dirty="0">
+                          <a:solidFill>
+                            <a:srgbClr val="1A1A1E"/>
+                          </a:solidFill>
+                          <a:latin typeface="Segoe UI" pitchFamily="34" charset="0"/>
+                          <a:ea typeface="Segoe UI" pitchFamily="34" charset="-122"/>
+                          <a:cs typeface="Segoe UI" pitchFamily="34" charset="-120"/>
+                        </a:rPr>
+                        <a:t>Set up the tool, the login and the reporting</a:t>
+                      </a:r>
+                      <a:endParaRPr lang="en-US" sz="1250" dirty="0">
+                        <a:latin typeface="Segoe UI" charset="0"/>
+                        <a:ea typeface="Segoe UI" charset="0"/>
+                        <a:cs typeface="Segoe UI" charset="0"/>
+                      </a:endParaRPr>
+                    </a:p>
+                  </a:txBody>
+                  <a:tcPr marL="73152" marR="73152" marT="73152" marB="73152" anchor="ctr">
+                    <a:lnL w="6350" cap="flat" cmpd="sng" algn="ctr">
+                      <a:solidFill>
+                        <a:srgbClr val="D9D9DE"/>
+                      </a:solidFill>
+                      <a:prstDash val="solid"/>
+                      <a:round/>
+                      <a:headEnd type="none" w="med" len="med"/>
+                      <a:tailEnd type="none" w="med" len="med"/>
+                    </a:lnL>
+                    <a:lnR w="6350" cap="flat" cmpd="sng" algn="ctr">
+                      <a:solidFill>
+                        <a:srgbClr val="D9D9DE"/>
+                      </a:solidFill>
+                      <a:prstDash val="solid"/>
+                      <a:round/>
+                      <a:headEnd type="none" w="med" len="med"/>
+                      <a:tailEnd type="none" w="med" len="med"/>
+                    </a:lnR>
+                    <a:lnT w="6350" cap="flat" cmpd="sng" algn="ctr">
+                      <a:solidFill>
+                        <a:srgbClr val="D9D9DE"/>
+                      </a:solidFill>
+                      <a:prstDash val="solid"/>
+                      <a:round/>
+                      <a:headEnd type="none" w="med" len="med"/>
+                      <a:tailEnd type="none" w="med" len="med"/>
+                    </a:lnT>
+                    <a:lnB w="6350" cap="flat" cmpd="sng" algn="ctr">
+                      <a:solidFill>
+                        <a:srgbClr val="D9D9DE"/>
+                      </a:solidFill>
+                      <a:prstDash val="solid"/>
+                      <a:round/>
+                      <a:headEnd type="none" w="med" len="med"/>
+                      <a:tailEnd type="none" w="med" len="med"/>
+                    </a:lnB>
+                    <a:solidFill>
+                      <a:srgbClr val="FFFFFF"/>
+                    </a:solidFill>
+                  </a:tcPr>
+                </a:tc>
+                <a:tc>
+                  <a:txBody>
+                    <a:bodyPr/>
+                    <a:lstStyle/>
+                    <a:p>
+                      <a:pPr indent="0" marL="0">
+                        <a:buNone/>
+                      </a:pPr>
+                      <a:r>
+                        <a:rPr lang="en-US" sz="1250" dirty="0">
+                          <a:solidFill>
+                            <a:srgbClr val="1A1A1E"/>
+                          </a:solidFill>
+                          <a:latin typeface="Segoe UI" pitchFamily="34" charset="0"/>
+                          <a:ea typeface="Segoe UI" pitchFamily="34" charset="-122"/>
+                          <a:cs typeface="Segoe UI" pitchFamily="34" charset="-120"/>
+                        </a:rPr>
+                        <a:t>half a day</a:t>
+                      </a:r>
+                      <a:endParaRPr lang="en-US" sz="1250" dirty="0">
+                        <a:latin typeface="Segoe UI" charset="0"/>
+                        <a:ea typeface="Segoe UI" charset="0"/>
+                        <a:cs typeface="Segoe UI" charset="0"/>
+                      </a:endParaRPr>
+                    </a:p>
+                  </a:txBody>
+                  <a:tcPr marL="73152" marR="73152" marT="73152" marB="73152" anchor="ctr">
+                    <a:lnL w="6350" cap="flat" cmpd="sng" algn="ctr">
+                      <a:solidFill>
+                        <a:srgbClr val="D9D9DE"/>
+                      </a:solidFill>
+                      <a:prstDash val="solid"/>
+                      <a:round/>
+                      <a:headEnd type="none" w="med" len="med"/>
+                      <a:tailEnd type="none" w="med" len="med"/>
+                    </a:lnL>
+                    <a:lnR w="6350" cap="flat" cmpd="sng" algn="ctr">
+                      <a:solidFill>
+                        <a:srgbClr val="D9D9DE"/>
+                      </a:solidFill>
+                      <a:prstDash val="solid"/>
+                      <a:round/>
+                      <a:headEnd type="none" w="med" len="med"/>
+                      <a:tailEnd type="none" w="med" len="med"/>
+                    </a:lnR>
+                    <a:lnT w="6350" cap="flat" cmpd="sng" algn="ctr">
+                      <a:solidFill>
+                        <a:srgbClr val="D9D9DE"/>
+                      </a:solidFill>
+                      <a:prstDash val="solid"/>
+                      <a:round/>
+                      <a:headEnd type="none" w="med" len="med"/>
+                      <a:tailEnd type="none" w="med" len="med"/>
+                    </a:lnT>
+                    <a:lnB w="6350" cap="flat" cmpd="sng" algn="ctr">
+                      <a:solidFill>
+                        <a:srgbClr val="D9D9DE"/>
+                      </a:solidFill>
+                      <a:prstDash val="solid"/>
+                      <a:round/>
+                      <a:headEnd type="none" w="med" len="med"/>
+                      <a:tailEnd type="none" w="med" len="med"/>
+                    </a:lnB>
+                    <a:solidFill>
+                      <a:srgbClr val="FFFFFF"/>
+                    </a:solidFill>
+                  </a:tcPr>
+                </a:tc>
+                <a:tc>
+                  <a:txBody>
+                    <a:bodyPr/>
+                    <a:lstStyle/>
+                    <a:p>
+                      <a:pPr indent="0" marL="0">
+                        <a:buNone/>
+                      </a:pPr>
+                      <a:r>
+                        <a:rPr lang="en-US" sz="1250" dirty="0">
+                          <a:solidFill>
+                            <a:srgbClr val="1A1A1E"/>
+                          </a:solidFill>
+                          <a:latin typeface="Segoe UI" pitchFamily="34" charset="0"/>
+                          <a:ea typeface="Segoe UI" pitchFamily="34" charset="-122"/>
+                          <a:cs typeface="Segoe UI" pitchFamily="34" charset="-120"/>
+                        </a:rPr>
+                        <a:t>~15 min</a:t>
+                      </a:r>
+                      <a:endParaRPr lang="en-US" sz="1250" dirty="0">
+                        <a:latin typeface="Segoe UI" charset="0"/>
+                        <a:ea typeface="Segoe UI" charset="0"/>
+                        <a:cs typeface="Segoe UI" charset="0"/>
+                      </a:endParaRPr>
+                    </a:p>
+                  </a:txBody>
+                  <a:tcPr marL="73152" marR="73152" marT="73152" marB="73152" anchor="ctr">
+                    <a:lnL w="6350" cap="flat" cmpd="sng" algn="ctr">
+                      <a:solidFill>
+                        <a:srgbClr val="D9D9DE"/>
+                      </a:solidFill>
+                      <a:prstDash val="solid"/>
+                      <a:round/>
+                      <a:headEnd type="none" w="med" len="med"/>
+                      <a:tailEnd type="none" w="med" len="med"/>
+                    </a:lnL>
+                    <a:lnR w="6350" cap="flat" cmpd="sng" algn="ctr">
+                      <a:solidFill>
+                        <a:srgbClr val="D9D9DE"/>
+                      </a:solidFill>
+                      <a:prstDash val="solid"/>
+                      <a:round/>
+                      <a:headEnd type="none" w="med" len="med"/>
+                      <a:tailEnd type="none" w="med" len="med"/>
+                    </a:lnR>
+                    <a:lnT w="6350" cap="flat" cmpd="sng" algn="ctr">
+                      <a:solidFill>
+                        <a:srgbClr val="D9D9DE"/>
+                      </a:solidFill>
+                      <a:prstDash val="solid"/>
+                      <a:round/>
+                      <a:headEnd type="none" w="med" len="med"/>
+                      <a:tailEnd type="none" w="med" len="med"/>
+                    </a:lnT>
+                    <a:lnB w="6350" cap="flat" cmpd="sng" algn="ctr">
+                      <a:solidFill>
+                        <a:srgbClr val="D9D9DE"/>
+                      </a:solidFill>
+                      <a:prstDash val="solid"/>
+                      <a:round/>
+                      <a:headEnd type="none" w="med" len="med"/>
+                      <a:tailEnd type="none" w="med" len="med"/>
+                    </a:lnB>
+                    <a:solidFill>
+                      <a:srgbClr val="FFFFFF"/>
+                    </a:solidFill>
+                  </a:tcPr>
+                </a:tc>
+              </a:tr>
+              <a:tr h="329184">
+                <a:tc>
+                  <a:txBody>
+                    <a:bodyPr/>
+                    <a:lstStyle/>
+                    <a:p>
+                      <a:pPr indent="0" marL="0">
+                        <a:buNone/>
+                      </a:pPr>
+                      <a:r>
+                        <a:rPr lang="en-US" sz="1250" dirty="0">
+                          <a:solidFill>
+                            <a:srgbClr val="1A1A1E"/>
+                          </a:solidFill>
+                          <a:latin typeface="Segoe UI" pitchFamily="34" charset="0"/>
+                          <a:ea typeface="Segoe UI" pitchFamily="34" charset="-122"/>
+                          <a:cs typeface="Segoe UI" pitchFamily="34" charset="-120"/>
+                        </a:rPr>
+                        <a:t>Find the right field on every screen</a:t>
+                      </a:r>
+                      <a:endParaRPr lang="en-US" sz="1250" dirty="0">
+                        <a:latin typeface="Segoe UI" charset="0"/>
+                        <a:ea typeface="Segoe UI" charset="0"/>
+                        <a:cs typeface="Segoe UI" charset="0"/>
+                      </a:endParaRPr>
+                    </a:p>
+                  </a:txBody>
+                  <a:tcPr marL="73152" marR="73152" marT="73152" marB="73152" anchor="ctr">
+                    <a:lnL w="6350" cap="flat" cmpd="sng" algn="ctr">
+                      <a:solidFill>
+                        <a:srgbClr val="D9D9DE"/>
+                      </a:solidFill>
+                      <a:prstDash val="solid"/>
+                      <a:round/>
+                      <a:headEnd type="none" w="med" len="med"/>
+                      <a:tailEnd type="none" w="med" len="med"/>
+                    </a:lnL>
+                    <a:lnR w="6350" cap="flat" cmpd="sng" algn="ctr">
+                      <a:solidFill>
+                        <a:srgbClr val="D9D9DE"/>
+                      </a:solidFill>
+                      <a:prstDash val="solid"/>
+                      <a:round/>
+                      <a:headEnd type="none" w="med" len="med"/>
+                      <a:tailEnd type="none" w="med" len="med"/>
+                    </a:lnR>
+                    <a:lnT w="6350" cap="flat" cmpd="sng" algn="ctr">
+                      <a:solidFill>
+                        <a:srgbClr val="D9D9DE"/>
+                      </a:solidFill>
+                      <a:prstDash val="solid"/>
+                      <a:round/>
+                      <a:headEnd type="none" w="med" len="med"/>
+                      <a:tailEnd type="none" w="med" len="med"/>
+                    </a:lnT>
+                    <a:lnB w="6350" cap="flat" cmpd="sng" algn="ctr">
+                      <a:solidFill>
+                        <a:srgbClr val="D9D9DE"/>
+                      </a:solidFill>
+                      <a:prstDash val="solid"/>
+                      <a:round/>
+                      <a:headEnd type="none" w="med" len="med"/>
+                      <a:tailEnd type="none" w="med" len="med"/>
+                    </a:lnB>
+                    <a:solidFill>
+                      <a:srgbClr val="F6F7F9"/>
+                    </a:solidFill>
+                  </a:tcPr>
+                </a:tc>
+                <a:tc>
+                  <a:txBody>
+                    <a:bodyPr/>
+                    <a:lstStyle/>
+                    <a:p>
+                      <a:pPr indent="0" marL="0">
+                        <a:buNone/>
+                      </a:pPr>
+                      <a:r>
+                        <a:rPr lang="en-US" sz="1250" dirty="0">
+                          <a:solidFill>
+                            <a:srgbClr val="1A1A1E"/>
+                          </a:solidFill>
+                          <a:latin typeface="Segoe UI" pitchFamily="34" charset="0"/>
+                          <a:ea typeface="Segoe UI" pitchFamily="34" charset="-122"/>
+                          <a:cs typeface="Segoe UI" pitchFamily="34" charset="-120"/>
+                        </a:rPr>
+                        <a:t>~1 day</a:t>
+                      </a:r>
+                      <a:endParaRPr lang="en-US" sz="1250" dirty="0">
+                        <a:latin typeface="Segoe UI" charset="0"/>
+                        <a:ea typeface="Segoe UI" charset="0"/>
+                        <a:cs typeface="Segoe UI" charset="0"/>
+                      </a:endParaRPr>
+                    </a:p>
+                  </a:txBody>
+                  <a:tcPr marL="73152" marR="73152" marT="73152" marB="73152" anchor="ctr">
+                    <a:lnL w="6350" cap="flat" cmpd="sng" algn="ctr">
+                      <a:solidFill>
+                        <a:srgbClr val="D9D9DE"/>
+                      </a:solidFill>
+                      <a:prstDash val="solid"/>
+                      <a:round/>
+                      <a:headEnd type="none" w="med" len="med"/>
+                      <a:tailEnd type="none" w="med" len="med"/>
+                    </a:lnL>
+                    <a:lnR w="6350" cap="flat" cmpd="sng" algn="ctr">
+                      <a:solidFill>
+                        <a:srgbClr val="D9D9DE"/>
+                      </a:solidFill>
+                      <a:prstDash val="solid"/>
+                      <a:round/>
+                      <a:headEnd type="none" w="med" len="med"/>
+                      <a:tailEnd type="none" w="med" len="med"/>
+                    </a:lnR>
+                    <a:lnT w="6350" cap="flat" cmpd="sng" algn="ctr">
+                      <a:solidFill>
+                        <a:srgbClr val="D9D9DE"/>
+                      </a:solidFill>
+                      <a:prstDash val="solid"/>
+                      <a:round/>
+                      <a:headEnd type="none" w="med" len="med"/>
+                      <a:tailEnd type="none" w="med" len="med"/>
+                    </a:lnT>
+                    <a:lnB w="6350" cap="flat" cmpd="sng" algn="ctr">
+                      <a:solidFill>
+                        <a:srgbClr val="D9D9DE"/>
+                      </a:solidFill>
+                      <a:prstDash val="solid"/>
+                      <a:round/>
+                      <a:headEnd type="none" w="med" len="med"/>
+                      <a:tailEnd type="none" w="med" len="med"/>
+                    </a:lnB>
+                    <a:solidFill>
+                      <a:srgbClr val="F6F7F9"/>
+                    </a:solidFill>
+                  </a:tcPr>
+                </a:tc>
+                <a:tc>
+                  <a:txBody>
+                    <a:bodyPr/>
+                    <a:lstStyle/>
+                    <a:p>
+                      <a:pPr indent="0" marL="0">
+                        <a:buNone/>
+                      </a:pPr>
+                      <a:r>
+                        <a:rPr lang="en-US" sz="1250" dirty="0">
+                          <a:solidFill>
+                            <a:srgbClr val="1A1A1E"/>
+                          </a:solidFill>
+                          <a:latin typeface="Segoe UI" pitchFamily="34" charset="0"/>
+                          <a:ea typeface="Segoe UI" pitchFamily="34" charset="-122"/>
+                          <a:cs typeface="Segoe UI" pitchFamily="34" charset="-120"/>
+                        </a:rPr>
+                        <a:t>minutes - it reads the pages</a:t>
+                      </a:r>
+                      <a:endParaRPr lang="en-US" sz="1250" dirty="0">
+                        <a:latin typeface="Segoe UI" charset="0"/>
+                        <a:ea typeface="Segoe UI" charset="0"/>
+                        <a:cs typeface="Segoe UI" charset="0"/>
+                      </a:endParaRPr>
+                    </a:p>
+                  </a:txBody>
+                  <a:tcPr marL="73152" marR="73152" marT="73152" marB="73152" anchor="ctr">
+                    <a:lnL w="6350" cap="flat" cmpd="sng" algn="ctr">
+                      <a:solidFill>
+                        <a:srgbClr val="D9D9DE"/>
+                      </a:solidFill>
+                      <a:prstDash val="solid"/>
+                      <a:round/>
+                      <a:headEnd type="none" w="med" len="med"/>
+                      <a:tailEnd type="none" w="med" len="med"/>
+                    </a:lnL>
+                    <a:lnR w="6350" cap="flat" cmpd="sng" algn="ctr">
+                      <a:solidFill>
+                        <a:srgbClr val="D9D9DE"/>
+                      </a:solidFill>
+                      <a:prstDash val="solid"/>
+                      <a:round/>
+                      <a:headEnd type="none" w="med" len="med"/>
+                      <a:tailEnd type="none" w="med" len="med"/>
+                    </a:lnR>
+                    <a:lnT w="6350" cap="flat" cmpd="sng" algn="ctr">
+                      <a:solidFill>
+                        <a:srgbClr val="D9D9DE"/>
+                      </a:solidFill>
+                      <a:prstDash val="solid"/>
+                      <a:round/>
+                      <a:headEnd type="none" w="med" len="med"/>
+                      <a:tailEnd type="none" w="med" len="med"/>
+                    </a:lnT>
+                    <a:lnB w="6350" cap="flat" cmpd="sng" algn="ctr">
+                      <a:solidFill>
+                        <a:srgbClr val="D9D9DE"/>
+                      </a:solidFill>
+                      <a:prstDash val="solid"/>
+                      <a:round/>
+                      <a:headEnd type="none" w="med" len="med"/>
+                      <a:tailEnd type="none" w="med" len="med"/>
+                    </a:lnB>
+                    <a:solidFill>
+                      <a:srgbClr val="F6F7F9"/>
+                    </a:solidFill>
+                  </a:tcPr>
+                </a:tc>
+              </a:tr>
+              <a:tr h="329184">
+                <a:tc>
+                  <a:txBody>
+                    <a:bodyPr/>
+                    <a:lstStyle/>
+                    <a:p>
+                      <a:pPr indent="0" marL="0">
+                        <a:buNone/>
+                      </a:pPr>
+                      <a:r>
+                        <a:rPr lang="en-US" sz="1250" dirty="0">
+                          <a:solidFill>
+                            <a:srgbClr val="1A1A1E"/>
+                          </a:solidFill>
+                          <a:latin typeface="Segoe UI" pitchFamily="34" charset="0"/>
+                          <a:ea typeface="Segoe UI" pitchFamily="34" charset="-122"/>
+                          <a:cs typeface="Segoe UI" pitchFamily="34" charset="-120"/>
+                        </a:rPr>
+                        <a:t>Write the 13 checks</a:t>
+                      </a:r>
+                      <a:endParaRPr lang="en-US" sz="1250" dirty="0">
+                        <a:latin typeface="Segoe UI" charset="0"/>
+                        <a:ea typeface="Segoe UI" charset="0"/>
+                        <a:cs typeface="Segoe UI" charset="0"/>
+                      </a:endParaRPr>
+                    </a:p>
+                  </a:txBody>
+                  <a:tcPr marL="73152" marR="73152" marT="73152" marB="73152" anchor="ctr">
+                    <a:lnL w="6350" cap="flat" cmpd="sng" algn="ctr">
+                      <a:solidFill>
+                        <a:srgbClr val="D9D9DE"/>
+                      </a:solidFill>
+                      <a:prstDash val="solid"/>
+                      <a:round/>
+                      <a:headEnd type="none" w="med" len="med"/>
+                      <a:tailEnd type="none" w="med" len="med"/>
+                    </a:lnL>
+                    <a:lnR w="6350" cap="flat" cmpd="sng" algn="ctr">
+                      <a:solidFill>
+                        <a:srgbClr val="D9D9DE"/>
+                      </a:solidFill>
+                      <a:prstDash val="solid"/>
+                      <a:round/>
+                      <a:headEnd type="none" w="med" len="med"/>
+                      <a:tailEnd type="none" w="med" len="med"/>
+                    </a:lnR>
+                    <a:lnT w="6350" cap="flat" cmpd="sng" algn="ctr">
+                      <a:solidFill>
+                        <a:srgbClr val="D9D9DE"/>
+                      </a:solidFill>
+                      <a:prstDash val="solid"/>
+                      <a:round/>
+                      <a:headEnd type="none" w="med" len="med"/>
+                      <a:tailEnd type="none" w="med" len="med"/>
+                    </a:lnT>
+                    <a:lnB w="6350" cap="flat" cmpd="sng" algn="ctr">
+                      <a:solidFill>
+                        <a:srgbClr val="D9D9DE"/>
+                      </a:solidFill>
+                      <a:prstDash val="solid"/>
+                      <a:round/>
+                      <a:headEnd type="none" w="med" len="med"/>
+                      <a:tailEnd type="none" w="med" len="med"/>
+                    </a:lnB>
+                    <a:solidFill>
+                      <a:srgbClr val="FFFFFF"/>
+                    </a:solidFill>
+                  </a:tcPr>
+                </a:tc>
+                <a:tc>
+                  <a:txBody>
+                    <a:bodyPr/>
+                    <a:lstStyle/>
+                    <a:p>
+                      <a:pPr indent="0" marL="0">
+                        <a:buNone/>
+                      </a:pPr>
+                      <a:r>
+                        <a:rPr lang="en-US" sz="1250" dirty="0">
+                          <a:solidFill>
+                            <a:srgbClr val="1A1A1E"/>
+                          </a:solidFill>
+                          <a:latin typeface="Segoe UI" pitchFamily="34" charset="0"/>
+                          <a:ea typeface="Segoe UI" pitchFamily="34" charset="-122"/>
+                          <a:cs typeface="Segoe UI" pitchFamily="34" charset="-120"/>
+                        </a:rPr>
+                        <a:t>~1.5 days</a:t>
+                      </a:r>
+                      <a:endParaRPr lang="en-US" sz="1250" dirty="0">
+                        <a:latin typeface="Segoe UI" charset="0"/>
+                        <a:ea typeface="Segoe UI" charset="0"/>
+                        <a:cs typeface="Segoe UI" charset="0"/>
+                      </a:endParaRPr>
+                    </a:p>
+                  </a:txBody>
+                  <a:tcPr marL="73152" marR="73152" marT="73152" marB="73152" anchor="ctr">
+                    <a:lnL w="6350" cap="flat" cmpd="sng" algn="ctr">
+                      <a:solidFill>
+                        <a:srgbClr val="D9D9DE"/>
+                      </a:solidFill>
+                      <a:prstDash val="solid"/>
+                      <a:round/>
+                      <a:headEnd type="none" w="med" len="med"/>
+                      <a:tailEnd type="none" w="med" len="med"/>
+                    </a:lnL>
+                    <a:lnR w="6350" cap="flat" cmpd="sng" algn="ctr">
+                      <a:solidFill>
+                        <a:srgbClr val="D9D9DE"/>
+                      </a:solidFill>
+                      <a:prstDash val="solid"/>
+                      <a:round/>
+                      <a:headEnd type="none" w="med" len="med"/>
+                      <a:tailEnd type="none" w="med" len="med"/>
+                    </a:lnR>
+                    <a:lnT w="6350" cap="flat" cmpd="sng" algn="ctr">
+                      <a:solidFill>
+                        <a:srgbClr val="D9D9DE"/>
+                      </a:solidFill>
+                      <a:prstDash val="solid"/>
+                      <a:round/>
+                      <a:headEnd type="none" w="med" len="med"/>
+                      <a:tailEnd type="none" w="med" len="med"/>
+                    </a:lnT>
+                    <a:lnB w="6350" cap="flat" cmpd="sng" algn="ctr">
+                      <a:solidFill>
+                        <a:srgbClr val="D9D9DE"/>
+                      </a:solidFill>
+                      <a:prstDash val="solid"/>
+                      <a:round/>
+                      <a:headEnd type="none" w="med" len="med"/>
+                      <a:tailEnd type="none" w="med" len="med"/>
+                    </a:lnB>
+                    <a:solidFill>
+                      <a:srgbClr val="FFFFFF"/>
+                    </a:solidFill>
+                  </a:tcPr>
+                </a:tc>
+                <a:tc>
+                  <a:txBody>
+                    <a:bodyPr/>
+                    <a:lstStyle/>
+                    <a:p>
+                      <a:pPr indent="0" marL="0">
+                        <a:buNone/>
+                      </a:pPr>
+                      <a:r>
+                        <a:rPr lang="en-US" sz="1250" dirty="0">
+                          <a:solidFill>
+                            <a:srgbClr val="1A1A1E"/>
+                          </a:solidFill>
+                          <a:latin typeface="Segoe UI" pitchFamily="34" charset="0"/>
+                          <a:ea typeface="Segoe UI" pitchFamily="34" charset="-122"/>
+                          <a:cs typeface="Segoe UI" pitchFamily="34" charset="-120"/>
+                        </a:rPr>
+                        <a:t>~40 min</a:t>
+                      </a:r>
+                      <a:endParaRPr lang="en-US" sz="1250" dirty="0">
+                        <a:latin typeface="Segoe UI" charset="0"/>
+                        <a:ea typeface="Segoe UI" charset="0"/>
+                        <a:cs typeface="Segoe UI" charset="0"/>
+                      </a:endParaRPr>
+                    </a:p>
+                  </a:txBody>
+                  <a:tcPr marL="73152" marR="73152" marT="73152" marB="73152" anchor="ctr">
+                    <a:lnL w="6350" cap="flat" cmpd="sng" algn="ctr">
+                      <a:solidFill>
+                        <a:srgbClr val="D9D9DE"/>
+                      </a:solidFill>
+                      <a:prstDash val="solid"/>
+                      <a:round/>
+                      <a:headEnd type="none" w="med" len="med"/>
+                      <a:tailEnd type="none" w="med" len="med"/>
+                    </a:lnL>
+                    <a:lnR w="6350" cap="flat" cmpd="sng" algn="ctr">
+                      <a:solidFill>
+                        <a:srgbClr val="D9D9DE"/>
+                      </a:solidFill>
+                      <a:prstDash val="solid"/>
+                      <a:round/>
+                      <a:headEnd type="none" w="med" len="med"/>
+                      <a:tailEnd type="none" w="med" len="med"/>
+                    </a:lnR>
+                    <a:lnT w="6350" cap="flat" cmpd="sng" algn="ctr">
+                      <a:solidFill>
+                        <a:srgbClr val="D9D9DE"/>
+                      </a:solidFill>
+                      <a:prstDash val="solid"/>
+                      <a:round/>
+                      <a:headEnd type="none" w="med" len="med"/>
+                      <a:tailEnd type="none" w="med" len="med"/>
+                    </a:lnT>
+                    <a:lnB w="6350" cap="flat" cmpd="sng" algn="ctr">
+                      <a:solidFill>
+                        <a:srgbClr val="D9D9DE"/>
+                      </a:solidFill>
+                      <a:prstDash val="solid"/>
+                      <a:round/>
+                      <a:headEnd type="none" w="med" len="med"/>
+                      <a:tailEnd type="none" w="med" len="med"/>
+                    </a:lnB>
+                    <a:solidFill>
+                      <a:srgbClr val="FFFFFF"/>
+                    </a:solidFill>
+                  </a:tcPr>
+                </a:tc>
+              </a:tr>
+              <a:tr h="329184">
+                <a:tc>
+                  <a:txBody>
+                    <a:bodyPr/>
+                    <a:lstStyle/>
+                    <a:p>
+                      <a:pPr indent="0" marL="0">
+                        <a:buNone/>
+                      </a:pPr>
+                      <a:r>
+                        <a:rPr lang="en-US" sz="1250" dirty="0">
+                          <a:solidFill>
+                            <a:srgbClr val="1A1A1E"/>
+                          </a:solidFill>
+                          <a:latin typeface="Segoe UI" pitchFamily="34" charset="0"/>
+                          <a:ea typeface="Segoe UI" pitchFamily="34" charset="-122"/>
+                          <a:cs typeface="Segoe UI" pitchFamily="34" charset="-120"/>
+                        </a:rPr>
+                        <a:t>Chase down why they are unreliable</a:t>
+                      </a:r>
+                      <a:endParaRPr lang="en-US" sz="1250" dirty="0">
+                        <a:latin typeface="Segoe UI" charset="0"/>
+                        <a:ea typeface="Segoe UI" charset="0"/>
+                        <a:cs typeface="Segoe UI" charset="0"/>
+                      </a:endParaRPr>
+                    </a:p>
+                  </a:txBody>
+                  <a:tcPr marL="73152" marR="73152" marT="73152" marB="73152" anchor="ctr">
+                    <a:lnL w="6350" cap="flat" cmpd="sng" algn="ctr">
+                      <a:solidFill>
+                        <a:srgbClr val="D9D9DE"/>
+                      </a:solidFill>
+                      <a:prstDash val="solid"/>
+                      <a:round/>
+                      <a:headEnd type="none" w="med" len="med"/>
+                      <a:tailEnd type="none" w="med" len="med"/>
+                    </a:lnL>
+                    <a:lnR w="6350" cap="flat" cmpd="sng" algn="ctr">
+                      <a:solidFill>
+                        <a:srgbClr val="D9D9DE"/>
+                      </a:solidFill>
+                      <a:prstDash val="solid"/>
+                      <a:round/>
+                      <a:headEnd type="none" w="med" len="med"/>
+                      <a:tailEnd type="none" w="med" len="med"/>
+                    </a:lnR>
+                    <a:lnT w="6350" cap="flat" cmpd="sng" algn="ctr">
+                      <a:solidFill>
+                        <a:srgbClr val="D9D9DE"/>
+                      </a:solidFill>
+                      <a:prstDash val="solid"/>
+                      <a:round/>
+                      <a:headEnd type="none" w="med" len="med"/>
+                      <a:tailEnd type="none" w="med" len="med"/>
+                    </a:lnT>
+                    <a:lnB w="6350" cap="flat" cmpd="sng" algn="ctr">
+                      <a:solidFill>
+                        <a:srgbClr val="D9D9DE"/>
+                      </a:solidFill>
+                      <a:prstDash val="solid"/>
+                      <a:round/>
+                      <a:headEnd type="none" w="med" len="med"/>
+                      <a:tailEnd type="none" w="med" len="med"/>
+                    </a:lnB>
+                    <a:solidFill>
+                      <a:srgbClr val="F6F7F9"/>
+                    </a:solidFill>
+                  </a:tcPr>
+                </a:tc>
+                <a:tc>
+                  <a:txBody>
+                    <a:bodyPr/>
+                    <a:lstStyle/>
+                    <a:p>
+                      <a:pPr indent="0" marL="0">
+                        <a:buNone/>
+                      </a:pPr>
+                      <a:r>
+                        <a:rPr lang="en-US" sz="1250" dirty="0">
+                          <a:solidFill>
+                            <a:srgbClr val="1A1A1E"/>
+                          </a:solidFill>
+                          <a:latin typeface="Segoe UI" pitchFamily="34" charset="0"/>
+                          <a:ea typeface="Segoe UI" pitchFamily="34" charset="-122"/>
+                          <a:cs typeface="Segoe UI" pitchFamily="34" charset="-120"/>
+                        </a:rPr>
+                        <a:t>~1 day</a:t>
+                      </a:r>
+                      <a:endParaRPr lang="en-US" sz="1250" dirty="0">
+                        <a:latin typeface="Segoe UI" charset="0"/>
+                        <a:ea typeface="Segoe UI" charset="0"/>
+                        <a:cs typeface="Segoe UI" charset="0"/>
+                      </a:endParaRPr>
+                    </a:p>
+                  </a:txBody>
+                  <a:tcPr marL="73152" marR="73152" marT="73152" marB="73152" anchor="ctr">
+                    <a:lnL w="6350" cap="flat" cmpd="sng" algn="ctr">
+                      <a:solidFill>
+                        <a:srgbClr val="D9D9DE"/>
+                      </a:solidFill>
+                      <a:prstDash val="solid"/>
+                      <a:round/>
+                      <a:headEnd type="none" w="med" len="med"/>
+                      <a:tailEnd type="none" w="med" len="med"/>
+                    </a:lnL>
+                    <a:lnR w="6350" cap="flat" cmpd="sng" algn="ctr">
+                      <a:solidFill>
+                        <a:srgbClr val="D9D9DE"/>
+                      </a:solidFill>
+                      <a:prstDash val="solid"/>
+                      <a:round/>
+                      <a:headEnd type="none" w="med" len="med"/>
+                      <a:tailEnd type="none" w="med" len="med"/>
+                    </a:lnR>
+                    <a:lnT w="6350" cap="flat" cmpd="sng" algn="ctr">
+                      <a:solidFill>
+                        <a:srgbClr val="D9D9DE"/>
+                      </a:solidFill>
+                      <a:prstDash val="solid"/>
+                      <a:round/>
+                      <a:headEnd type="none" w="med" len="med"/>
+                      <a:tailEnd type="none" w="med" len="med"/>
+                    </a:lnT>
+                    <a:lnB w="6350" cap="flat" cmpd="sng" algn="ctr">
+                      <a:solidFill>
+                        <a:srgbClr val="D9D9DE"/>
+                      </a:solidFill>
+                      <a:prstDash val="solid"/>
+                      <a:round/>
+                      <a:headEnd type="none" w="med" len="med"/>
+                      <a:tailEnd type="none" w="med" len="med"/>
+                    </a:lnB>
+                    <a:solidFill>
+                      <a:srgbClr val="F6F7F9"/>
+                    </a:solidFill>
+                  </a:tcPr>
+                </a:tc>
+                <a:tc>
+                  <a:txBody>
+                    <a:bodyPr/>
+                    <a:lstStyle/>
+                    <a:p>
+                      <a:pPr indent="0" marL="0">
+                        <a:buNone/>
+                      </a:pPr>
+                      <a:r>
+                        <a:rPr lang="en-US" sz="1250" dirty="0">
+                          <a:solidFill>
+                            <a:srgbClr val="1A1A1E"/>
+                          </a:solidFill>
+                          <a:latin typeface="Segoe UI" pitchFamily="34" charset="0"/>
+                          <a:ea typeface="Segoe UI" pitchFamily="34" charset="-122"/>
+                          <a:cs typeface="Segoe UI" pitchFamily="34" charset="-120"/>
+                        </a:rPr>
+                        <a:t>~30 min</a:t>
+                      </a:r>
+                      <a:endParaRPr lang="en-US" sz="1250" dirty="0">
+                        <a:latin typeface="Segoe UI" charset="0"/>
+                        <a:ea typeface="Segoe UI" charset="0"/>
+                        <a:cs typeface="Segoe UI" charset="0"/>
+                      </a:endParaRPr>
+                    </a:p>
+                  </a:txBody>
+                  <a:tcPr marL="73152" marR="73152" marT="73152" marB="73152" anchor="ctr">
+                    <a:lnL w="6350" cap="flat" cmpd="sng" algn="ctr">
+                      <a:solidFill>
+                        <a:srgbClr val="D9D9DE"/>
+                      </a:solidFill>
+                      <a:prstDash val="solid"/>
+                      <a:round/>
+                      <a:headEnd type="none" w="med" len="med"/>
+                      <a:tailEnd type="none" w="med" len="med"/>
+                    </a:lnL>
+                    <a:lnR w="6350" cap="flat" cmpd="sng" algn="ctr">
+                      <a:solidFill>
+                        <a:srgbClr val="D9D9DE"/>
+                      </a:solidFill>
+                      <a:prstDash val="solid"/>
+                      <a:round/>
+                      <a:headEnd type="none" w="med" len="med"/>
+                      <a:tailEnd type="none" w="med" len="med"/>
+                    </a:lnR>
+                    <a:lnT w="6350" cap="flat" cmpd="sng" algn="ctr">
+                      <a:solidFill>
+                        <a:srgbClr val="D9D9DE"/>
+                      </a:solidFill>
+                      <a:prstDash val="solid"/>
+                      <a:round/>
+                      <a:headEnd type="none" w="med" len="med"/>
+                      <a:tailEnd type="none" w="med" len="med"/>
+                    </a:lnT>
+                    <a:lnB w="6350" cap="flat" cmpd="sng" algn="ctr">
+                      <a:solidFill>
+                        <a:srgbClr val="D9D9DE"/>
+                      </a:solidFill>
+                      <a:prstDash val="solid"/>
+                      <a:round/>
+                      <a:headEnd type="none" w="med" len="med"/>
+                      <a:tailEnd type="none" w="med" len="med"/>
+                    </a:lnB>
+                    <a:solidFill>
+                      <a:srgbClr val="F6F7F9"/>
+                    </a:solidFill>
+                  </a:tcPr>
+                </a:tc>
+              </a:tr>
+            </a:tbl>
+          </a:graphicData>
+        </a:graphic>
+      </p:graphicFrame>
+      <p:sp>
+        <p:nvSpPr>
+          <p:cNvPr id="14" name="Text 11"/>
+          <p:cNvSpPr/>
+          <p:nvPr/>
+        </p:nvSpPr>
+        <p:spPr>
+          <a:xfrm>
+            <a:off x="566928" y="5605272"/>
+            <a:ext cx="11057839" cy="274320"/>
+          </a:xfrm>
+          <a:prstGeom prst="rect">
+            <a:avLst/>
+          </a:prstGeom>
+          <a:noFill/>
+          <a:ln/>
+        </p:spPr>
+        <p:txBody>
+          <a:bodyPr wrap="square" rtlCol="0" anchor="ctr"/>
+          <a:lstStyle/>
+          <a:p>
+            <a:pPr indent="0" marL="0">
+              <a:buNone/>
+            </a:pPr>
+            <a:r>
+              <a:rPr lang="en-US" sz="1150" i="1" dirty="0">
+                <a:solidFill>
+                  <a:srgbClr val="71717A"/>
+                </a:solidFill>
+                <a:latin typeface="Segoe UI" pitchFamily="34" charset="0"/>
+                <a:ea typeface="Segoe UI" pitchFamily="34" charset="-122"/>
+                <a:cs typeface="Segoe UI" pitchFamily="34" charset="-120"/>
+              </a:rPr>
+              <a:t>"By hand" is an estimate built from those four lines. "With the agent" was measured during the session.</a:t>
+            </a:r>
+            <a:endParaRPr lang="en-US" sz="1150" dirty="0"/>
+          </a:p>
+        </p:txBody>
+      </p:sp>
+      <p:sp>
+        <p:nvSpPr>
+          <p:cNvPr id="15" name="Text 12"/>
+          <p:cNvSpPr/>
+          <p:nvPr/>
+        </p:nvSpPr>
+        <p:spPr>
+          <a:xfrm>
+            <a:off x="566928" y="5925312"/>
             <a:ext cx="11057839" cy="411480"/>
           </a:xfrm>
           <a:prstGeom prst="rect">
@@ -3565,7 +4092,7 @@
                 <a:ea typeface="Segoe UI" pitchFamily="34" charset="-122"/>
                 <a:cs typeface="Segoe UI" pitchFamily="34" charset="-120"/>
               </a:rPr>
-              <a:t>Where the human time still goes</a:t>
+              <a:t>Why it is faster - four reasons</a:t>
             </a:r>
             <a:endParaRPr lang="en-US" sz="2600" dirty="0"/>
           </a:p>
@@ -3604,7 +4131,7 @@
                 <a:ea typeface="Segoe UI" pitchFamily="34" charset="-122"/>
                 <a:cs typeface="Segoe UI" pitchFamily="34" charset="-120"/>
               </a:rPr>
-              <a:t>The agent is fast at the mechanical work; judgement stays with us</a:t>
+              <a:t>None of them is "it types quickly"</a:t>
             </a:r>
             <a:endParaRPr lang="en-US" sz="1400" dirty="0"/>
           </a:p>
@@ -3639,11 +4166,11 @@
         <p:spPr>
           <a:xfrm>
             <a:off x="566928" y="1627632"/>
-            <a:ext cx="5300320" cy="3474720"/>
+            <a:ext cx="2572436" cy="3703320"/>
           </a:xfrm>
           <a:prstGeom prst="roundRect">
             <a:avLst>
-              <a:gd name="adj" fmla="val 2105"/>
+              <a:gd name="adj" fmla="val 2844"/>
             </a:avLst>
           </a:prstGeom>
           <a:solidFill>
@@ -3659,14 +4186,39 @@
       </p:sp>
       <p:sp>
         <p:nvSpPr>
-          <p:cNvPr id="6" name="Text 4"/>
-          <p:cNvSpPr/>
-          <p:nvPr/>
-        </p:nvSpPr>
-        <p:spPr>
-          <a:xfrm>
-            <a:off x="786384" y="1810512"/>
-            <a:ext cx="4861408" cy="365760"/>
+          <p:cNvPr id="6" name="Shape 4"/>
+          <p:cNvSpPr/>
+          <p:nvPr/>
+        </p:nvSpPr>
+        <p:spPr>
+          <a:xfrm>
+            <a:off x="566928" y="1627632"/>
+            <a:ext cx="2572436" cy="54864"/>
+          </a:xfrm>
+          <a:prstGeom prst="rect">
+            <a:avLst/>
+          </a:prstGeom>
+          <a:solidFill>
+            <a:srgbClr val="0B5FA5"/>
+          </a:solidFill>
+          <a:ln w="12700">
+            <a:solidFill>
+              <a:srgbClr val="0B5FA5"/>
+            </a:solidFill>
+            <a:prstDash val="solid"/>
+          </a:ln>
+        </p:spPr>
+      </p:sp>
+      <p:sp>
+        <p:nvSpPr>
+          <p:cNvPr id="7" name="Text 5"/>
+          <p:cNvSpPr/>
+          <p:nvPr/>
+        </p:nvSpPr>
+        <p:spPr>
+          <a:xfrm>
+            <a:off x="768096" y="1792224"/>
+            <a:ext cx="2170100" cy="475488"/>
           </a:xfrm>
           <a:prstGeom prst="rect">
             <a:avLst/>
@@ -3675,37 +4227,37 @@
           <a:ln/>
         </p:spPr>
         <p:txBody>
-          <a:bodyPr wrap="square" rtlCol="0" anchor="ctr"/>
+          <a:bodyPr wrap="square" rtlCol="0" anchor="t"/>
           <a:lstStyle/>
           <a:p>
             <a:pPr indent="0" marL="0">
               <a:buNone/>
             </a:pPr>
             <a:r>
-              <a:rPr lang="en-US" sz="1500" b="1" dirty="0">
-                <a:solidFill>
-                  <a:srgbClr val="15803D"/>
-                </a:solidFill>
-                <a:latin typeface="Segoe UI" pitchFamily="34" charset="0"/>
-                <a:ea typeface="Segoe UI" pitchFamily="34" charset="-122"/>
-                <a:cs typeface="Segoe UI" pitchFamily="34" charset="-120"/>
-              </a:rPr>
-              <a:t>The agent does the work</a:t>
-            </a:r>
-            <a:endParaRPr lang="en-US" sz="1500" dirty="0"/>
-          </a:p>
-        </p:txBody>
-      </p:sp>
-      <p:sp>
-        <p:nvSpPr>
-          <p:cNvPr id="7" name="Text 5"/>
-          <p:cNvSpPr/>
-          <p:nvPr/>
-        </p:nvSpPr>
-        <p:spPr>
-          <a:xfrm>
-            <a:off x="786384" y="2231136"/>
-            <a:ext cx="4861408" cy="2651760"/>
+              <a:rPr lang="en-US" sz="1450" b="1" dirty="0">
+                <a:solidFill>
+                  <a:srgbClr val="1A1A1E"/>
+                </a:solidFill>
+                <a:latin typeface="Segoe UI" pitchFamily="34" charset="0"/>
+                <a:ea typeface="Segoe UI" pitchFamily="34" charset="-122"/>
+                <a:cs typeface="Segoe UI" pitchFamily="34" charset="-120"/>
+              </a:rPr>
+              <a:t>1. It reads everything at once</a:t>
+            </a:r>
+            <a:endParaRPr lang="en-US" sz="1450" dirty="0"/>
+          </a:p>
+        </p:txBody>
+      </p:sp>
+      <p:sp>
+        <p:nvSpPr>
+          <p:cNvPr id="8" name="Text 6"/>
+          <p:cNvSpPr/>
+          <p:nvPr/>
+        </p:nvSpPr>
+        <p:spPr>
+          <a:xfrm>
+            <a:off x="768096" y="2322576"/>
+            <a:ext cx="2170100" cy="731520"/>
           </a:xfrm>
           <a:prstGeom prst="rect">
             <a:avLst/>
@@ -3717,15 +4269,54 @@
           <a:bodyPr wrap="square" rtlCol="0" anchor="t"/>
           <a:lstStyle/>
           <a:p>
+            <a:pPr indent="0" marL="0">
+              <a:buNone/>
+            </a:pPr>
+            <a:r>
+              <a:rPr lang="en-US" sz="1200" i="1" dirty="0">
+                <a:solidFill>
+                  <a:srgbClr val="71717A"/>
+                </a:solidFill>
+                <a:latin typeface="Segoe UI" pitchFamily="34" charset="0"/>
+                <a:ea typeface="Segoe UI" pitchFamily="34" charset="-122"/>
+                <a:cs typeface="Segoe UI" pitchFamily="34" charset="-120"/>
+              </a:rPr>
+              <a:t>A person opens one file at a time.</a:t>
+            </a:r>
+            <a:endParaRPr lang="en-US" sz="1200" dirty="0"/>
+          </a:p>
+        </p:txBody>
+      </p:sp>
+      <p:sp>
+        <p:nvSpPr>
+          <p:cNvPr id="9" name="Text 7"/>
+          <p:cNvSpPr/>
+          <p:nvPr/>
+        </p:nvSpPr>
+        <p:spPr>
+          <a:xfrm>
+            <a:off x="768096" y="3090672"/>
+            <a:ext cx="2170100" cy="2103120"/>
+          </a:xfrm>
+          <a:prstGeom prst="rect">
+            <a:avLst/>
+          </a:prstGeom>
+          <a:noFill/>
+          <a:ln/>
+        </p:spPr>
+        <p:txBody>
+          <a:bodyPr wrap="square" rtlCol="0" anchor="t"/>
+          <a:lstStyle/>
+          <a:p>
             <a:pPr marL="342900" indent="-342900">
               <a:spcAft>
-                <a:spcPts val="700"/>
+                <a:spcPts val="600"/>
               </a:spcAft>
               <a:buSzPct val="100000"/>
               <a:buChar char="•"/>
             </a:pPr>
             <a:r>
-              <a:rPr lang="en-US" sz="1300" dirty="0">
+              <a:rPr lang="en-US" sz="1200" dirty="0">
                 <a:solidFill>
                   <a:srgbClr val="3F3F46"/>
                 </a:solidFill>
@@ -3733,20 +4324,20 @@
                 <a:ea typeface="Segoe UI" pitchFamily="34" charset="-122"/>
                 <a:cs typeface="Segoe UI" pitchFamily="34" charset="-120"/>
               </a:rPr>
-              <a:t>Writes the tests</a:t>
-            </a:r>
-            <a:endParaRPr lang="en-US" sz="1300" dirty="0"/>
+              <a:t>To write a test you must know what every box on the screen is called</a:t>
+            </a:r>
+            <a:endParaRPr lang="en-US" sz="1200" dirty="0"/>
           </a:p>
           <a:p>
             <a:pPr marL="342900" indent="-342900">
               <a:spcAft>
-                <a:spcPts val="700"/>
+                <a:spcPts val="600"/>
               </a:spcAft>
               <a:buSzPct val="100000"/>
               <a:buChar char="•"/>
             </a:pPr>
             <a:r>
-              <a:rPr lang="en-US" sz="1300" dirty="0">
+              <a:rPr lang="en-US" sz="1200" dirty="0">
                 <a:solidFill>
                   <a:srgbClr val="3F3F46"/>
                 </a:solidFill>
@@ -3754,20 +4345,20 @@
                 <a:ea typeface="Segoe UI" pitchFamily="34" charset="-122"/>
                 <a:cs typeface="Segoe UI" pitchFamily="34" charset="-120"/>
               </a:rPr>
-              <a:t>Runs them and reads what failed</a:t>
-            </a:r>
-            <a:endParaRPr lang="en-US" sz="1300" dirty="0"/>
+              <a:t>A person clicks around and guesses, or digs through the code</a:t>
+            </a:r>
+            <a:endParaRPr lang="en-US" sz="1200" dirty="0"/>
           </a:p>
           <a:p>
             <a:pPr marL="342900" indent="-342900">
               <a:spcAft>
-                <a:spcPts val="700"/>
+                <a:spcPts val="600"/>
               </a:spcAft>
               <a:buSzPct val="100000"/>
               <a:buChar char="•"/>
             </a:pPr>
             <a:r>
-              <a:rPr lang="en-US" sz="1300" dirty="0">
+              <a:rPr lang="en-US" sz="1200" dirty="0">
                 <a:solidFill>
                   <a:srgbClr val="3F3F46"/>
                 </a:solidFill>
@@ -3775,47 +4366,26 @@
                 <a:ea typeface="Segoe UI" pitchFamily="34" charset="-122"/>
                 <a:cs typeface="Segoe UI" pitchFamily="34" charset="-120"/>
               </a:rPr>
-              <a:t>Fixes and runs again until they pass</a:t>
-            </a:r>
-            <a:endParaRPr lang="en-US" sz="1300" dirty="0"/>
-          </a:p>
-          <a:p>
-            <a:pPr marL="342900" indent="-342900">
-              <a:spcAft>
-                <a:spcPts val="700"/>
-              </a:spcAft>
-              <a:buSzPct val="100000"/>
-              <a:buChar char="•"/>
-            </a:pPr>
-            <a:r>
-              <a:rPr lang="en-US" sz="1300" dirty="0">
-                <a:solidFill>
-                  <a:srgbClr val="3F3F46"/>
-                </a:solidFill>
-                <a:latin typeface="Segoe UI" pitchFamily="34" charset="0"/>
-                <a:ea typeface="Segoe UI" pitchFamily="34" charset="-122"/>
-                <a:cs typeface="Segoe UI" pitchFamily="34" charset="-120"/>
-              </a:rPr>
-              <a:t>Writes down what it learned</a:t>
-            </a:r>
-            <a:endParaRPr lang="en-US" sz="1300" dirty="0"/>
-          </a:p>
-        </p:txBody>
-      </p:sp>
-      <p:sp>
-        <p:nvSpPr>
-          <p:cNvPr id="8" name="Shape 6"/>
-          <p:cNvSpPr/>
-          <p:nvPr/>
-        </p:nvSpPr>
-        <p:spPr>
-          <a:xfrm>
-            <a:off x="6324448" y="1627632"/>
-            <a:ext cx="5300320" cy="3474720"/>
+              <a:t>The agent read the pages behind those screens and took the names straight from them</a:t>
+            </a:r>
+            <a:endParaRPr lang="en-US" sz="1200" dirty="0"/>
+          </a:p>
+        </p:txBody>
+      </p:sp>
+      <p:sp>
+        <p:nvSpPr>
+          <p:cNvPr id="10" name="Shape 8"/>
+          <p:cNvSpPr/>
+          <p:nvPr/>
+        </p:nvSpPr>
+        <p:spPr>
+          <a:xfrm>
+            <a:off x="3395396" y="1627632"/>
+            <a:ext cx="2572436" cy="3703320"/>
           </a:xfrm>
           <a:prstGeom prst="roundRect">
             <a:avLst>
-              <a:gd name="adj" fmla="val 2105"/>
+              <a:gd name="adj" fmla="val 2844"/>
             </a:avLst>
           </a:prstGeom>
           <a:solidFill>
@@ -3831,14 +4401,39 @@
       </p:sp>
       <p:sp>
         <p:nvSpPr>
-          <p:cNvPr id="9" name="Text 7"/>
-          <p:cNvSpPr/>
-          <p:nvPr/>
-        </p:nvSpPr>
-        <p:spPr>
-          <a:xfrm>
-            <a:off x="6543904" y="1810512"/>
-            <a:ext cx="4861408" cy="365760"/>
+          <p:cNvPr id="11" name="Shape 9"/>
+          <p:cNvSpPr/>
+          <p:nvPr/>
+        </p:nvSpPr>
+        <p:spPr>
+          <a:xfrm>
+            <a:off x="3395396" y="1627632"/>
+            <a:ext cx="2572436" cy="54864"/>
+          </a:xfrm>
+          <a:prstGeom prst="rect">
+            <a:avLst/>
+          </a:prstGeom>
+          <a:solidFill>
+            <a:srgbClr val="15803D"/>
+          </a:solidFill>
+          <a:ln w="12700">
+            <a:solidFill>
+              <a:srgbClr val="15803D"/>
+            </a:solidFill>
+            <a:prstDash val="solid"/>
+          </a:ln>
+        </p:spPr>
+      </p:sp>
+      <p:sp>
+        <p:nvSpPr>
+          <p:cNvPr id="12" name="Text 10"/>
+          <p:cNvSpPr/>
+          <p:nvPr/>
+        </p:nvSpPr>
+        <p:spPr>
+          <a:xfrm>
+            <a:off x="3596564" y="1792224"/>
+            <a:ext cx="2170100" cy="475488"/>
           </a:xfrm>
           <a:prstGeom prst="rect">
             <a:avLst/>
@@ -3847,37 +4442,37 @@
           <a:ln/>
         </p:spPr>
         <p:txBody>
-          <a:bodyPr wrap="square" rtlCol="0" anchor="ctr"/>
+          <a:bodyPr wrap="square" rtlCol="0" anchor="t"/>
           <a:lstStyle/>
           <a:p>
             <a:pPr indent="0" marL="0">
               <a:buNone/>
             </a:pPr>
             <a:r>
-              <a:rPr lang="en-US" sz="1500" b="1" dirty="0">
-                <a:solidFill>
-                  <a:srgbClr val="0B5FA5"/>
-                </a:solidFill>
-                <a:latin typeface="Segoe UI" pitchFamily="34" charset="0"/>
-                <a:ea typeface="Segoe UI" pitchFamily="34" charset="-122"/>
-                <a:cs typeface="Segoe UI" pitchFamily="34" charset="-120"/>
-              </a:rPr>
-              <a:t>We still decide</a:t>
-            </a:r>
-            <a:endParaRPr lang="en-US" sz="1500" dirty="0"/>
-          </a:p>
-        </p:txBody>
-      </p:sp>
-      <p:sp>
-        <p:nvSpPr>
-          <p:cNvPr id="10" name="Text 8"/>
-          <p:cNvSpPr/>
-          <p:nvPr/>
-        </p:nvSpPr>
-        <p:spPr>
-          <a:xfrm>
-            <a:off x="6543904" y="2231136"/>
-            <a:ext cx="4861408" cy="2651760"/>
+              <a:rPr lang="en-US" sz="1450" b="1" dirty="0">
+                <a:solidFill>
+                  <a:srgbClr val="1A1A1E"/>
+                </a:solidFill>
+                <a:latin typeface="Segoe UI" pitchFamily="34" charset="0"/>
+                <a:ea typeface="Segoe UI" pitchFamily="34" charset="-122"/>
+                <a:cs typeface="Segoe UI" pitchFamily="34" charset="-120"/>
+              </a:rPr>
+              <a:t>2. It never loses the thread</a:t>
+            </a:r>
+            <a:endParaRPr lang="en-US" sz="1450" dirty="0"/>
+          </a:p>
+        </p:txBody>
+      </p:sp>
+      <p:sp>
+        <p:nvSpPr>
+          <p:cNvPr id="13" name="Text 11"/>
+          <p:cNvSpPr/>
+          <p:nvPr/>
+        </p:nvSpPr>
+        <p:spPr>
+          <a:xfrm>
+            <a:off x="3596564" y="2322576"/>
+            <a:ext cx="2170100" cy="731520"/>
           </a:xfrm>
           <a:prstGeom prst="rect">
             <a:avLst/>
@@ -3889,15 +4484,54 @@
           <a:bodyPr wrap="square" rtlCol="0" anchor="t"/>
           <a:lstStyle/>
           <a:p>
+            <a:pPr indent="0" marL="0">
+              <a:buNone/>
+            </a:pPr>
+            <a:r>
+              <a:rPr lang="en-US" sz="1200" i="1" dirty="0">
+                <a:solidFill>
+                  <a:srgbClr val="71717A"/>
+                </a:solidFill>
+                <a:latin typeface="Segoe UI" pitchFamily="34" charset="0"/>
+                <a:ea typeface="Segoe UI" pitchFamily="34" charset="-122"/>
+                <a:cs typeface="Segoe UI" pitchFamily="34" charset="-120"/>
+              </a:rPr>
+              <a:t>No meetings, no interruptions, no tomorrow.</a:t>
+            </a:r>
+            <a:endParaRPr lang="en-US" sz="1200" dirty="0"/>
+          </a:p>
+        </p:txBody>
+      </p:sp>
+      <p:sp>
+        <p:nvSpPr>
+          <p:cNvPr id="14" name="Text 12"/>
+          <p:cNvSpPr/>
+          <p:nvPr/>
+        </p:nvSpPr>
+        <p:spPr>
+          <a:xfrm>
+            <a:off x="3596564" y="3090672"/>
+            <a:ext cx="2170100" cy="2103120"/>
+          </a:xfrm>
+          <a:prstGeom prst="rect">
+            <a:avLst/>
+          </a:prstGeom>
+          <a:noFill/>
+          <a:ln/>
+        </p:spPr>
+        <p:txBody>
+          <a:bodyPr wrap="square" rtlCol="0" anchor="t"/>
+          <a:lstStyle/>
+          <a:p>
             <a:pPr marL="342900" indent="-342900">
               <a:spcAft>
-                <a:spcPts val="700"/>
+                <a:spcPts val="600"/>
               </a:spcAft>
               <a:buSzPct val="100000"/>
               <a:buChar char="•"/>
             </a:pPr>
             <a:r>
-              <a:rPr lang="en-US" sz="1300" dirty="0">
+              <a:rPr lang="en-US" sz="1200" dirty="0">
                 <a:solidFill>
                   <a:srgbClr val="3F3F46"/>
                 </a:solidFill>
@@ -3905,20 +4539,20 @@
                 <a:ea typeface="Segoe UI" pitchFamily="34" charset="-122"/>
                 <a:cs typeface="Segoe UI" pitchFamily="34" charset="-120"/>
               </a:rPr>
-              <a:t>Which journeys are worth automating</a:t>
-            </a:r>
-            <a:endParaRPr lang="en-US" sz="1300" dirty="0"/>
+              <a:t>Work like this is normally spread across days, and half of each day is spent remembering where you were</a:t>
+            </a:r>
+            <a:endParaRPr lang="en-US" sz="1200" dirty="0"/>
           </a:p>
           <a:p>
             <a:pPr marL="342900" indent="-342900">
               <a:spcAft>
-                <a:spcPts val="700"/>
+                <a:spcPts val="600"/>
               </a:spcAft>
               <a:buSzPct val="100000"/>
               <a:buChar char="•"/>
             </a:pPr>
             <a:r>
-              <a:rPr lang="en-US" sz="1300" dirty="0">
+              <a:rPr lang="en-US" sz="1200" dirty="0">
                 <a:solidFill>
                   <a:srgbClr val="3F3F46"/>
                 </a:solidFill>
@@ -3926,20 +4560,172 @@
                 <a:ea typeface="Segoe UI" pitchFamily="34" charset="-122"/>
                 <a:cs typeface="Segoe UI" pitchFamily="34" charset="-120"/>
               </a:rPr>
-              <a:t>Whether a failure is a test problem or a real bug</a:t>
-            </a:r>
-            <a:endParaRPr lang="en-US" sz="1300" dirty="0"/>
-          </a:p>
+              <a:t>The whole suite was built in one unbroken sitting</a:t>
+            </a:r>
+            <a:endParaRPr lang="en-US" sz="1200" dirty="0"/>
+          </a:p>
+        </p:txBody>
+      </p:sp>
+      <p:sp>
+        <p:nvSpPr>
+          <p:cNvPr id="15" name="Shape 13"/>
+          <p:cNvSpPr/>
+          <p:nvPr/>
+        </p:nvSpPr>
+        <p:spPr>
+          <a:xfrm>
+            <a:off x="6223864" y="1627632"/>
+            <a:ext cx="2572436" cy="3703320"/>
+          </a:xfrm>
+          <a:prstGeom prst="roundRect">
+            <a:avLst>
+              <a:gd name="adj" fmla="val 2844"/>
+            </a:avLst>
+          </a:prstGeom>
+          <a:solidFill>
+            <a:srgbClr val="F6F7F9"/>
+          </a:solidFill>
+          <a:ln w="12700">
+            <a:solidFill>
+              <a:srgbClr val="D9D9DE"/>
+            </a:solidFill>
+            <a:prstDash val="solid"/>
+          </a:ln>
+        </p:spPr>
+      </p:sp>
+      <p:sp>
+        <p:nvSpPr>
+          <p:cNvPr id="16" name="Shape 14"/>
+          <p:cNvSpPr/>
+          <p:nvPr/>
+        </p:nvSpPr>
+        <p:spPr>
+          <a:xfrm>
+            <a:off x="6223864" y="1627632"/>
+            <a:ext cx="2572436" cy="54864"/>
+          </a:xfrm>
+          <a:prstGeom prst="rect">
+            <a:avLst/>
+          </a:prstGeom>
+          <a:solidFill>
+            <a:srgbClr val="B45309"/>
+          </a:solidFill>
+          <a:ln w="12700">
+            <a:solidFill>
+              <a:srgbClr val="B45309"/>
+            </a:solidFill>
+            <a:prstDash val="solid"/>
+          </a:ln>
+        </p:spPr>
+      </p:sp>
+      <p:sp>
+        <p:nvSpPr>
+          <p:cNvPr id="17" name="Text 15"/>
+          <p:cNvSpPr/>
+          <p:nvPr/>
+        </p:nvSpPr>
+        <p:spPr>
+          <a:xfrm>
+            <a:off x="6425032" y="1792224"/>
+            <a:ext cx="2170100" cy="475488"/>
+          </a:xfrm>
+          <a:prstGeom prst="rect">
+            <a:avLst/>
+          </a:prstGeom>
+          <a:noFill/>
+          <a:ln/>
+        </p:spPr>
+        <p:txBody>
+          <a:bodyPr wrap="square" rtlCol="0" anchor="t"/>
+          <a:lstStyle/>
+          <a:p>
+            <a:pPr indent="0" marL="0">
+              <a:buNone/>
+            </a:pPr>
+            <a:r>
+              <a:rPr lang="en-US" sz="1450" b="1" dirty="0">
+                <a:solidFill>
+                  <a:srgbClr val="1A1A1E"/>
+                </a:solidFill>
+                <a:latin typeface="Segoe UI" pitchFamily="34" charset="0"/>
+                <a:ea typeface="Segoe UI" pitchFamily="34" charset="-122"/>
+                <a:cs typeface="Segoe UI" pitchFamily="34" charset="-120"/>
+              </a:rPr>
+              <a:t>3. Run, fix, run again - in seconds</a:t>
+            </a:r>
+            <a:endParaRPr lang="en-US" sz="1450" dirty="0"/>
+          </a:p>
+        </p:txBody>
+      </p:sp>
+      <p:sp>
+        <p:nvSpPr>
+          <p:cNvPr id="18" name="Text 16"/>
+          <p:cNvSpPr/>
+          <p:nvPr/>
+        </p:nvSpPr>
+        <p:spPr>
+          <a:xfrm>
+            <a:off x="6425032" y="2322576"/>
+            <a:ext cx="2170100" cy="731520"/>
+          </a:xfrm>
+          <a:prstGeom prst="rect">
+            <a:avLst/>
+          </a:prstGeom>
+          <a:noFill/>
+          <a:ln/>
+        </p:spPr>
+        <p:txBody>
+          <a:bodyPr wrap="square" rtlCol="0" anchor="t"/>
+          <a:lstStyle/>
+          <a:p>
+            <a:pPr indent="0" marL="0">
+              <a:buNone/>
+            </a:pPr>
+            <a:r>
+              <a:rPr lang="en-US" sz="1200" i="1" dirty="0">
+                <a:solidFill>
+                  <a:srgbClr val="71717A"/>
+                </a:solidFill>
+                <a:latin typeface="Segoe UI" pitchFamily="34" charset="0"/>
+                <a:ea typeface="Segoe UI" pitchFamily="34" charset="-122"/>
+                <a:cs typeface="Segoe UI" pitchFamily="34" charset="-120"/>
+              </a:rPr>
+              <a:t>The loop is the slow part, not the typing.</a:t>
+            </a:r>
+            <a:endParaRPr lang="en-US" sz="1200" dirty="0"/>
+          </a:p>
+        </p:txBody>
+      </p:sp>
+      <p:sp>
+        <p:nvSpPr>
+          <p:cNvPr id="19" name="Text 17"/>
+          <p:cNvSpPr/>
+          <p:nvPr/>
+        </p:nvSpPr>
+        <p:spPr>
+          <a:xfrm>
+            <a:off x="6425032" y="3090672"/>
+            <a:ext cx="2170100" cy="2103120"/>
+          </a:xfrm>
+          <a:prstGeom prst="rect">
+            <a:avLst/>
+          </a:prstGeom>
+          <a:noFill/>
+          <a:ln/>
+        </p:spPr>
+        <p:txBody>
+          <a:bodyPr wrap="square" rtlCol="0" anchor="t"/>
+          <a:lstStyle/>
           <a:p>
             <a:pPr marL="342900" indent="-342900">
               <a:spcAft>
-                <a:spcPts val="700"/>
+                <a:spcPts val="600"/>
               </a:spcAft>
               <a:buSzPct val="100000"/>
               <a:buChar char="•"/>
             </a:pPr>
             <a:r>
-              <a:rPr lang="en-US" sz="1300" dirty="0">
+              <a:rPr lang="en-US" sz="1200" dirty="0">
                 <a:solidFill>
                   <a:srgbClr val="3F3F46"/>
                 </a:solidFill>
@@ -3947,20 +4733,20 @@
                 <a:ea typeface="Segoe UI" pitchFamily="34" charset="-122"/>
                 <a:cs typeface="Segoe UI" pitchFamily="34" charset="-120"/>
               </a:rPr>
-              <a:t>What may touch production, and what may never</a:t>
-            </a:r>
-            <a:endParaRPr lang="en-US" sz="1300" dirty="0"/>
+              <a:t>A test fails, you read why, you fix it, you run it again - dozens of times</a:t>
+            </a:r>
+            <a:endParaRPr lang="en-US" sz="1200" dirty="0"/>
           </a:p>
           <a:p>
             <a:pPr marL="342900" indent="-342900">
               <a:spcAft>
-                <a:spcPts val="700"/>
+                <a:spcPts val="600"/>
               </a:spcAft>
               <a:buSzPct val="100000"/>
               <a:buChar char="•"/>
             </a:pPr>
             <a:r>
-              <a:rPr lang="en-US" sz="1300" dirty="0">
+              <a:rPr lang="en-US" sz="1200" dirty="0">
                 <a:solidFill>
                   <a:srgbClr val="3F3F46"/>
                 </a:solidFill>
@@ -3968,22 +4754,74 @@
                 <a:ea typeface="Segoe UI" pitchFamily="34" charset="-122"/>
                 <a:cs typeface="Segoe UI" pitchFamily="34" charset="-120"/>
               </a:rPr>
-              <a:t>Nothing merges without a review - same bar as any code</a:t>
-            </a:r>
-            <a:endParaRPr lang="en-US" sz="1300" dirty="0"/>
-          </a:p>
-        </p:txBody>
-      </p:sp>
-      <p:sp>
-        <p:nvSpPr>
-          <p:cNvPr id="11" name="Text 9"/>
-          <p:cNvSpPr/>
-          <p:nvPr/>
-        </p:nvSpPr>
-        <p:spPr>
-          <a:xfrm>
-            <a:off x="566928" y="5760720"/>
-            <a:ext cx="11057839" cy="365760"/>
+              <a:t>For a person each turn of that loop is minutes; here it is seconds, and it never gets bored of repeating it</a:t>
+            </a:r>
+            <a:endParaRPr lang="en-US" sz="1200" dirty="0"/>
+          </a:p>
+        </p:txBody>
+      </p:sp>
+      <p:sp>
+        <p:nvSpPr>
+          <p:cNvPr id="20" name="Shape 18"/>
+          <p:cNvSpPr/>
+          <p:nvPr/>
+        </p:nvSpPr>
+        <p:spPr>
+          <a:xfrm>
+            <a:off x="9052331" y="1627632"/>
+            <a:ext cx="2572436" cy="3703320"/>
+          </a:xfrm>
+          <a:prstGeom prst="roundRect">
+            <a:avLst>
+              <a:gd name="adj" fmla="val 2844"/>
+            </a:avLst>
+          </a:prstGeom>
+          <a:solidFill>
+            <a:srgbClr val="F6F7F9"/>
+          </a:solidFill>
+          <a:ln w="12700">
+            <a:solidFill>
+              <a:srgbClr val="D9D9DE"/>
+            </a:solidFill>
+            <a:prstDash val="solid"/>
+          </a:ln>
+        </p:spPr>
+      </p:sp>
+      <p:sp>
+        <p:nvSpPr>
+          <p:cNvPr id="21" name="Shape 19"/>
+          <p:cNvSpPr/>
+          <p:nvPr/>
+        </p:nvSpPr>
+        <p:spPr>
+          <a:xfrm>
+            <a:off x="9052331" y="1627632"/>
+            <a:ext cx="2572436" cy="54864"/>
+          </a:xfrm>
+          <a:prstGeom prst="rect">
+            <a:avLst/>
+          </a:prstGeom>
+          <a:solidFill>
+            <a:srgbClr val="0B5FA5"/>
+          </a:solidFill>
+          <a:ln w="12700">
+            <a:solidFill>
+              <a:srgbClr val="0B5FA5"/>
+            </a:solidFill>
+            <a:prstDash val="solid"/>
+          </a:ln>
+        </p:spPr>
+      </p:sp>
+      <p:sp>
+        <p:nvSpPr>
+          <p:cNvPr id="22" name="Text 20"/>
+          <p:cNvSpPr/>
+          <p:nvPr/>
+        </p:nvSpPr>
+        <p:spPr>
+          <a:xfrm>
+            <a:off x="9253499" y="1792224"/>
+            <a:ext cx="2170100" cy="475488"/>
           </a:xfrm>
           <a:prstGeom prst="rect">
             <a:avLst/>
@@ -3992,6 +4830,200 @@
           <a:ln/>
         </p:spPr>
         <p:txBody>
+          <a:bodyPr wrap="square" rtlCol="0" anchor="t"/>
+          <a:lstStyle/>
+          <a:p>
+            <a:pPr indent="0" marL="0">
+              <a:buNone/>
+            </a:pPr>
+            <a:r>
+              <a:rPr lang="en-US" sz="1450" b="1" dirty="0">
+                <a:solidFill>
+                  <a:srgbClr val="1A1A1E"/>
+                </a:solidFill>
+                <a:latin typeface="Segoe UI" pitchFamily="34" charset="0"/>
+                <a:ea typeface="Segoe UI" pitchFamily="34" charset="-122"/>
+                <a:cs typeface="Segoe UI" pitchFamily="34" charset="-120"/>
+              </a:rPr>
+              <a:t>4. It writes it down as it goes</a:t>
+            </a:r>
+            <a:endParaRPr lang="en-US" sz="1450" dirty="0"/>
+          </a:p>
+        </p:txBody>
+      </p:sp>
+      <p:sp>
+        <p:nvSpPr>
+          <p:cNvPr id="23" name="Text 21"/>
+          <p:cNvSpPr/>
+          <p:nvPr/>
+        </p:nvSpPr>
+        <p:spPr>
+          <a:xfrm>
+            <a:off x="9253499" y="2322576"/>
+            <a:ext cx="2170100" cy="731520"/>
+          </a:xfrm>
+          <a:prstGeom prst="rect">
+            <a:avLst/>
+          </a:prstGeom>
+          <a:noFill/>
+          <a:ln/>
+        </p:spPr>
+        <p:txBody>
+          <a:bodyPr wrap="square" rtlCol="0" anchor="t"/>
+          <a:lstStyle/>
+          <a:p>
+            <a:pPr indent="0" marL="0">
+              <a:buNone/>
+            </a:pPr>
+            <a:r>
+              <a:rPr lang="en-US" sz="1200" i="1" dirty="0">
+                <a:solidFill>
+                  <a:srgbClr val="71717A"/>
+                </a:solidFill>
+                <a:latin typeface="Segoe UI" pitchFamily="34" charset="0"/>
+                <a:ea typeface="Segoe UI" pitchFamily="34" charset="-122"/>
+                <a:cs typeface="Segoe UI" pitchFamily="34" charset="-120"/>
+              </a:rPr>
+              <a:t>Normally the last job, usually skipped.</a:t>
+            </a:r>
+            <a:endParaRPr lang="en-US" sz="1200" dirty="0"/>
+          </a:p>
+        </p:txBody>
+      </p:sp>
+      <p:sp>
+        <p:nvSpPr>
+          <p:cNvPr id="24" name="Text 22"/>
+          <p:cNvSpPr/>
+          <p:nvPr/>
+        </p:nvSpPr>
+        <p:spPr>
+          <a:xfrm>
+            <a:off x="9253499" y="3090672"/>
+            <a:ext cx="2170100" cy="2103120"/>
+          </a:xfrm>
+          <a:prstGeom prst="rect">
+            <a:avLst/>
+          </a:prstGeom>
+          <a:noFill/>
+          <a:ln/>
+        </p:spPr>
+        <p:txBody>
+          <a:bodyPr wrap="square" rtlCol="0" anchor="t"/>
+          <a:lstStyle/>
+          <a:p>
+            <a:pPr marL="342900" indent="-342900">
+              <a:spcAft>
+                <a:spcPts val="600"/>
+              </a:spcAft>
+              <a:buSzPct val="100000"/>
+              <a:buChar char="•"/>
+            </a:pPr>
+            <a:r>
+              <a:rPr lang="en-US" sz="1200" dirty="0">
+                <a:solidFill>
+                  <a:srgbClr val="3F3F46"/>
+                </a:solidFill>
+                <a:latin typeface="Segoe UI" pitchFamily="34" charset="0"/>
+                <a:ea typeface="Segoe UI" pitchFamily="34" charset="-122"/>
+                <a:cs typeface="Segoe UI" pitchFamily="34" charset="-120"/>
+              </a:rPr>
+              <a:t>Every reason, gotcha and dead end went into the README while it was still fresh</a:t>
+            </a:r>
+            <a:endParaRPr lang="en-US" sz="1200" dirty="0"/>
+          </a:p>
+          <a:p>
+            <a:pPr marL="342900" indent="-342900">
+              <a:spcAft>
+                <a:spcPts val="600"/>
+              </a:spcAft>
+              <a:buSzPct val="100000"/>
+              <a:buChar char="•"/>
+            </a:pPr>
+            <a:r>
+              <a:rPr lang="en-US" sz="1200" dirty="0">
+                <a:solidFill>
+                  <a:srgbClr val="3F3F46"/>
+                </a:solidFill>
+                <a:latin typeface="Segoe UI" pitchFamily="34" charset="0"/>
+                <a:ea typeface="Segoe UI" pitchFamily="34" charset="-122"/>
+                <a:cs typeface="Segoe UI" pitchFamily="34" charset="-120"/>
+              </a:rPr>
+              <a:t>That is the part that usually never happens, and the reason the next person starts from zero</a:t>
+            </a:r>
+            <a:endParaRPr lang="en-US" sz="1200" dirty="0"/>
+          </a:p>
+        </p:txBody>
+      </p:sp>
+      <p:sp>
+        <p:nvSpPr>
+          <p:cNvPr id="25" name="Shape 23"/>
+          <p:cNvSpPr/>
+          <p:nvPr/>
+        </p:nvSpPr>
+        <p:spPr>
+          <a:xfrm>
+            <a:off x="566928" y="5559552"/>
+            <a:ext cx="11057839" cy="685800"/>
+          </a:xfrm>
+          <a:prstGeom prst="roundRect">
+            <a:avLst>
+              <a:gd name="adj" fmla="val 8000"/>
+            </a:avLst>
+          </a:prstGeom>
+          <a:solidFill>
+            <a:srgbClr val="FDF6E7"/>
+          </a:solidFill>
+          <a:ln w="12700">
+            <a:solidFill>
+              <a:srgbClr val="EBD9AE"/>
+            </a:solidFill>
+            <a:prstDash val="solid"/>
+          </a:ln>
+        </p:spPr>
+      </p:sp>
+      <p:sp>
+        <p:nvSpPr>
+          <p:cNvPr id="26" name="Shape 24"/>
+          <p:cNvSpPr/>
+          <p:nvPr/>
+        </p:nvSpPr>
+        <p:spPr>
+          <a:xfrm>
+            <a:off x="566928" y="5559552"/>
+            <a:ext cx="64008" cy="685800"/>
+          </a:xfrm>
+          <a:prstGeom prst="rect">
+            <a:avLst/>
+          </a:prstGeom>
+          <a:solidFill>
+            <a:srgbClr val="B45309"/>
+          </a:solidFill>
+          <a:ln w="12700">
+            <a:solidFill>
+              <a:srgbClr val="B45309"/>
+            </a:solidFill>
+            <a:prstDash val="solid"/>
+          </a:ln>
+        </p:spPr>
+      </p:sp>
+      <p:sp>
+        <p:nvSpPr>
+          <p:cNvPr id="27" name="Text 25"/>
+          <p:cNvSpPr/>
+          <p:nvPr/>
+        </p:nvSpPr>
+        <p:spPr>
+          <a:xfrm>
+            <a:off x="822960" y="5559552"/>
+            <a:ext cx="10600639" cy="685800"/>
+          </a:xfrm>
+          <a:prstGeom prst="rect">
+            <a:avLst/>
+          </a:prstGeom>
+          <a:noFill/>
+          <a:ln/>
+        </p:spPr>
+        <p:txBody>
           <a:bodyPr wrap="square" rtlCol="0" anchor="ctr"/>
           <a:lstStyle/>
           <a:p>
@@ -3999,17 +5031,17 @@
               <a:buNone/>
             </a:pPr>
             <a:r>
-              <a:rPr lang="en-US" sz="1300" i="1" dirty="0">
-                <a:solidFill>
-                  <a:srgbClr val="71717A"/>
-                </a:solidFill>
-                <a:latin typeface="Segoe UI" pitchFamily="34" charset="0"/>
-                <a:ea typeface="Segoe UI" pitchFamily="34" charset="-122"/>
-                <a:cs typeface="Segoe UI" pitchFamily="34" charset="-120"/>
-              </a:rPr>
-              <a:t>The workshop point: the cost of an automated check has dropped far enough that "we do not have time to automate it" is no longer the real constraint.</a:t>
-            </a:r>
-            <a:endParaRPr lang="en-US" sz="1300" dirty="0"/>
+              <a:rPr lang="en-US" sz="1350" dirty="0">
+                <a:solidFill>
+                  <a:srgbClr val="1A1A1E"/>
+                </a:solidFill>
+                <a:latin typeface="Segoe UI" pitchFamily="34" charset="0"/>
+                <a:ea typeface="Segoe UI" pitchFamily="34" charset="-122"/>
+                <a:cs typeface="Segoe UI" pitchFamily="34" charset="-120"/>
+              </a:rPr>
+              <a:t>Put simply: a person is fast at deciding what to test and slow at everything around it. The agent is the other way round - which is why the pair is quicker than either alone.</a:t>
+            </a:r>
+            <a:endParaRPr lang="en-US" sz="1350" dirty="0"/>
           </a:p>
         </p:txBody>
       </p:sp>
@@ -4078,7 +5110,7 @@
                 <a:ea typeface="Segoe UI" pitchFamily="34" charset="-122"/>
                 <a:cs typeface="Segoe UI" pitchFamily="34" charset="-120"/>
               </a:rPr>
-              <a:t>Running it in CI</a:t>
+              <a:t>Where the human time still goes</a:t>
             </a:r>
             <a:endParaRPr lang="en-US" sz="2600" dirty="0"/>
           </a:p>
@@ -4117,7 +5149,7 @@
                 <a:ea typeface="Segoe UI" pitchFamily="34" charset="-122"/>
                 <a:cs typeface="Segoe UI" pitchFamily="34" charset="-120"/>
               </a:rPr>
-              <a:t>The same command a developer runs is the command the pipeline runs</a:t>
+              <a:t>The agent is fast at the mechanical work; judgement stays with us</a:t>
             </a:r>
             <a:endParaRPr lang="en-US" sz="1400" dirty="0"/>
           </a:p>
@@ -4152,19 +5184,19 @@
         <p:spPr>
           <a:xfrm>
             <a:off x="566928" y="1627632"/>
-            <a:ext cx="11057839" cy="2011680"/>
+            <a:ext cx="5300320" cy="3474720"/>
           </a:xfrm>
           <a:prstGeom prst="roundRect">
             <a:avLst>
-              <a:gd name="adj" fmla="val 2727"/>
+              <a:gd name="adj" fmla="val 2105"/>
             </a:avLst>
           </a:prstGeom>
           <a:solidFill>
-            <a:srgbClr val="1E1E24"/>
+            <a:srgbClr val="F6F7F9"/>
           </a:solidFill>
           <a:ln w="12700">
             <a:solidFill>
-              <a:srgbClr val="1E1E24"/>
+              <a:srgbClr val="D9D9DE"/>
             </a:solidFill>
             <a:prstDash val="solid"/>
           </a:ln>
@@ -4178,8 +5210,8 @@
         </p:nvSpPr>
         <p:spPr>
           <a:xfrm>
-            <a:off x="768096" y="1773936"/>
-            <a:ext cx="10655503" cy="1719072"/>
+            <a:off x="786384" y="1810512"/>
+            <a:ext cx="4861408" cy="365760"/>
           </a:xfrm>
           <a:prstGeom prst="rect">
             <a:avLst/>
@@ -4188,116 +5220,24 @@
           <a:ln/>
         </p:spPr>
         <p:txBody>
-          <a:bodyPr wrap="square" rtlCol="0" anchor="t"/>
+          <a:bodyPr wrap="square" rtlCol="0" anchor="ctr"/>
           <a:lstStyle/>
           <a:p>
             <a:pPr indent="0" marL="0">
-              <a:lnSpc>
-                <a:spcPct val="112000"/>
-              </a:lnSpc>
-              <a:buNone/>
-            </a:pPr>
-            <a:r>
-              <a:rPr lang="en-US" sz="1150" dirty="0">
-                <a:solidFill>
-                  <a:srgbClr val="E8E8EC"/>
-                </a:solidFill>
-                <a:latin typeface="Consolas" pitchFamily="34" charset="0"/>
-                <a:ea typeface="Consolas" pitchFamily="34" charset="-122"/>
-                <a:cs typeface="Consolas" pitchFamily="34" charset="-120"/>
-              </a:rPr>
-              <a:t># any CI runner - CodeBuild, Bitbucket Pipelines, GitHub Actions</a:t>
-            </a:r>
-            <a:endParaRPr lang="en-US" sz="1150" dirty="0"/>
-          </a:p>
-          <a:p>
-            <a:pPr indent="0" marL="0">
-              <a:lnSpc>
-                <a:spcPct val="112000"/>
-              </a:lnSpc>
-              <a:buNone/>
-            </a:pPr>
-            <a:r>
-              <a:rPr lang="en-US" sz="1150" dirty="0">
-                <a:solidFill>
-                  <a:srgbClr val="E8E8EC"/>
-                </a:solidFill>
-                <a:latin typeface="Consolas" pitchFamily="34" charset="0"/>
-                <a:ea typeface="Consolas" pitchFamily="34" charset="-122"/>
-                <a:cs typeface="Consolas" pitchFamily="34" charset="-120"/>
-              </a:rPr>
-              <a:t>npm ci</a:t>
-            </a:r>
-            <a:endParaRPr lang="en-US" sz="1150" dirty="0"/>
-          </a:p>
-          <a:p>
-            <a:pPr indent="0" marL="0">
-              <a:lnSpc>
-                <a:spcPct val="112000"/>
-              </a:lnSpc>
-              <a:buNone/>
-            </a:pPr>
-            <a:r>
-              <a:rPr lang="en-US" sz="1150" dirty="0">
-                <a:solidFill>
-                  <a:srgbClr val="E8E8EC"/>
-                </a:solidFill>
-                <a:latin typeface="Consolas" pitchFamily="34" charset="0"/>
-                <a:ea typeface="Consolas" pitchFamily="34" charset="-122"/>
-                <a:cs typeface="Consolas" pitchFamily="34" charset="-120"/>
-              </a:rPr>
-              <a:t>npx playwright install --with-deps chromium</a:t>
-            </a:r>
-            <a:endParaRPr lang="en-US" sz="1150" dirty="0"/>
-          </a:p>
-          <a:p>
-            <a:pPr indent="0" marL="0">
-              <a:lnSpc>
-                <a:spcPct val="112000"/>
-              </a:lnSpc>
-              <a:buNone/>
-            </a:pPr>
-            <a:r>
-              <a:rPr lang="en-US" sz="1150" dirty="0">
-                <a:solidFill>
-                  <a:srgbClr val="E8E8EC"/>
-                </a:solidFill>
-                <a:latin typeface="Consolas" pitchFamily="34" charset="0"/>
-                <a:ea typeface="Consolas" pitchFamily="34" charset="-122"/>
-                <a:cs typeface="Consolas" pitchFamily="34" charset="-120"/>
-              </a:rPr>
-              <a:t>npm test                       # retries once on CI, serial, ~1 minute</a:t>
-            </a:r>
-            <a:endParaRPr lang="en-US" sz="1150" dirty="0"/>
-          </a:p>
-          <a:p>
-            <a:pPr indent="0" marL="0">
-              <a:lnSpc>
-                <a:spcPct val="112000"/>
-              </a:lnSpc>
-              <a:buNone/>
-            </a:pPr>
-            <a:endParaRPr lang="en-US" sz="1150" dirty="0"/>
-          </a:p>
-          <a:p>
-            <a:pPr indent="0" marL="0">
-              <a:lnSpc>
-                <a:spcPct val="112000"/>
-              </a:lnSpc>
-              <a:buNone/>
-            </a:pPr>
-            <a:r>
-              <a:rPr lang="en-US" sz="1150" dirty="0">
-                <a:solidFill>
-                  <a:srgbClr val="E8E8EC"/>
-                </a:solidFill>
-                <a:latin typeface="Consolas" pitchFamily="34" charset="0"/>
-                <a:ea typeface="Consolas" pitchFamily="34" charset="-122"/>
-                <a:cs typeface="Consolas" pitchFamily="34" charset="-120"/>
-              </a:rPr>
-              <a:t># artefacts to keep: playwright-report/  reports/junit.xml</a:t>
-            </a:r>
-            <a:endParaRPr lang="en-US" sz="1150" dirty="0"/>
+              <a:buNone/>
+            </a:pPr>
+            <a:r>
+              <a:rPr lang="en-US" sz="1500" b="1" dirty="0">
+                <a:solidFill>
+                  <a:srgbClr val="15803D"/>
+                </a:solidFill>
+                <a:latin typeface="Segoe UI" pitchFamily="34" charset="0"/>
+                <a:ea typeface="Segoe UI" pitchFamily="34" charset="-122"/>
+                <a:cs typeface="Segoe UI" pitchFamily="34" charset="-120"/>
+              </a:rPr>
+              <a:t>The agent does the work</a:t>
+            </a:r>
+            <a:endParaRPr lang="en-US" sz="1500" dirty="0"/>
           </a:p>
         </p:txBody>
       </p:sp>
@@ -4309,8 +5249,8 @@
         </p:nvSpPr>
         <p:spPr>
           <a:xfrm>
-            <a:off x="566928" y="3694176"/>
-            <a:ext cx="11057839" cy="274320"/>
+            <a:off x="786384" y="2231136"/>
+            <a:ext cx="4861408" cy="2651760"/>
           </a:xfrm>
           <a:prstGeom prst="rect">
             <a:avLst/>
@@ -4319,118 +5259,302 @@
           <a:ln/>
         </p:spPr>
         <p:txBody>
-          <a:bodyPr wrap="square" rtlCol="0" anchor="ctr"/>
-          <a:lstStyle/>
-          <a:p>
-            <a:pPr indent="0" marL="0">
-              <a:buNone/>
-            </a:pPr>
-            <a:r>
-              <a:rPr lang="en-US" sz="1100" i="1" dirty="0">
-                <a:solidFill>
-                  <a:srgbClr val="71717A"/>
-                </a:solidFill>
-                <a:latin typeface="Segoe UI" pitchFamily="34" charset="0"/>
-                <a:ea typeface="Segoe UI" pitchFamily="34" charset="-122"/>
-                <a:cs typeface="Segoe UI" pitchFamily="34" charset="-120"/>
-              </a:rPr>
-              <a:t>JUnit XML is what a CI dashboard reads; the HTML report is what a human opens.</a:t>
-            </a:r>
-            <a:endParaRPr lang="en-US" sz="1100" dirty="0"/>
-          </a:p>
-        </p:txBody>
-      </p:sp>
-      <p:sp>
-        <p:nvSpPr>
-          <p:cNvPr id="8" name="Text 6"/>
-          <p:cNvSpPr/>
-          <p:nvPr/>
-        </p:nvSpPr>
-        <p:spPr>
-          <a:xfrm>
-            <a:off x="566928" y="4142232"/>
-            <a:ext cx="11057839" cy="4023360"/>
-          </a:xfrm>
-          <a:prstGeom prst="rect">
-            <a:avLst/>
-          </a:prstGeom>
-          <a:noFill/>
-          <a:ln/>
-        </p:spPr>
-        <p:txBody>
           <a:bodyPr wrap="square" rtlCol="0" anchor="t"/>
           <a:lstStyle/>
           <a:p>
             <a:pPr marL="342900" indent="-342900">
-              <a:lnSpc>
-                <a:spcPct val="115000"/>
-              </a:lnSpc>
               <a:spcAft>
-                <a:spcPts val="1000"/>
+                <a:spcPts val="700"/>
               </a:spcAft>
               <a:buSzPct val="100000"/>
               <a:buChar char="•"/>
             </a:pPr>
             <a:r>
-              <a:rPr lang="en-US" sz="1450" dirty="0">
-                <a:solidFill>
-                  <a:srgbClr val="1A1A1E"/>
-                </a:solidFill>
-                <a:latin typeface="Segoe UI" pitchFamily="34" charset="0"/>
-                <a:ea typeface="Segoe UI" pitchFamily="34" charset="-122"/>
-                <a:cs typeface="Segoe UI" pitchFamily="34" charset="-120"/>
-              </a:rPr>
-              <a:t>Run on every pull request against the target branch, and nightly against UAT</a:t>
-            </a:r>
-            <a:endParaRPr lang="en-US" sz="1450" dirty="0"/>
+              <a:rPr lang="en-US" sz="1300" dirty="0">
+                <a:solidFill>
+                  <a:srgbClr val="3F3F46"/>
+                </a:solidFill>
+                <a:latin typeface="Segoe UI" pitchFamily="34" charset="0"/>
+                <a:ea typeface="Segoe UI" pitchFamily="34" charset="-122"/>
+                <a:cs typeface="Segoe UI" pitchFamily="34" charset="-120"/>
+              </a:rPr>
+              <a:t>Writes the tests</a:t>
+            </a:r>
+            <a:endParaRPr lang="en-US" sz="1300" dirty="0"/>
           </a:p>
           <a:p>
             <a:pPr marL="342900" indent="-342900">
-              <a:lnSpc>
-                <a:spcPct val="115000"/>
-              </a:lnSpc>
               <a:spcAft>
-                <a:spcPts val="1000"/>
+                <a:spcPts val="700"/>
               </a:spcAft>
               <a:buSzPct val="100000"/>
               <a:buChar char="•"/>
             </a:pPr>
             <a:r>
-              <a:rPr lang="en-US" sz="1450" dirty="0">
-                <a:solidFill>
-                  <a:srgbClr val="1A1A1E"/>
-                </a:solidFill>
-                <a:latin typeface="Segoe UI" pitchFamily="34" charset="0"/>
-                <a:ea typeface="Segoe UI" pitchFamily="34" charset="-122"/>
-                <a:cs typeface="Segoe UI" pitchFamily="34" charset="-120"/>
-              </a:rPr>
-              <a:t>A red suite blocks the merge - that is the whole point of the investment</a:t>
-            </a:r>
-            <a:endParaRPr lang="en-US" sz="1450" dirty="0"/>
+              <a:rPr lang="en-US" sz="1300" dirty="0">
+                <a:solidFill>
+                  <a:srgbClr val="3F3F46"/>
+                </a:solidFill>
+                <a:latin typeface="Segoe UI" pitchFamily="34" charset="0"/>
+                <a:ea typeface="Segoe UI" pitchFamily="34" charset="-122"/>
+                <a:cs typeface="Segoe UI" pitchFamily="34" charset="-120"/>
+              </a:rPr>
+              <a:t>Runs them and reads what failed</a:t>
+            </a:r>
+            <a:endParaRPr lang="en-US" sz="1300" dirty="0"/>
           </a:p>
           <a:p>
             <a:pPr marL="342900" indent="-342900">
-              <a:lnSpc>
-                <a:spcPct val="115000"/>
-              </a:lnSpc>
               <a:spcAft>
-                <a:spcPts val="1000"/>
+                <a:spcPts val="700"/>
               </a:spcAft>
               <a:buSzPct val="100000"/>
               <a:buChar char="•"/>
             </a:pPr>
             <a:r>
-              <a:rPr lang="en-US" sz="1450" dirty="0">
-                <a:solidFill>
-                  <a:srgbClr val="1A1A1E"/>
-                </a:solidFill>
-                <a:latin typeface="Segoe UI" pitchFamily="34" charset="0"/>
-                <a:ea typeface="Segoe UI" pitchFamily="34" charset="-122"/>
-                <a:cs typeface="Segoe UI" pitchFamily="34" charset="-120"/>
-              </a:rPr>
-              <a:t>Still to arrange: CI credentials and a stable non-production account that does not rotate</a:t>
-            </a:r>
-            <a:endParaRPr lang="en-US" sz="1450" dirty="0"/>
+              <a:rPr lang="en-US" sz="1300" dirty="0">
+                <a:solidFill>
+                  <a:srgbClr val="3F3F46"/>
+                </a:solidFill>
+                <a:latin typeface="Segoe UI" pitchFamily="34" charset="0"/>
+                <a:ea typeface="Segoe UI" pitchFamily="34" charset="-122"/>
+                <a:cs typeface="Segoe UI" pitchFamily="34" charset="-120"/>
+              </a:rPr>
+              <a:t>Fixes and runs again until they pass</a:t>
+            </a:r>
+            <a:endParaRPr lang="en-US" sz="1300" dirty="0"/>
+          </a:p>
+          <a:p>
+            <a:pPr marL="342900" indent="-342900">
+              <a:spcAft>
+                <a:spcPts val="700"/>
+              </a:spcAft>
+              <a:buSzPct val="100000"/>
+              <a:buChar char="•"/>
+            </a:pPr>
+            <a:r>
+              <a:rPr lang="en-US" sz="1300" dirty="0">
+                <a:solidFill>
+                  <a:srgbClr val="3F3F46"/>
+                </a:solidFill>
+                <a:latin typeface="Segoe UI" pitchFamily="34" charset="0"/>
+                <a:ea typeface="Segoe UI" pitchFamily="34" charset="-122"/>
+                <a:cs typeface="Segoe UI" pitchFamily="34" charset="-120"/>
+              </a:rPr>
+              <a:t>Writes down what it learned</a:t>
+            </a:r>
+            <a:endParaRPr lang="en-US" sz="1300" dirty="0"/>
+          </a:p>
+        </p:txBody>
+      </p:sp>
+      <p:sp>
+        <p:nvSpPr>
+          <p:cNvPr id="8" name="Shape 6"/>
+          <p:cNvSpPr/>
+          <p:nvPr/>
+        </p:nvSpPr>
+        <p:spPr>
+          <a:xfrm>
+            <a:off x="6324448" y="1627632"/>
+            <a:ext cx="5300320" cy="3474720"/>
+          </a:xfrm>
+          <a:prstGeom prst="roundRect">
+            <a:avLst>
+              <a:gd name="adj" fmla="val 2105"/>
+            </a:avLst>
+          </a:prstGeom>
+          <a:solidFill>
+            <a:srgbClr val="F6F7F9"/>
+          </a:solidFill>
+          <a:ln w="12700">
+            <a:solidFill>
+              <a:srgbClr val="D9D9DE"/>
+            </a:solidFill>
+            <a:prstDash val="solid"/>
+          </a:ln>
+        </p:spPr>
+      </p:sp>
+      <p:sp>
+        <p:nvSpPr>
+          <p:cNvPr id="9" name="Text 7"/>
+          <p:cNvSpPr/>
+          <p:nvPr/>
+        </p:nvSpPr>
+        <p:spPr>
+          <a:xfrm>
+            <a:off x="6543904" y="1810512"/>
+            <a:ext cx="4861408" cy="365760"/>
+          </a:xfrm>
+          <a:prstGeom prst="rect">
+            <a:avLst/>
+          </a:prstGeom>
+          <a:noFill/>
+          <a:ln/>
+        </p:spPr>
+        <p:txBody>
+          <a:bodyPr wrap="square" rtlCol="0" anchor="ctr"/>
+          <a:lstStyle/>
+          <a:p>
+            <a:pPr indent="0" marL="0">
+              <a:buNone/>
+            </a:pPr>
+            <a:r>
+              <a:rPr lang="en-US" sz="1500" b="1" dirty="0">
+                <a:solidFill>
+                  <a:srgbClr val="0B5FA5"/>
+                </a:solidFill>
+                <a:latin typeface="Segoe UI" pitchFamily="34" charset="0"/>
+                <a:ea typeface="Segoe UI" pitchFamily="34" charset="-122"/>
+                <a:cs typeface="Segoe UI" pitchFamily="34" charset="-120"/>
+              </a:rPr>
+              <a:t>We still decide</a:t>
+            </a:r>
+            <a:endParaRPr lang="en-US" sz="1500" dirty="0"/>
+          </a:p>
+        </p:txBody>
+      </p:sp>
+      <p:sp>
+        <p:nvSpPr>
+          <p:cNvPr id="10" name="Text 8"/>
+          <p:cNvSpPr/>
+          <p:nvPr/>
+        </p:nvSpPr>
+        <p:spPr>
+          <a:xfrm>
+            <a:off x="6543904" y="2231136"/>
+            <a:ext cx="4861408" cy="2651760"/>
+          </a:xfrm>
+          <a:prstGeom prst="rect">
+            <a:avLst/>
+          </a:prstGeom>
+          <a:noFill/>
+          <a:ln/>
+        </p:spPr>
+        <p:txBody>
+          <a:bodyPr wrap="square" rtlCol="0" anchor="t"/>
+          <a:lstStyle/>
+          <a:p>
+            <a:pPr marL="342900" indent="-342900">
+              <a:spcAft>
+                <a:spcPts val="700"/>
+              </a:spcAft>
+              <a:buSzPct val="100000"/>
+              <a:buChar char="•"/>
+            </a:pPr>
+            <a:r>
+              <a:rPr lang="en-US" sz="1300" dirty="0">
+                <a:solidFill>
+                  <a:srgbClr val="3F3F46"/>
+                </a:solidFill>
+                <a:latin typeface="Segoe UI" pitchFamily="34" charset="0"/>
+                <a:ea typeface="Segoe UI" pitchFamily="34" charset="-122"/>
+                <a:cs typeface="Segoe UI" pitchFamily="34" charset="-120"/>
+              </a:rPr>
+              <a:t>Which journeys are worth automating</a:t>
+            </a:r>
+            <a:endParaRPr lang="en-US" sz="1300" dirty="0"/>
+          </a:p>
+          <a:p>
+            <a:pPr marL="342900" indent="-342900">
+              <a:spcAft>
+                <a:spcPts val="700"/>
+              </a:spcAft>
+              <a:buSzPct val="100000"/>
+              <a:buChar char="•"/>
+            </a:pPr>
+            <a:r>
+              <a:rPr lang="en-US" sz="1300" dirty="0">
+                <a:solidFill>
+                  <a:srgbClr val="3F3F46"/>
+                </a:solidFill>
+                <a:latin typeface="Segoe UI" pitchFamily="34" charset="0"/>
+                <a:ea typeface="Segoe UI" pitchFamily="34" charset="-122"/>
+                <a:cs typeface="Segoe UI" pitchFamily="34" charset="-120"/>
+              </a:rPr>
+              <a:t>Whether a failure is a test problem or a real bug</a:t>
+            </a:r>
+            <a:endParaRPr lang="en-US" sz="1300" dirty="0"/>
+          </a:p>
+          <a:p>
+            <a:pPr marL="342900" indent="-342900">
+              <a:spcAft>
+                <a:spcPts val="700"/>
+              </a:spcAft>
+              <a:buSzPct val="100000"/>
+              <a:buChar char="•"/>
+            </a:pPr>
+            <a:r>
+              <a:rPr lang="en-US" sz="1300" dirty="0">
+                <a:solidFill>
+                  <a:srgbClr val="3F3F46"/>
+                </a:solidFill>
+                <a:latin typeface="Segoe UI" pitchFamily="34" charset="0"/>
+                <a:ea typeface="Segoe UI" pitchFamily="34" charset="-122"/>
+                <a:cs typeface="Segoe UI" pitchFamily="34" charset="-120"/>
+              </a:rPr>
+              <a:t>What may touch production, and what may never</a:t>
+            </a:r>
+            <a:endParaRPr lang="en-US" sz="1300" dirty="0"/>
+          </a:p>
+          <a:p>
+            <a:pPr marL="342900" indent="-342900">
+              <a:spcAft>
+                <a:spcPts val="700"/>
+              </a:spcAft>
+              <a:buSzPct val="100000"/>
+              <a:buChar char="•"/>
+            </a:pPr>
+            <a:r>
+              <a:rPr lang="en-US" sz="1300" dirty="0">
+                <a:solidFill>
+                  <a:srgbClr val="3F3F46"/>
+                </a:solidFill>
+                <a:latin typeface="Segoe UI" pitchFamily="34" charset="0"/>
+                <a:ea typeface="Segoe UI" pitchFamily="34" charset="-122"/>
+                <a:cs typeface="Segoe UI" pitchFamily="34" charset="-120"/>
+              </a:rPr>
+              <a:t>Nothing merges without a review - same bar as any code</a:t>
+            </a:r>
+            <a:endParaRPr lang="en-US" sz="1300" dirty="0"/>
+          </a:p>
+        </p:txBody>
+      </p:sp>
+      <p:sp>
+        <p:nvSpPr>
+          <p:cNvPr id="11" name="Text 9"/>
+          <p:cNvSpPr/>
+          <p:nvPr/>
+        </p:nvSpPr>
+        <p:spPr>
+          <a:xfrm>
+            <a:off x="566928" y="5760720"/>
+            <a:ext cx="11057839" cy="365760"/>
+          </a:xfrm>
+          <a:prstGeom prst="rect">
+            <a:avLst/>
+          </a:prstGeom>
+          <a:noFill/>
+          <a:ln/>
+        </p:spPr>
+        <p:txBody>
+          <a:bodyPr wrap="square" rtlCol="0" anchor="ctr"/>
+          <a:lstStyle/>
+          <a:p>
+            <a:pPr indent="0" marL="0">
+              <a:buNone/>
+            </a:pPr>
+            <a:r>
+              <a:rPr lang="en-US" sz="1300" i="1" dirty="0">
+                <a:solidFill>
+                  <a:srgbClr val="71717A"/>
+                </a:solidFill>
+                <a:latin typeface="Segoe UI" pitchFamily="34" charset="0"/>
+                <a:ea typeface="Segoe UI" pitchFamily="34" charset="-122"/>
+                <a:cs typeface="Segoe UI" pitchFamily="34" charset="-120"/>
+              </a:rPr>
+              <a:t>The workshop point: the cost of an automated check has dropped far enough that "we do not have time to automate it" is no longer the real constraint.</a:t>
+            </a:r>
+            <a:endParaRPr lang="en-US" sz="1300" dirty="0"/>
           </a:p>
         </p:txBody>
       </p:sp>
@@ -4445,6 +5569,427 @@
 <file path=ppt/slides/slide14.xml><?xml version="1.0" encoding="utf-8"?>
 <p:sld xmlns:a="http://schemas.openxmlformats.org/drawingml/2006/main" xmlns:r="http://schemas.openxmlformats.org/officeDocument/2006/relationships" xmlns:p="http://schemas.openxmlformats.org/presentationml/2006/main">
   <p:cSld name="Slide 14">
+    <p:bg>
+      <p:bgPr>
+        <a:solidFill>
+          <a:srgbClr val="FFFFFF"/>
+        </a:solidFill>
+      </p:bgPr>
+    </p:bg>
+    <p:spTree>
+      <p:nvGrpSpPr>
+        <p:cNvPr id="1" name=""/>
+        <p:cNvGrpSpPr/>
+        <p:nvPr/>
+      </p:nvGrpSpPr>
+      <p:grpSpPr>
+        <a:xfrm>
+          <a:off x="0" y="0"/>
+          <a:ext cx="0" cy="0"/>
+          <a:chOff x="0" y="0"/>
+          <a:chExt cx="0" cy="0"/>
+        </a:xfrm>
+      </p:grpSpPr>
+      <p:sp>
+        <p:nvSpPr>
+          <p:cNvPr id="2" name="Text 0"/>
+          <p:cNvSpPr/>
+          <p:nvPr/>
+        </p:nvSpPr>
+        <p:spPr>
+          <a:xfrm>
+            <a:off x="566928" y="384048"/>
+            <a:ext cx="11057839" cy="548640"/>
+          </a:xfrm>
+          <a:prstGeom prst="rect">
+            <a:avLst/>
+          </a:prstGeom>
+          <a:noFill/>
+          <a:ln/>
+        </p:spPr>
+        <p:txBody>
+          <a:bodyPr wrap="square" rtlCol="0" anchor="ctr"/>
+          <a:lstStyle/>
+          <a:p>
+            <a:pPr indent="0" marL="0">
+              <a:buNone/>
+            </a:pPr>
+            <a:r>
+              <a:rPr lang="en-US" sz="2600" b="1" dirty="0">
+                <a:solidFill>
+                  <a:srgbClr val="1A1A1E"/>
+                </a:solidFill>
+                <a:latin typeface="Segoe UI" pitchFamily="34" charset="0"/>
+                <a:ea typeface="Segoe UI" pitchFamily="34" charset="-122"/>
+                <a:cs typeface="Segoe UI" pitchFamily="34" charset="-120"/>
+              </a:rPr>
+              <a:t>Running it in CI</a:t>
+            </a:r>
+            <a:endParaRPr lang="en-US" sz="2600" dirty="0"/>
+          </a:p>
+        </p:txBody>
+      </p:sp>
+      <p:sp>
+        <p:nvSpPr>
+          <p:cNvPr id="3" name="Text 1"/>
+          <p:cNvSpPr/>
+          <p:nvPr/>
+        </p:nvSpPr>
+        <p:spPr>
+          <a:xfrm>
+            <a:off x="566928" y="932688"/>
+            <a:ext cx="11057839" cy="365760"/>
+          </a:xfrm>
+          <a:prstGeom prst="rect">
+            <a:avLst/>
+          </a:prstGeom>
+          <a:noFill/>
+          <a:ln/>
+        </p:spPr>
+        <p:txBody>
+          <a:bodyPr wrap="square" rtlCol="0" anchor="ctr"/>
+          <a:lstStyle/>
+          <a:p>
+            <a:pPr indent="0" marL="0">
+              <a:buNone/>
+            </a:pPr>
+            <a:r>
+              <a:rPr lang="en-US" sz="1400" dirty="0">
+                <a:solidFill>
+                  <a:srgbClr val="71717A"/>
+                </a:solidFill>
+                <a:latin typeface="Segoe UI" pitchFamily="34" charset="0"/>
+                <a:ea typeface="Segoe UI" pitchFamily="34" charset="-122"/>
+                <a:cs typeface="Segoe UI" pitchFamily="34" charset="-120"/>
+              </a:rPr>
+              <a:t>The same command a developer runs is the command the pipeline runs</a:t>
+            </a:r>
+            <a:endParaRPr lang="en-US" sz="1400" dirty="0"/>
+          </a:p>
+        </p:txBody>
+      </p:sp>
+      <p:sp>
+        <p:nvSpPr>
+          <p:cNvPr id="4" name="Shape 2"/>
+          <p:cNvSpPr/>
+          <p:nvPr/>
+        </p:nvSpPr>
+        <p:spPr>
+          <a:xfrm>
+            <a:off x="566928" y="1371600"/>
+            <a:ext cx="11057839" cy="18288"/>
+          </a:xfrm>
+          <a:prstGeom prst="rect">
+            <a:avLst/>
+          </a:prstGeom>
+          <a:solidFill>
+            <a:srgbClr val="D9D9DE"/>
+          </a:solidFill>
+          <a:ln/>
+        </p:spPr>
+      </p:sp>
+      <p:sp>
+        <p:nvSpPr>
+          <p:cNvPr id="5" name="Shape 3"/>
+          <p:cNvSpPr/>
+          <p:nvPr/>
+        </p:nvSpPr>
+        <p:spPr>
+          <a:xfrm>
+            <a:off x="566928" y="1627632"/>
+            <a:ext cx="11057839" cy="2011680"/>
+          </a:xfrm>
+          <a:prstGeom prst="roundRect">
+            <a:avLst>
+              <a:gd name="adj" fmla="val 2727"/>
+            </a:avLst>
+          </a:prstGeom>
+          <a:solidFill>
+            <a:srgbClr val="1E1E24"/>
+          </a:solidFill>
+          <a:ln w="12700">
+            <a:solidFill>
+              <a:srgbClr val="1E1E24"/>
+            </a:solidFill>
+            <a:prstDash val="solid"/>
+          </a:ln>
+        </p:spPr>
+      </p:sp>
+      <p:sp>
+        <p:nvSpPr>
+          <p:cNvPr id="6" name="Text 4"/>
+          <p:cNvSpPr/>
+          <p:nvPr/>
+        </p:nvSpPr>
+        <p:spPr>
+          <a:xfrm>
+            <a:off x="768096" y="1773936"/>
+            <a:ext cx="10655503" cy="1719072"/>
+          </a:xfrm>
+          <a:prstGeom prst="rect">
+            <a:avLst/>
+          </a:prstGeom>
+          <a:noFill/>
+          <a:ln/>
+        </p:spPr>
+        <p:txBody>
+          <a:bodyPr wrap="square" rtlCol="0" anchor="t"/>
+          <a:lstStyle/>
+          <a:p>
+            <a:pPr indent="0" marL="0">
+              <a:lnSpc>
+                <a:spcPct val="112000"/>
+              </a:lnSpc>
+              <a:buNone/>
+            </a:pPr>
+            <a:r>
+              <a:rPr lang="en-US" sz="1150" dirty="0">
+                <a:solidFill>
+                  <a:srgbClr val="E8E8EC"/>
+                </a:solidFill>
+                <a:latin typeface="Consolas" pitchFamily="34" charset="0"/>
+                <a:ea typeface="Consolas" pitchFamily="34" charset="-122"/>
+                <a:cs typeface="Consolas" pitchFamily="34" charset="-120"/>
+              </a:rPr>
+              <a:t># any CI runner - CodeBuild, Bitbucket Pipelines, GitHub Actions</a:t>
+            </a:r>
+            <a:endParaRPr lang="en-US" sz="1150" dirty="0"/>
+          </a:p>
+          <a:p>
+            <a:pPr indent="0" marL="0">
+              <a:lnSpc>
+                <a:spcPct val="112000"/>
+              </a:lnSpc>
+              <a:buNone/>
+            </a:pPr>
+            <a:r>
+              <a:rPr lang="en-US" sz="1150" dirty="0">
+                <a:solidFill>
+                  <a:srgbClr val="E8E8EC"/>
+                </a:solidFill>
+                <a:latin typeface="Consolas" pitchFamily="34" charset="0"/>
+                <a:ea typeface="Consolas" pitchFamily="34" charset="-122"/>
+                <a:cs typeface="Consolas" pitchFamily="34" charset="-120"/>
+              </a:rPr>
+              <a:t>npm ci</a:t>
+            </a:r>
+            <a:endParaRPr lang="en-US" sz="1150" dirty="0"/>
+          </a:p>
+          <a:p>
+            <a:pPr indent="0" marL="0">
+              <a:lnSpc>
+                <a:spcPct val="112000"/>
+              </a:lnSpc>
+              <a:buNone/>
+            </a:pPr>
+            <a:r>
+              <a:rPr lang="en-US" sz="1150" dirty="0">
+                <a:solidFill>
+                  <a:srgbClr val="E8E8EC"/>
+                </a:solidFill>
+                <a:latin typeface="Consolas" pitchFamily="34" charset="0"/>
+                <a:ea typeface="Consolas" pitchFamily="34" charset="-122"/>
+                <a:cs typeface="Consolas" pitchFamily="34" charset="-120"/>
+              </a:rPr>
+              <a:t>npx playwright install --with-deps chromium</a:t>
+            </a:r>
+            <a:endParaRPr lang="en-US" sz="1150" dirty="0"/>
+          </a:p>
+          <a:p>
+            <a:pPr indent="0" marL="0">
+              <a:lnSpc>
+                <a:spcPct val="112000"/>
+              </a:lnSpc>
+              <a:buNone/>
+            </a:pPr>
+            <a:r>
+              <a:rPr lang="en-US" sz="1150" dirty="0">
+                <a:solidFill>
+                  <a:srgbClr val="E8E8EC"/>
+                </a:solidFill>
+                <a:latin typeface="Consolas" pitchFamily="34" charset="0"/>
+                <a:ea typeface="Consolas" pitchFamily="34" charset="-122"/>
+                <a:cs typeface="Consolas" pitchFamily="34" charset="-120"/>
+              </a:rPr>
+              <a:t>npm test                       # retries once on CI, serial, ~1 minute</a:t>
+            </a:r>
+            <a:endParaRPr lang="en-US" sz="1150" dirty="0"/>
+          </a:p>
+          <a:p>
+            <a:pPr indent="0" marL="0">
+              <a:lnSpc>
+                <a:spcPct val="112000"/>
+              </a:lnSpc>
+              <a:buNone/>
+            </a:pPr>
+            <a:endParaRPr lang="en-US" sz="1150" dirty="0"/>
+          </a:p>
+          <a:p>
+            <a:pPr indent="0" marL="0">
+              <a:lnSpc>
+                <a:spcPct val="112000"/>
+              </a:lnSpc>
+              <a:buNone/>
+            </a:pPr>
+            <a:r>
+              <a:rPr lang="en-US" sz="1150" dirty="0">
+                <a:solidFill>
+                  <a:srgbClr val="E8E8EC"/>
+                </a:solidFill>
+                <a:latin typeface="Consolas" pitchFamily="34" charset="0"/>
+                <a:ea typeface="Consolas" pitchFamily="34" charset="-122"/>
+                <a:cs typeface="Consolas" pitchFamily="34" charset="-120"/>
+              </a:rPr>
+              <a:t># artefacts to keep: playwright-report/  reports/junit.xml</a:t>
+            </a:r>
+            <a:endParaRPr lang="en-US" sz="1150" dirty="0"/>
+          </a:p>
+        </p:txBody>
+      </p:sp>
+      <p:sp>
+        <p:nvSpPr>
+          <p:cNvPr id="7" name="Text 5"/>
+          <p:cNvSpPr/>
+          <p:nvPr/>
+        </p:nvSpPr>
+        <p:spPr>
+          <a:xfrm>
+            <a:off x="566928" y="3694176"/>
+            <a:ext cx="11057839" cy="274320"/>
+          </a:xfrm>
+          <a:prstGeom prst="rect">
+            <a:avLst/>
+          </a:prstGeom>
+          <a:noFill/>
+          <a:ln/>
+        </p:spPr>
+        <p:txBody>
+          <a:bodyPr wrap="square" rtlCol="0" anchor="ctr"/>
+          <a:lstStyle/>
+          <a:p>
+            <a:pPr indent="0" marL="0">
+              <a:buNone/>
+            </a:pPr>
+            <a:r>
+              <a:rPr lang="en-US" sz="1100" i="1" dirty="0">
+                <a:solidFill>
+                  <a:srgbClr val="71717A"/>
+                </a:solidFill>
+                <a:latin typeface="Segoe UI" pitchFamily="34" charset="0"/>
+                <a:ea typeface="Segoe UI" pitchFamily="34" charset="-122"/>
+                <a:cs typeface="Segoe UI" pitchFamily="34" charset="-120"/>
+              </a:rPr>
+              <a:t>JUnit XML is what a CI dashboard reads; the HTML report is what a human opens.</a:t>
+            </a:r>
+            <a:endParaRPr lang="en-US" sz="1100" dirty="0"/>
+          </a:p>
+        </p:txBody>
+      </p:sp>
+      <p:sp>
+        <p:nvSpPr>
+          <p:cNvPr id="8" name="Text 6"/>
+          <p:cNvSpPr/>
+          <p:nvPr/>
+        </p:nvSpPr>
+        <p:spPr>
+          <a:xfrm>
+            <a:off x="566928" y="4142232"/>
+            <a:ext cx="11057839" cy="4023360"/>
+          </a:xfrm>
+          <a:prstGeom prst="rect">
+            <a:avLst/>
+          </a:prstGeom>
+          <a:noFill/>
+          <a:ln/>
+        </p:spPr>
+        <p:txBody>
+          <a:bodyPr wrap="square" rtlCol="0" anchor="t"/>
+          <a:lstStyle/>
+          <a:p>
+            <a:pPr marL="342900" indent="-342900">
+              <a:lnSpc>
+                <a:spcPct val="115000"/>
+              </a:lnSpc>
+              <a:spcAft>
+                <a:spcPts val="1000"/>
+              </a:spcAft>
+              <a:buSzPct val="100000"/>
+              <a:buChar char="•"/>
+            </a:pPr>
+            <a:r>
+              <a:rPr lang="en-US" sz="1450" dirty="0">
+                <a:solidFill>
+                  <a:srgbClr val="1A1A1E"/>
+                </a:solidFill>
+                <a:latin typeface="Segoe UI" pitchFamily="34" charset="0"/>
+                <a:ea typeface="Segoe UI" pitchFamily="34" charset="-122"/>
+                <a:cs typeface="Segoe UI" pitchFamily="34" charset="-120"/>
+              </a:rPr>
+              <a:t>Run on every pull request against the target branch, and nightly against UAT</a:t>
+            </a:r>
+            <a:endParaRPr lang="en-US" sz="1450" dirty="0"/>
+          </a:p>
+          <a:p>
+            <a:pPr marL="342900" indent="-342900">
+              <a:lnSpc>
+                <a:spcPct val="115000"/>
+              </a:lnSpc>
+              <a:spcAft>
+                <a:spcPts val="1000"/>
+              </a:spcAft>
+              <a:buSzPct val="100000"/>
+              <a:buChar char="•"/>
+            </a:pPr>
+            <a:r>
+              <a:rPr lang="en-US" sz="1450" dirty="0">
+                <a:solidFill>
+                  <a:srgbClr val="1A1A1E"/>
+                </a:solidFill>
+                <a:latin typeface="Segoe UI" pitchFamily="34" charset="0"/>
+                <a:ea typeface="Segoe UI" pitchFamily="34" charset="-122"/>
+                <a:cs typeface="Segoe UI" pitchFamily="34" charset="-120"/>
+              </a:rPr>
+              <a:t>A red suite blocks the merge - that is the whole point of the investment</a:t>
+            </a:r>
+            <a:endParaRPr lang="en-US" sz="1450" dirty="0"/>
+          </a:p>
+          <a:p>
+            <a:pPr marL="342900" indent="-342900">
+              <a:lnSpc>
+                <a:spcPct val="115000"/>
+              </a:lnSpc>
+              <a:spcAft>
+                <a:spcPts val="1000"/>
+              </a:spcAft>
+              <a:buSzPct val="100000"/>
+              <a:buChar char="•"/>
+            </a:pPr>
+            <a:r>
+              <a:rPr lang="en-US" sz="1450" dirty="0">
+                <a:solidFill>
+                  <a:srgbClr val="1A1A1E"/>
+                </a:solidFill>
+                <a:latin typeface="Segoe UI" pitchFamily="34" charset="0"/>
+                <a:ea typeface="Segoe UI" pitchFamily="34" charset="-122"/>
+                <a:cs typeface="Segoe UI" pitchFamily="34" charset="-120"/>
+              </a:rPr>
+              <a:t>Still to arrange: CI credentials and a stable non-production account that does not rotate</a:t>
+            </a:r>
+            <a:endParaRPr lang="en-US" sz="1450" dirty="0"/>
+          </a:p>
+        </p:txBody>
+      </p:sp>
+    </p:spTree>
+  </p:cSld>
+  <p:clrMapOvr>
+    <a:masterClrMapping/>
+  </p:clrMapOvr>
+</p:sld>
+</file>
+
+<file path=ppt/slides/slide15.xml><?xml version="1.0" encoding="utf-8"?>
+<p:sld xmlns:a="http://schemas.openxmlformats.org/drawingml/2006/main" xmlns:r="http://schemas.openxmlformats.org/officeDocument/2006/relationships" xmlns:p="http://schemas.openxmlformats.org/presentationml/2006/main">
+  <p:cSld name="Slide 15">
     <p:bg>
       <p:bgPr>
         <a:solidFill>

</xml_diff>